<commit_message>
docs: add GRAAL context to presentation
</commit_message>
<xml_diff>
--- a/presentations/graal_analysis_framework_asimmetrie.pptx
+++ b/presentations/graal_analysis_framework_asimmetrie.pptx
@@ -3327,40 +3327,7 @@
       </p:sp>
       <p:sp>
         <p:nvSpPr>
-          <p:cNvPr id="9" name="Text 9"/>
-          <p:cNvSpPr txBox="1"/>
-          <p:nvPr/>
-        </p:nvSpPr>
-        <p:spPr>
-          <a:xfrm>
-            <a:off x="8083296" y="0"/>
-            <a:ext cx="493776" cy="260604"/>
-          </a:xfrm>
-          <a:noFill/>
-          <a:ln>
-            <a:noFill/>
-          </a:ln>
-        </p:spPr>
-        <p:txBody>
-          <a:bodyPr wrap="square" lIns="0" rIns="0" tIns="0" bIns="0" anchor="ctr"/>
-          <a:lstStyle/>
-          <a:p>
-            <a:pPr algn="r"/>
-            <a:r>
-              <a:rPr lang="it-IT" sz="1000" b="1" i="0">
-                <a:solidFill>
-                  <a:srgbClr val="FFFFFF"/>
-                </a:solidFill>
-                <a:latin typeface="Aptos"/>
-              </a:rPr>
-              <a:t>01/19</a:t>
-            </a:r>
-          </a:p>
-        </p:txBody>
-      </p:sp>
-      <p:sp>
-        <p:nvSpPr>
-          <p:cNvPr id="10" name="Fill 10"/>
+          <p:cNvPr id="9" name="Fill 9"/>
           <p:cNvSpPr/>
           <p:nvPr/>
         </p:nvSpPr>
@@ -3382,7 +3349,7 @@
       </p:sp>
       <p:sp>
         <p:nvSpPr>
-          <p:cNvPr id="11" name="Fill 11"/>
+          <p:cNvPr id="10" name="Fill 10"/>
           <p:cNvSpPr/>
           <p:nvPr/>
         </p:nvSpPr>
@@ -3404,7 +3371,7 @@
       </p:sp>
       <p:sp>
         <p:nvSpPr>
-          <p:cNvPr id="12" name="Text 12"/>
+          <p:cNvPr id="11" name="Text 11"/>
           <p:cNvSpPr txBox="1"/>
           <p:nvPr/>
         </p:nvSpPr>
@@ -3437,7 +3404,7 @@
       </p:sp>
       <p:sp>
         <p:nvSpPr>
-          <p:cNvPr id="13" name="Text 13"/>
+          <p:cNvPr id="12" name="Text 12"/>
           <p:cNvSpPr txBox="1"/>
           <p:nvPr/>
         </p:nvSpPr>
@@ -4042,40 +4009,7 @@
       </p:sp>
       <p:sp>
         <p:nvSpPr>
-          <p:cNvPr id="19" name="Text 19"/>
-          <p:cNvSpPr txBox="1"/>
-          <p:nvPr/>
-        </p:nvSpPr>
-        <p:spPr>
-          <a:xfrm>
-            <a:off x="8083296" y="0"/>
-            <a:ext cx="493776" cy="260604"/>
-          </a:xfrm>
-          <a:noFill/>
-          <a:ln>
-            <a:noFill/>
-          </a:ln>
-        </p:spPr>
-        <p:txBody>
-          <a:bodyPr wrap="square" lIns="0" rIns="0" tIns="0" bIns="0" anchor="ctr"/>
-          <a:lstStyle/>
-          <a:p>
-            <a:pPr algn="r"/>
-            <a:r>
-              <a:rPr lang="it-IT" sz="1000" b="1" i="0">
-                <a:solidFill>
-                  <a:srgbClr val="FFFFFF"/>
-                </a:solidFill>
-                <a:latin typeface="Aptos"/>
-              </a:rPr>
-              <a:t>10/19</a:t>
-            </a:r>
-          </a:p>
-        </p:txBody>
-      </p:sp>
-      <p:sp>
-        <p:nvSpPr>
-          <p:cNvPr id="20" name="Fill 20"/>
+          <p:cNvPr id="19" name="Fill 19"/>
           <p:cNvSpPr/>
           <p:nvPr/>
         </p:nvSpPr>
@@ -4097,7 +4031,7 @@
       </p:sp>
       <p:sp>
         <p:nvSpPr>
-          <p:cNvPr id="21" name="Fill 21"/>
+          <p:cNvPr id="20" name="Fill 20"/>
           <p:cNvSpPr/>
           <p:nvPr/>
         </p:nvSpPr>
@@ -4119,7 +4053,7 @@
       </p:sp>
       <p:sp>
         <p:nvSpPr>
-          <p:cNvPr id="22" name="Text 22"/>
+          <p:cNvPr id="21" name="Text 21"/>
           <p:cNvSpPr txBox="1"/>
           <p:nvPr/>
         </p:nvSpPr>
@@ -4152,7 +4086,7 @@
       </p:sp>
       <p:sp>
         <p:nvSpPr>
-          <p:cNvPr id="23" name="Text 23"/>
+          <p:cNvPr id="22" name="Text 22"/>
           <p:cNvSpPr txBox="1"/>
           <p:nvPr/>
         </p:nvSpPr>
@@ -4574,40 +4508,7 @@
       </p:sp>
       <p:sp>
         <p:nvSpPr>
-          <p:cNvPr id="14" name="Text 14"/>
-          <p:cNvSpPr txBox="1"/>
-          <p:nvPr/>
-        </p:nvSpPr>
-        <p:spPr>
-          <a:xfrm>
-            <a:off x="8083296" y="0"/>
-            <a:ext cx="493776" cy="260604"/>
-          </a:xfrm>
-          <a:noFill/>
-          <a:ln>
-            <a:noFill/>
-          </a:ln>
-        </p:spPr>
-        <p:txBody>
-          <a:bodyPr wrap="square" lIns="0" rIns="0" tIns="0" bIns="0" anchor="ctr"/>
-          <a:lstStyle/>
-          <a:p>
-            <a:pPr algn="r"/>
-            <a:r>
-              <a:rPr lang="it-IT" sz="1000" b="1" i="0">
-                <a:solidFill>
-                  <a:srgbClr val="FFFFFF"/>
-                </a:solidFill>
-                <a:latin typeface="Aptos"/>
-              </a:rPr>
-              <a:t>11/19</a:t>
-            </a:r>
-          </a:p>
-        </p:txBody>
-      </p:sp>
-      <p:sp>
-        <p:nvSpPr>
-          <p:cNvPr id="15" name="Fill 15"/>
+          <p:cNvPr id="14" name="Fill 14"/>
           <p:cNvSpPr/>
           <p:nvPr/>
         </p:nvSpPr>
@@ -4629,7 +4530,7 @@
       </p:sp>
       <p:sp>
         <p:nvSpPr>
-          <p:cNvPr id="16" name="Fill 16"/>
+          <p:cNvPr id="15" name="Fill 15"/>
           <p:cNvSpPr/>
           <p:nvPr/>
         </p:nvSpPr>
@@ -4651,7 +4552,7 @@
       </p:sp>
       <p:sp>
         <p:nvSpPr>
-          <p:cNvPr id="17" name="Text 17"/>
+          <p:cNvPr id="16" name="Text 16"/>
           <p:cNvSpPr txBox="1"/>
           <p:nvPr/>
         </p:nvSpPr>
@@ -4684,7 +4585,7 @@
       </p:sp>
       <p:sp>
         <p:nvSpPr>
-          <p:cNvPr id="18" name="Text 18"/>
+          <p:cNvPr id="17" name="Text 17"/>
           <p:cNvSpPr txBox="1"/>
           <p:nvPr/>
         </p:nvSpPr>
@@ -5157,40 +5058,7 @@
       </p:sp>
       <p:sp>
         <p:nvSpPr>
-          <p:cNvPr id="15" name="Text 15"/>
-          <p:cNvSpPr txBox="1"/>
-          <p:nvPr/>
-        </p:nvSpPr>
-        <p:spPr>
-          <a:xfrm>
-            <a:off x="8083296" y="0"/>
-            <a:ext cx="493776" cy="260604"/>
-          </a:xfrm>
-          <a:noFill/>
-          <a:ln>
-            <a:noFill/>
-          </a:ln>
-        </p:spPr>
-        <p:txBody>
-          <a:bodyPr wrap="square" lIns="0" rIns="0" tIns="0" bIns="0" anchor="ctr"/>
-          <a:lstStyle/>
-          <a:p>
-            <a:pPr algn="r"/>
-            <a:r>
-              <a:rPr lang="it-IT" sz="1000" b="1" i="0">
-                <a:solidFill>
-                  <a:srgbClr val="FFFFFF"/>
-                </a:solidFill>
-                <a:latin typeface="Aptos"/>
-              </a:rPr>
-              <a:t>12/19</a:t>
-            </a:r>
-          </a:p>
-        </p:txBody>
-      </p:sp>
-      <p:sp>
-        <p:nvSpPr>
-          <p:cNvPr id="16" name="Fill 16"/>
+          <p:cNvPr id="15" name="Fill 15"/>
           <p:cNvSpPr/>
           <p:nvPr/>
         </p:nvSpPr>
@@ -5212,7 +5080,7 @@
       </p:sp>
       <p:sp>
         <p:nvSpPr>
-          <p:cNvPr id="17" name="Fill 17"/>
+          <p:cNvPr id="16" name="Fill 16"/>
           <p:cNvSpPr/>
           <p:nvPr/>
         </p:nvSpPr>
@@ -5234,7 +5102,7 @@
       </p:sp>
       <p:sp>
         <p:nvSpPr>
-          <p:cNvPr id="18" name="Text 18"/>
+          <p:cNvPr id="17" name="Text 17"/>
           <p:cNvSpPr txBox="1"/>
           <p:nvPr/>
         </p:nvSpPr>
@@ -5267,7 +5135,7 @@
       </p:sp>
       <p:sp>
         <p:nvSpPr>
-          <p:cNvPr id="19" name="Text 19"/>
+          <p:cNvPr id="18" name="Text 18"/>
           <p:cNvSpPr txBox="1"/>
           <p:nvPr/>
         </p:nvSpPr>
@@ -5707,40 +5575,7 @@
       </p:sp>
       <p:sp>
         <p:nvSpPr>
-          <p:cNvPr id="14" name="Text 14"/>
-          <p:cNvSpPr txBox="1"/>
-          <p:nvPr/>
-        </p:nvSpPr>
-        <p:spPr>
-          <a:xfrm>
-            <a:off x="8083296" y="0"/>
-            <a:ext cx="493776" cy="260604"/>
-          </a:xfrm>
-          <a:noFill/>
-          <a:ln>
-            <a:noFill/>
-          </a:ln>
-        </p:spPr>
-        <p:txBody>
-          <a:bodyPr wrap="square" lIns="0" rIns="0" tIns="0" bIns="0" anchor="ctr"/>
-          <a:lstStyle/>
-          <a:p>
-            <a:pPr algn="r"/>
-            <a:r>
-              <a:rPr lang="it-IT" sz="1000" b="1" i="0">
-                <a:solidFill>
-                  <a:srgbClr val="FFFFFF"/>
-                </a:solidFill>
-                <a:latin typeface="Aptos"/>
-              </a:rPr>
-              <a:t>13/19</a:t>
-            </a:r>
-          </a:p>
-        </p:txBody>
-      </p:sp>
-      <p:sp>
-        <p:nvSpPr>
-          <p:cNvPr id="15" name="Fill 15"/>
+          <p:cNvPr id="14" name="Fill 14"/>
           <p:cNvSpPr/>
           <p:nvPr/>
         </p:nvSpPr>
@@ -5762,7 +5597,7 @@
       </p:sp>
       <p:sp>
         <p:nvSpPr>
-          <p:cNvPr id="16" name="Fill 16"/>
+          <p:cNvPr id="15" name="Fill 15"/>
           <p:cNvSpPr/>
           <p:nvPr/>
         </p:nvSpPr>
@@ -5784,7 +5619,7 @@
       </p:sp>
       <p:sp>
         <p:nvSpPr>
-          <p:cNvPr id="17" name="Text 17"/>
+          <p:cNvPr id="16" name="Text 16"/>
           <p:cNvSpPr txBox="1"/>
           <p:nvPr/>
         </p:nvSpPr>
@@ -5817,7 +5652,7 @@
       </p:sp>
       <p:sp>
         <p:nvSpPr>
-          <p:cNvPr id="18" name="Text 18"/>
+          <p:cNvPr id="17" name="Text 17"/>
           <p:cNvSpPr txBox="1"/>
           <p:nvPr/>
         </p:nvSpPr>
@@ -6116,40 +5951,7 @@
       </p:sp>
       <p:sp>
         <p:nvSpPr>
-          <p:cNvPr id="10" name="Text 10"/>
-          <p:cNvSpPr txBox="1"/>
-          <p:nvPr/>
-        </p:nvSpPr>
-        <p:spPr>
-          <a:xfrm>
-            <a:off x="8083296" y="0"/>
-            <a:ext cx="493776" cy="260604"/>
-          </a:xfrm>
-          <a:noFill/>
-          <a:ln>
-            <a:noFill/>
-          </a:ln>
-        </p:spPr>
-        <p:txBody>
-          <a:bodyPr wrap="square" lIns="0" rIns="0" tIns="0" bIns="0" anchor="ctr"/>
-          <a:lstStyle/>
-          <a:p>
-            <a:pPr algn="r"/>
-            <a:r>
-              <a:rPr lang="it-IT" sz="1000" b="1" i="0">
-                <a:solidFill>
-                  <a:srgbClr val="FFFFFF"/>
-                </a:solidFill>
-                <a:latin typeface="Aptos"/>
-              </a:rPr>
-              <a:t>14/19</a:t>
-            </a:r>
-          </a:p>
-        </p:txBody>
-      </p:sp>
-      <p:sp>
-        <p:nvSpPr>
-          <p:cNvPr id="11" name="Fill 11"/>
+          <p:cNvPr id="10" name="Fill 10"/>
           <p:cNvSpPr/>
           <p:nvPr/>
         </p:nvSpPr>
@@ -6171,7 +5973,7 @@
       </p:sp>
       <p:sp>
         <p:nvSpPr>
-          <p:cNvPr id="12" name="Fill 12"/>
+          <p:cNvPr id="11" name="Fill 11"/>
           <p:cNvSpPr/>
           <p:nvPr/>
         </p:nvSpPr>
@@ -6193,7 +5995,7 @@
       </p:sp>
       <p:sp>
         <p:nvSpPr>
-          <p:cNvPr id="13" name="Text 13"/>
+          <p:cNvPr id="12" name="Text 12"/>
           <p:cNvSpPr txBox="1"/>
           <p:nvPr/>
         </p:nvSpPr>
@@ -6226,7 +6028,7 @@
       </p:sp>
       <p:sp>
         <p:nvSpPr>
-          <p:cNvPr id="14" name="Text 14"/>
+          <p:cNvPr id="13" name="Text 13"/>
           <p:cNvSpPr txBox="1"/>
           <p:nvPr/>
         </p:nvSpPr>
@@ -6525,40 +6327,7 @@
       </p:sp>
       <p:sp>
         <p:nvSpPr>
-          <p:cNvPr id="10" name="Text 10"/>
-          <p:cNvSpPr txBox="1"/>
-          <p:nvPr/>
-        </p:nvSpPr>
-        <p:spPr>
-          <a:xfrm>
-            <a:off x="8083296" y="0"/>
-            <a:ext cx="493776" cy="260604"/>
-          </a:xfrm>
-          <a:noFill/>
-          <a:ln>
-            <a:noFill/>
-          </a:ln>
-        </p:spPr>
-        <p:txBody>
-          <a:bodyPr wrap="square" lIns="0" rIns="0" tIns="0" bIns="0" anchor="ctr"/>
-          <a:lstStyle/>
-          <a:p>
-            <a:pPr algn="r"/>
-            <a:r>
-              <a:rPr lang="it-IT" sz="1000" b="1" i="0">
-                <a:solidFill>
-                  <a:srgbClr val="FFFFFF"/>
-                </a:solidFill>
-                <a:latin typeface="Aptos"/>
-              </a:rPr>
-              <a:t>15/19</a:t>
-            </a:r>
-          </a:p>
-        </p:txBody>
-      </p:sp>
-      <p:sp>
-        <p:nvSpPr>
-          <p:cNvPr id="11" name="Fill 11"/>
+          <p:cNvPr id="10" name="Fill 10"/>
           <p:cNvSpPr/>
           <p:nvPr/>
         </p:nvSpPr>
@@ -6580,7 +6349,7 @@
       </p:sp>
       <p:sp>
         <p:nvSpPr>
-          <p:cNvPr id="12" name="Fill 12"/>
+          <p:cNvPr id="11" name="Fill 11"/>
           <p:cNvSpPr/>
           <p:nvPr/>
         </p:nvSpPr>
@@ -6602,7 +6371,7 @@
       </p:sp>
       <p:sp>
         <p:nvSpPr>
-          <p:cNvPr id="13" name="Text 13"/>
+          <p:cNvPr id="12" name="Text 12"/>
           <p:cNvSpPr txBox="1"/>
           <p:nvPr/>
         </p:nvSpPr>
@@ -6635,7 +6404,7 @@
       </p:sp>
       <p:sp>
         <p:nvSpPr>
-          <p:cNvPr id="14" name="Text 14"/>
+          <p:cNvPr id="13" name="Text 13"/>
           <p:cNvSpPr txBox="1"/>
           <p:nvPr/>
         </p:nvSpPr>
@@ -6934,40 +6703,7 @@
       </p:sp>
       <p:sp>
         <p:nvSpPr>
-          <p:cNvPr id="10" name="Text 10"/>
-          <p:cNvSpPr txBox="1"/>
-          <p:nvPr/>
-        </p:nvSpPr>
-        <p:spPr>
-          <a:xfrm>
-            <a:off x="8083296" y="0"/>
-            <a:ext cx="493776" cy="260604"/>
-          </a:xfrm>
-          <a:noFill/>
-          <a:ln>
-            <a:noFill/>
-          </a:ln>
-        </p:spPr>
-        <p:txBody>
-          <a:bodyPr wrap="square" lIns="0" rIns="0" tIns="0" bIns="0" anchor="ctr"/>
-          <a:lstStyle/>
-          <a:p>
-            <a:pPr algn="r"/>
-            <a:r>
-              <a:rPr lang="it-IT" sz="1000" b="1" i="0">
-                <a:solidFill>
-                  <a:srgbClr val="FFFFFF"/>
-                </a:solidFill>
-                <a:latin typeface="Aptos"/>
-              </a:rPr>
-              <a:t>16/19</a:t>
-            </a:r>
-          </a:p>
-        </p:txBody>
-      </p:sp>
-      <p:sp>
-        <p:nvSpPr>
-          <p:cNvPr id="11" name="Fill 11"/>
+          <p:cNvPr id="10" name="Fill 10"/>
           <p:cNvSpPr/>
           <p:nvPr/>
         </p:nvSpPr>
@@ -6989,7 +6725,7 @@
       </p:sp>
       <p:sp>
         <p:nvSpPr>
-          <p:cNvPr id="12" name="Fill 12"/>
+          <p:cNvPr id="11" name="Fill 11"/>
           <p:cNvSpPr/>
           <p:nvPr/>
         </p:nvSpPr>
@@ -7011,7 +6747,7 @@
       </p:sp>
       <p:sp>
         <p:nvSpPr>
-          <p:cNvPr id="13" name="Text 13"/>
+          <p:cNvPr id="12" name="Text 12"/>
           <p:cNvSpPr txBox="1"/>
           <p:nvPr/>
         </p:nvSpPr>
@@ -7044,7 +6780,7 @@
       </p:sp>
       <p:sp>
         <p:nvSpPr>
-          <p:cNvPr id="14" name="Text 14"/>
+          <p:cNvPr id="13" name="Text 13"/>
           <p:cNvSpPr txBox="1"/>
           <p:nvPr/>
         </p:nvSpPr>
@@ -7442,40 +7178,7 @@
       </p:sp>
       <p:sp>
         <p:nvSpPr>
-          <p:cNvPr id="13" name="Text 13"/>
-          <p:cNvSpPr txBox="1"/>
-          <p:nvPr/>
-        </p:nvSpPr>
-        <p:spPr>
-          <a:xfrm>
-            <a:off x="8083296" y="0"/>
-            <a:ext cx="493776" cy="260604"/>
-          </a:xfrm>
-          <a:noFill/>
-          <a:ln>
-            <a:noFill/>
-          </a:ln>
-        </p:spPr>
-        <p:txBody>
-          <a:bodyPr wrap="square" lIns="0" rIns="0" tIns="0" bIns="0" anchor="ctr"/>
-          <a:lstStyle/>
-          <a:p>
-            <a:pPr algn="r"/>
-            <a:r>
-              <a:rPr lang="it-IT" sz="1000" b="1" i="0">
-                <a:solidFill>
-                  <a:srgbClr val="FFFFFF"/>
-                </a:solidFill>
-                <a:latin typeface="Aptos"/>
-              </a:rPr>
-              <a:t>17/19</a:t>
-            </a:r>
-          </a:p>
-        </p:txBody>
-      </p:sp>
-      <p:sp>
-        <p:nvSpPr>
-          <p:cNvPr id="14" name="Fill 14"/>
+          <p:cNvPr id="13" name="Fill 13"/>
           <p:cNvSpPr/>
           <p:nvPr/>
         </p:nvSpPr>
@@ -7497,7 +7200,7 @@
       </p:sp>
       <p:sp>
         <p:nvSpPr>
-          <p:cNvPr id="15" name="Fill 15"/>
+          <p:cNvPr id="14" name="Fill 14"/>
           <p:cNvSpPr/>
           <p:nvPr/>
         </p:nvSpPr>
@@ -7519,7 +7222,7 @@
       </p:sp>
       <p:sp>
         <p:nvSpPr>
-          <p:cNvPr id="16" name="Text 16"/>
+          <p:cNvPr id="15" name="Text 15"/>
           <p:cNvSpPr txBox="1"/>
           <p:nvPr/>
         </p:nvSpPr>
@@ -7552,7 +7255,7 @@
       </p:sp>
       <p:sp>
         <p:nvSpPr>
-          <p:cNvPr id="17" name="Text 17"/>
+          <p:cNvPr id="16" name="Text 16"/>
           <p:cNvSpPr txBox="1"/>
           <p:nvPr/>
         </p:nvSpPr>
@@ -8157,40 +7860,7 @@
       </p:sp>
       <p:sp>
         <p:nvSpPr>
-          <p:cNvPr id="19" name="Text 19"/>
-          <p:cNvSpPr txBox="1"/>
-          <p:nvPr/>
-        </p:nvSpPr>
-        <p:spPr>
-          <a:xfrm>
-            <a:off x="8083296" y="0"/>
-            <a:ext cx="493776" cy="260604"/>
-          </a:xfrm>
-          <a:noFill/>
-          <a:ln>
-            <a:noFill/>
-          </a:ln>
-        </p:spPr>
-        <p:txBody>
-          <a:bodyPr wrap="square" lIns="0" rIns="0" tIns="0" bIns="0" anchor="ctr"/>
-          <a:lstStyle/>
-          <a:p>
-            <a:pPr algn="r"/>
-            <a:r>
-              <a:rPr lang="it-IT" sz="1000" b="1" i="0">
-                <a:solidFill>
-                  <a:srgbClr val="FFFFFF"/>
-                </a:solidFill>
-                <a:latin typeface="Aptos"/>
-              </a:rPr>
-              <a:t>18/19</a:t>
-            </a:r>
-          </a:p>
-        </p:txBody>
-      </p:sp>
-      <p:sp>
-        <p:nvSpPr>
-          <p:cNvPr id="20" name="Fill 20"/>
+          <p:cNvPr id="19" name="Fill 19"/>
           <p:cNvSpPr/>
           <p:nvPr/>
         </p:nvSpPr>
@@ -8212,7 +7882,7 @@
       </p:sp>
       <p:sp>
         <p:nvSpPr>
-          <p:cNvPr id="21" name="Fill 21"/>
+          <p:cNvPr id="20" name="Fill 20"/>
           <p:cNvSpPr/>
           <p:nvPr/>
         </p:nvSpPr>
@@ -8234,7 +7904,7 @@
       </p:sp>
       <p:sp>
         <p:nvSpPr>
-          <p:cNvPr id="22" name="Text 22"/>
+          <p:cNvPr id="21" name="Text 21"/>
           <p:cNvSpPr txBox="1"/>
           <p:nvPr/>
         </p:nvSpPr>
@@ -8267,7 +7937,7 @@
       </p:sp>
       <p:sp>
         <p:nvSpPr>
-          <p:cNvPr id="23" name="Text 23"/>
+          <p:cNvPr id="22" name="Text 22"/>
           <p:cNvSpPr txBox="1"/>
           <p:nvPr/>
         </p:nvSpPr>
@@ -8740,40 +8410,7 @@
       </p:sp>
       <p:sp>
         <p:nvSpPr>
-          <p:cNvPr id="15" name="Text 15"/>
-          <p:cNvSpPr txBox="1"/>
-          <p:nvPr/>
-        </p:nvSpPr>
-        <p:spPr>
-          <a:xfrm>
-            <a:off x="8083296" y="0"/>
-            <a:ext cx="493776" cy="260604"/>
-          </a:xfrm>
-          <a:noFill/>
-          <a:ln>
-            <a:noFill/>
-          </a:ln>
-        </p:spPr>
-        <p:txBody>
-          <a:bodyPr wrap="square" lIns="0" rIns="0" tIns="0" bIns="0" anchor="ctr"/>
-          <a:lstStyle/>
-          <a:p>
-            <a:pPr algn="r"/>
-            <a:r>
-              <a:rPr lang="it-IT" sz="1000" b="1" i="0">
-                <a:solidFill>
-                  <a:srgbClr val="FFFFFF"/>
-                </a:solidFill>
-                <a:latin typeface="Aptos"/>
-              </a:rPr>
-              <a:t>19/19</a:t>
-            </a:r>
-          </a:p>
-        </p:txBody>
-      </p:sp>
-      <p:sp>
-        <p:nvSpPr>
-          <p:cNvPr id="16" name="Fill 16"/>
+          <p:cNvPr id="15" name="Fill 15"/>
           <p:cNvSpPr/>
           <p:nvPr/>
         </p:nvSpPr>
@@ -8795,7 +8432,7 @@
       </p:sp>
       <p:sp>
         <p:nvSpPr>
-          <p:cNvPr id="17" name="Fill 17"/>
+          <p:cNvPr id="16" name="Fill 16"/>
           <p:cNvSpPr/>
           <p:nvPr/>
         </p:nvSpPr>
@@ -8817,7 +8454,7 @@
       </p:sp>
       <p:sp>
         <p:nvSpPr>
-          <p:cNvPr id="18" name="Text 18"/>
+          <p:cNvPr id="17" name="Text 17"/>
           <p:cNvSpPr txBox="1"/>
           <p:nvPr/>
         </p:nvSpPr>
@@ -8850,7 +8487,7 @@
       </p:sp>
       <p:sp>
         <p:nvSpPr>
-          <p:cNvPr id="19" name="Text 19"/>
+          <p:cNvPr id="18" name="Text 18"/>
           <p:cNvSpPr txBox="1"/>
           <p:nvPr/>
         </p:nvSpPr>
@@ -8942,7 +8579,7 @@
                 </a:solidFill>
                 <a:latin typeface="Aptos"/>
               </a:rPr>
-              <a:t>La domanda fisica</a:t>
+              <a:t>GRAAL e obiettivo del lavoro</a:t>
             </a:r>
           </a:p>
         </p:txBody>
@@ -8975,7 +8612,7 @@
                 </a:solidFill>
                 <a:latin typeface="Aptos"/>
               </a:rPr>
-              <a:t>Fonte: wiki/scientific-foundations.md; Ajaka et al. (2008)</a:t>
+              <a:t>Fonte: D. Rebreyend (MENU04); V. Nedorezov (2015); Ajaka et al., PRL 100 (2008)</a:t>
             </a:r>
           </a:p>
         </p:txBody>
@@ -8988,27 +8625,27 @@
         </p:nvSpPr>
         <p:spPr>
           <a:xfrm>
-            <a:off x="676656" y="1170432"/>
-            <a:ext cx="7772400" cy="585216"/>
-          </a:xfrm>
-          <a:noFill/>
-          <a:ln>
-            <a:noFill/>
-          </a:ln>
-        </p:spPr>
-        <p:txBody>
-          <a:bodyPr wrap="square" lIns="0" rIns="0" tIns="0" bIns="0" anchor="t"/>
-          <a:lstStyle/>
-          <a:p>
-            <a:pPr algn="l"/>
-            <a:r>
-              <a:rPr lang="it-IT" sz="3440" b="1" i="0">
+            <a:off x="658368" y="1042416"/>
+            <a:ext cx="3840480" cy="347472"/>
+          </a:xfrm>
+          <a:noFill/>
+          <a:ln>
+            <a:noFill/>
+          </a:ln>
+        </p:spPr>
+        <p:txBody>
+          <a:bodyPr wrap="square" lIns="0" rIns="0" tIns="0" bIns="0" anchor="t"/>
+          <a:lstStyle/>
+          <a:p>
+            <a:pPr algn="l"/>
+            <a:r>
+              <a:rPr lang="it-IT" sz="1806" b="1" i="0">
                 <a:solidFill>
                   <a:srgbClr val="0B5FA5"/>
                 </a:solidFill>
                 <a:latin typeface="Aptos"/>
               </a:rPr>
-              <a:t>γ p  →  p η π⁰</a:t>
+              <a:t>GRAAL all'ESRF</a:t>
             </a:r>
           </a:p>
         </p:txBody>
@@ -9021,27 +8658,27 @@
         </p:nvSpPr>
         <p:spPr>
           <a:xfrm>
-            <a:off x="704088" y="1847088"/>
-            <a:ext cx="7040880" cy="347472"/>
-          </a:xfrm>
-          <a:noFill/>
-          <a:ln>
-            <a:noFill/>
-          </a:ln>
-        </p:spPr>
-        <p:txBody>
-          <a:bodyPr wrap="square" lIns="0" rIns="0" tIns="0" bIns="0" anchor="t"/>
-          <a:lstStyle/>
-          <a:p>
-            <a:pPr algn="l"/>
-            <a:r>
-              <a:rPr lang="it-IT" sz="2064" b="0" i="0">
+            <a:off x="658368" y="1417320"/>
+            <a:ext cx="3776472" cy="969264"/>
+          </a:xfrm>
+          <a:noFill/>
+          <a:ln>
+            <a:noFill/>
+          </a:ln>
+        </p:spPr>
+        <p:txBody>
+          <a:bodyPr wrap="square" lIns="0" rIns="0" tIns="0" bIns="0" anchor="t"/>
+          <a:lstStyle/>
+          <a:p>
+            <a:pPr algn="l"/>
+            <a:r>
+              <a:rPr lang="it-IT" sz="1462" b="0" i="0">
                 <a:solidFill>
                   <a:srgbClr val="112642"/>
                 </a:solidFill>
                 <a:latin typeface="Aptos"/>
               </a:rPr>
-              <a:t>η → γγ     π⁰ → γγ</a:t>
+              <a:t>A Grenoble, la retrodiffusione Compton del laser sugli elettroni dell'anello produce fotoni polarizzati. LAGRANγE registra i prodotti della reazione su un ampio angolo.</a:t>
             </a:r>
           </a:p>
         </p:txBody>
@@ -9054,60 +8691,60 @@
         </p:nvSpPr>
         <p:spPr>
           <a:xfrm>
-            <a:off x="704088" y="2432304"/>
-            <a:ext cx="7680960" cy="448056"/>
-          </a:xfrm>
-          <a:noFill/>
-          <a:ln>
-            <a:noFill/>
-          </a:ln>
-        </p:spPr>
-        <p:txBody>
-          <a:bodyPr wrap="square" lIns="0" rIns="0" tIns="0" bIns="0" anchor="t"/>
-          <a:lstStyle/>
-          <a:p>
-            <a:pPr algn="l"/>
-            <a:r>
-              <a:rPr lang="it-IT" sz="1720" b="0" i="0">
+            <a:off x="658368" y="2542032"/>
+            <a:ext cx="3840480" cy="347472"/>
+          </a:xfrm>
+          <a:noFill/>
+          <a:ln>
+            <a:noFill/>
+          </a:ln>
+        </p:spPr>
+        <p:txBody>
+          <a:bodyPr wrap="square" lIns="0" rIns="0" tIns="0" bIns="0" anchor="t"/>
+          <a:lstStyle/>
+          <a:p>
+            <a:pPr algn="l"/>
+            <a:r>
+              <a:rPr lang="it-IT" sz="1806" b="1" i="0">
+                <a:solidFill>
+                  <a:srgbClr val="0B5FA5"/>
+                </a:solidFill>
+                <a:latin typeface="Aptos"/>
+              </a:rPr>
+              <a:t>Il nostro lavoro</a:t>
+            </a:r>
+          </a:p>
+        </p:txBody>
+      </p:sp>
+      <p:sp>
+        <p:nvSpPr>
+          <p:cNvPr id="7" name="Text 7"/>
+          <p:cNvSpPr txBox="1"/>
+          <p:nvPr/>
+        </p:nvSpPr>
+        <p:spPr>
+          <a:xfrm>
+            <a:off x="658368" y="2907792"/>
+            <a:ext cx="3776472" cy="621792"/>
+          </a:xfrm>
+          <a:noFill/>
+          <a:ln>
+            <a:noFill/>
+          </a:ln>
+        </p:spPr>
+        <p:txBody>
+          <a:bodyPr wrap="square" lIns="0" rIns="0" tIns="0" bIns="0" anchor="t"/>
+          <a:lstStyle/>
+          <a:p>
+            <a:pPr algn="l"/>
+            <a:r>
+              <a:rPr lang="it-IT" sz="1462" b="0" i="0">
                 <a:solidFill>
                   <a:srgbClr val="112642"/>
                 </a:solidFill>
                 <a:latin typeface="Aptos"/>
               </a:rPr>
-              <a:t>Negli eventi cerchiamo quattro fotoni e un protone di rinculo.</a:t>
-            </a:r>
-          </a:p>
-        </p:txBody>
-      </p:sp>
-      <p:sp>
-        <p:nvSpPr>
-          <p:cNvPr id="7" name="Text 7"/>
-          <p:cNvSpPr txBox="1"/>
-          <p:nvPr/>
-        </p:nvSpPr>
-        <p:spPr>
-          <a:xfrm>
-            <a:off x="704088" y="3108960"/>
-            <a:ext cx="7589520" cy="384048"/>
-          </a:xfrm>
-          <a:noFill/>
-          <a:ln>
-            <a:noFill/>
-          </a:ln>
-        </p:spPr>
-        <p:txBody>
-          <a:bodyPr wrap="square" lIns="0" rIns="0" tIns="0" bIns="0" anchor="t"/>
-          <a:lstStyle/>
-          <a:p>
-            <a:pPr algn="l"/>
-            <a:r>
-              <a:rPr lang="it-IT" sz="1978" b="1" i="0">
-                <a:solidFill>
-                  <a:srgbClr val="0B5FA5"/>
-                </a:solidFill>
-                <a:latin typeface="Aptos"/>
-              </a:rPr>
-              <a:t>Σ in pπ⁰, pη ed ηπ⁰</a:t>
+              <a:t>Abbiamo costruito un framework che porta i dati GRAAL dalla preselezione all'estrazione dell'asimmetria Σ.</a:t>
             </a:r>
           </a:p>
         </p:txBody>
@@ -9120,67 +8757,125 @@
         </p:nvSpPr>
         <p:spPr>
           <a:xfrm>
-            <a:off x="704088" y="3593592"/>
-            <a:ext cx="7772400" cy="347472"/>
-          </a:xfrm>
-          <a:noFill/>
-          <a:ln>
-            <a:noFill/>
-          </a:ln>
-        </p:spPr>
-        <p:txBody>
-          <a:bodyPr wrap="square" lIns="0" rIns="0" tIns="0" bIns="0" anchor="t"/>
-          <a:lstStyle/>
-          <a:p>
-            <a:pPr algn="l"/>
-            <a:r>
-              <a:rPr lang="it-IT" sz="1634" b="0" i="0">
+            <a:off x="658368" y="3602736"/>
+            <a:ext cx="3776472" cy="548640"/>
+          </a:xfrm>
+          <a:noFill/>
+          <a:ln>
+            <a:noFill/>
+          </a:ln>
+        </p:spPr>
+        <p:txBody>
+          <a:bodyPr wrap="square" lIns="0" rIns="0" tIns="0" bIns="0" anchor="t"/>
+          <a:lstStyle/>
+          <a:p>
+            <a:pPr algn="l"/>
+            <a:r>
+              <a:rPr lang="it-IT" sz="1462" b="0" i="0">
                 <a:solidFill>
                   <a:srgbClr val="112642"/>
                 </a:solidFill>
                 <a:latin typeface="Aptos"/>
               </a:rPr>
-              <a:t>UV: 1,10–1,50 GeV · VIS: 0,9313–1,10 GeV</a:t>
-            </a:r>
-          </a:p>
-        </p:txBody>
-      </p:sp>
-      <p:sp>
-        <p:nvSpPr>
-          <p:cNvPr id="9" name="Text 9"/>
-          <p:cNvSpPr txBox="1"/>
-          <p:nvPr/>
-        </p:nvSpPr>
-        <p:spPr>
-          <a:xfrm>
-            <a:off x="704088" y="4096512"/>
-            <a:ext cx="7726680" cy="365760"/>
-          </a:xfrm>
-          <a:noFill/>
-          <a:ln>
-            <a:noFill/>
-          </a:ln>
-        </p:spPr>
-        <p:txBody>
-          <a:bodyPr wrap="square" lIns="0" rIns="0" tIns="0" bIns="0" anchor="t"/>
-          <a:lstStyle/>
-          <a:p>
-            <a:pPr algn="l"/>
-            <a:r>
-              <a:rPr lang="it-IT" sz="1462" b="0" i="0">
+              <a:t>Lo testiamo su γp → pηπ⁰, confrontando i risultati con Ajaka et al. (2008).</a:t>
+            </a:r>
+          </a:p>
+        </p:txBody>
+      </p:sp>
+      <p:pic>
+        <p:nvPicPr>
+          <p:cNvPr id="9" name="graal_detector_source.jpg" descr="graal_detector_source.jpg"/>
+          <p:cNvPicPr>
+            <a:picLocks noChangeAspect="1" noGrp="1"/>
+          </p:cNvPicPr>
+          <p:nvPr/>
+        </p:nvPicPr>
+        <p:blipFill>
+          <a:blip r:embed="rId2"/>
+          <a:srcRect l="5000" t="18000" r="34000" b="24000"/>
+          <a:stretch>
+            <a:fillRect/>
+          </a:stretch>
+        </p:blipFill>
+        <p:spPr>
+          <a:xfrm>
+            <a:off x="4700016" y="1106424"/>
+            <a:ext cx="3730752" cy="2660904"/>
+          </a:xfrm>
+          <a:prstGeom prst="rect">
+            <a:avLst/>
+          </a:prstGeom>
+        </p:spPr>
+      </p:pic>
+      <p:sp>
+        <p:nvSpPr>
+          <p:cNvPr id="10" name="Text 10"/>
+          <p:cNvSpPr txBox="1"/>
+          <p:nvPr/>
+        </p:nvSpPr>
+        <p:spPr>
+          <a:xfrm>
+            <a:off x="4709160" y="3803904"/>
+            <a:ext cx="3703320" cy="219456"/>
+          </a:xfrm>
+          <a:noFill/>
+          <a:ln>
+            <a:noFill/>
+          </a:ln>
+        </p:spPr>
+        <p:txBody>
+          <a:bodyPr wrap="square" lIns="0" rIns="0" tIns="0" bIns="0" anchor="t"/>
+          <a:lstStyle/>
+          <a:p>
+            <a:pPr algn="l"/>
+            <a:r>
+              <a:rPr lang="it-IT" sz="1100" b="0" i="0">
                 <a:solidFill>
                   <a:srgbClr val="52657B"/>
                 </a:solidFill>
                 <a:latin typeface="Aptos"/>
               </a:rPr>
-              <a:t>Usiamo i risultati di Ajaka et al. (2008) per verificare l'analisi.</a:t>
-            </a:r>
-          </a:p>
-        </p:txBody>
-      </p:sp>
-      <p:sp>
-        <p:nvSpPr>
-          <p:cNvPr id="10" name="Fill 10"/>
+              <a:t>LAGRANγE: fascio (1), bersaglio (2), BGO (3), parete (8)</a:t>
+            </a:r>
+          </a:p>
+        </p:txBody>
+      </p:sp>
+      <p:sp>
+        <p:nvSpPr>
+          <p:cNvPr id="11" name="Text 11"/>
+          <p:cNvSpPr txBox="1"/>
+          <p:nvPr/>
+        </p:nvSpPr>
+        <p:spPr>
+          <a:xfrm>
+            <a:off x="658368" y="4215384"/>
+            <a:ext cx="7808976" cy="393192"/>
+          </a:xfrm>
+          <a:noFill/>
+          <a:ln>
+            <a:noFill/>
+          </a:ln>
+        </p:spPr>
+        <p:txBody>
+          <a:bodyPr wrap="square" lIns="0" rIns="0" tIns="0" bIns="0" anchor="t"/>
+          <a:lstStyle/>
+          <a:p>
+            <a:pPr algn="l"/>
+            <a:r>
+              <a:rPr lang="it-IT" sz="1376" b="0" i="0">
+                <a:solidFill>
+                  <a:srgbClr val="112642"/>
+                </a:solidFill>
+                <a:latin typeface="Aptos"/>
+              </a:rPr>
+              <a:t>Aggiungiamo una selezione BDT addestrata sul nuovo MC e calibriamo i flussi per run. Estendiamo inoltre l'analisi ai dati VIS vicini alla soglia.</a:t>
+            </a:r>
+          </a:p>
+        </p:txBody>
+      </p:sp>
+      <p:sp>
+        <p:nvSpPr>
+          <p:cNvPr id="12" name="Fill 12"/>
           <p:cNvSpPr/>
           <p:nvPr/>
         </p:nvSpPr>
@@ -9202,7 +8897,7 @@
       </p:sp>
       <p:sp>
         <p:nvSpPr>
-          <p:cNvPr id="11" name="Fill 11"/>
+          <p:cNvPr id="13" name="Fill 13"/>
           <p:cNvSpPr/>
           <p:nvPr/>
         </p:nvSpPr>
@@ -9224,7 +8919,7 @@
       </p:sp>
       <p:sp>
         <p:nvSpPr>
-          <p:cNvPr id="12" name="Text 12"/>
+          <p:cNvPr id="14" name="Text 14"/>
           <p:cNvSpPr txBox="1"/>
           <p:nvPr/>
         </p:nvSpPr>
@@ -9257,40 +8952,7 @@
       </p:sp>
       <p:sp>
         <p:nvSpPr>
-          <p:cNvPr id="13" name="Text 13"/>
-          <p:cNvSpPr txBox="1"/>
-          <p:nvPr/>
-        </p:nvSpPr>
-        <p:spPr>
-          <a:xfrm>
-            <a:off x="8083296" y="0"/>
-            <a:ext cx="493776" cy="260604"/>
-          </a:xfrm>
-          <a:noFill/>
-          <a:ln>
-            <a:noFill/>
-          </a:ln>
-        </p:spPr>
-        <p:txBody>
-          <a:bodyPr wrap="square" lIns="0" rIns="0" tIns="0" bIns="0" anchor="ctr"/>
-          <a:lstStyle/>
-          <a:p>
-            <a:pPr algn="r"/>
-            <a:r>
-              <a:rPr lang="it-IT" sz="1000" b="1" i="0">
-                <a:solidFill>
-                  <a:srgbClr val="FFFFFF"/>
-                </a:solidFill>
-                <a:latin typeface="Aptos"/>
-              </a:rPr>
-              <a:t>02/19</a:t>
-            </a:r>
-          </a:p>
-        </p:txBody>
-      </p:sp>
-      <p:sp>
-        <p:nvSpPr>
-          <p:cNvPr id="14" name="Fill 14"/>
+          <p:cNvPr id="15" name="Fill 15"/>
           <p:cNvSpPr/>
           <p:nvPr/>
         </p:nvSpPr>
@@ -9312,7 +8974,7 @@
       </p:sp>
       <p:sp>
         <p:nvSpPr>
-          <p:cNvPr id="15" name="Fill 15"/>
+          <p:cNvPr id="16" name="Fill 16"/>
           <p:cNvSpPr/>
           <p:nvPr/>
         </p:nvSpPr>
@@ -9334,7 +8996,7 @@
       </p:sp>
       <p:sp>
         <p:nvSpPr>
-          <p:cNvPr id="16" name="Text 16"/>
+          <p:cNvPr id="17" name="Text 17"/>
           <p:cNvSpPr txBox="1"/>
           <p:nvPr/>
         </p:nvSpPr>
@@ -9367,7 +9029,7 @@
       </p:sp>
       <p:sp>
         <p:nvSpPr>
-          <p:cNvPr id="17" name="Text 17"/>
+          <p:cNvPr id="18" name="Text 18"/>
           <p:cNvSpPr txBox="1"/>
           <p:nvPr/>
         </p:nvSpPr>
@@ -9909,40 +9571,7 @@
       </p:sp>
       <p:sp>
         <p:nvSpPr>
-          <p:cNvPr id="16" name="Text 16"/>
-          <p:cNvSpPr txBox="1"/>
-          <p:nvPr/>
-        </p:nvSpPr>
-        <p:spPr>
-          <a:xfrm>
-            <a:off x="8083296" y="0"/>
-            <a:ext cx="493776" cy="260604"/>
-          </a:xfrm>
-          <a:noFill/>
-          <a:ln>
-            <a:noFill/>
-          </a:ln>
-        </p:spPr>
-        <p:txBody>
-          <a:bodyPr wrap="square" lIns="0" rIns="0" tIns="0" bIns="0" anchor="ctr"/>
-          <a:lstStyle/>
-          <a:p>
-            <a:pPr algn="r"/>
-            <a:r>
-              <a:rPr lang="it-IT" sz="1000" b="1" i="0">
-                <a:solidFill>
-                  <a:srgbClr val="FFFFFF"/>
-                </a:solidFill>
-                <a:latin typeface="Aptos"/>
-              </a:rPr>
-              <a:t>03/19</a:t>
-            </a:r>
-          </a:p>
-        </p:txBody>
-      </p:sp>
-      <p:sp>
-        <p:nvSpPr>
-          <p:cNvPr id="17" name="Fill 17"/>
+          <p:cNvPr id="16" name="Fill 16"/>
           <p:cNvSpPr/>
           <p:nvPr/>
         </p:nvSpPr>
@@ -9964,7 +9593,7 @@
       </p:sp>
       <p:sp>
         <p:nvSpPr>
-          <p:cNvPr id="18" name="Fill 18"/>
+          <p:cNvPr id="17" name="Fill 17"/>
           <p:cNvSpPr/>
           <p:nvPr/>
         </p:nvSpPr>
@@ -9986,7 +9615,7 @@
       </p:sp>
       <p:sp>
         <p:nvSpPr>
-          <p:cNvPr id="19" name="Text 19"/>
+          <p:cNvPr id="18" name="Text 18"/>
           <p:cNvSpPr txBox="1"/>
           <p:nvPr/>
         </p:nvSpPr>
@@ -10019,7 +9648,7 @@
       </p:sp>
       <p:sp>
         <p:nvSpPr>
-          <p:cNvPr id="20" name="Text 20"/>
+          <p:cNvPr id="19" name="Text 19"/>
           <p:cNvSpPr txBox="1"/>
           <p:nvPr/>
         </p:nvSpPr>
@@ -10438,40 +10067,7 @@
       </p:sp>
       <p:sp>
         <p:nvSpPr>
-          <p:cNvPr id="13" name="Text 13"/>
-          <p:cNvSpPr txBox="1"/>
-          <p:nvPr/>
-        </p:nvSpPr>
-        <p:spPr>
-          <a:xfrm>
-            <a:off x="8083296" y="0"/>
-            <a:ext cx="493776" cy="260604"/>
-          </a:xfrm>
-          <a:noFill/>
-          <a:ln>
-            <a:noFill/>
-          </a:ln>
-        </p:spPr>
-        <p:txBody>
-          <a:bodyPr wrap="square" lIns="0" rIns="0" tIns="0" bIns="0" anchor="ctr"/>
-          <a:lstStyle/>
-          <a:p>
-            <a:pPr algn="r"/>
-            <a:r>
-              <a:rPr lang="it-IT" sz="1000" b="1" i="0">
-                <a:solidFill>
-                  <a:srgbClr val="FFFFFF"/>
-                </a:solidFill>
-                <a:latin typeface="Aptos"/>
-              </a:rPr>
-              <a:t>04/19</a:t>
-            </a:r>
-          </a:p>
-        </p:txBody>
-      </p:sp>
-      <p:sp>
-        <p:nvSpPr>
-          <p:cNvPr id="14" name="Fill 14"/>
+          <p:cNvPr id="13" name="Fill 13"/>
           <p:cNvSpPr/>
           <p:nvPr/>
         </p:nvSpPr>
@@ -10493,7 +10089,7 @@
       </p:sp>
       <p:sp>
         <p:nvSpPr>
-          <p:cNvPr id="15" name="Fill 15"/>
+          <p:cNvPr id="14" name="Fill 14"/>
           <p:cNvSpPr/>
           <p:nvPr/>
         </p:nvSpPr>
@@ -10515,7 +10111,7 @@
       </p:sp>
       <p:sp>
         <p:nvSpPr>
-          <p:cNvPr id="16" name="Text 16"/>
+          <p:cNvPr id="15" name="Text 15"/>
           <p:cNvSpPr txBox="1"/>
           <p:nvPr/>
         </p:nvSpPr>
@@ -10548,7 +10144,7 @@
       </p:sp>
       <p:sp>
         <p:nvSpPr>
-          <p:cNvPr id="17" name="Text 17"/>
+          <p:cNvPr id="16" name="Text 16"/>
           <p:cNvSpPr txBox="1"/>
           <p:nvPr/>
         </p:nvSpPr>
@@ -11021,40 +10617,7 @@
       </p:sp>
       <p:sp>
         <p:nvSpPr>
-          <p:cNvPr id="15" name="Text 15"/>
-          <p:cNvSpPr txBox="1"/>
-          <p:nvPr/>
-        </p:nvSpPr>
-        <p:spPr>
-          <a:xfrm>
-            <a:off x="8083296" y="0"/>
-            <a:ext cx="493776" cy="260604"/>
-          </a:xfrm>
-          <a:noFill/>
-          <a:ln>
-            <a:noFill/>
-          </a:ln>
-        </p:spPr>
-        <p:txBody>
-          <a:bodyPr wrap="square" lIns="0" rIns="0" tIns="0" bIns="0" anchor="ctr"/>
-          <a:lstStyle/>
-          <a:p>
-            <a:pPr algn="r"/>
-            <a:r>
-              <a:rPr lang="it-IT" sz="1000" b="1" i="0">
-                <a:solidFill>
-                  <a:srgbClr val="FFFFFF"/>
-                </a:solidFill>
-                <a:latin typeface="Aptos"/>
-              </a:rPr>
-              <a:t>05/19</a:t>
-            </a:r>
-          </a:p>
-        </p:txBody>
-      </p:sp>
-      <p:sp>
-        <p:nvSpPr>
-          <p:cNvPr id="16" name="Fill 16"/>
+          <p:cNvPr id="15" name="Fill 15"/>
           <p:cNvSpPr/>
           <p:nvPr/>
         </p:nvSpPr>
@@ -11076,7 +10639,7 @@
       </p:sp>
       <p:sp>
         <p:nvSpPr>
-          <p:cNvPr id="17" name="Fill 17"/>
+          <p:cNvPr id="16" name="Fill 16"/>
           <p:cNvSpPr/>
           <p:nvPr/>
         </p:nvSpPr>
@@ -11098,7 +10661,7 @@
       </p:sp>
       <p:sp>
         <p:nvSpPr>
-          <p:cNvPr id="18" name="Text 18"/>
+          <p:cNvPr id="17" name="Text 17"/>
           <p:cNvSpPr txBox="1"/>
           <p:nvPr/>
         </p:nvSpPr>
@@ -11131,7 +10694,7 @@
       </p:sp>
       <p:sp>
         <p:nvSpPr>
-          <p:cNvPr id="19" name="Text 19"/>
+          <p:cNvPr id="18" name="Text 18"/>
           <p:cNvSpPr txBox="1"/>
           <p:nvPr/>
         </p:nvSpPr>
@@ -11571,40 +11134,7 @@
       </p:sp>
       <p:sp>
         <p:nvSpPr>
-          <p:cNvPr id="14" name="Text 14"/>
-          <p:cNvSpPr txBox="1"/>
-          <p:nvPr/>
-        </p:nvSpPr>
-        <p:spPr>
-          <a:xfrm>
-            <a:off x="8083296" y="0"/>
-            <a:ext cx="493776" cy="260604"/>
-          </a:xfrm>
-          <a:noFill/>
-          <a:ln>
-            <a:noFill/>
-          </a:ln>
-        </p:spPr>
-        <p:txBody>
-          <a:bodyPr wrap="square" lIns="0" rIns="0" tIns="0" bIns="0" anchor="ctr"/>
-          <a:lstStyle/>
-          <a:p>
-            <a:pPr algn="r"/>
-            <a:r>
-              <a:rPr lang="it-IT" sz="1000" b="1" i="0">
-                <a:solidFill>
-                  <a:srgbClr val="FFFFFF"/>
-                </a:solidFill>
-                <a:latin typeface="Aptos"/>
-              </a:rPr>
-              <a:t>06/19</a:t>
-            </a:r>
-          </a:p>
-        </p:txBody>
-      </p:sp>
-      <p:sp>
-        <p:nvSpPr>
-          <p:cNvPr id="15" name="Fill 15"/>
+          <p:cNvPr id="14" name="Fill 14"/>
           <p:cNvSpPr/>
           <p:nvPr/>
         </p:nvSpPr>
@@ -11626,7 +11156,7 @@
       </p:sp>
       <p:sp>
         <p:nvSpPr>
-          <p:cNvPr id="16" name="Fill 16"/>
+          <p:cNvPr id="15" name="Fill 15"/>
           <p:cNvSpPr/>
           <p:nvPr/>
         </p:nvSpPr>
@@ -11648,7 +11178,7 @@
       </p:sp>
       <p:sp>
         <p:nvSpPr>
-          <p:cNvPr id="17" name="Text 17"/>
+          <p:cNvPr id="16" name="Text 16"/>
           <p:cNvSpPr txBox="1"/>
           <p:nvPr/>
         </p:nvSpPr>
@@ -11681,7 +11211,7 @@
       </p:sp>
       <p:sp>
         <p:nvSpPr>
-          <p:cNvPr id="18" name="Text 18"/>
+          <p:cNvPr id="17" name="Text 17"/>
           <p:cNvSpPr txBox="1"/>
           <p:nvPr/>
         </p:nvSpPr>
@@ -12088,40 +11618,7 @@
       </p:sp>
       <p:sp>
         <p:nvSpPr>
-          <p:cNvPr id="13" name="Text 13"/>
-          <p:cNvSpPr txBox="1"/>
-          <p:nvPr/>
-        </p:nvSpPr>
-        <p:spPr>
-          <a:xfrm>
-            <a:off x="8083296" y="0"/>
-            <a:ext cx="493776" cy="260604"/>
-          </a:xfrm>
-          <a:noFill/>
-          <a:ln>
-            <a:noFill/>
-          </a:ln>
-        </p:spPr>
-        <p:txBody>
-          <a:bodyPr wrap="square" lIns="0" rIns="0" tIns="0" bIns="0" anchor="ctr"/>
-          <a:lstStyle/>
-          <a:p>
-            <a:pPr algn="r"/>
-            <a:r>
-              <a:rPr lang="it-IT" sz="1000" b="1" i="0">
-                <a:solidFill>
-                  <a:srgbClr val="FFFFFF"/>
-                </a:solidFill>
-                <a:latin typeface="Aptos"/>
-              </a:rPr>
-              <a:t>07/19</a:t>
-            </a:r>
-          </a:p>
-        </p:txBody>
-      </p:sp>
-      <p:sp>
-        <p:nvSpPr>
-          <p:cNvPr id="14" name="Fill 14"/>
+          <p:cNvPr id="13" name="Fill 13"/>
           <p:cNvSpPr/>
           <p:nvPr/>
         </p:nvSpPr>
@@ -12143,7 +11640,7 @@
       </p:sp>
       <p:sp>
         <p:nvSpPr>
-          <p:cNvPr id="15" name="Fill 15"/>
+          <p:cNvPr id="14" name="Fill 14"/>
           <p:cNvSpPr/>
           <p:nvPr/>
         </p:nvSpPr>
@@ -12165,7 +11662,7 @@
       </p:sp>
       <p:sp>
         <p:nvSpPr>
-          <p:cNvPr id="16" name="Text 16"/>
+          <p:cNvPr id="15" name="Text 15"/>
           <p:cNvSpPr txBox="1"/>
           <p:nvPr/>
         </p:nvSpPr>
@@ -12198,7 +11695,7 @@
       </p:sp>
       <p:sp>
         <p:nvSpPr>
-          <p:cNvPr id="17" name="Text 17"/>
+          <p:cNvPr id="16" name="Text 16"/>
           <p:cNvSpPr txBox="1"/>
           <p:nvPr/>
         </p:nvSpPr>
@@ -12662,40 +12159,7 @@
       </p:sp>
       <p:sp>
         <p:nvSpPr>
-          <p:cNvPr id="14" name="Text 14"/>
-          <p:cNvSpPr txBox="1"/>
-          <p:nvPr/>
-        </p:nvSpPr>
-        <p:spPr>
-          <a:xfrm>
-            <a:off x="8083296" y="0"/>
-            <a:ext cx="493776" cy="260604"/>
-          </a:xfrm>
-          <a:noFill/>
-          <a:ln>
-            <a:noFill/>
-          </a:ln>
-        </p:spPr>
-        <p:txBody>
-          <a:bodyPr wrap="square" lIns="0" rIns="0" tIns="0" bIns="0" anchor="ctr"/>
-          <a:lstStyle/>
-          <a:p>
-            <a:pPr algn="r"/>
-            <a:r>
-              <a:rPr lang="it-IT" sz="1000" b="1" i="0">
-                <a:solidFill>
-                  <a:srgbClr val="FFFFFF"/>
-                </a:solidFill>
-                <a:latin typeface="Aptos"/>
-              </a:rPr>
-              <a:t>08/19</a:t>
-            </a:r>
-          </a:p>
-        </p:txBody>
-      </p:sp>
-      <p:sp>
-        <p:nvSpPr>
-          <p:cNvPr id="15" name="Fill 15"/>
+          <p:cNvPr id="14" name="Fill 14"/>
           <p:cNvSpPr/>
           <p:nvPr/>
         </p:nvSpPr>
@@ -12717,7 +12181,7 @@
       </p:sp>
       <p:sp>
         <p:nvSpPr>
-          <p:cNvPr id="16" name="Fill 16"/>
+          <p:cNvPr id="15" name="Fill 15"/>
           <p:cNvSpPr/>
           <p:nvPr/>
         </p:nvSpPr>
@@ -12739,7 +12203,7 @@
       </p:sp>
       <p:sp>
         <p:nvSpPr>
-          <p:cNvPr id="17" name="Text 17"/>
+          <p:cNvPr id="16" name="Text 16"/>
           <p:cNvSpPr txBox="1"/>
           <p:nvPr/>
         </p:nvSpPr>
@@ -12772,7 +12236,7 @@
       </p:sp>
       <p:sp>
         <p:nvSpPr>
-          <p:cNvPr id="18" name="Text 18"/>
+          <p:cNvPr id="17" name="Text 17"/>
           <p:cNvSpPr txBox="1"/>
           <p:nvPr/>
         </p:nvSpPr>
@@ -13137,40 +12601,7 @@
       </p:sp>
       <p:sp>
         <p:nvSpPr>
-          <p:cNvPr id="12" name="Text 12"/>
-          <p:cNvSpPr txBox="1"/>
-          <p:nvPr/>
-        </p:nvSpPr>
-        <p:spPr>
-          <a:xfrm>
-            <a:off x="8083296" y="0"/>
-            <a:ext cx="493776" cy="260604"/>
-          </a:xfrm>
-          <a:noFill/>
-          <a:ln>
-            <a:noFill/>
-          </a:ln>
-        </p:spPr>
-        <p:txBody>
-          <a:bodyPr wrap="square" lIns="0" rIns="0" tIns="0" bIns="0" anchor="ctr"/>
-          <a:lstStyle/>
-          <a:p>
-            <a:pPr algn="r"/>
-            <a:r>
-              <a:rPr lang="it-IT" sz="1000" b="1" i="0">
-                <a:solidFill>
-                  <a:srgbClr val="FFFFFF"/>
-                </a:solidFill>
-                <a:latin typeface="Aptos"/>
-              </a:rPr>
-              <a:t>09/19</a:t>
-            </a:r>
-          </a:p>
-        </p:txBody>
-      </p:sp>
-      <p:sp>
-        <p:nvSpPr>
-          <p:cNvPr id="13" name="Fill 13"/>
+          <p:cNvPr id="12" name="Fill 12"/>
           <p:cNvSpPr/>
           <p:nvPr/>
         </p:nvSpPr>
@@ -13192,7 +12623,7 @@
       </p:sp>
       <p:sp>
         <p:nvSpPr>
-          <p:cNvPr id="14" name="Fill 14"/>
+          <p:cNvPr id="13" name="Fill 13"/>
           <p:cNvSpPr/>
           <p:nvPr/>
         </p:nvSpPr>
@@ -13214,7 +12645,7 @@
       </p:sp>
       <p:sp>
         <p:nvSpPr>
-          <p:cNvPr id="15" name="Text 15"/>
+          <p:cNvPr id="14" name="Text 14"/>
           <p:cNvSpPr txBox="1"/>
           <p:nvPr/>
         </p:nvSpPr>
@@ -13247,7 +12678,7 @@
       </p:sp>
       <p:sp>
         <p:nvSpPr>
-          <p:cNvPr id="16" name="Text 16"/>
+          <p:cNvPr id="15" name="Text 15"/>
           <p:cNvSpPr txBox="1"/>
           <p:nvPr/>
         </p:nvSpPr>

</xml_diff>

<commit_message>
docs: add workflow and merge preselection slides
</commit_message>
<xml_diff>
--- a/presentations/graal_analysis_framework_asimmetrie.pptx
+++ b/presentations/graal_analysis_framework_asimmetrie.pptx
@@ -8527,7 +8527,7 @@
 </file>
 
 <file path=ppt/slides/slide2.xml><?xml version="1.0" encoding="utf-8"?>
-<p:sld xmlns:p="http://schemas.openxmlformats.org/presentationml/2006/main" xmlns:a="http://schemas.openxmlformats.org/drawingml/2006/main" xmlns:r="http://schemas.openxmlformats.org/officeDocument/2006/relationships">
+<p:sld xmlns:a="http://schemas.openxmlformats.org/drawingml/2006/main" xmlns:r="http://schemas.openxmlformats.org/officeDocument/2006/relationships" xmlns:p="http://schemas.openxmlformats.org/presentationml/2006/main">
   <p:cSld>
     <p:bg>
       <p:bgPr>
@@ -8568,7 +8568,7 @@
           </a:ln>
         </p:spPr>
         <p:txBody>
-          <a:bodyPr wrap="square" lIns="0" rIns="0" tIns="0" bIns="0" anchor="t"/>
+          <a:bodyPr wrap="square" lIns="0" tIns="0" rIns="0" bIns="0" anchor="t"/>
           <a:lstStyle/>
           <a:p>
             <a:pPr algn="l"/>
@@ -8601,7 +8601,7 @@
           </a:ln>
         </p:spPr>
         <p:txBody>
-          <a:bodyPr wrap="square" lIns="0" rIns="0" tIns="0" bIns="0" anchor="t"/>
+          <a:bodyPr wrap="square" lIns="0" tIns="0" rIns="0" bIns="0" anchor="t"/>
           <a:lstStyle/>
           <a:p>
             <a:pPr algn="l"/>
@@ -8634,7 +8634,7 @@
           </a:ln>
         </p:spPr>
         <p:txBody>
-          <a:bodyPr wrap="square" lIns="0" rIns="0" tIns="0" bIns="0" anchor="t"/>
+          <a:bodyPr wrap="square" lIns="0" tIns="0" rIns="0" bIns="0" anchor="t"/>
           <a:lstStyle/>
           <a:p>
             <a:pPr algn="l"/>
@@ -8667,18 +8667,54 @@
           </a:ln>
         </p:spPr>
         <p:txBody>
-          <a:bodyPr wrap="square" lIns="0" rIns="0" tIns="0" bIns="0" anchor="t"/>
-          <a:lstStyle/>
-          <a:p>
-            <a:pPr algn="l"/>
-            <a:r>
-              <a:rPr lang="it-IT" sz="1462" b="0" i="0">
+          <a:bodyPr wrap="square" lIns="0" tIns="0" rIns="0" bIns="0" anchor="t"/>
+          <a:lstStyle/>
+          <a:p>
+            <a:pPr algn="l"/>
+            <a:r>
+              <a:rPr lang="it-IT" sz="1462" b="0" i="0" dirty="0">
                 <a:solidFill>
                   <a:srgbClr val="112642"/>
                 </a:solidFill>
                 <a:latin typeface="Aptos"/>
               </a:rPr>
-              <a:t>A Grenoble, la retrodiffusione Compton del laser sugli elettroni dell'anello produce fotoni polarizzati. LAGRANγE registra i prodotti della reazione su un ampio angolo.</a:t>
+              <a:t>A Grenoble, il </a:t>
+            </a:r>
+            <a:r>
+              <a:rPr lang="it-IT" sz="1462" b="0" i="0" dirty="0" err="1">
+                <a:solidFill>
+                  <a:srgbClr val="112642"/>
+                </a:solidFill>
+                <a:latin typeface="Aptos"/>
+              </a:rPr>
+              <a:t>backscattering</a:t>
+            </a:r>
+            <a:r>
+              <a:rPr lang="it-IT" sz="1462" b="0" i="0" dirty="0">
+                <a:solidFill>
+                  <a:srgbClr val="112642"/>
+                </a:solidFill>
+                <a:latin typeface="Aptos"/>
+              </a:rPr>
+              <a:t> Compton del laser sugli elettroni dell'anello produce fotoni polarizzati. </a:t>
+            </a:r>
+            <a:r>
+              <a:rPr lang="it-IT" sz="1462" b="0" i="0" dirty="0" err="1">
+                <a:solidFill>
+                  <a:srgbClr val="112642"/>
+                </a:solidFill>
+                <a:latin typeface="Aptos"/>
+              </a:rPr>
+              <a:t>LAGRANγE</a:t>
+            </a:r>
+            <a:r>
+              <a:rPr lang="it-IT" sz="1462" b="0" i="0" dirty="0">
+                <a:solidFill>
+                  <a:srgbClr val="112642"/>
+                </a:solidFill>
+                <a:latin typeface="Aptos"/>
+              </a:rPr>
+              <a:t> registra i prodotti della reazione su un ampio angolo.</a:t>
             </a:r>
           </a:p>
         </p:txBody>
@@ -8700,7 +8736,7 @@
           </a:ln>
         </p:spPr>
         <p:txBody>
-          <a:bodyPr wrap="square" lIns="0" rIns="0" tIns="0" bIns="0" anchor="t"/>
+          <a:bodyPr wrap="square" lIns="0" tIns="0" rIns="0" bIns="0" anchor="t"/>
           <a:lstStyle/>
           <a:p>
             <a:pPr algn="l"/>
@@ -8725,26 +8761,47 @@
         <p:spPr>
           <a:xfrm>
             <a:off x="658368" y="2907792"/>
-            <a:ext cx="3776472" cy="621792"/>
-          </a:xfrm>
-          <a:noFill/>
-          <a:ln>
-            <a:noFill/>
-          </a:ln>
-        </p:spPr>
-        <p:txBody>
-          <a:bodyPr wrap="square" lIns="0" rIns="0" tIns="0" bIns="0" anchor="t"/>
-          <a:lstStyle/>
-          <a:p>
-            <a:pPr algn="l"/>
-            <a:r>
-              <a:rPr lang="it-IT" sz="1462" b="0" i="0">
+            <a:ext cx="3970782" cy="621792"/>
+          </a:xfrm>
+          <a:noFill/>
+          <a:ln>
+            <a:noFill/>
+          </a:ln>
+        </p:spPr>
+        <p:txBody>
+          <a:bodyPr wrap="square" lIns="0" tIns="0" rIns="0" bIns="0" anchor="t"/>
+          <a:lstStyle/>
+          <a:p>
+            <a:pPr marL="285750" indent="-285750" algn="l">
+              <a:buFont typeface="Arial" panose="020B0604020202020204" pitchFamily="34" charset="0"/>
+              <a:buChar char="•"/>
+            </a:pPr>
+            <a:r>
+              <a:rPr lang="it-IT" sz="1462" b="0" i="0" dirty="0">
                 <a:solidFill>
                   <a:srgbClr val="112642"/>
                 </a:solidFill>
                 <a:latin typeface="Aptos"/>
               </a:rPr>
-              <a:t>Abbiamo costruito un framework che porta i dati GRAAL dalla preselezione all'estrazione dell'asimmetria Σ.</a:t>
+              <a:t>Framework che porta i dati GRAAL dalla </a:t>
+            </a:r>
+            <a:r>
+              <a:rPr lang="it-IT" sz="1462" b="0" i="0" dirty="0" err="1">
+                <a:solidFill>
+                  <a:srgbClr val="112642"/>
+                </a:solidFill>
+                <a:latin typeface="Aptos"/>
+              </a:rPr>
+              <a:t>pre</a:t>
+            </a:r>
+            <a:r>
+              <a:rPr lang="it-IT" sz="1462" b="0" i="0" dirty="0">
+                <a:solidFill>
+                  <a:srgbClr val="112642"/>
+                </a:solidFill>
+                <a:latin typeface="Aptos"/>
+              </a:rPr>
+              <a:t>-selezione all'estrazione delle asimmetrie</a:t>
             </a:r>
           </a:p>
         </p:txBody>
@@ -8766,18 +8823,75 @@
           </a:ln>
         </p:spPr>
         <p:txBody>
-          <a:bodyPr wrap="square" lIns="0" rIns="0" tIns="0" bIns="0" anchor="t"/>
-          <a:lstStyle/>
-          <a:p>
-            <a:pPr algn="l"/>
-            <a:r>
-              <a:rPr lang="it-IT" sz="1462" b="0" i="0">
+          <a:bodyPr wrap="square" lIns="0" tIns="0" rIns="0" bIns="0" anchor="t"/>
+          <a:lstStyle/>
+          <a:p>
+            <a:pPr marL="285750" indent="-285750" algn="l">
+              <a:buFont typeface="Arial" panose="020B0604020202020204" pitchFamily="34" charset="0"/>
+              <a:buChar char="•"/>
+            </a:pPr>
+            <a:r>
+              <a:rPr lang="it-IT" sz="1462" b="0" i="0" dirty="0">
                 <a:solidFill>
                   <a:srgbClr val="112642"/>
                 </a:solidFill>
                 <a:latin typeface="Aptos"/>
               </a:rPr>
-              <a:t>Lo testiamo su γp → pηπ⁰, confrontando i risultati con Ajaka et al. (2008).</a:t>
+              <a:t>Testato su </a:t>
+            </a:r>
+            <a:r>
+              <a:rPr lang="it-IT" sz="1462" b="0" i="0" dirty="0" err="1">
+                <a:solidFill>
+                  <a:srgbClr val="112642"/>
+                </a:solidFill>
+                <a:latin typeface="Aptos"/>
+              </a:rPr>
+              <a:t>γp</a:t>
+            </a:r>
+            <a:r>
+              <a:rPr lang="it-IT" sz="1462" b="0" i="0" dirty="0">
+                <a:solidFill>
+                  <a:srgbClr val="112642"/>
+                </a:solidFill>
+                <a:latin typeface="Aptos"/>
+              </a:rPr>
+              <a:t> → </a:t>
+            </a:r>
+            <a:r>
+              <a:rPr lang="it-IT" sz="1462" b="0" i="0" dirty="0" err="1">
+                <a:solidFill>
+                  <a:srgbClr val="112642"/>
+                </a:solidFill>
+                <a:latin typeface="Aptos"/>
+              </a:rPr>
+              <a:t>pη</a:t>
+            </a:r>
+            <a:r>
+              <a:rPr lang="it-IT" sz="1462" b="0" i="0" dirty="0">
+                <a:solidFill>
+                  <a:srgbClr val="112642"/>
+                </a:solidFill>
+                <a:latin typeface="Aptos"/>
+              </a:rPr>
+              <a:t>π⁰, confrontando i risultati con </a:t>
+            </a:r>
+            <a:r>
+              <a:rPr lang="it-IT" sz="1462" b="0" i="0" dirty="0" err="1">
+                <a:solidFill>
+                  <a:srgbClr val="112642"/>
+                </a:solidFill>
+                <a:latin typeface="Aptos"/>
+              </a:rPr>
+              <a:t>Ajaka</a:t>
+            </a:r>
+            <a:r>
+              <a:rPr lang="it-IT" sz="1462" b="0" i="0" dirty="0">
+                <a:solidFill>
+                  <a:srgbClr val="112642"/>
+                </a:solidFill>
+                <a:latin typeface="Aptos"/>
+              </a:rPr>
+              <a:t> et al. (2008).</a:t>
             </a:r>
           </a:p>
         </p:txBody>
@@ -8786,7 +8900,7 @@
         <p:nvPicPr>
           <p:cNvPr id="9" name="graal_detector_source.jpg" descr="graal_detector_source.jpg"/>
           <p:cNvPicPr>
-            <a:picLocks noChangeAspect="1" noGrp="1"/>
+            <a:picLocks noGrp="1" noChangeAspect="1"/>
           </p:cNvPicPr>
           <p:nvPr/>
         </p:nvPicPr>
@@ -8824,7 +8938,7 @@
           </a:ln>
         </p:spPr>
         <p:txBody>
-          <a:bodyPr wrap="square" lIns="0" rIns="0" tIns="0" bIns="0" anchor="t"/>
+          <a:bodyPr wrap="square" lIns="0" tIns="0" rIns="0" bIns="0" anchor="t"/>
           <a:lstStyle/>
           <a:p>
             <a:pPr algn="l"/>
@@ -8836,39 +8950,6 @@
                 <a:latin typeface="Aptos"/>
               </a:rPr>
               <a:t>LAGRANγE: fascio (1), bersaglio (2), BGO (3), parete (8)</a:t>
-            </a:r>
-          </a:p>
-        </p:txBody>
-      </p:sp>
-      <p:sp>
-        <p:nvSpPr>
-          <p:cNvPr id="11" name="Text 11"/>
-          <p:cNvSpPr txBox="1"/>
-          <p:nvPr/>
-        </p:nvSpPr>
-        <p:spPr>
-          <a:xfrm>
-            <a:off x="658368" y="4215384"/>
-            <a:ext cx="7808976" cy="393192"/>
-          </a:xfrm>
-          <a:noFill/>
-          <a:ln>
-            <a:noFill/>
-          </a:ln>
-        </p:spPr>
-        <p:txBody>
-          <a:bodyPr wrap="square" lIns="0" rIns="0" tIns="0" bIns="0" anchor="t"/>
-          <a:lstStyle/>
-          <a:p>
-            <a:pPr algn="l"/>
-            <a:r>
-              <a:rPr lang="it-IT" sz="1376" b="0" i="0">
-                <a:solidFill>
-                  <a:srgbClr val="112642"/>
-                </a:solidFill>
-                <a:latin typeface="Aptos"/>
-              </a:rPr>
-              <a:t>Aggiungiamo una selezione BDT addestrata sul nuovo MC e calibriamo i flussi per run. Estendiamo inoltre l'analisi ai dati VIS vicini alla soglia.</a:t>
             </a:r>
           </a:p>
         </p:txBody>
@@ -8934,7 +9015,7 @@
           </a:ln>
         </p:spPr>
         <p:txBody>
-          <a:bodyPr wrap="square" lIns="0" rIns="0" tIns="0" bIns="0" anchor="ctr"/>
+          <a:bodyPr wrap="square" lIns="0" tIns="0" rIns="0" bIns="0" anchor="ctr"/>
           <a:lstStyle/>
           <a:p>
             <a:pPr algn="l"/>
@@ -9011,7 +9092,7 @@
           </a:ln>
         </p:spPr>
         <p:txBody>
-          <a:bodyPr wrap="square" lIns="0" rIns="0" tIns="0" bIns="0" anchor="ctr"/>
+          <a:bodyPr wrap="square" lIns="0" tIns="0" rIns="0" bIns="0" anchor="ctr"/>
           <a:lstStyle/>
           <a:p>
             <a:pPr algn="l"/>
@@ -9044,7 +9125,7 @@
           </a:ln>
         </p:spPr>
         <p:txBody>
-          <a:bodyPr wrap="square" lIns="0" rIns="0" tIns="0" bIns="0" anchor="ctr"/>
+          <a:bodyPr wrap="square" lIns="0" tIns="0" rIns="0" bIns="0" anchor="ctr"/>
           <a:lstStyle/>
           <a:p>
             <a:pPr algn="r"/>
@@ -9121,7 +9202,7 @@
                 </a:solidFill>
                 <a:latin typeface="Aptos"/>
               </a:rPr>
-              <a:t>Dal Fortran ai file ROOT</a:t>
+              <a:t>Il flusso completo dell'analisi</a:t>
             </a:r>
           </a:p>
         </p:txBody>
@@ -9154,7 +9235,7 @@
                 </a:solidFill>
                 <a:latin typeface="Aptos"/>
               </a:rPr>
-              <a:t>Fonte: wiki/01-pre-analysis.md; 01_pre_analysis/PreAnalysis.C</a:t>
+              <a:t>Fonte: wiki/workflow.md; wiki/data-and-artifacts.md</a:t>
             </a:r>
           </a:p>
         </p:txBody>
@@ -9167,8 +9248,8 @@
         </p:nvSpPr>
         <p:spPr>
           <a:xfrm>
-            <a:off x="658368" y="1115568"/>
-            <a:ext cx="960120" cy="576072"/>
+            <a:off x="612648" y="1207008"/>
+            <a:ext cx="694944" cy="274320"/>
           </a:xfrm>
           <a:noFill/>
           <a:ln>
@@ -9181,27 +9262,482 @@
           <a:p>
             <a:pPr algn="l"/>
             <a:r>
-              <a:rPr lang="it-IT" sz="3440" b="1" i="0">
+              <a:rPr lang="it-IT" sz="1200" b="1" i="0">
                 <a:solidFill>
                   <a:srgbClr val="0B5FA5"/>
                 </a:solidFill>
                 <a:latin typeface="Aptos"/>
               </a:rPr>
-              <a:t>01</a:t>
-            </a:r>
-          </a:p>
-        </p:txBody>
-      </p:sp>
-      <p:sp>
-        <p:nvSpPr>
-          <p:cNvPr id="5" name="Text 5"/>
-          <p:cNvSpPr txBox="1"/>
-          <p:nvPr/>
-        </p:nvSpPr>
-        <p:spPr>
-          <a:xfrm>
-            <a:off x="1664208" y="1133856"/>
-            <a:ext cx="6309360" cy="320040"/>
+              <a:t>DATI</a:t>
+            </a:r>
+          </a:p>
+        </p:txBody>
+      </p:sp>
+      <p:sp>
+        <p:nvSpPr>
+          <p:cNvPr id="5" name="Fill 5"/>
+          <p:cNvSpPr/>
+          <p:nvPr/>
+        </p:nvSpPr>
+        <p:spPr>
+          <a:xfrm>
+            <a:off x="1325880" y="1033272"/>
+            <a:ext cx="1207008" cy="576072"/>
+          </a:xfrm>
+          <a:prstGeom prst="roundRect">
+            <a:avLst/>
+          </a:prstGeom>
+          <a:solidFill>
+            <a:srgbClr val="DDEFFA"/>
+          </a:solidFill>
+          <a:ln>
+            <a:noFill/>
+          </a:ln>
+        </p:spPr>
+      </p:sp>
+      <p:sp>
+        <p:nvSpPr>
+          <p:cNvPr id="6" name="Text 6"/>
+          <p:cNvSpPr txBox="1"/>
+          <p:nvPr/>
+        </p:nvSpPr>
+        <p:spPr>
+          <a:xfrm>
+            <a:off x="1399032" y="1069848"/>
+            <a:ext cx="1060704" cy="502920"/>
+          </a:xfrm>
+          <a:noFill/>
+          <a:ln>
+            <a:noFill/>
+          </a:ln>
+        </p:spPr>
+        <p:txBody>
+          <a:bodyPr wrap="square" lIns="0" rIns="0" tIns="0" bIns="0" anchor="ctr"/>
+          <a:lstStyle/>
+          <a:p>
+            <a:pPr algn="ctr"/>
+            <a:r>
+              <a:rPr lang="it-IT" sz="1500" b="1" i="0">
+                <a:solidFill>
+                  <a:srgbClr val="071E42"/>
+                </a:solidFill>
+                <a:latin typeface="Aptos"/>
+              </a:rPr>
+              <a:t>ROOT h70</a:t>
+            </a:r>
+          </a:p>
+          <a:p>
+            <a:pPr algn="ctr"/>
+            <a:r>
+              <a:rPr lang="it-IT" sz="1500" b="1" i="0">
+                <a:solidFill>
+                  <a:srgbClr val="071E42"/>
+                </a:solidFill>
+                <a:latin typeface="Aptos"/>
+              </a:rPr>
+              <a:t>grezzi</a:t>
+            </a:r>
+          </a:p>
+        </p:txBody>
+      </p:sp>
+      <p:sp>
+        <p:nvSpPr>
+          <p:cNvPr id="7" name="Fill 7"/>
+          <p:cNvSpPr/>
+          <p:nvPr/>
+        </p:nvSpPr>
+        <p:spPr>
+          <a:xfrm>
+            <a:off x="2752344" y="1033272"/>
+            <a:ext cx="1261872" cy="576072"/>
+          </a:xfrm>
+          <a:prstGeom prst="roundRect">
+            <a:avLst/>
+          </a:prstGeom>
+          <a:solidFill>
+            <a:srgbClr val="DDEFFA"/>
+          </a:solidFill>
+          <a:ln>
+            <a:noFill/>
+          </a:ln>
+        </p:spPr>
+      </p:sp>
+      <p:sp>
+        <p:nvSpPr>
+          <p:cNvPr id="8" name="Text 8"/>
+          <p:cNvSpPr txBox="1"/>
+          <p:nvPr/>
+        </p:nvSpPr>
+        <p:spPr>
+          <a:xfrm>
+            <a:off x="2825496" y="1069848"/>
+            <a:ext cx="1115568" cy="502920"/>
+          </a:xfrm>
+          <a:noFill/>
+          <a:ln>
+            <a:noFill/>
+          </a:ln>
+        </p:spPr>
+        <p:txBody>
+          <a:bodyPr wrap="square" lIns="0" rIns="0" tIns="0" bIns="0" anchor="ctr"/>
+          <a:lstStyle/>
+          <a:p>
+            <a:pPr algn="ctr"/>
+            <a:r>
+              <a:rPr lang="it-IT" sz="1500" b="1" i="0">
+                <a:solidFill>
+                  <a:srgbClr val="071E42"/>
+                </a:solidFill>
+                <a:latin typeface="Aptos"/>
+              </a:rPr>
+              <a:t>Pre-analisi</a:t>
+            </a:r>
+          </a:p>
+          <a:p>
+            <a:pPr algn="ctr"/>
+            <a:r>
+              <a:rPr lang="it-IT" sz="1500" b="1" i="0">
+                <a:solidFill>
+                  <a:srgbClr val="071E42"/>
+                </a:solidFill>
+                <a:latin typeface="Aptos"/>
+              </a:rPr>
+              <a:t>h80</a:t>
+            </a:r>
+          </a:p>
+        </p:txBody>
+      </p:sp>
+      <p:sp>
+        <p:nvSpPr>
+          <p:cNvPr id="9" name="Fill 9"/>
+          <p:cNvSpPr/>
+          <p:nvPr/>
+        </p:nvSpPr>
+        <p:spPr>
+          <a:xfrm>
+            <a:off x="4242816" y="1033272"/>
+            <a:ext cx="1234440" cy="576072"/>
+          </a:xfrm>
+          <a:prstGeom prst="roundRect">
+            <a:avLst/>
+          </a:prstGeom>
+          <a:solidFill>
+            <a:srgbClr val="DDEFFA"/>
+          </a:solidFill>
+          <a:ln>
+            <a:noFill/>
+          </a:ln>
+        </p:spPr>
+      </p:sp>
+      <p:sp>
+        <p:nvSpPr>
+          <p:cNvPr id="10" name="Text 10"/>
+          <p:cNvSpPr txBox="1"/>
+          <p:nvPr/>
+        </p:nvSpPr>
+        <p:spPr>
+          <a:xfrm>
+            <a:off x="4315968" y="1069848"/>
+            <a:ext cx="1088136" cy="502920"/>
+          </a:xfrm>
+          <a:noFill/>
+          <a:ln>
+            <a:noFill/>
+          </a:ln>
+        </p:spPr>
+        <p:txBody>
+          <a:bodyPr wrap="square" lIns="0" rIns="0" tIns="0" bIns="0" anchor="ctr"/>
+          <a:lstStyle/>
+          <a:p>
+            <a:pPr algn="ctr"/>
+            <a:r>
+              <a:rPr lang="it-IT" sz="1500" b="1" i="0">
+                <a:solidFill>
+                  <a:srgbClr val="071E42"/>
+                </a:solidFill>
+                <a:latin typeface="Aptos"/>
+              </a:rPr>
+              <a:t>Selezione</a:t>
+            </a:r>
+          </a:p>
+          <a:p>
+            <a:pPr algn="ctr"/>
+            <a:r>
+              <a:rPr lang="it-IT" sz="1500" b="1" i="0">
+                <a:solidFill>
+                  <a:srgbClr val="071E42"/>
+                </a:solidFill>
+                <a:latin typeface="Aptos"/>
+              </a:rPr>
+              <a:t>h85</a:t>
+            </a:r>
+          </a:p>
+        </p:txBody>
+      </p:sp>
+      <p:sp>
+        <p:nvSpPr>
+          <p:cNvPr id="11" name="Fill 11"/>
+          <p:cNvSpPr/>
+          <p:nvPr/>
+        </p:nvSpPr>
+        <p:spPr>
+          <a:xfrm>
+            <a:off x="5705856" y="1033272"/>
+            <a:ext cx="1307592" cy="576072"/>
+          </a:xfrm>
+          <a:prstGeom prst="roundRect">
+            <a:avLst/>
+          </a:prstGeom>
+          <a:solidFill>
+            <a:srgbClr val="DDEFFA"/>
+          </a:solidFill>
+          <a:ln>
+            <a:noFill/>
+          </a:ln>
+        </p:spPr>
+      </p:sp>
+      <p:sp>
+        <p:nvSpPr>
+          <p:cNvPr id="12" name="Text 12"/>
+          <p:cNvSpPr txBox="1"/>
+          <p:nvPr/>
+        </p:nvSpPr>
+        <p:spPr>
+          <a:xfrm>
+            <a:off x="5779008" y="1069848"/>
+            <a:ext cx="1161288" cy="502920"/>
+          </a:xfrm>
+          <a:noFill/>
+          <a:ln>
+            <a:noFill/>
+          </a:ln>
+        </p:spPr>
+        <p:txBody>
+          <a:bodyPr wrap="square" lIns="0" rIns="0" tIns="0" bIns="0" anchor="ctr"/>
+          <a:lstStyle/>
+          <a:p>
+            <a:pPr algn="ctr"/>
+            <a:r>
+              <a:rPr lang="it-IT" sz="1300" b="1" i="0">
+                <a:solidFill>
+                  <a:srgbClr val="071E42"/>
+                </a:solidFill>
+                <a:latin typeface="Aptos"/>
+              </a:rPr>
+              <a:t>Ricostruzione</a:t>
+            </a:r>
+          </a:p>
+          <a:p>
+            <a:pPr algn="ctr"/>
+            <a:r>
+              <a:rPr lang="it-IT" sz="1300" b="1" i="0">
+                <a:solidFill>
+                  <a:srgbClr val="071E42"/>
+                </a:solidFill>
+                <a:latin typeface="Aptos"/>
+              </a:rPr>
+              <a:t>pηπ⁰</a:t>
+            </a:r>
+          </a:p>
+        </p:txBody>
+      </p:sp>
+      <p:sp>
+        <p:nvSpPr>
+          <p:cNvPr id="13" name="Fill 13"/>
+          <p:cNvSpPr/>
+          <p:nvPr/>
+        </p:nvSpPr>
+        <p:spPr>
+          <a:xfrm>
+            <a:off x="7260336" y="1033272"/>
+            <a:ext cx="1252728" cy="576072"/>
+          </a:xfrm>
+          <a:prstGeom prst="roundRect">
+            <a:avLst/>
+          </a:prstGeom>
+          <a:solidFill>
+            <a:srgbClr val="DDEFFA"/>
+          </a:solidFill>
+          <a:ln>
+            <a:noFill/>
+          </a:ln>
+        </p:spPr>
+      </p:sp>
+      <p:sp>
+        <p:nvSpPr>
+          <p:cNvPr id="14" name="Text 14"/>
+          <p:cNvSpPr txBox="1"/>
+          <p:nvPr/>
+        </p:nvSpPr>
+        <p:spPr>
+          <a:xfrm>
+            <a:off x="7333488" y="1069848"/>
+            <a:ext cx="1106424" cy="502920"/>
+          </a:xfrm>
+          <a:noFill/>
+          <a:ln>
+            <a:noFill/>
+          </a:ln>
+        </p:spPr>
+        <p:txBody>
+          <a:bodyPr wrap="square" lIns="0" rIns="0" tIns="0" bIns="0" anchor="ctr"/>
+          <a:lstStyle/>
+          <a:p>
+            <a:pPr algn="ctr"/>
+            <a:r>
+              <a:rPr lang="it-IT" sz="1500" b="1" i="0">
+                <a:solidFill>
+                  <a:srgbClr val="071E42"/>
+                </a:solidFill>
+                <a:latin typeface="Aptos"/>
+              </a:rPr>
+              <a:t>Σ e figure</a:t>
+            </a:r>
+          </a:p>
+        </p:txBody>
+      </p:sp>
+      <p:sp>
+        <p:nvSpPr>
+          <p:cNvPr id="15" name="Text 15"/>
+          <p:cNvSpPr txBox="1"/>
+          <p:nvPr/>
+        </p:nvSpPr>
+        <p:spPr>
+          <a:xfrm>
+            <a:off x="2523744" y="1033272"/>
+            <a:ext cx="274320" cy="576072"/>
+          </a:xfrm>
+          <a:noFill/>
+          <a:ln>
+            <a:noFill/>
+          </a:ln>
+        </p:spPr>
+        <p:txBody>
+          <a:bodyPr wrap="square" lIns="0" rIns="0" tIns="0" bIns="0" anchor="ctr"/>
+          <a:lstStyle/>
+          <a:p>
+            <a:pPr algn="ctr"/>
+            <a:r>
+              <a:rPr lang="it-IT" sz="1978" b="1" i="0">
+                <a:solidFill>
+                  <a:srgbClr val="0B5FA5"/>
+                </a:solidFill>
+                <a:latin typeface="Aptos"/>
+              </a:rPr>
+              <a:t>→</a:t>
+            </a:r>
+          </a:p>
+        </p:txBody>
+      </p:sp>
+      <p:sp>
+        <p:nvSpPr>
+          <p:cNvPr id="16" name="Text 16"/>
+          <p:cNvSpPr txBox="1"/>
+          <p:nvPr/>
+        </p:nvSpPr>
+        <p:spPr>
+          <a:xfrm>
+            <a:off x="4014216" y="1033272"/>
+            <a:ext cx="274320" cy="576072"/>
+          </a:xfrm>
+          <a:noFill/>
+          <a:ln>
+            <a:noFill/>
+          </a:ln>
+        </p:spPr>
+        <p:txBody>
+          <a:bodyPr wrap="square" lIns="0" rIns="0" tIns="0" bIns="0" anchor="ctr"/>
+          <a:lstStyle/>
+          <a:p>
+            <a:pPr algn="ctr"/>
+            <a:r>
+              <a:rPr lang="it-IT" sz="1978" b="1" i="0">
+                <a:solidFill>
+                  <a:srgbClr val="0B5FA5"/>
+                </a:solidFill>
+                <a:latin typeface="Aptos"/>
+              </a:rPr>
+              <a:t>→</a:t>
+            </a:r>
+          </a:p>
+        </p:txBody>
+      </p:sp>
+      <p:sp>
+        <p:nvSpPr>
+          <p:cNvPr id="17" name="Text 17"/>
+          <p:cNvSpPr txBox="1"/>
+          <p:nvPr/>
+        </p:nvSpPr>
+        <p:spPr>
+          <a:xfrm>
+            <a:off x="5477256" y="1033272"/>
+            <a:ext cx="274320" cy="576072"/>
+          </a:xfrm>
+          <a:noFill/>
+          <a:ln>
+            <a:noFill/>
+          </a:ln>
+        </p:spPr>
+        <p:txBody>
+          <a:bodyPr wrap="square" lIns="0" rIns="0" tIns="0" bIns="0" anchor="ctr"/>
+          <a:lstStyle/>
+          <a:p>
+            <a:pPr algn="ctr"/>
+            <a:r>
+              <a:rPr lang="it-IT" sz="1978" b="1" i="0">
+                <a:solidFill>
+                  <a:srgbClr val="0B5FA5"/>
+                </a:solidFill>
+                <a:latin typeface="Aptos"/>
+              </a:rPr>
+              <a:t>→</a:t>
+            </a:r>
+          </a:p>
+        </p:txBody>
+      </p:sp>
+      <p:sp>
+        <p:nvSpPr>
+          <p:cNvPr id="18" name="Text 18"/>
+          <p:cNvSpPr txBox="1"/>
+          <p:nvPr/>
+        </p:nvSpPr>
+        <p:spPr>
+          <a:xfrm>
+            <a:off x="7013448" y="1033272"/>
+            <a:ext cx="274320" cy="576072"/>
+          </a:xfrm>
+          <a:noFill/>
+          <a:ln>
+            <a:noFill/>
+          </a:ln>
+        </p:spPr>
+        <p:txBody>
+          <a:bodyPr wrap="square" lIns="0" rIns="0" tIns="0" bIns="0" anchor="ctr"/>
+          <a:lstStyle/>
+          <a:p>
+            <a:pPr algn="ctr"/>
+            <a:r>
+              <a:rPr lang="it-IT" sz="1978" b="1" i="0">
+                <a:solidFill>
+                  <a:srgbClr val="0B5FA5"/>
+                </a:solidFill>
+                <a:latin typeface="Aptos"/>
+              </a:rPr>
+              <a:t>→</a:t>
+            </a:r>
+          </a:p>
+        </p:txBody>
+      </p:sp>
+      <p:sp>
+        <p:nvSpPr>
+          <p:cNvPr id="19" name="Text 19"/>
+          <p:cNvSpPr txBox="1"/>
+          <p:nvPr/>
+        </p:nvSpPr>
+        <p:spPr>
+          <a:xfrm>
+            <a:off x="1335024" y="1673352"/>
+            <a:ext cx="7159752" cy="283464"/>
           </a:xfrm>
           <a:noFill/>
           <a:ln>
@@ -9214,287 +9750,786 @@
           <a:p>
             <a:pPr algn="l"/>
             <a:r>
-              <a:rPr lang="it-IT" sz="1892" b="1" i="0">
+              <a:rPr lang="it-IT" sz="1450" b="0" i="0">
+                <a:solidFill>
+                  <a:srgbClr val="52657B"/>
+                </a:solidFill>
+                <a:latin typeface="Aptos"/>
+              </a:rPr>
+              <a:t>Il percorso principale trasforma i dati del rivelatore in eventi ricostruiti e osservabili.</a:t>
+            </a:r>
+          </a:p>
+        </p:txBody>
+      </p:sp>
+      <p:sp>
+        <p:nvSpPr>
+          <p:cNvPr id="20" name="Text 20"/>
+          <p:cNvSpPr txBox="1"/>
+          <p:nvPr/>
+        </p:nvSpPr>
+        <p:spPr>
+          <a:xfrm>
+            <a:off x="612648" y="2340864"/>
+            <a:ext cx="694944" cy="310896"/>
+          </a:xfrm>
+          <a:noFill/>
+          <a:ln>
+            <a:noFill/>
+          </a:ln>
+        </p:spPr>
+        <p:txBody>
+          <a:bodyPr wrap="square" lIns="0" rIns="0" tIns="0" bIns="0" anchor="t"/>
+          <a:lstStyle/>
+          <a:p>
+            <a:pPr algn="l"/>
+            <a:r>
+              <a:rPr lang="it-IT" sz="1200" b="1" i="0">
+                <a:solidFill>
+                  <a:srgbClr val="0B5FA5"/>
+                </a:solidFill>
+                <a:latin typeface="Aptos"/>
+              </a:rPr>
+              <a:t>MC / BDT</a:t>
+            </a:r>
+          </a:p>
+        </p:txBody>
+      </p:sp>
+      <p:sp>
+        <p:nvSpPr>
+          <p:cNvPr id="21" name="Fill 21"/>
+          <p:cNvSpPr/>
+          <p:nvPr/>
+        </p:nvSpPr>
+        <p:spPr>
+          <a:xfrm>
+            <a:off x="1325880" y="2157984"/>
+            <a:ext cx="1581912" cy="576072"/>
+          </a:xfrm>
+          <a:prstGeom prst="roundRect">
+            <a:avLst/>
+          </a:prstGeom>
+          <a:solidFill>
+            <a:srgbClr val="EAF4FB"/>
+          </a:solidFill>
+          <a:ln>
+            <a:noFill/>
+          </a:ln>
+        </p:spPr>
+      </p:sp>
+      <p:sp>
+        <p:nvSpPr>
+          <p:cNvPr id="22" name="Text 22"/>
+          <p:cNvSpPr txBox="1"/>
+          <p:nvPr/>
+        </p:nvSpPr>
+        <p:spPr>
+          <a:xfrm>
+            <a:off x="1399032" y="2194560"/>
+            <a:ext cx="1435608" cy="502920"/>
+          </a:xfrm>
+          <a:noFill/>
+          <a:ln>
+            <a:noFill/>
+          </a:ln>
+        </p:spPr>
+        <p:txBody>
+          <a:bodyPr wrap="square" lIns="0" rIns="0" tIns="0" bIns="0" anchor="ctr"/>
+          <a:lstStyle/>
+          <a:p>
+            <a:pPr algn="ctr"/>
+            <a:r>
+              <a:rPr lang="it-IT" sz="1450" b="1" i="0">
+                <a:solidFill>
+                  <a:srgbClr val="071E42"/>
+                </a:solidFill>
+                <a:latin typeface="Aptos"/>
+              </a:rPr>
+              <a:t>9 canali MC</a:t>
+            </a:r>
+          </a:p>
+          <a:p>
+            <a:pPr algn="ctr"/>
+            <a:r>
+              <a:rPr lang="it-IT" sz="1450" b="1" i="0">
+                <a:solidFill>
+                  <a:srgbClr val="071E42"/>
+                </a:solidFill>
+                <a:latin typeface="Aptos"/>
+              </a:rPr>
+              <a:t>e spettro h85</a:t>
+            </a:r>
+          </a:p>
+        </p:txBody>
+      </p:sp>
+      <p:sp>
+        <p:nvSpPr>
+          <p:cNvPr id="23" name="Fill 23"/>
+          <p:cNvSpPr/>
+          <p:nvPr/>
+        </p:nvSpPr>
+        <p:spPr>
+          <a:xfrm>
+            <a:off x="3236976" y="2157984"/>
+            <a:ext cx="1554480" cy="576072"/>
+          </a:xfrm>
+          <a:prstGeom prst="roundRect">
+            <a:avLst/>
+          </a:prstGeom>
+          <a:solidFill>
+            <a:srgbClr val="EAF4FB"/>
+          </a:solidFill>
+          <a:ln>
+            <a:noFill/>
+          </a:ln>
+        </p:spPr>
+      </p:sp>
+      <p:sp>
+        <p:nvSpPr>
+          <p:cNvPr id="24" name="Text 24"/>
+          <p:cNvSpPr txBox="1"/>
+          <p:nvPr/>
+        </p:nvSpPr>
+        <p:spPr>
+          <a:xfrm>
+            <a:off x="3310128" y="2194560"/>
+            <a:ext cx="1408176" cy="502920"/>
+          </a:xfrm>
+          <a:noFill/>
+          <a:ln>
+            <a:noFill/>
+          </a:ln>
+        </p:spPr>
+        <p:txBody>
+          <a:bodyPr wrap="square" lIns="0" rIns="0" tIns="0" bIns="0" anchor="ctr"/>
+          <a:lstStyle/>
+          <a:p>
+            <a:pPr algn="ctr"/>
+            <a:r>
+              <a:rPr lang="it-IT" sz="1450" b="1" i="0">
+                <a:solidFill>
+                  <a:srgbClr val="071E42"/>
+                </a:solidFill>
+                <a:latin typeface="Aptos"/>
+              </a:rPr>
+              <a:t>26 variabili</a:t>
+            </a:r>
+          </a:p>
+          <a:p>
+            <a:pPr algn="ctr"/>
+            <a:r>
+              <a:rPr lang="it-IT" sz="1450" b="1" i="0">
+                <a:solidFill>
+                  <a:srgbClr val="071E42"/>
+                </a:solidFill>
+                <a:latin typeface="Aptos"/>
+              </a:rPr>
+              <a:t>per evento</a:t>
+            </a:r>
+          </a:p>
+        </p:txBody>
+      </p:sp>
+      <p:sp>
+        <p:nvSpPr>
+          <p:cNvPr id="25" name="Fill 25"/>
+          <p:cNvSpPr/>
+          <p:nvPr/>
+        </p:nvSpPr>
+        <p:spPr>
+          <a:xfrm>
+            <a:off x="5120640" y="2157984"/>
+            <a:ext cx="1554480" cy="576072"/>
+          </a:xfrm>
+          <a:prstGeom prst="roundRect">
+            <a:avLst/>
+          </a:prstGeom>
+          <a:solidFill>
+            <a:srgbClr val="EAF4FB"/>
+          </a:solidFill>
+          <a:ln>
+            <a:noFill/>
+          </a:ln>
+        </p:spPr>
+      </p:sp>
+      <p:sp>
+        <p:nvSpPr>
+          <p:cNvPr id="26" name="Text 26"/>
+          <p:cNvSpPr txBox="1"/>
+          <p:nvPr/>
+        </p:nvSpPr>
+        <p:spPr>
+          <a:xfrm>
+            <a:off x="5193792" y="2194560"/>
+            <a:ext cx="1408176" cy="502920"/>
+          </a:xfrm>
+          <a:noFill/>
+          <a:ln>
+            <a:noFill/>
+          </a:ln>
+        </p:spPr>
+        <p:txBody>
+          <a:bodyPr wrap="square" lIns="0" rIns="0" tIns="0" bIns="0" anchor="ctr"/>
+          <a:lstStyle/>
+          <a:p>
+            <a:pPr algn="ctr"/>
+            <a:r>
+              <a:rPr lang="it-IT" sz="1450" b="1" i="0">
+                <a:solidFill>
+                  <a:srgbClr val="071E42"/>
+                </a:solidFill>
+                <a:latin typeface="Aptos"/>
+              </a:rPr>
+              <a:t>Training</a:t>
+            </a:r>
+          </a:p>
+          <a:p>
+            <a:pPr algn="ctr"/>
+            <a:r>
+              <a:rPr lang="it-IT" sz="1450" b="1" i="0">
+                <a:solidFill>
+                  <a:srgbClr val="071E42"/>
+                </a:solidFill>
+                <a:latin typeface="Aptos"/>
+              </a:rPr>
+              <a:t>UV e VIS</a:t>
+            </a:r>
+          </a:p>
+        </p:txBody>
+      </p:sp>
+      <p:sp>
+        <p:nvSpPr>
+          <p:cNvPr id="27" name="Fill 27"/>
+          <p:cNvSpPr/>
+          <p:nvPr/>
+        </p:nvSpPr>
+        <p:spPr>
+          <a:xfrm>
+            <a:off x="7004304" y="2157984"/>
+            <a:ext cx="1508760" cy="576072"/>
+          </a:xfrm>
+          <a:prstGeom prst="roundRect">
+            <a:avLst/>
+          </a:prstGeom>
+          <a:solidFill>
+            <a:srgbClr val="EAF4FB"/>
+          </a:solidFill>
+          <a:ln>
+            <a:noFill/>
+          </a:ln>
+        </p:spPr>
+      </p:sp>
+      <p:sp>
+        <p:nvSpPr>
+          <p:cNvPr id="28" name="Text 28"/>
+          <p:cNvSpPr txBox="1"/>
+          <p:nvPr/>
+        </p:nvSpPr>
+        <p:spPr>
+          <a:xfrm>
+            <a:off x="7077456" y="2194560"/>
+            <a:ext cx="1362456" cy="502920"/>
+          </a:xfrm>
+          <a:noFill/>
+          <a:ln>
+            <a:noFill/>
+          </a:ln>
+        </p:spPr>
+        <p:txBody>
+          <a:bodyPr wrap="square" lIns="0" rIns="0" tIns="0" bIns="0" anchor="ctr"/>
+          <a:lstStyle/>
+          <a:p>
+            <a:pPr algn="ctr"/>
+            <a:r>
+              <a:rPr lang="it-IT" sz="1450" b="1" i="0">
+                <a:solidFill>
+                  <a:srgbClr val="071E42"/>
+                </a:solidFill>
+                <a:latin typeface="Aptos"/>
+              </a:rPr>
+              <a:t>Gate BDT</a:t>
+            </a:r>
+          </a:p>
+          <a:p>
+            <a:pPr algn="ctr"/>
+            <a:r>
+              <a:rPr lang="it-IT" sz="1450" b="1" i="0">
+                <a:solidFill>
+                  <a:srgbClr val="071E42"/>
+                </a:solidFill>
+                <a:latin typeface="Aptos"/>
+              </a:rPr>
+              <a:t>sui dati</a:t>
+            </a:r>
+          </a:p>
+        </p:txBody>
+      </p:sp>
+      <p:sp>
+        <p:nvSpPr>
+          <p:cNvPr id="29" name="Text 29"/>
+          <p:cNvSpPr txBox="1"/>
+          <p:nvPr/>
+        </p:nvSpPr>
+        <p:spPr>
+          <a:xfrm>
+            <a:off x="2916936" y="2157984"/>
+            <a:ext cx="274320" cy="576072"/>
+          </a:xfrm>
+          <a:noFill/>
+          <a:ln>
+            <a:noFill/>
+          </a:ln>
+        </p:spPr>
+        <p:txBody>
+          <a:bodyPr wrap="square" lIns="0" rIns="0" tIns="0" bIns="0" anchor="ctr"/>
+          <a:lstStyle/>
+          <a:p>
+            <a:pPr algn="ctr"/>
+            <a:r>
+              <a:rPr lang="it-IT" sz="1978" b="1" i="0">
+                <a:solidFill>
+                  <a:srgbClr val="0B5FA5"/>
+                </a:solidFill>
+                <a:latin typeface="Aptos"/>
+              </a:rPr>
+              <a:t>→</a:t>
+            </a:r>
+          </a:p>
+        </p:txBody>
+      </p:sp>
+      <p:sp>
+        <p:nvSpPr>
+          <p:cNvPr id="30" name="Text 30"/>
+          <p:cNvSpPr txBox="1"/>
+          <p:nvPr/>
+        </p:nvSpPr>
+        <p:spPr>
+          <a:xfrm>
+            <a:off x="4800600" y="2157984"/>
+            <a:ext cx="274320" cy="576072"/>
+          </a:xfrm>
+          <a:noFill/>
+          <a:ln>
+            <a:noFill/>
+          </a:ln>
+        </p:spPr>
+        <p:txBody>
+          <a:bodyPr wrap="square" lIns="0" rIns="0" tIns="0" bIns="0" anchor="ctr"/>
+          <a:lstStyle/>
+          <a:p>
+            <a:pPr algn="ctr"/>
+            <a:r>
+              <a:rPr lang="it-IT" sz="1978" b="1" i="0">
+                <a:solidFill>
+                  <a:srgbClr val="0B5FA5"/>
+                </a:solidFill>
+                <a:latin typeface="Aptos"/>
+              </a:rPr>
+              <a:t>→</a:t>
+            </a:r>
+          </a:p>
+        </p:txBody>
+      </p:sp>
+      <p:sp>
+        <p:nvSpPr>
+          <p:cNvPr id="31" name="Text 31"/>
+          <p:cNvSpPr txBox="1"/>
+          <p:nvPr/>
+        </p:nvSpPr>
+        <p:spPr>
+          <a:xfrm>
+            <a:off x="6684264" y="2157984"/>
+            <a:ext cx="274320" cy="576072"/>
+          </a:xfrm>
+          <a:noFill/>
+          <a:ln>
+            <a:noFill/>
+          </a:ln>
+        </p:spPr>
+        <p:txBody>
+          <a:bodyPr wrap="square" lIns="0" rIns="0" tIns="0" bIns="0" anchor="ctr"/>
+          <a:lstStyle/>
+          <a:p>
+            <a:pPr algn="ctr"/>
+            <a:r>
+              <a:rPr lang="it-IT" sz="1978" b="1" i="0">
+                <a:solidFill>
+                  <a:srgbClr val="0B5FA5"/>
+                </a:solidFill>
+                <a:latin typeface="Aptos"/>
+              </a:rPr>
+              <a:t>→</a:t>
+            </a:r>
+          </a:p>
+        </p:txBody>
+      </p:sp>
+      <p:sp>
+        <p:nvSpPr>
+          <p:cNvPr id="32" name="Text 32"/>
+          <p:cNvSpPr txBox="1"/>
+          <p:nvPr/>
+        </p:nvSpPr>
+        <p:spPr>
+          <a:xfrm>
+            <a:off x="1335024" y="2798064"/>
+            <a:ext cx="7159752" cy="283464"/>
+          </a:xfrm>
+          <a:noFill/>
+          <a:ln>
+            <a:noFill/>
+          </a:ln>
+        </p:spPr>
+        <p:txBody>
+          <a:bodyPr wrap="square" lIns="0" rIns="0" tIns="0" bIns="0" anchor="t"/>
+          <a:lstStyle/>
+          <a:p>
+            <a:pPr algn="l"/>
+            <a:r>
+              <a:rPr lang="it-IT" sz="1450" b="0" i="0">
+                <a:solidFill>
+                  <a:srgbClr val="52657B"/>
+                </a:solidFill>
+                <a:latin typeface="Aptos"/>
+              </a:rPr>
+              <a:t>Il classificatore apprende dal MC e dallo spettro misurato; il gate precede la ricostruzione.</a:t>
+            </a:r>
+          </a:p>
+        </p:txBody>
+      </p:sp>
+      <p:sp>
+        <p:nvSpPr>
+          <p:cNvPr id="33" name="Text 33"/>
+          <p:cNvSpPr txBox="1"/>
+          <p:nvPr/>
+        </p:nvSpPr>
+        <p:spPr>
+          <a:xfrm>
+            <a:off x="612648" y="3465576"/>
+            <a:ext cx="694944" cy="310896"/>
+          </a:xfrm>
+          <a:noFill/>
+          <a:ln>
+            <a:noFill/>
+          </a:ln>
+        </p:spPr>
+        <p:txBody>
+          <a:bodyPr wrap="square" lIns="0" rIns="0" tIns="0" bIns="0" anchor="t"/>
+          <a:lstStyle/>
+          <a:p>
+            <a:pPr algn="l"/>
+            <a:r>
+              <a:rPr lang="it-IT" sz="1200" b="1" i="0">
+                <a:solidFill>
+                  <a:srgbClr val="0B5FA5"/>
+                </a:solidFill>
+                <a:latin typeface="Aptos"/>
+              </a:rPr>
+              <a:t>FLUSSI</a:t>
+            </a:r>
+          </a:p>
+        </p:txBody>
+      </p:sp>
+      <p:sp>
+        <p:nvSpPr>
+          <p:cNvPr id="34" name="Fill 34"/>
+          <p:cNvSpPr/>
+          <p:nvPr/>
+        </p:nvSpPr>
+        <p:spPr>
+          <a:xfrm>
+            <a:off x="1325880" y="3282696"/>
+            <a:ext cx="1901952" cy="576072"/>
+          </a:xfrm>
+          <a:prstGeom prst="roundRect">
+            <a:avLst/>
+          </a:prstGeom>
+          <a:solidFill>
+            <a:srgbClr val="EEF6FC"/>
+          </a:solidFill>
+          <a:ln>
+            <a:noFill/>
+          </a:ln>
+        </p:spPr>
+      </p:sp>
+      <p:sp>
+        <p:nvSpPr>
+          <p:cNvPr id="35" name="Text 35"/>
+          <p:cNvSpPr txBox="1"/>
+          <p:nvPr/>
+        </p:nvSpPr>
+        <p:spPr>
+          <a:xfrm>
+            <a:off x="1399032" y="3319272"/>
+            <a:ext cx="1755648" cy="502920"/>
+          </a:xfrm>
+          <a:noFill/>
+          <a:ln>
+            <a:noFill/>
+          </a:ln>
+        </p:spPr>
+        <p:txBody>
+          <a:bodyPr wrap="square" lIns="0" rIns="0" tIns="0" bIns="0" anchor="ctr"/>
+          <a:lstStyle/>
+          <a:p>
+            <a:pPr algn="ctr"/>
+            <a:r>
+              <a:rPr lang="it-IT" sz="1450" b="1" i="0">
+                <a:solidFill>
+                  <a:srgbClr val="071E42"/>
+                </a:solidFill>
+                <a:latin typeface="Aptos"/>
+              </a:rPr>
+              <a:t>h80, manifest</a:t>
+            </a:r>
+          </a:p>
+          <a:p>
+            <a:pPr algn="ctr"/>
+            <a:r>
+              <a:rPr lang="it-IT" sz="1450" b="1" i="0">
+                <a:solidFill>
+                  <a:srgbClr val="071E42"/>
+                </a:solidFill>
+                <a:latin typeface="Aptos"/>
+              </a:rPr>
+              <a:t>e flussi esterni</a:t>
+            </a:r>
+          </a:p>
+        </p:txBody>
+      </p:sp>
+      <p:sp>
+        <p:nvSpPr>
+          <p:cNvPr id="36" name="Fill 36"/>
+          <p:cNvSpPr/>
+          <p:nvPr/>
+        </p:nvSpPr>
+        <p:spPr>
+          <a:xfrm>
+            <a:off x="3602736" y="3282696"/>
+            <a:ext cx="2011680" cy="576072"/>
+          </a:xfrm>
+          <a:prstGeom prst="roundRect">
+            <a:avLst/>
+          </a:prstGeom>
+          <a:solidFill>
+            <a:srgbClr val="EEF6FC"/>
+          </a:solidFill>
+          <a:ln>
+            <a:noFill/>
+          </a:ln>
+        </p:spPr>
+      </p:sp>
+      <p:sp>
+        <p:nvSpPr>
+          <p:cNvPr id="37" name="Text 37"/>
+          <p:cNvSpPr txBox="1"/>
+          <p:nvPr/>
+        </p:nvSpPr>
+        <p:spPr>
+          <a:xfrm>
+            <a:off x="3675888" y="3319272"/>
+            <a:ext cx="1865376" cy="502920"/>
+          </a:xfrm>
+          <a:noFill/>
+          <a:ln>
+            <a:noFill/>
+          </a:ln>
+        </p:spPr>
+        <p:txBody>
+          <a:bodyPr wrap="square" lIns="0" rIns="0" tIns="0" bIns="0" anchor="ctr"/>
+          <a:lstStyle/>
+          <a:p>
+            <a:pPr algn="ctr"/>
+            <a:r>
+              <a:rPr lang="it-IT" sz="1450" b="1" i="0">
+                <a:solidFill>
+                  <a:srgbClr val="071E42"/>
+                </a:solidFill>
+                <a:latin typeface="Aptos"/>
+              </a:rPr>
+              <a:t>Energia per strip</a:t>
+            </a:r>
+          </a:p>
+          <a:p>
+            <a:pPr algn="ctr"/>
+            <a:r>
+              <a:rPr lang="it-IT" sz="1450" b="1" i="0">
+                <a:solidFill>
+                  <a:srgbClr val="071E42"/>
+                </a:solidFill>
+                <a:latin typeface="Aptos"/>
+              </a:rPr>
+              <a:t>e polarizzazione</a:t>
+            </a:r>
+          </a:p>
+        </p:txBody>
+      </p:sp>
+      <p:sp>
+        <p:nvSpPr>
+          <p:cNvPr id="38" name="Fill 38"/>
+          <p:cNvSpPr/>
+          <p:nvPr/>
+        </p:nvSpPr>
+        <p:spPr>
+          <a:xfrm>
+            <a:off x="5998464" y="3282696"/>
+            <a:ext cx="2514600" cy="576072"/>
+          </a:xfrm>
+          <a:prstGeom prst="roundRect">
+            <a:avLst/>
+          </a:prstGeom>
+          <a:solidFill>
+            <a:srgbClr val="EEF6FC"/>
+          </a:solidFill>
+          <a:ln>
+            <a:noFill/>
+          </a:ln>
+        </p:spPr>
+      </p:sp>
+      <p:sp>
+        <p:nvSpPr>
+          <p:cNvPr id="39" name="Text 39"/>
+          <p:cNvSpPr txBox="1"/>
+          <p:nvPr/>
+        </p:nvSpPr>
+        <p:spPr>
+          <a:xfrm>
+            <a:off x="6071616" y="3319272"/>
+            <a:ext cx="2368296" cy="502920"/>
+          </a:xfrm>
+          <a:noFill/>
+          <a:ln>
+            <a:noFill/>
+          </a:ln>
+        </p:spPr>
+        <p:txBody>
+          <a:bodyPr wrap="square" lIns="0" rIns="0" tIns="0" bIns="0" anchor="ctr"/>
+          <a:lstStyle/>
+          <a:p>
+            <a:pPr algn="ctr"/>
+            <a:r>
+              <a:rPr lang="it-IT" sz="1450" b="1" i="0">
+                <a:solidFill>
+                  <a:srgbClr val="071E42"/>
+                </a:solidFill>
+                <a:latin typeface="Aptos"/>
+              </a:rPr>
+              <a:t>Flussi calibrati</a:t>
+            </a:r>
+          </a:p>
+          <a:p>
+            <a:pPr algn="ctr"/>
+            <a:r>
+              <a:rPr lang="it-IT" sz="1450" b="1" i="0">
+                <a:solidFill>
+                  <a:srgbClr val="071E42"/>
+                </a:solidFill>
+                <a:latin typeface="Aptos"/>
+              </a:rPr>
+              <a:t>POL1 / POL2 / BREM</a:t>
+            </a:r>
+          </a:p>
+        </p:txBody>
+      </p:sp>
+      <p:sp>
+        <p:nvSpPr>
+          <p:cNvPr id="40" name="Text 40"/>
+          <p:cNvSpPr txBox="1"/>
+          <p:nvPr/>
+        </p:nvSpPr>
+        <p:spPr>
+          <a:xfrm>
+            <a:off x="3255264" y="3282696"/>
+            <a:ext cx="274320" cy="576072"/>
+          </a:xfrm>
+          <a:noFill/>
+          <a:ln>
+            <a:noFill/>
+          </a:ln>
+        </p:spPr>
+        <p:txBody>
+          <a:bodyPr wrap="square" lIns="0" rIns="0" tIns="0" bIns="0" anchor="ctr"/>
+          <a:lstStyle/>
+          <a:p>
+            <a:pPr algn="ctr"/>
+            <a:r>
+              <a:rPr lang="it-IT" sz="1978" b="1" i="0">
+                <a:solidFill>
+                  <a:srgbClr val="0B5FA5"/>
+                </a:solidFill>
+                <a:latin typeface="Aptos"/>
+              </a:rPr>
+              <a:t>→</a:t>
+            </a:r>
+          </a:p>
+        </p:txBody>
+      </p:sp>
+      <p:sp>
+        <p:nvSpPr>
+          <p:cNvPr id="41" name="Text 41"/>
+          <p:cNvSpPr txBox="1"/>
+          <p:nvPr/>
+        </p:nvSpPr>
+        <p:spPr>
+          <a:xfrm>
+            <a:off x="5650992" y="3282696"/>
+            <a:ext cx="274320" cy="576072"/>
+          </a:xfrm>
+          <a:noFill/>
+          <a:ln>
+            <a:noFill/>
+          </a:ln>
+        </p:spPr>
+        <p:txBody>
+          <a:bodyPr wrap="square" lIns="0" rIns="0" tIns="0" bIns="0" anchor="ctr"/>
+          <a:lstStyle/>
+          <a:p>
+            <a:pPr algn="ctr"/>
+            <a:r>
+              <a:rPr lang="it-IT" sz="1978" b="1" i="0">
+                <a:solidFill>
+                  <a:srgbClr val="0B5FA5"/>
+                </a:solidFill>
+                <a:latin typeface="Aptos"/>
+              </a:rPr>
+              <a:t>→</a:t>
+            </a:r>
+          </a:p>
+        </p:txBody>
+      </p:sp>
+      <p:sp>
+        <p:nvSpPr>
+          <p:cNvPr id="42" name="Text 42"/>
+          <p:cNvSpPr txBox="1"/>
+          <p:nvPr/>
+        </p:nvSpPr>
+        <p:spPr>
+          <a:xfrm>
+            <a:off x="667512" y="4123944"/>
+            <a:ext cx="7891272" cy="384048"/>
+          </a:xfrm>
+          <a:noFill/>
+          <a:ln>
+            <a:noFill/>
+          </a:ln>
+        </p:spPr>
+        <p:txBody>
+          <a:bodyPr wrap="square" lIns="0" rIns="0" tIns="0" bIns="0" anchor="t"/>
+          <a:lstStyle/>
+          <a:p>
+            <a:pPr algn="l"/>
+            <a:r>
+              <a:rPr lang="it-IT" sz="1333" b="0" i="0">
                 <a:solidFill>
                   <a:srgbClr val="112642"/>
                 </a:solidFill>
                 <a:latin typeface="Aptos"/>
               </a:rPr>
-              <a:t>Eredità Fortran</a:t>
-            </a:r>
-          </a:p>
-        </p:txBody>
-      </p:sp>
-      <p:sp>
-        <p:nvSpPr>
-          <p:cNvPr id="6" name="Text 6"/>
-          <p:cNvSpPr txBox="1"/>
-          <p:nvPr/>
-        </p:nvSpPr>
-        <p:spPr>
-          <a:xfrm>
-            <a:off x="1664208" y="1508760"/>
-            <a:ext cx="6766560" cy="630936"/>
-          </a:xfrm>
-          <a:noFill/>
-          <a:ln>
-            <a:noFill/>
-          </a:ln>
-        </p:spPr>
-        <p:txBody>
-          <a:bodyPr wrap="square" lIns="0" rIns="0" tIns="0" bIns="0" anchor="t"/>
-          <a:lstStyle/>
-          <a:p>
-            <a:pPr algn="l"/>
-            <a:r>
-              <a:rPr lang="it-IT" sz="1462" b="0" i="0">
-                <a:solidFill>
-                  <a:srgbClr val="112642"/>
-                </a:solidFill>
-                <a:latin typeface="Aptos"/>
-              </a:rPr>
-              <a:t>Il formato h70 conserva gli array e i metadati originali. Nel passaggio</a:t>
-            </a:r>
-          </a:p>
-          <a:p>
-            <a:pPr algn="l"/>
-            <a:r>
-              <a:rPr lang="it-IT" sz="1462" b="0" i="0">
-                <a:solidFill>
-                  <a:srgbClr val="112642"/>
-                </a:solidFill>
-                <a:latin typeface="Aptos"/>
-              </a:rPr>
-              <a:t>a C++, l'indice forward passa dalla base 1 alla base 0.</a:t>
-            </a:r>
-          </a:p>
-        </p:txBody>
-      </p:sp>
-      <p:sp>
-        <p:nvSpPr>
-          <p:cNvPr id="7" name="Text 7"/>
-          <p:cNvSpPr txBox="1"/>
-          <p:nvPr/>
-        </p:nvSpPr>
-        <p:spPr>
-          <a:xfrm>
-            <a:off x="658368" y="2295144"/>
-            <a:ext cx="960120" cy="576072"/>
-          </a:xfrm>
-          <a:noFill/>
-          <a:ln>
-            <a:noFill/>
-          </a:ln>
-        </p:spPr>
-        <p:txBody>
-          <a:bodyPr wrap="square" lIns="0" rIns="0" tIns="0" bIns="0" anchor="t"/>
-          <a:lstStyle/>
-          <a:p>
-            <a:pPr algn="l"/>
-            <a:r>
-              <a:rPr lang="it-IT" sz="3440" b="1" i="0">
-                <a:solidFill>
-                  <a:srgbClr val="0B5FA5"/>
-                </a:solidFill>
-                <a:latin typeface="Aptos"/>
-              </a:rPr>
-              <a:t>02</a:t>
-            </a:r>
-          </a:p>
-        </p:txBody>
-      </p:sp>
-      <p:sp>
-        <p:nvSpPr>
-          <p:cNvPr id="8" name="Text 8"/>
-          <p:cNvSpPr txBox="1"/>
-          <p:nvPr/>
-        </p:nvSpPr>
-        <p:spPr>
-          <a:xfrm>
-            <a:off x="1664208" y="2313432"/>
-            <a:ext cx="6309360" cy="320040"/>
-          </a:xfrm>
-          <a:noFill/>
-          <a:ln>
-            <a:noFill/>
-          </a:ln>
-        </p:spPr>
-        <p:txBody>
-          <a:bodyPr wrap="square" lIns="0" rIns="0" tIns="0" bIns="0" anchor="t"/>
-          <a:lstStyle/>
-          <a:p>
-            <a:pPr algn="l"/>
-            <a:r>
-              <a:rPr lang="it-IT" sz="1892" b="1" i="0">
-                <a:solidFill>
-                  <a:srgbClr val="112642"/>
-                </a:solidFill>
-                <a:latin typeface="Aptos"/>
-              </a:rPr>
-              <a:t>Pre-analisi C++/ROOT</a:t>
-            </a:r>
-          </a:p>
-        </p:txBody>
-      </p:sp>
-      <p:sp>
-        <p:nvSpPr>
-          <p:cNvPr id="9" name="Text 9"/>
-          <p:cNvSpPr txBox="1"/>
-          <p:nvPr/>
-        </p:nvSpPr>
-        <p:spPr>
-          <a:xfrm>
-            <a:off x="1664208" y="2679192"/>
-            <a:ext cx="6766560" cy="630936"/>
-          </a:xfrm>
-          <a:noFill/>
-          <a:ln>
-            <a:noFill/>
-          </a:ln>
-        </p:spPr>
-        <p:txBody>
-          <a:bodyPr wrap="square" lIns="0" rIns="0" tIns="0" bIns="0" anchor="t"/>
-          <a:lstStyle/>
-          <a:p>
-            <a:pPr algn="l"/>
-            <a:r>
-              <a:rPr lang="it-IT" sz="1462" b="0" i="0">
-                <a:solidFill>
-                  <a:srgbClr val="112642"/>
-                </a:solidFill>
-                <a:latin typeface="Aptos"/>
-              </a:rPr>
-              <a:t>PreAnalysis.C applica i criteri PID del singolo run e ricostruisce</a:t>
-            </a:r>
-          </a:p>
-          <a:p>
-            <a:pPr algn="l"/>
-            <a:r>
-              <a:rPr lang="it-IT" sz="1462" b="0" i="0">
-                <a:solidFill>
-                  <a:srgbClr val="112642"/>
-                </a:solidFill>
-                <a:latin typeface="Aptos"/>
-              </a:rPr>
-              <a:t>fascio, fotoni, tracce cariche e polarizzazione.</a:t>
-            </a:r>
-          </a:p>
-        </p:txBody>
-      </p:sp>
-      <p:sp>
-        <p:nvSpPr>
-          <p:cNvPr id="10" name="Text 10"/>
-          <p:cNvSpPr txBox="1"/>
-          <p:nvPr/>
-        </p:nvSpPr>
-        <p:spPr>
-          <a:xfrm>
-            <a:off x="658368" y="3474720"/>
-            <a:ext cx="960120" cy="576072"/>
-          </a:xfrm>
-          <a:noFill/>
-          <a:ln>
-            <a:noFill/>
-          </a:ln>
-        </p:spPr>
-        <p:txBody>
-          <a:bodyPr wrap="square" lIns="0" rIns="0" tIns="0" bIns="0" anchor="t"/>
-          <a:lstStyle/>
-          <a:p>
-            <a:pPr algn="l"/>
-            <a:r>
-              <a:rPr lang="it-IT" sz="3440" b="1" i="0">
-                <a:solidFill>
-                  <a:srgbClr val="0B5FA5"/>
-                </a:solidFill>
-                <a:latin typeface="Aptos"/>
-              </a:rPr>
-              <a:t>03</a:t>
-            </a:r>
-          </a:p>
-        </p:txBody>
-      </p:sp>
-      <p:sp>
-        <p:nvSpPr>
-          <p:cNvPr id="11" name="Text 11"/>
-          <p:cNvSpPr txBox="1"/>
-          <p:nvPr/>
-        </p:nvSpPr>
-        <p:spPr>
-          <a:xfrm>
-            <a:off x="1664208" y="3493008"/>
-            <a:ext cx="6309360" cy="320040"/>
-          </a:xfrm>
-          <a:noFill/>
-          <a:ln>
-            <a:noFill/>
-          </a:ln>
-        </p:spPr>
-        <p:txBody>
-          <a:bodyPr wrap="square" lIns="0" rIns="0" tIns="0" bIns="0" anchor="t"/>
-          <a:lstStyle/>
-          <a:p>
-            <a:pPr algn="l"/>
-            <a:r>
-              <a:rPr lang="it-IT" sz="1892" b="1" i="0">
-                <a:solidFill>
-                  <a:srgbClr val="112642"/>
-                </a:solidFill>
-                <a:latin typeface="Aptos"/>
-              </a:rPr>
-              <a:t>Output normalizzato</a:t>
-            </a:r>
-          </a:p>
-        </p:txBody>
-      </p:sp>
-      <p:sp>
-        <p:nvSpPr>
-          <p:cNvPr id="12" name="Text 12"/>
-          <p:cNvSpPr txBox="1"/>
-          <p:nvPr/>
-        </p:nvSpPr>
-        <p:spPr>
-          <a:xfrm>
-            <a:off x="1664208" y="3858768"/>
-            <a:ext cx="6766560" cy="630936"/>
-          </a:xfrm>
-          <a:noFill/>
-          <a:ln>
-            <a:noFill/>
-          </a:ln>
-        </p:spPr>
-        <p:txBody>
-          <a:bodyPr wrap="square" lIns="0" rIns="0" tIns="0" bIns="0" anchor="t"/>
-          <a:lstStyle/>
-          <a:p>
-            <a:pPr algn="l"/>
-            <a:r>
-              <a:rPr lang="it-IT" sz="1462" b="0" i="0">
-                <a:solidFill>
-                  <a:srgbClr val="112642"/>
-                </a:solidFill>
-                <a:latin typeface="Aptos"/>
-              </a:rPr>
-              <a:t>Otteniamo un file ROOT h80 per periodo. La preselezione produce h85,</a:t>
-            </a:r>
-          </a:p>
-          <a:p>
-            <a:pPr algn="l"/>
-            <a:r>
-              <a:rPr lang="it-IT" sz="1462" b="0" i="0">
-                <a:solidFill>
-                  <a:srgbClr val="112642"/>
-                </a:solidFill>
-                <a:latin typeface="Aptos"/>
-              </a:rPr>
-              <a:t>mentre RunNumber e Xstrip conservano il legame con la calibrazione.</a:t>
-            </a:r>
-          </a:p>
-        </p:txBody>
-      </p:sp>
-      <p:sp>
-        <p:nvSpPr>
-          <p:cNvPr id="13" name="Fill 13"/>
+              <a:t>Gli estimatori di Σ combinano eventi ricostruiti, esposizione calibrata e polarizzazione per run.</a:t>
+            </a:r>
+          </a:p>
+        </p:txBody>
+      </p:sp>
+      <p:sp>
+        <p:nvSpPr>
+          <p:cNvPr id="43" name="Fill 43"/>
           <p:cNvSpPr/>
           <p:nvPr/>
         </p:nvSpPr>
@@ -9516,7 +10551,7 @@
       </p:sp>
       <p:sp>
         <p:nvSpPr>
-          <p:cNvPr id="14" name="Fill 14"/>
+          <p:cNvPr id="44" name="Fill 44"/>
           <p:cNvSpPr/>
           <p:nvPr/>
         </p:nvSpPr>
@@ -9538,7 +10573,7 @@
       </p:sp>
       <p:sp>
         <p:nvSpPr>
-          <p:cNvPr id="15" name="Text 15"/>
+          <p:cNvPr id="45" name="Text 45"/>
           <p:cNvSpPr txBox="1"/>
           <p:nvPr/>
         </p:nvSpPr>
@@ -9571,7 +10606,7 @@
       </p:sp>
       <p:sp>
         <p:nvSpPr>
-          <p:cNvPr id="16" name="Fill 16"/>
+          <p:cNvPr id="46" name="Fill 46"/>
           <p:cNvSpPr/>
           <p:nvPr/>
         </p:nvSpPr>
@@ -9593,7 +10628,7 @@
       </p:sp>
       <p:sp>
         <p:nvSpPr>
-          <p:cNvPr id="17" name="Fill 17"/>
+          <p:cNvPr id="47" name="Fill 47"/>
           <p:cNvSpPr/>
           <p:nvPr/>
         </p:nvSpPr>
@@ -9615,7 +10650,7 @@
       </p:sp>
       <p:sp>
         <p:nvSpPr>
-          <p:cNvPr id="18" name="Text 18"/>
+          <p:cNvPr id="48" name="Text 48"/>
           <p:cNvSpPr txBox="1"/>
           <p:nvPr/>
         </p:nvSpPr>
@@ -9641,14 +10676,14 @@
                 </a:solidFill>
                 <a:latin typeface="Aptos"/>
               </a:rPr>
-              <a:t>DATI</a:t>
-            </a:r>
-          </a:p>
-        </p:txBody>
-      </p:sp>
-      <p:sp>
-        <p:nvSpPr>
-          <p:cNvPr id="19" name="Text 19"/>
+              <a:t>FRAMEWORK</a:t>
+            </a:r>
+          </a:p>
+        </p:txBody>
+      </p:sp>
+      <p:sp>
+        <p:nvSpPr>
+          <p:cNvPr id="49" name="Text 49"/>
           <p:cNvSpPr txBox="1"/>
           <p:nvPr/>
         </p:nvSpPr>
@@ -9740,7 +10775,7 @@
                 </a:solidFill>
                 <a:latin typeface="Aptos"/>
               </a:rPr>
-              <a:t>Preselezione dei dati</a:t>
+              <a:t>Dai dati Fortran alla preselezione</a:t>
             </a:r>
           </a:p>
         </p:txBody>
@@ -9773,7 +10808,7 @@
                 </a:solidFill>
                 <a:latin typeface="Aptos"/>
               </a:rPr>
-              <a:t>Fonte: wiki/02-event-selection.md; wiki/05-reconstruction.md</a:t>
+              <a:t>Fonte: codice semplificato da PreAnalysis.C e select_events.py; attribuzione: progetto</a:t>
             </a:r>
           </a:p>
         </p:txBody>
@@ -9786,8 +10821,8 @@
         </p:nvSpPr>
         <p:spPr>
           <a:xfrm>
-            <a:off x="713232" y="1097280"/>
-            <a:ext cx="1920240" cy="566928"/>
+            <a:off x="658368" y="987552"/>
+            <a:ext cx="7845552" cy="566928"/>
           </a:xfrm>
           <a:noFill/>
           <a:ln>
@@ -9800,27 +10835,406 @@
           <a:p>
             <a:pPr algn="l"/>
             <a:r>
-              <a:rPr lang="it-IT" sz="3784" b="1" i="0">
+              <a:rPr lang="it-IT" sz="1419" b="0" i="0">
+                <a:solidFill>
+                  <a:srgbClr val="112642"/>
+                </a:solidFill>
+                <a:latin typeface="Aptos"/>
+              </a:rPr>
+              <a:t>Le routine Fortran hanno prodotto i dati storici. Antonio Riggio li ha convertiti in ROOT h70 e ha preparato i tagli PID; il codice della repo parte dai file h70 già convertiti.</a:t>
+            </a:r>
+          </a:p>
+        </p:txBody>
+      </p:sp>
+      <p:sp>
+        <p:nvSpPr>
+          <p:cNvPr id="5" name="Text 5"/>
+          <p:cNvSpPr txBox="1"/>
+          <p:nvPr/>
+        </p:nvSpPr>
+        <p:spPr>
+          <a:xfrm>
+            <a:off x="658368" y="1618488"/>
+            <a:ext cx="7845552" cy="457200"/>
+          </a:xfrm>
+          <a:noFill/>
+          <a:ln>
+            <a:noFill/>
+          </a:ln>
+        </p:spPr>
+        <p:txBody>
+          <a:bodyPr wrap="square" lIns="0" rIns="0" tIns="0" bIns="0" anchor="t"/>
+          <a:lstStyle/>
+          <a:p>
+            <a:pPr algn="l"/>
+            <a:r>
+              <a:rPr lang="it-IT" sz="1376" b="1" i="0">
                 <a:solidFill>
                   <a:srgbClr val="0B5FA5"/>
                 </a:solidFill>
                 <a:latin typeface="Aptos"/>
               </a:rPr>
-              <a:t>h80</a:t>
-            </a:r>
-          </a:p>
-        </p:txBody>
-      </p:sp>
-      <p:sp>
-        <p:nvSpPr>
-          <p:cNvPr id="5" name="Text 5"/>
-          <p:cNvSpPr txBox="1"/>
-          <p:nvPr/>
-        </p:nvSpPr>
-        <p:spPr>
-          <a:xfrm>
-            <a:off x="6309360" y="1097280"/>
-            <a:ext cx="1920240" cy="566928"/>
+              <a:t>Con C++/ROOT produciamo h80; Python/PyROOT filtra gli eventi in h85. La ricostruzione e gli osservabili usano entrambi gli ambienti.</a:t>
+            </a:r>
+          </a:p>
+        </p:txBody>
+      </p:sp>
+      <p:sp>
+        <p:nvSpPr>
+          <p:cNvPr id="6" name="Fill 6"/>
+          <p:cNvSpPr/>
+          <p:nvPr/>
+        </p:nvSpPr>
+        <p:spPr>
+          <a:xfrm>
+            <a:off x="667512" y="2258568"/>
+            <a:ext cx="3374136" cy="804672"/>
+          </a:xfrm>
+          <a:prstGeom prst="roundRect">
+            <a:avLst/>
+          </a:prstGeom>
+          <a:solidFill>
+            <a:srgbClr val="071E42"/>
+          </a:solidFill>
+          <a:ln>
+            <a:noFill/>
+          </a:ln>
+        </p:spPr>
+      </p:sp>
+      <p:sp>
+        <p:nvSpPr>
+          <p:cNvPr id="7" name="Text 7"/>
+          <p:cNvSpPr txBox="1"/>
+          <p:nvPr/>
+        </p:nvSpPr>
+        <p:spPr>
+          <a:xfrm>
+            <a:off x="832104" y="2350008"/>
+            <a:ext cx="3054096" cy="576072"/>
+          </a:xfrm>
+          <a:noFill/>
+          <a:ln>
+            <a:noFill/>
+          </a:ln>
+        </p:spPr>
+        <p:txBody>
+          <a:bodyPr wrap="square" lIns="0" rIns="0" tIns="0" bIns="0" anchor="ctr"/>
+          <a:lstStyle/>
+          <a:p>
+            <a:pPr algn="l"/>
+            <a:r>
+              <a:rPr lang="it-IT" sz="1280" b="0" i="0">
+                <a:solidFill>
+                  <a:srgbClr val="FFFFFF"/>
+                </a:solidFill>
+                <a:latin typeface="Aptos"/>
+              </a:rPr>
+              <a:t>auto* cut = RequireCut("Proton","Cnt",Idrun);</a:t>
+            </a:r>
+          </a:p>
+          <a:p>
+            <a:pPr algn="l"/>
+            <a:r>
+              <a:rPr lang="it-IT" sz="1280" b="0" i="0">
+                <a:solidFill>
+                  <a:srgbClr val="FFFFFF"/>
+                </a:solidFill>
+                <a:latin typeface="Aptos"/>
+              </a:rPr>
+              <a:t>cut-&gt;IsInside(Eclusc_track[i],</a:t>
+            </a:r>
+          </a:p>
+          <a:p>
+            <a:pPr algn="l"/>
+            <a:r>
+              <a:rPr lang="it-IT" sz="1280" b="0" i="0">
+                <a:solidFill>
+                  <a:srgbClr val="FFFFFF"/>
+                </a:solidFill>
+                <a:latin typeface="Aptos"/>
+              </a:rPr>
+              <a:t>              Dedx_track[i]);</a:t>
+            </a:r>
+          </a:p>
+        </p:txBody>
+      </p:sp>
+      <p:sp>
+        <p:nvSpPr>
+          <p:cNvPr id="8" name="Text 8"/>
+          <p:cNvSpPr txBox="1"/>
+          <p:nvPr/>
+        </p:nvSpPr>
+        <p:spPr>
+          <a:xfrm>
+            <a:off x="4123944" y="2368296"/>
+            <a:ext cx="411480" cy="585216"/>
+          </a:xfrm>
+          <a:noFill/>
+          <a:ln>
+            <a:noFill/>
+          </a:ln>
+        </p:spPr>
+        <p:txBody>
+          <a:bodyPr wrap="square" lIns="0" rIns="0" tIns="0" bIns="0" anchor="ctr"/>
+          <a:lstStyle/>
+          <a:p>
+            <a:pPr algn="ctr"/>
+            <a:r>
+              <a:rPr lang="it-IT" sz="2408" b="1" i="0">
+                <a:solidFill>
+                  <a:srgbClr val="0B5FA5"/>
+                </a:solidFill>
+                <a:latin typeface="Aptos"/>
+              </a:rPr>
+              <a:t>→</a:t>
+            </a:r>
+          </a:p>
+        </p:txBody>
+      </p:sp>
+      <p:sp>
+        <p:nvSpPr>
+          <p:cNvPr id="9" name="Fill 9"/>
+          <p:cNvSpPr/>
+          <p:nvPr/>
+        </p:nvSpPr>
+        <p:spPr>
+          <a:xfrm>
+            <a:off x="4608576" y="2258568"/>
+            <a:ext cx="3877056" cy="804672"/>
+          </a:xfrm>
+          <a:prstGeom prst="roundRect">
+            <a:avLst/>
+          </a:prstGeom>
+          <a:solidFill>
+            <a:srgbClr val="DDEFFA"/>
+          </a:solidFill>
+          <a:ln>
+            <a:noFill/>
+          </a:ln>
+        </p:spPr>
+      </p:sp>
+      <p:sp>
+        <p:nvSpPr>
+          <p:cNvPr id="10" name="Text 10"/>
+          <p:cNvSpPr txBox="1"/>
+          <p:nvPr/>
+        </p:nvSpPr>
+        <p:spPr>
+          <a:xfrm>
+            <a:off x="4754880" y="2331720"/>
+            <a:ext cx="3602736" cy="640080"/>
+          </a:xfrm>
+          <a:noFill/>
+          <a:ln>
+            <a:noFill/>
+          </a:ln>
+        </p:spPr>
+        <p:txBody>
+          <a:bodyPr wrap="square" lIns="0" rIns="0" tIns="0" bIns="0" anchor="ctr"/>
+          <a:lstStyle/>
+          <a:p>
+            <a:pPr algn="l"/>
+            <a:r>
+              <a:rPr lang="it-IT" sz="1500" b="0" i="0">
+                <a:solidFill>
+                  <a:srgbClr val="112642"/>
+                </a:solidFill>
+                <a:latin typeface="Aptos"/>
+              </a:rPr>
+              <a:t>I poligoni PID del run classificano le tracce centrali. PreAnalysis.C scrive h80 con particelle e metadati.</a:t>
+            </a:r>
+          </a:p>
+        </p:txBody>
+      </p:sp>
+      <p:sp>
+        <p:nvSpPr>
+          <p:cNvPr id="11" name="Fill 11"/>
+          <p:cNvSpPr/>
+          <p:nvPr/>
+        </p:nvSpPr>
+        <p:spPr>
+          <a:xfrm>
+            <a:off x="667512" y="3255264"/>
+            <a:ext cx="3374136" cy="950976"/>
+          </a:xfrm>
+          <a:prstGeom prst="roundRect">
+            <a:avLst/>
+          </a:prstGeom>
+          <a:solidFill>
+            <a:srgbClr val="071E42"/>
+          </a:solidFill>
+          <a:ln>
+            <a:noFill/>
+          </a:ln>
+        </p:spPr>
+      </p:sp>
+      <p:sp>
+        <p:nvSpPr>
+          <p:cNvPr id="12" name="Text 12"/>
+          <p:cNvSpPr txBox="1"/>
+          <p:nvPr/>
+        </p:nvSpPr>
+        <p:spPr>
+          <a:xfrm>
+            <a:off x="832104" y="3310128"/>
+            <a:ext cx="3054096" cy="859536"/>
+          </a:xfrm>
+          <a:noFill/>
+          <a:ln>
+            <a:noFill/>
+          </a:ln>
+        </p:spPr>
+        <p:txBody>
+          <a:bodyPr wrap="square" lIns="0" rIns="0" tIns="0" bIns="0" anchor="ctr"/>
+          <a:lstStyle/>
+          <a:p>
+            <a:pPr algn="l"/>
+            <a:r>
+              <a:rPr lang="it-IT" sz="1230" b="0" i="0">
+                <a:solidFill>
+                  <a:srgbClr val="FFFFFF"/>
+                </a:solidFill>
+                <a:latin typeface="Aptos"/>
+              </a:rPr>
+              <a:t>selected = frame.Filter(</a:t>
+            </a:r>
+          </a:p>
+          <a:p>
+            <a:pPr algn="l"/>
+            <a:r>
+              <a:rPr lang="it-IT" sz="1230" b="0" i="0">
+                <a:solidFill>
+                  <a:srgbClr val="FFFFFF"/>
+                </a:solidFill>
+                <a:latin typeface="Aptos"/>
+              </a:rPr>
+              <a:t>  "gammas.size() &gt; 1 &amp;&amp;"</a:t>
+            </a:r>
+          </a:p>
+          <a:p>
+            <a:pPr algn="l"/>
+            <a:r>
+              <a:rPr lang="it-IT" sz="1230" b="0" i="0">
+                <a:solidFill>
+                  <a:srgbClr val="FFFFFF"/>
+                </a:solidFill>
+                <a:latin typeface="Aptos"/>
+              </a:rPr>
+              <a:t>  " fcharged_theta.size() == 1")</a:t>
+            </a:r>
+          </a:p>
+          <a:p>
+            <a:pPr algn="l"/>
+            <a:r>
+              <a:rPr lang="it-IT" sz="1230" b="0" i="0">
+                <a:solidFill>
+                  <a:srgbClr val="FFFFFF"/>
+                </a:solidFill>
+                <a:latin typeface="Aptos"/>
+              </a:rPr>
+              <a:t>selected.Snapshot("h85", ...)</a:t>
+            </a:r>
+          </a:p>
+        </p:txBody>
+      </p:sp>
+      <p:sp>
+        <p:nvSpPr>
+          <p:cNvPr id="13" name="Text 13"/>
+          <p:cNvSpPr txBox="1"/>
+          <p:nvPr/>
+        </p:nvSpPr>
+        <p:spPr>
+          <a:xfrm>
+            <a:off x="4123944" y="3438144"/>
+            <a:ext cx="411480" cy="585216"/>
+          </a:xfrm>
+          <a:noFill/>
+          <a:ln>
+            <a:noFill/>
+          </a:ln>
+        </p:spPr>
+        <p:txBody>
+          <a:bodyPr wrap="square" lIns="0" rIns="0" tIns="0" bIns="0" anchor="ctr"/>
+          <a:lstStyle/>
+          <a:p>
+            <a:pPr algn="ctr"/>
+            <a:r>
+              <a:rPr lang="it-IT" sz="2408" b="1" i="0">
+                <a:solidFill>
+                  <a:srgbClr val="0B5FA5"/>
+                </a:solidFill>
+                <a:latin typeface="Aptos"/>
+              </a:rPr>
+              <a:t>→</a:t>
+            </a:r>
+          </a:p>
+        </p:txBody>
+      </p:sp>
+      <p:sp>
+        <p:nvSpPr>
+          <p:cNvPr id="14" name="Fill 14"/>
+          <p:cNvSpPr/>
+          <p:nvPr/>
+        </p:nvSpPr>
+        <p:spPr>
+          <a:xfrm>
+            <a:off x="4608576" y="3255264"/>
+            <a:ext cx="3877056" cy="950976"/>
+          </a:xfrm>
+          <a:prstGeom prst="roundRect">
+            <a:avLst/>
+          </a:prstGeom>
+          <a:solidFill>
+            <a:srgbClr val="DDEFFA"/>
+          </a:solidFill>
+          <a:ln>
+            <a:noFill/>
+          </a:ln>
+        </p:spPr>
+      </p:sp>
+      <p:sp>
+        <p:nvSpPr>
+          <p:cNvPr id="15" name="Text 15"/>
+          <p:cNvSpPr txBox="1"/>
+          <p:nvPr/>
+        </p:nvSpPr>
+        <p:spPr>
+          <a:xfrm>
+            <a:off x="4754880" y="3337560"/>
+            <a:ext cx="3602736" cy="777240"/>
+          </a:xfrm>
+          <a:noFill/>
+          <a:ln>
+            <a:noFill/>
+          </a:ln>
+        </p:spPr>
+        <p:txBody>
+          <a:bodyPr wrap="square" lIns="0" rIns="0" tIns="0" bIns="0" anchor="ctr"/>
+          <a:lstStyle/>
+          <a:p>
+            <a:pPr algn="l"/>
+            <a:r>
+              <a:rPr lang="it-IT" sz="1450" b="0" i="0">
+                <a:solidFill>
+                  <a:srgbClr val="112642"/>
+                </a:solidFill>
+                <a:latin typeface="Aptos"/>
+              </a:rPr>
+              <a:t>La preselezione richiede almeno 2 fotoni e una traccia carica in avanti. h85 conserva tutti i rami; i 4 fotoni si richiedono più avanti.</a:t>
+            </a:r>
+          </a:p>
+        </p:txBody>
+      </p:sp>
+      <p:sp>
+        <p:nvSpPr>
+          <p:cNvPr id="16" name="Text 16"/>
+          <p:cNvSpPr txBox="1"/>
+          <p:nvPr/>
+        </p:nvSpPr>
+        <p:spPr>
+          <a:xfrm>
+            <a:off x="685800" y="4315968"/>
+            <a:ext cx="7818120" cy="256032"/>
           </a:xfrm>
           <a:noFill/>
           <a:ln>
@@ -9831,166 +11245,22 @@
           <a:bodyPr wrap="square" lIns="0" rIns="0" tIns="0" bIns="0" anchor="t"/>
           <a:lstStyle/>
           <a:p>
-            <a:pPr algn="r"/>
-            <a:r>
-              <a:rPr lang="it-IT" sz="3784" b="1" i="0">
-                <a:solidFill>
-                  <a:srgbClr val="0B5FA5"/>
-                </a:solidFill>
-                <a:latin typeface="Aptos"/>
-              </a:rPr>
-              <a:t>h85</a:t>
-            </a:r>
-          </a:p>
-        </p:txBody>
-      </p:sp>
-      <p:sp>
-        <p:nvSpPr>
-          <p:cNvPr id="6" name="Text 6"/>
-          <p:cNvSpPr txBox="1"/>
-          <p:nvPr/>
-        </p:nvSpPr>
-        <p:spPr>
-          <a:xfrm>
-            <a:off x="713232" y="1847088"/>
-            <a:ext cx="7680960" cy="365760"/>
-          </a:xfrm>
-          <a:noFill/>
-          <a:ln>
-            <a:noFill/>
-          </a:ln>
-        </p:spPr>
-        <p:txBody>
-          <a:bodyPr wrap="square" lIns="0" rIns="0" tIns="0" bIns="0" anchor="t"/>
-          <a:lstStyle/>
-          <a:p>
-            <a:pPr algn="l"/>
-            <a:r>
-              <a:rPr lang="it-IT" sz="1892" b="1" i="0">
-                <a:solidFill>
-                  <a:srgbClr val="112642"/>
-                </a:solidFill>
-                <a:latin typeface="Aptos"/>
-              </a:rPr>
-              <a:t>Applichiamo un filtro topologico con ROOT RDataFrame</a:t>
-            </a:r>
-          </a:p>
-        </p:txBody>
-      </p:sp>
-      <p:sp>
-        <p:nvSpPr>
-          <p:cNvPr id="7" name="Text 7"/>
-          <p:cNvSpPr txBox="1"/>
-          <p:nvPr/>
-        </p:nvSpPr>
-        <p:spPr>
-          <a:xfrm>
-            <a:off x="713232" y="2331720"/>
-            <a:ext cx="7772400" cy="457200"/>
-          </a:xfrm>
-          <a:noFill/>
-          <a:ln>
-            <a:noFill/>
-          </a:ln>
-        </p:spPr>
-        <p:txBody>
-          <a:bodyPr wrap="square" lIns="0" rIns="0" tIns="0" bIns="0" anchor="t"/>
-          <a:lstStyle/>
-          <a:p>
-            <a:pPr algn="l"/>
-            <a:r>
-              <a:rPr lang="it-IT" sz="1806" b="0" i="0">
-                <a:solidFill>
-                  <a:srgbClr val="0B5FA5"/>
-                </a:solidFill>
-                <a:latin typeface="Aptos"/>
-              </a:rPr>
-              <a:t>gammas.size() &gt; 1  &amp;&amp;  fcharged_theta.size() == 1</a:t>
-            </a:r>
-          </a:p>
-        </p:txBody>
-      </p:sp>
-      <p:sp>
-        <p:nvSpPr>
-          <p:cNvPr id="8" name="Text 8"/>
-          <p:cNvSpPr txBox="1"/>
-          <p:nvPr/>
-        </p:nvSpPr>
-        <p:spPr>
-          <a:xfrm>
-            <a:off x="713232" y="3044952"/>
-            <a:ext cx="7772400" cy="466344"/>
-          </a:xfrm>
-          <a:noFill/>
-          <a:ln>
-            <a:noFill/>
-          </a:ln>
-        </p:spPr>
-        <p:txBody>
-          <a:bodyPr wrap="square" lIns="0" rIns="0" tIns="0" bIns="0" anchor="t"/>
-          <a:lstStyle/>
-          <a:p>
-            <a:pPr algn="l"/>
-            <a:r>
-              <a:rPr lang="it-IT" sz="1634" b="0" i="0">
-                <a:solidFill>
-                  <a:srgbClr val="112642"/>
-                </a:solidFill>
-                <a:latin typeface="Aptos"/>
-              </a:rPr>
-              <a:t>In questa fase bastano almeno due fotoni. I quattro fotoni dello stato finale vengono richiesti più avanti.</a:t>
-            </a:r>
-          </a:p>
-        </p:txBody>
-      </p:sp>
-      <p:sp>
-        <p:nvSpPr>
-          <p:cNvPr id="9" name="Text 9"/>
-          <p:cNvSpPr txBox="1"/>
-          <p:nvPr/>
-        </p:nvSpPr>
-        <p:spPr>
-          <a:xfrm>
-            <a:off x="713232" y="3675888"/>
-            <a:ext cx="7726680" cy="704088"/>
-          </a:xfrm>
-          <a:noFill/>
-          <a:ln>
-            <a:noFill/>
-          </a:ln>
-        </p:spPr>
-        <p:txBody>
-          <a:bodyPr wrap="square" lIns="0" rIns="0" tIns="0" bIns="0" anchor="t"/>
-          <a:lstStyle/>
-          <a:p>
-            <a:pPr algn="l"/>
-            <a:r>
-              <a:rPr lang="it-IT" sz="1505" b="0" i="0">
+            <a:pPr algn="l"/>
+            <a:r>
+              <a:rPr lang="it-IT" sz="1400" b="0" i="0">
                 <a:solidFill>
                   <a:srgbClr val="52657B"/>
                 </a:solidFill>
                 <a:latin typeface="Aptos"/>
               </a:rPr>
-              <a:t>Il tree h85 conserva tutti i rami. RunNumber, Polarization e Xstrip</a:t>
-            </a:r>
-          </a:p>
-          <a:p>
-            <a:pPr algn="l"/>
-            <a:r>
-              <a:rPr lang="it-IT" sz="1505" b="0" i="0">
-                <a:solidFill>
-                  <a:srgbClr val="52657B"/>
-                </a:solidFill>
-                <a:latin typeface="Aptos"/>
-              </a:rPr>
-              <a:t>accompagnano ogni evento nella ricostruzione e nella calibrazione.</a:t>
-            </a:r>
-          </a:p>
-        </p:txBody>
-      </p:sp>
-      <p:sp>
-        <p:nvSpPr>
-          <p:cNvPr id="10" name="Fill 10"/>
+              <a:t>RunNumber, Polarization e Xstrip restano disponibili per ricostruzione e calibrazione.</a:t>
+            </a:r>
+          </a:p>
+        </p:txBody>
+      </p:sp>
+      <p:sp>
+        <p:nvSpPr>
+          <p:cNvPr id="17" name="Fill 17"/>
           <p:cNvSpPr/>
           <p:nvPr/>
         </p:nvSpPr>
@@ -10012,7 +11282,7 @@
       </p:sp>
       <p:sp>
         <p:nvSpPr>
-          <p:cNvPr id="11" name="Fill 11"/>
+          <p:cNvPr id="18" name="Fill 18"/>
           <p:cNvSpPr/>
           <p:nvPr/>
         </p:nvSpPr>
@@ -10034,7 +11304,7 @@
       </p:sp>
       <p:sp>
         <p:nvSpPr>
-          <p:cNvPr id="12" name="Text 12"/>
+          <p:cNvPr id="19" name="Text 19"/>
           <p:cNvSpPr txBox="1"/>
           <p:nvPr/>
         </p:nvSpPr>
@@ -10067,7 +11337,7 @@
       </p:sp>
       <p:sp>
         <p:nvSpPr>
-          <p:cNvPr id="13" name="Fill 13"/>
+          <p:cNvPr id="20" name="Fill 20"/>
           <p:cNvSpPr/>
           <p:nvPr/>
         </p:nvSpPr>
@@ -10089,7 +11359,7 @@
       </p:sp>
       <p:sp>
         <p:nvSpPr>
-          <p:cNvPr id="14" name="Fill 14"/>
+          <p:cNvPr id="21" name="Fill 21"/>
           <p:cNvSpPr/>
           <p:nvPr/>
         </p:nvSpPr>
@@ -10111,7 +11381,7 @@
       </p:sp>
       <p:sp>
         <p:nvSpPr>
-          <p:cNvPr id="15" name="Text 15"/>
+          <p:cNvPr id="22" name="Text 22"/>
           <p:cNvSpPr txBox="1"/>
           <p:nvPr/>
         </p:nvSpPr>
@@ -10144,7 +11414,7 @@
       </p:sp>
       <p:sp>
         <p:nvSpPr>
-          <p:cNvPr id="16" name="Text 16"/>
+          <p:cNvPr id="23" name="Text 23"/>
           <p:cNvSpPr txBox="1"/>
           <p:nvPr/>
         </p:nvSpPr>

</xml_diff>

<commit_message>
docs: explain MC generation and channel choices
</commit_message>
<xml_diff>
--- a/presentations/graal_analysis_framework_asimmetrie.pptx
+++ b/presentations/graal_analysis_framework_asimmetrie.pptx
@@ -11651,7 +11651,7 @@
 </file>
 
 <file path=ppt/slides/slide6.xml><?xml version="1.0" encoding="utf-8"?>
-<p:sld xmlns:a="http://schemas.openxmlformats.org/drawingml/2006/main" xmlns:r="http://schemas.openxmlformats.org/officeDocument/2006/relationships" xmlns:p="http://schemas.openxmlformats.org/presentationml/2006/main">
+<p:sld xmlns:p="http://schemas.openxmlformats.org/presentationml/2006/main" xmlns:a="http://schemas.openxmlformats.org/drawingml/2006/main" xmlns:r="http://schemas.openxmlformats.org/officeDocument/2006/relationships">
   <p:cSld>
     <p:bg>
       <p:bgPr>
@@ -11692,7 +11692,7 @@
           </a:ln>
         </p:spPr>
         <p:txBody>
-          <a:bodyPr wrap="square" lIns="0" tIns="0" rIns="0" bIns="0" anchor="t"/>
+          <a:bodyPr wrap="square" lIns="0" rIns="0" tIns="0" bIns="0" anchor="t"/>
           <a:lstStyle/>
           <a:p>
             <a:pPr algn="l"/>
@@ -11703,7 +11703,7 @@
                 </a:solidFill>
                 <a:latin typeface="Aptos"/>
               </a:rPr>
-              <a:t>Simulazione Monte Carlo senza G3</a:t>
+              <a:t>Simulazione Monte Carlo</a:t>
             </a:r>
           </a:p>
         </p:txBody>
@@ -11725,7 +11725,7 @@
           </a:ln>
         </p:spPr>
         <p:txBody>
-          <a:bodyPr wrap="square" lIns="0" tIns="0" rIns="0" bIns="0" anchor="t"/>
+          <a:bodyPr wrap="square" lIns="0" rIns="0" tIns="0" bIns="0" anchor="t"/>
           <a:lstStyle/>
           <a:p>
             <a:pPr algn="l"/>
@@ -11736,7 +11736,7 @@
                 </a:solidFill>
                 <a:latin typeface="Aptos"/>
               </a:rPr>
-              <a:t>Fonte: wiki/03-monte-carlo-simulation.md; 03_mc_simulation/generators/smearing.h</a:t>
+              <a:t>Fonte: 03_mc_simulation/generators/generate_eta_pi0_dataset.C e smearing.h; 04_bdt_training/dataset/mc_samples.py</a:t>
             </a:r>
           </a:p>
         </p:txBody>
@@ -11749,235 +11749,690 @@
         </p:nvSpPr>
         <p:spPr>
           <a:xfrm>
-            <a:off x="685800" y="1097280"/>
-            <a:ext cx="3657600" cy="338328"/>
-          </a:xfrm>
-          <a:noFill/>
-          <a:ln>
-            <a:noFill/>
-          </a:ln>
-        </p:spPr>
-        <p:txBody>
-          <a:bodyPr wrap="square" lIns="0" tIns="0" rIns="0" bIns="0" anchor="t"/>
-          <a:lstStyle/>
-          <a:p>
-            <a:pPr algn="l"/>
-            <a:r>
-              <a:rPr lang="it-IT" sz="1892" b="1" i="0">
+            <a:off x="676656" y="932688"/>
+            <a:ext cx="7818120" cy="438912"/>
+          </a:xfrm>
+          <a:noFill/>
+          <a:ln>
+            <a:noFill/>
+          </a:ln>
+        </p:spPr>
+        <p:txBody>
+          <a:bodyPr wrap="square" lIns="0" rIns="0" tIns="0" bIns="0" anchor="t"/>
+          <a:lstStyle/>
+          <a:p>
+            <a:pPr algn="l"/>
+            <a:r>
+              <a:rPr lang="it-IT" sz="1350" b="0" i="0">
+                <a:solidFill>
+                  <a:srgbClr val="112642"/>
+                </a:solidFill>
+                <a:latin typeface="Aptos"/>
+              </a:rPr>
+              <a:t>I generatori descrivono produzione e decadimenti. Prima del training, applichiamo una risposta strumentale semplificata e selezioniamo gli eventi con quattro fotoni osservabili.</a:t>
+            </a:r>
+          </a:p>
+        </p:txBody>
+      </p:sp>
+      <p:sp>
+        <p:nvSpPr>
+          <p:cNvPr id="5" name="Fill 5"/>
+          <p:cNvSpPr/>
+          <p:nvPr/>
+        </p:nvSpPr>
+        <p:spPr>
+          <a:xfrm>
+            <a:off x="667512" y="1444752"/>
+            <a:ext cx="3657600" cy="658368"/>
+          </a:xfrm>
+          <a:prstGeom prst="roundRect">
+            <a:avLst/>
+          </a:prstGeom>
+          <a:solidFill>
+            <a:srgbClr val="071E42"/>
+          </a:solidFill>
+          <a:ln>
+            <a:noFill/>
+          </a:ln>
+        </p:spPr>
+      </p:sp>
+      <p:sp>
+        <p:nvSpPr>
+          <p:cNvPr id="6" name="Text 6"/>
+          <p:cNvSpPr txBox="1"/>
+          <p:nvPr/>
+        </p:nvSpPr>
+        <p:spPr>
+          <a:xfrm>
+            <a:off x="832104" y="1490472"/>
+            <a:ext cx="3337560" cy="566928"/>
+          </a:xfrm>
+          <a:noFill/>
+          <a:ln>
+            <a:noFill/>
+          </a:ln>
+        </p:spPr>
+        <p:txBody>
+          <a:bodyPr wrap="square" lIns="0" rIns="0" tIns="0" bIns="0" anchor="ctr"/>
+          <a:lstStyle/>
+          <a:p>
+            <a:pPr algn="l"/>
+            <a:r>
+              <a:rPr lang="it-IT" sz="1210" b="0" i="0">
+                <a:solidFill>
+                  <a:srgbClr val="FFFFFF"/>
+                </a:solidFill>
+                <a:latin typeface="Aptos"/>
+              </a:rPr>
+              <a:t>const BeamWindow beam_window =</a:t>
+            </a:r>
+          </a:p>
+          <a:p>
+            <a:pPr algn="l"/>
+            <a:r>
+              <a:rPr lang="it-IT" sz="1210" b="0" i="0">
+                <a:solidFill>
+                  <a:srgbClr val="FFFFFF"/>
+                </a:solidFill>
+                <a:latin typeface="Aptos"/>
+              </a:rPr>
+              <a:t>  ResolveBeamWindow(threshold,</a:t>
+            </a:r>
+          </a:p>
+          <a:p>
+            <a:pPr algn="l"/>
+            <a:r>
+              <a:rPr lang="it-IT" sz="1210" b="0" i="0">
+                <a:solidFill>
+                  <a:srgbClr val="FFFFFF"/>
+                </a:solidFill>
+                <a:latin typeface="Aptos"/>
+              </a:rPr>
+              <a:t>    requested_min_gev, requested_max_gev);</a:t>
+            </a:r>
+          </a:p>
+        </p:txBody>
+      </p:sp>
+      <p:sp>
+        <p:nvSpPr>
+          <p:cNvPr id="7" name="Text 7"/>
+          <p:cNvSpPr txBox="1"/>
+          <p:nvPr/>
+        </p:nvSpPr>
+        <p:spPr>
+          <a:xfrm>
+            <a:off x="4389120" y="1499616"/>
+            <a:ext cx="338328" cy="530352"/>
+          </a:xfrm>
+          <a:noFill/>
+          <a:ln>
+            <a:noFill/>
+          </a:ln>
+        </p:spPr>
+        <p:txBody>
+          <a:bodyPr wrap="square" lIns="0" rIns="0" tIns="0" bIns="0" anchor="ctr"/>
+          <a:lstStyle/>
+          <a:p>
+            <a:pPr algn="ctr"/>
+            <a:r>
+              <a:rPr lang="it-IT" sz="2236" b="1" i="0">
                 <a:solidFill>
                   <a:srgbClr val="0B5FA5"/>
                 </a:solidFill>
                 <a:latin typeface="Aptos"/>
               </a:rPr>
-              <a:t>Generazione</a:t>
-            </a:r>
-          </a:p>
-        </p:txBody>
-      </p:sp>
-      <p:sp>
-        <p:nvSpPr>
-          <p:cNvPr id="5" name="Text 5"/>
-          <p:cNvSpPr txBox="1"/>
-          <p:nvPr/>
-        </p:nvSpPr>
-        <p:spPr>
-          <a:xfrm>
-            <a:off x="685800" y="1481328"/>
-            <a:ext cx="7735824" cy="658368"/>
-          </a:xfrm>
-          <a:noFill/>
-          <a:ln>
-            <a:noFill/>
-          </a:ln>
-        </p:spPr>
-        <p:txBody>
-          <a:bodyPr wrap="square" lIns="0" tIns="0" rIns="0" bIns="0" anchor="t"/>
-          <a:lstStyle/>
-          <a:p>
-            <a:pPr algn="l"/>
-            <a:r>
-              <a:rPr lang="it-IT" sz="1591" b="0" i="0">
+              <a:t>→</a:t>
+            </a:r>
+          </a:p>
+        </p:txBody>
+      </p:sp>
+      <p:sp>
+        <p:nvSpPr>
+          <p:cNvPr id="8" name="Fill 8"/>
+          <p:cNvSpPr/>
+          <p:nvPr/>
+        </p:nvSpPr>
+        <p:spPr>
+          <a:xfrm>
+            <a:off x="4773168" y="1444752"/>
+            <a:ext cx="3694176" cy="658368"/>
+          </a:xfrm>
+          <a:prstGeom prst="roundRect">
+            <a:avLst/>
+          </a:prstGeom>
+          <a:solidFill>
+            <a:srgbClr val="DDEFFA"/>
+          </a:solidFill>
+          <a:ln>
+            <a:noFill/>
+          </a:ln>
+        </p:spPr>
+      </p:sp>
+      <p:sp>
+        <p:nvSpPr>
+          <p:cNvPr id="9" name="Text 9"/>
+          <p:cNvSpPr txBox="1"/>
+          <p:nvPr/>
+        </p:nvSpPr>
+        <p:spPr>
+          <a:xfrm>
+            <a:off x="4919472" y="1490472"/>
+            <a:ext cx="3401568" cy="566928"/>
+          </a:xfrm>
+          <a:noFill/>
+          <a:ln>
+            <a:noFill/>
+          </a:ln>
+        </p:spPr>
+        <p:txBody>
+          <a:bodyPr wrap="square" lIns="0" rIns="0" tIns="0" bIns="0" anchor="ctr"/>
+          <a:lstStyle/>
+          <a:p>
+            <a:pPr algn="l"/>
+            <a:r>
+              <a:rPr lang="it-IT" sz="1340" b="0" i="0">
                 <a:solidFill>
                   <a:srgbClr val="112642"/>
                 </a:solidFill>
                 <a:latin typeface="Aptos"/>
               </a:rPr>
-              <a:t>Generiamo eventi non pesati con ROOT TGenPhaseSpace. La soglia deriva dalle masse dei prodotti finali.</a:t>
-            </a:r>
-          </a:p>
-        </p:txBody>
-      </p:sp>
-      <p:sp>
-        <p:nvSpPr>
-          <p:cNvPr id="6" name="Text 6"/>
-          <p:cNvSpPr txBox="1"/>
-          <p:nvPr/>
-        </p:nvSpPr>
-        <p:spPr>
-          <a:xfrm>
-            <a:off x="685800" y="2295144"/>
-            <a:ext cx="3749040" cy="338328"/>
-          </a:xfrm>
-          <a:noFill/>
-          <a:ln>
-            <a:noFill/>
-          </a:ln>
-        </p:spPr>
-        <p:txBody>
-          <a:bodyPr wrap="square" lIns="0" tIns="0" rIns="0" bIns="0" anchor="t"/>
-          <a:lstStyle/>
-          <a:p>
-            <a:pPr algn="l"/>
-            <a:r>
-              <a:rPr lang="it-IT" sz="1892" b="1" i="0">
+              <a:t>L'energia parte dalla soglia calcolata con le masse finali. Il limite predefinito è 1,75 GeV; la finestra VIS si ferma a 1,10 GeV.</a:t>
+            </a:r>
+          </a:p>
+        </p:txBody>
+      </p:sp>
+      <p:sp>
+        <p:nvSpPr>
+          <p:cNvPr id="10" name="Fill 10"/>
+          <p:cNvSpPr/>
+          <p:nvPr/>
+        </p:nvSpPr>
+        <p:spPr>
+          <a:xfrm>
+            <a:off x="667512" y="2194560"/>
+            <a:ext cx="3657600" cy="658368"/>
+          </a:xfrm>
+          <a:prstGeom prst="roundRect">
+            <a:avLst/>
+          </a:prstGeom>
+          <a:solidFill>
+            <a:srgbClr val="071E42"/>
+          </a:solidFill>
+          <a:ln>
+            <a:noFill/>
+          </a:ln>
+        </p:spPr>
+      </p:sp>
+      <p:sp>
+        <p:nvSpPr>
+          <p:cNvPr id="11" name="Text 11"/>
+          <p:cNvSpPr txBox="1"/>
+          <p:nvPr/>
+        </p:nvSpPr>
+        <p:spPr>
+          <a:xfrm>
+            <a:off x="832104" y="2240280"/>
+            <a:ext cx="3337560" cy="566928"/>
+          </a:xfrm>
+          <a:noFill/>
+          <a:ln>
+            <a:noFill/>
+          </a:ln>
+        </p:spPr>
+        <p:txBody>
+          <a:bodyPr wrap="square" lIns="0" rIns="0" tIns="0" bIns="0" anchor="ctr"/>
+          <a:lstStyle/>
+          <a:p>
+            <a:pPr algn="l"/>
+            <a:r>
+              <a:rPr lang="it-IT" sz="1210" b="0" i="0">
+                <a:solidFill>
+                  <a:srgbClr val="FFFFFF"/>
+                </a:solidFill>
+                <a:latin typeface="Aptos"/>
+              </a:rPr>
+              <a:t>if (!event.SetDecay(W, 3, masses))</a:t>
+            </a:r>
+          </a:p>
+          <a:p>
+            <a:pPr algn="l"/>
+            <a:r>
+              <a:rPr lang="it-IT" sz="1210" b="0" i="0">
+                <a:solidFill>
+                  <a:srgbClr val="FFFFFF"/>
+                </a:solidFill>
+                <a:latin typeface="Aptos"/>
+              </a:rPr>
+              <a:t>    continue;</a:t>
+            </a:r>
+          </a:p>
+          <a:p>
+            <a:pPr algn="l"/>
+            <a:r>
+              <a:rPr lang="it-IT" sz="1210" b="0" i="0">
+                <a:solidFill>
+                  <a:srgbClr val="FFFFFF"/>
+                </a:solidFill>
+                <a:latin typeface="Aptos"/>
+              </a:rPr>
+              <a:t>GenerateUnweighted(event, rng);</a:t>
+            </a:r>
+          </a:p>
+        </p:txBody>
+      </p:sp>
+      <p:sp>
+        <p:nvSpPr>
+          <p:cNvPr id="12" name="Text 12"/>
+          <p:cNvSpPr txBox="1"/>
+          <p:nvPr/>
+        </p:nvSpPr>
+        <p:spPr>
+          <a:xfrm>
+            <a:off x="4389120" y="2249424"/>
+            <a:ext cx="338328" cy="530352"/>
+          </a:xfrm>
+          <a:noFill/>
+          <a:ln>
+            <a:noFill/>
+          </a:ln>
+        </p:spPr>
+        <p:txBody>
+          <a:bodyPr wrap="square" lIns="0" rIns="0" tIns="0" bIns="0" anchor="ctr"/>
+          <a:lstStyle/>
+          <a:p>
+            <a:pPr algn="ctr"/>
+            <a:r>
+              <a:rPr lang="it-IT" sz="2236" b="1" i="0">
                 <a:solidFill>
                   <a:srgbClr val="0B5FA5"/>
                 </a:solidFill>
                 <a:latin typeface="Aptos"/>
               </a:rPr>
-              <a:t>Finestra energetica</a:t>
-            </a:r>
-          </a:p>
-        </p:txBody>
-      </p:sp>
-      <p:sp>
-        <p:nvSpPr>
-          <p:cNvPr id="7" name="Text 7"/>
-          <p:cNvSpPr txBox="1"/>
-          <p:nvPr/>
-        </p:nvSpPr>
-        <p:spPr>
-          <a:xfrm>
-            <a:off x="685800" y="2688336"/>
-            <a:ext cx="7726680" cy="685800"/>
-          </a:xfrm>
-          <a:noFill/>
-          <a:ln>
-            <a:noFill/>
-          </a:ln>
-        </p:spPr>
-        <p:txBody>
-          <a:bodyPr wrap="square" lIns="0" tIns="0" rIns="0" bIns="0" anchor="t"/>
-          <a:lstStyle/>
-          <a:p>
-            <a:pPr algn="l"/>
-            <a:r>
-              <a:rPr lang="it-IT" sz="1591" b="0" i="0">
+              <a:t>→</a:t>
+            </a:r>
+          </a:p>
+        </p:txBody>
+      </p:sp>
+      <p:sp>
+        <p:nvSpPr>
+          <p:cNvPr id="13" name="Fill 13"/>
+          <p:cNvSpPr/>
+          <p:nvPr/>
+        </p:nvSpPr>
+        <p:spPr>
+          <a:xfrm>
+            <a:off x="4773168" y="2194560"/>
+            <a:ext cx="3694176" cy="658368"/>
+          </a:xfrm>
+          <a:prstGeom prst="roundRect">
+            <a:avLst/>
+          </a:prstGeom>
+          <a:solidFill>
+            <a:srgbClr val="DDEFFA"/>
+          </a:solidFill>
+          <a:ln>
+            <a:noFill/>
+          </a:ln>
+        </p:spPr>
+      </p:sp>
+      <p:sp>
+        <p:nvSpPr>
+          <p:cNvPr id="14" name="Text 14"/>
+          <p:cNvSpPr txBox="1"/>
+          <p:nvPr/>
+        </p:nvSpPr>
+        <p:spPr>
+          <a:xfrm>
+            <a:off x="4919472" y="2240280"/>
+            <a:ext cx="3401568" cy="566928"/>
+          </a:xfrm>
+          <a:noFill/>
+          <a:ln>
+            <a:noFill/>
+          </a:ln>
+        </p:spPr>
+        <p:txBody>
+          <a:bodyPr wrap="square" lIns="0" rIns="0" tIns="0" bIns="0" anchor="ctr"/>
+          <a:lstStyle/>
+          <a:p>
+            <a:pPr algn="l"/>
+            <a:r>
+              <a:rPr lang="it-IT" sz="1360" b="0" i="0">
                 <a:solidFill>
                   <a:srgbClr val="112642"/>
                 </a:solidFill>
                 <a:latin typeface="Aptos"/>
               </a:rPr>
-              <a:t>Il campione esteso arriva a 1,75 GeV. Per VIS produciamo un campione dedicato tra la soglia fisica, o 0,9313 GeV se più alta, e 1,10 GeV.</a:t>
-            </a:r>
-          </a:p>
-        </p:txBody>
-      </p:sp>
-      <p:sp>
-        <p:nvSpPr>
-          <p:cNvPr id="8" name="Text 8"/>
-          <p:cNvSpPr txBox="1"/>
-          <p:nvPr/>
-        </p:nvSpPr>
-        <p:spPr>
-          <a:xfrm>
-            <a:off x="685800" y="3511296"/>
-            <a:ext cx="4297680" cy="338328"/>
-          </a:xfrm>
-          <a:noFill/>
-          <a:ln>
-            <a:noFill/>
-          </a:ln>
-        </p:spPr>
-        <p:txBody>
-          <a:bodyPr wrap="square" lIns="0" tIns="0" rIns="0" bIns="0" anchor="t"/>
-          <a:lstStyle/>
-          <a:p>
-            <a:pPr algn="l"/>
-            <a:r>
-              <a:rPr lang="it-IT" sz="1892" b="1" i="0">
+              <a:t>TGenPhaseSpace genera pηπ⁰ senza pesi finali; η e π⁰ decadono poi in due fotoni ciascuno.</a:t>
+            </a:r>
+          </a:p>
+        </p:txBody>
+      </p:sp>
+      <p:sp>
+        <p:nvSpPr>
+          <p:cNvPr id="15" name="Fill 15"/>
+          <p:cNvSpPr/>
+          <p:nvPr/>
+        </p:nvSpPr>
+        <p:spPr>
+          <a:xfrm>
+            <a:off x="667512" y="2944368"/>
+            <a:ext cx="3657600" cy="658368"/>
+          </a:xfrm>
+          <a:prstGeom prst="roundRect">
+            <a:avLst/>
+          </a:prstGeom>
+          <a:solidFill>
+            <a:srgbClr val="071E42"/>
+          </a:solidFill>
+          <a:ln>
+            <a:noFill/>
+          </a:ln>
+        </p:spPr>
+      </p:sp>
+      <p:sp>
+        <p:nvSpPr>
+          <p:cNvPr id="16" name="Text 16"/>
+          <p:cNvSpPr txBox="1"/>
+          <p:nvPr/>
+        </p:nvSpPr>
+        <p:spPr>
+          <a:xfrm>
+            <a:off x="832104" y="2990088"/>
+            <a:ext cx="3337560" cy="566928"/>
+          </a:xfrm>
+          <a:noFill/>
+          <a:ln>
+            <a:noFill/>
+          </a:ln>
+        </p:spPr>
+        <p:txBody>
+          <a:bodyPr wrap="square" lIns="0" rIns="0" tIns="0" bIns="0" anchor="ctr"/>
+          <a:lstStyle/>
+          <a:p>
+            <a:pPr algn="l"/>
+            <a:r>
+              <a:rPr lang="it-IT" sz="1210" b="0" i="0">
+                <a:solidFill>
+                  <a:srgbClr val="FFFFFF"/>
+                </a:solidFill>
+                <a:latin typeface="Aptos"/>
+              </a:rPr>
+              <a:t>constexpr double kTaggerFwhmGeV = 0.016;</a:t>
+            </a:r>
+          </a:p>
+          <a:p>
+            <a:pPr algn="l"/>
+            <a:r>
+              <a:rPr lang="it-IT" sz="1210" b="0" i="0">
+                <a:solidFill>
+                  <a:srgbClr val="FFFFFF"/>
+                </a:solidFill>
+                <a:latin typeface="Aptos"/>
+              </a:rPr>
+              <a:t>beam = SmearTaggedPhoton(Ebeam, rng);</a:t>
+            </a:r>
+          </a:p>
+        </p:txBody>
+      </p:sp>
+      <p:sp>
+        <p:nvSpPr>
+          <p:cNvPr id="17" name="Text 17"/>
+          <p:cNvSpPr txBox="1"/>
+          <p:nvPr/>
+        </p:nvSpPr>
+        <p:spPr>
+          <a:xfrm>
+            <a:off x="4389120" y="2999232"/>
+            <a:ext cx="338328" cy="530352"/>
+          </a:xfrm>
+          <a:noFill/>
+          <a:ln>
+            <a:noFill/>
+          </a:ln>
+        </p:spPr>
+        <p:txBody>
+          <a:bodyPr wrap="square" lIns="0" rIns="0" tIns="0" bIns="0" anchor="ctr"/>
+          <a:lstStyle/>
+          <a:p>
+            <a:pPr algn="ctr"/>
+            <a:r>
+              <a:rPr lang="it-IT" sz="2236" b="1" i="0">
                 <a:solidFill>
                   <a:srgbClr val="0B5FA5"/>
                 </a:solidFill>
                 <a:latin typeface="Aptos"/>
               </a:rPr>
-              <a:t>Risposta strumentale</a:t>
-            </a:r>
-          </a:p>
-        </p:txBody>
-      </p:sp>
-      <p:sp>
-        <p:nvSpPr>
-          <p:cNvPr id="9" name="Text 9"/>
-          <p:cNvSpPr txBox="1"/>
-          <p:nvPr/>
-        </p:nvSpPr>
-        <p:spPr>
-          <a:xfrm>
-            <a:off x="685800" y="3895344"/>
-            <a:ext cx="7735824" cy="658368"/>
-          </a:xfrm>
-          <a:noFill/>
-          <a:ln>
-            <a:noFill/>
-          </a:ln>
-        </p:spPr>
-        <p:txBody>
-          <a:bodyPr wrap="square" lIns="0" tIns="0" rIns="0" bIns="0" anchor="t"/>
-          <a:lstStyle/>
-          <a:p>
-            <a:pPr algn="l"/>
-            <a:r>
-              <a:rPr lang="it-IT" sz="1505" b="0" i="0" dirty="0">
+              <a:t>→</a:t>
+            </a:r>
+          </a:p>
+        </p:txBody>
+      </p:sp>
+      <p:sp>
+        <p:nvSpPr>
+          <p:cNvPr id="18" name="Fill 18"/>
+          <p:cNvSpPr/>
+          <p:nvPr/>
+        </p:nvSpPr>
+        <p:spPr>
+          <a:xfrm>
+            <a:off x="4773168" y="2944368"/>
+            <a:ext cx="3694176" cy="658368"/>
+          </a:xfrm>
+          <a:prstGeom prst="roundRect">
+            <a:avLst/>
+          </a:prstGeom>
+          <a:solidFill>
+            <a:srgbClr val="DDEFFA"/>
+          </a:solidFill>
+          <a:ln>
+            <a:noFill/>
+          </a:ln>
+        </p:spPr>
+      </p:sp>
+      <p:sp>
+        <p:nvSpPr>
+          <p:cNvPr id="19" name="Text 19"/>
+          <p:cNvSpPr txBox="1"/>
+          <p:nvPr/>
+        </p:nvSpPr>
+        <p:spPr>
+          <a:xfrm>
+            <a:off x="4919472" y="2990088"/>
+            <a:ext cx="3401568" cy="566928"/>
+          </a:xfrm>
+          <a:noFill/>
+          <a:ln>
+            <a:noFill/>
+          </a:ln>
+        </p:spPr>
+        <p:txBody>
+          <a:bodyPr wrap="square" lIns="0" rIns="0" tIns="0" bIns="0" anchor="ctr"/>
+          <a:lstStyle/>
+          <a:p>
+            <a:pPr algn="l"/>
+            <a:r>
+              <a:rPr lang="it-IT" sz="1360" b="0" i="0">
                 <a:solidFill>
                   <a:srgbClr val="112642"/>
                 </a:solidFill>
                 <a:latin typeface="Aptos"/>
               </a:rPr>
-              <a:t>Applichiamo lo </a:t>
-            </a:r>
-            <a:r>
-              <a:rPr lang="it-IT" sz="1505" b="0" i="0" dirty="0" err="1">
+              <a:t>Smearing gaussiano per fotoni e protone; il tagger usa una risoluzione FWHM di 16 MeV.</a:t>
+            </a:r>
+          </a:p>
+        </p:txBody>
+      </p:sp>
+      <p:sp>
+        <p:nvSpPr>
+          <p:cNvPr id="20" name="Fill 20"/>
+          <p:cNvSpPr/>
+          <p:nvPr/>
+        </p:nvSpPr>
+        <p:spPr>
+          <a:xfrm>
+            <a:off x="667512" y="3694176"/>
+            <a:ext cx="3657600" cy="658368"/>
+          </a:xfrm>
+          <a:prstGeom prst="roundRect">
+            <a:avLst/>
+          </a:prstGeom>
+          <a:solidFill>
+            <a:srgbClr val="071E42"/>
+          </a:solidFill>
+          <a:ln>
+            <a:noFill/>
+          </a:ln>
+        </p:spPr>
+      </p:sp>
+      <p:sp>
+        <p:nvSpPr>
+          <p:cNvPr id="21" name="Text 21"/>
+          <p:cNvSpPr txBox="1"/>
+          <p:nvPr/>
+        </p:nvSpPr>
+        <p:spPr>
+          <a:xfrm>
+            <a:off x="832104" y="3730752"/>
+            <a:ext cx="3337560" cy="594360"/>
+          </a:xfrm>
+          <a:noFill/>
+          <a:ln>
+            <a:noFill/>
+          </a:ln>
+        </p:spPr>
+        <p:txBody>
+          <a:bodyPr wrap="square" lIns="0" rIns="0" tIns="0" bIns="0" anchor="ctr"/>
+          <a:lstStyle/>
+          <a:p>
+            <a:pPr algn="l"/>
+            <a:r>
+              <a:rPr lang="it-IT" sz="1060" b="0" i="0">
+                <a:solidFill>
+                  <a:srgbClr val="FFFFFF"/>
+                </a:solidFill>
+                <a:latin typeface="Aptos"/>
+              </a:rPr>
+              <a:t>photons_4, event_mask = sample_surviving_photons(</a:t>
+            </a:r>
+          </a:p>
+          <a:p>
+            <a:pPr algn="l"/>
+            <a:r>
+              <a:rPr lang="it-IT" sz="1060" b="0" i="0">
+                <a:solidFill>
+                  <a:srgbClr val="FFFFFF"/>
+                </a:solidFill>
+                <a:latin typeface="Aptos"/>
+              </a:rPr>
+              <a:t>    photons_all, ph_E, ph_theta, rng, params, n_keep=4</a:t>
+            </a:r>
+          </a:p>
+          <a:p>
+            <a:pPr algn="l"/>
+            <a:r>
+              <a:rPr lang="it-IT" sz="1060" b="0" i="0">
+                <a:solidFill>
+                  <a:srgbClr val="FFFFFF"/>
+                </a:solidFill>
+                <a:latin typeface="Aptos"/>
+              </a:rPr>
+              <a:t>)</a:t>
+            </a:r>
+          </a:p>
+        </p:txBody>
+      </p:sp>
+      <p:sp>
+        <p:nvSpPr>
+          <p:cNvPr id="22" name="Text 22"/>
+          <p:cNvSpPr txBox="1"/>
+          <p:nvPr/>
+        </p:nvSpPr>
+        <p:spPr>
+          <a:xfrm>
+            <a:off x="4389120" y="3749040"/>
+            <a:ext cx="338328" cy="530352"/>
+          </a:xfrm>
+          <a:noFill/>
+          <a:ln>
+            <a:noFill/>
+          </a:ln>
+        </p:spPr>
+        <p:txBody>
+          <a:bodyPr wrap="square" lIns="0" rIns="0" tIns="0" bIns="0" anchor="ctr"/>
+          <a:lstStyle/>
+          <a:p>
+            <a:pPr algn="ctr"/>
+            <a:r>
+              <a:rPr lang="it-IT" sz="2236" b="1" i="0">
+                <a:solidFill>
+                  <a:srgbClr val="0B5FA5"/>
+                </a:solidFill>
+                <a:latin typeface="Aptos"/>
+              </a:rPr>
+              <a:t>→</a:t>
+            </a:r>
+          </a:p>
+        </p:txBody>
+      </p:sp>
+      <p:sp>
+        <p:nvSpPr>
+          <p:cNvPr id="23" name="Fill 23"/>
+          <p:cNvSpPr/>
+          <p:nvPr/>
+        </p:nvSpPr>
+        <p:spPr>
+          <a:xfrm>
+            <a:off x="4773168" y="3694176"/>
+            <a:ext cx="3694176" cy="658368"/>
+          </a:xfrm>
+          <a:prstGeom prst="roundRect">
+            <a:avLst/>
+          </a:prstGeom>
+          <a:solidFill>
+            <a:srgbClr val="DDEFFA"/>
+          </a:solidFill>
+          <a:ln>
+            <a:noFill/>
+          </a:ln>
+        </p:spPr>
+      </p:sp>
+      <p:sp>
+        <p:nvSpPr>
+          <p:cNvPr id="24" name="Text 24"/>
+          <p:cNvSpPr txBox="1"/>
+          <p:nvPr/>
+        </p:nvSpPr>
+        <p:spPr>
+          <a:xfrm>
+            <a:off x="4919472" y="3739896"/>
+            <a:ext cx="3401568" cy="566928"/>
+          </a:xfrm>
+          <a:noFill/>
+          <a:ln>
+            <a:noFill/>
+          </a:ln>
+        </p:spPr>
+        <p:txBody>
+          <a:bodyPr wrap="square" lIns="0" rIns="0" tIns="0" bIns="0" anchor="ctr"/>
+          <a:lstStyle/>
+          <a:p>
+            <a:pPr algn="l"/>
+            <a:r>
+              <a:rPr lang="it-IT" sz="1340" b="0" i="0">
                 <a:solidFill>
                   <a:srgbClr val="112642"/>
                 </a:solidFill>
                 <a:latin typeface="Aptos"/>
               </a:rPr>
-              <a:t>smearing</a:t>
-            </a:r>
-            <a:r>
-              <a:rPr lang="it-IT" sz="1505" b="0" i="0" dirty="0">
-                <a:solidFill>
-                  <a:srgbClr val="112642"/>
-                </a:solidFill>
-                <a:latin typeface="Aptos"/>
-              </a:rPr>
-              <a:t> a fotoni, protone e </a:t>
-            </a:r>
-            <a:r>
-              <a:rPr lang="it-IT" sz="1505" b="0" i="0" dirty="0" err="1">
-                <a:solidFill>
-                  <a:srgbClr val="112642"/>
-                </a:solidFill>
-                <a:latin typeface="Aptos"/>
-              </a:rPr>
-              <a:t>tagger</a:t>
-            </a:r>
-            <a:r>
-              <a:rPr lang="it-IT" sz="1505" b="0" i="0" dirty="0">
-                <a:solidFill>
-                  <a:srgbClr val="112642"/>
-                </a:solidFill>
-                <a:latin typeface="Aptos"/>
-              </a:rPr>
-              <a:t> (FWHM 16 MeV), con un'accettanza semplificata. La simulazione non usa il vecchio G3.</a:t>
-            </a:r>
-          </a:p>
-        </p:txBody>
-      </p:sp>
-      <p:sp>
-        <p:nvSpPr>
-          <p:cNvPr id="10" name="Fill 10"/>
+              <a:t>La perdita di fotoni dipende da energia e angolo. Teniamo quattro fotoni osservati, con la stessa procedura per segnale e fondi.</a:t>
+            </a:r>
+          </a:p>
+        </p:txBody>
+      </p:sp>
+      <p:sp>
+        <p:nvSpPr>
+          <p:cNvPr id="25" name="Fill 25"/>
           <p:cNvSpPr/>
           <p:nvPr/>
         </p:nvSpPr>
@@ -11999,7 +12454,7 @@
       </p:sp>
       <p:sp>
         <p:nvSpPr>
-          <p:cNvPr id="11" name="Fill 11"/>
+          <p:cNvPr id="26" name="Fill 26"/>
           <p:cNvSpPr/>
           <p:nvPr/>
         </p:nvSpPr>
@@ -12021,7 +12476,7 @@
       </p:sp>
       <p:sp>
         <p:nvSpPr>
-          <p:cNvPr id="12" name="Text 12"/>
+          <p:cNvPr id="27" name="Text 27"/>
           <p:cNvSpPr txBox="1"/>
           <p:nvPr/>
         </p:nvSpPr>
@@ -12036,7 +12491,7 @@
           </a:ln>
         </p:spPr>
         <p:txBody>
-          <a:bodyPr wrap="square" lIns="0" tIns="0" rIns="0" bIns="0" anchor="ctr"/>
+          <a:bodyPr wrap="square" lIns="0" rIns="0" tIns="0" bIns="0" anchor="ctr"/>
           <a:lstStyle/>
           <a:p>
             <a:pPr algn="l"/>
@@ -12054,7 +12509,7 @@
       </p:sp>
       <p:sp>
         <p:nvSpPr>
-          <p:cNvPr id="13" name="Fill 13"/>
+          <p:cNvPr id="28" name="Fill 28"/>
           <p:cNvSpPr/>
           <p:nvPr/>
         </p:nvSpPr>
@@ -12076,7 +12531,7 @@
       </p:sp>
       <p:sp>
         <p:nvSpPr>
-          <p:cNvPr id="14" name="Fill 14"/>
+          <p:cNvPr id="29" name="Fill 29"/>
           <p:cNvSpPr/>
           <p:nvPr/>
         </p:nvSpPr>
@@ -12098,7 +12553,7 @@
       </p:sp>
       <p:sp>
         <p:nvSpPr>
-          <p:cNvPr id="15" name="Text 15"/>
+          <p:cNvPr id="30" name="Text 30"/>
           <p:cNvSpPr txBox="1"/>
           <p:nvPr/>
         </p:nvSpPr>
@@ -12113,7 +12568,7 @@
           </a:ln>
         </p:spPr>
         <p:txBody>
-          <a:bodyPr wrap="square" lIns="0" tIns="0" rIns="0" bIns="0" anchor="ctr"/>
+          <a:bodyPr wrap="square" lIns="0" rIns="0" tIns="0" bIns="0" anchor="ctr"/>
           <a:lstStyle/>
           <a:p>
             <a:pPr algn="l"/>
@@ -12131,7 +12586,7 @@
       </p:sp>
       <p:sp>
         <p:nvSpPr>
-          <p:cNvPr id="16" name="Text 16"/>
+          <p:cNvPr id="31" name="Text 31"/>
           <p:cNvSpPr txBox="1"/>
           <p:nvPr/>
         </p:nvSpPr>
@@ -12146,7 +12601,7 @@
           </a:ln>
         </p:spPr>
         <p:txBody>
-          <a:bodyPr wrap="square" lIns="0" tIns="0" rIns="0" bIns="0" anchor="ctr"/>
+          <a:bodyPr wrap="square" lIns="0" rIns="0" tIns="0" bIns="0" anchor="ctr"/>
           <a:lstStyle/>
           <a:p>
             <a:pPr algn="r"/>
@@ -12223,7 +12678,7 @@
                 </a:solidFill>
                 <a:latin typeface="Aptos"/>
               </a:rPr>
-              <a:t>Nove canali simulati</a:t>
+              <a:t>Perché questi nove canali</a:t>
             </a:r>
           </a:p>
         </p:txBody>
@@ -12256,7 +12711,7 @@
                 </a:solidFill>
                 <a:latin typeface="Aptos"/>
               </a:rPr>
-              <a:t>Fonte: wiki/physics-channels.md; wiki/03-monte-carlo-simulation.md</a:t>
+              <a:t>Fonte: 00_common/physics/channels.py; generatori MC; 04_bdt_training/photon_loss.py</a:t>
             </a:r>
           </a:p>
         </p:txBody>
@@ -12269,8 +12724,8 @@
         </p:nvSpPr>
         <p:spPr>
           <a:xfrm>
-            <a:off x="685800" y="1060704"/>
-            <a:ext cx="2286000" cy="310896"/>
+            <a:off x="685800" y="950976"/>
+            <a:ext cx="7772400" cy="530352"/>
           </a:xfrm>
           <a:noFill/>
           <a:ln>
@@ -12283,27 +12738,291 @@
           <a:p>
             <a:pPr algn="l"/>
             <a:r>
-              <a:rPr lang="it-IT" sz="1720" b="1" i="0">
+              <a:rPr lang="it-IT" sz="1376" b="0" i="0">
+                <a:solidFill>
+                  <a:srgbClr val="112642"/>
+                </a:solidFill>
+                <a:latin typeface="Aptos"/>
+              </a:rPr>
+              <a:t>Segnale: pηπ⁰ con η → γγ e π⁰ → γγ. Gli altri canali coprono le reazioni che possono produrre quattro fotoni osservati o imitare le masse cercate.</a:t>
+            </a:r>
+          </a:p>
+        </p:txBody>
+      </p:sp>
+      <p:sp>
+        <p:nvSpPr>
+          <p:cNvPr id="5" name="Fill 5"/>
+          <p:cNvSpPr/>
+          <p:nvPr/>
+        </p:nvSpPr>
+        <p:spPr>
+          <a:xfrm>
+            <a:off x="676656" y="1618488"/>
+            <a:ext cx="7790688" cy="694944"/>
+          </a:xfrm>
+          <a:prstGeom prst="roundRect">
+            <a:avLst/>
+          </a:prstGeom>
+          <a:solidFill>
+            <a:srgbClr val="DDEFFA"/>
+          </a:solidFill>
+          <a:ln>
+            <a:noFill/>
+          </a:ln>
+        </p:spPr>
+      </p:sp>
+      <p:sp>
+        <p:nvSpPr>
+          <p:cNvPr id="6" name="Text 6"/>
+          <p:cNvSpPr txBox="1"/>
+          <p:nvPr/>
+        </p:nvSpPr>
+        <p:spPr>
+          <a:xfrm>
+            <a:off x="832104" y="1700784"/>
+            <a:ext cx="2798064" cy="530352"/>
+          </a:xfrm>
+          <a:noFill/>
+          <a:ln>
+            <a:noFill/>
+          </a:ln>
+        </p:spPr>
+        <p:txBody>
+          <a:bodyPr wrap="square" lIns="0" rIns="0" tIns="0" bIns="0" anchor="ctr"/>
+          <a:lstStyle/>
+          <a:p>
+            <a:pPr algn="l"/>
+            <a:r>
+              <a:rPr lang="it-IT" sz="1548" b="1" i="0">
                 <a:solidFill>
                   <a:srgbClr val="0B5FA5"/>
                 </a:solidFill>
                 <a:latin typeface="Aptos"/>
               </a:rPr>
-              <a:t>Segnale</a:t>
-            </a:r>
-          </a:p>
-        </p:txBody>
-      </p:sp>
-      <p:sp>
-        <p:nvSpPr>
-          <p:cNvPr id="5" name="Text 5"/>
-          <p:cNvSpPr txBox="1"/>
-          <p:nvPr/>
-        </p:nvSpPr>
-        <p:spPr>
-          <a:xfrm>
-            <a:off x="685800" y="1417320"/>
-            <a:ext cx="2377440" cy="438912"/>
+              <a:t>π⁰π⁰ · 3π⁰ · 4π⁰</a:t>
+            </a:r>
+          </a:p>
+        </p:txBody>
+      </p:sp>
+      <p:sp>
+        <p:nvSpPr>
+          <p:cNvPr id="7" name="Text 7"/>
+          <p:cNvSpPr txBox="1"/>
+          <p:nvPr/>
+        </p:nvSpPr>
+        <p:spPr>
+          <a:xfrm>
+            <a:off x="3675888" y="1673352"/>
+            <a:ext cx="4626864" cy="585216"/>
+          </a:xfrm>
+          <a:noFill/>
+          <a:ln>
+            <a:noFill/>
+          </a:ln>
+        </p:spPr>
+        <p:txBody>
+          <a:bodyPr wrap="square" lIns="0" rIns="0" tIns="0" bIns="0" anchor="ctr"/>
+          <a:lstStyle/>
+          <a:p>
+            <a:pPr algn="l"/>
+            <a:r>
+              <a:rPr lang="it-IT" sz="1390" b="0" i="0">
+                <a:solidFill>
+                  <a:srgbClr val="112642"/>
+                </a:solidFill>
+                <a:latin typeface="Aptos"/>
+              </a:rPr>
+              <a:t>Il primo produce già quattro fotoni; gli altri ne producono sei o otto e possono apparire come eventi a quattro fotoni quando alcuni sfuggono al rivelatore.</a:t>
+            </a:r>
+          </a:p>
+        </p:txBody>
+      </p:sp>
+      <p:sp>
+        <p:nvSpPr>
+          <p:cNvPr id="8" name="Fill 8"/>
+          <p:cNvSpPr/>
+          <p:nvPr/>
+        </p:nvSpPr>
+        <p:spPr>
+          <a:xfrm>
+            <a:off x="676656" y="2441448"/>
+            <a:ext cx="7790688" cy="777240"/>
+          </a:xfrm>
+          <a:prstGeom prst="roundRect">
+            <a:avLst/>
+          </a:prstGeom>
+          <a:solidFill>
+            <a:srgbClr val="DDEFFA"/>
+          </a:solidFill>
+          <a:ln>
+            <a:noFill/>
+          </a:ln>
+        </p:spPr>
+      </p:sp>
+      <p:sp>
+        <p:nvSpPr>
+          <p:cNvPr id="9" name="Text 9"/>
+          <p:cNvSpPr txBox="1"/>
+          <p:nvPr/>
+        </p:nvSpPr>
+        <p:spPr>
+          <a:xfrm>
+            <a:off x="832104" y="2523744"/>
+            <a:ext cx="2798064" cy="603504"/>
+          </a:xfrm>
+          <a:noFill/>
+          <a:ln>
+            <a:noFill/>
+          </a:ln>
+        </p:spPr>
+        <p:txBody>
+          <a:bodyPr wrap="square" lIns="0" rIns="0" tIns="0" bIns="0" anchor="ctr"/>
+          <a:lstStyle/>
+          <a:p>
+            <a:pPr algn="l"/>
+            <a:r>
+              <a:rPr lang="it-IT" sz="1376" b="1" i="0">
+                <a:solidFill>
+                  <a:srgbClr val="0B5FA5"/>
+                </a:solidFill>
+                <a:latin typeface="Aptos"/>
+              </a:rPr>
+              <a:t>η → 3π⁰ · ηπ⁰ (η → 3π⁰)</a:t>
+            </a:r>
+          </a:p>
+        </p:txBody>
+      </p:sp>
+      <p:sp>
+        <p:nvSpPr>
+          <p:cNvPr id="10" name="Text 10"/>
+          <p:cNvSpPr txBox="1"/>
+          <p:nvPr/>
+        </p:nvSpPr>
+        <p:spPr>
+          <a:xfrm>
+            <a:off x="3675888" y="2496312"/>
+            <a:ext cx="4626864" cy="667512"/>
+          </a:xfrm>
+          <a:noFill/>
+          <a:ln>
+            <a:noFill/>
+          </a:ln>
+        </p:spPr>
+        <p:txBody>
+          <a:bodyPr wrap="square" lIns="0" rIns="0" tIns="0" bIns="0" anchor="ctr"/>
+          <a:lstStyle/>
+          <a:p>
+            <a:pPr algn="l"/>
+            <a:r>
+              <a:rPr lang="it-IT" sz="1370" b="0" i="0">
+                <a:solidFill>
+                  <a:srgbClr val="112642"/>
+                </a:solidFill>
+                <a:latin typeface="Aptos"/>
+              </a:rPr>
+              <a:t>La prima contiene una η reale; la seconda è la reazione del segnale con un diverso decadimento della η. Perdendo fotoni, entrambe possono contaminare il campione.</a:t>
+            </a:r>
+          </a:p>
+        </p:txBody>
+      </p:sp>
+      <p:sp>
+        <p:nvSpPr>
+          <p:cNvPr id="11" name="Fill 11"/>
+          <p:cNvSpPr/>
+          <p:nvPr/>
+        </p:nvSpPr>
+        <p:spPr>
+          <a:xfrm>
+            <a:off x="676656" y="3346704"/>
+            <a:ext cx="7790688" cy="768096"/>
+          </a:xfrm>
+          <a:prstGeom prst="roundRect">
+            <a:avLst/>
+          </a:prstGeom>
+          <a:solidFill>
+            <a:srgbClr val="DDEFFA"/>
+          </a:solidFill>
+          <a:ln>
+            <a:noFill/>
+          </a:ln>
+        </p:spPr>
+      </p:sp>
+      <p:sp>
+        <p:nvSpPr>
+          <p:cNvPr id="12" name="Text 12"/>
+          <p:cNvSpPr txBox="1"/>
+          <p:nvPr/>
+        </p:nvSpPr>
+        <p:spPr>
+          <a:xfrm>
+            <a:off x="832104" y="3429000"/>
+            <a:ext cx="2798064" cy="603504"/>
+          </a:xfrm>
+          <a:noFill/>
+          <a:ln>
+            <a:noFill/>
+          </a:ln>
+        </p:spPr>
+        <p:txBody>
+          <a:bodyPr wrap="square" lIns="0" rIns="0" tIns="0" bIns="0" anchor="ctr"/>
+          <a:lstStyle/>
+          <a:p>
+            <a:pPr algn="l"/>
+            <a:r>
+              <a:rPr lang="it-IT" sz="1479" b="1" i="0">
+                <a:solidFill>
+                  <a:srgbClr val="0B5FA5"/>
+                </a:solidFill>
+                <a:latin typeface="Aptos"/>
+              </a:rPr>
+              <a:t>η2π⁰ · ωπ⁰ · η′</a:t>
+            </a:r>
+          </a:p>
+        </p:txBody>
+      </p:sp>
+      <p:sp>
+        <p:nvSpPr>
+          <p:cNvPr id="13" name="Text 13"/>
+          <p:cNvSpPr txBox="1"/>
+          <p:nvPr/>
+        </p:nvSpPr>
+        <p:spPr>
+          <a:xfrm>
+            <a:off x="3675888" y="3401568"/>
+            <a:ext cx="4626864" cy="658368"/>
+          </a:xfrm>
+          <a:noFill/>
+          <a:ln>
+            <a:noFill/>
+          </a:ln>
+        </p:spPr>
+        <p:txBody>
+          <a:bodyPr wrap="square" lIns="0" rIns="0" tIns="0" bIns="0" anchor="ctr"/>
+          <a:lstStyle/>
+          <a:p>
+            <a:pPr algn="l"/>
+            <a:r>
+              <a:rPr lang="it-IT" sz="1370" b="0" i="0">
+                <a:solidFill>
+                  <a:srgbClr val="112642"/>
+                </a:solidFill>
+                <a:latin typeface="Aptos"/>
+              </a:rPr>
+              <a:t>Producono cinque o sei fotoni; η2π⁰ ed η′ contengono anche una η reale. Le loro soglie sono oltre 1,10 GeV: contribuiscono al catalogo UV, non al VIS.</a:t>
+            </a:r>
+          </a:p>
+        </p:txBody>
+      </p:sp>
+      <p:sp>
+        <p:nvSpPr>
+          <p:cNvPr id="14" name="Text 14"/>
+          <p:cNvSpPr txBox="1"/>
+          <p:nvPr/>
+        </p:nvSpPr>
+        <p:spPr>
+          <a:xfrm>
+            <a:off x="685800" y="4251960"/>
+            <a:ext cx="7781544" cy="283464"/>
           </a:xfrm>
           <a:noFill/>
           <a:ln>
@@ -12316,209 +13035,20 @@
           <a:p>
             <a:pPr algn="l"/>
             <a:r>
-              <a:rPr lang="it-IT" sz="2580" b="1" i="0">
-                <a:solidFill>
-                  <a:srgbClr val="112642"/>
-                </a:solidFill>
-                <a:latin typeface="Aptos"/>
-              </a:rPr>
-              <a:t>ηπ⁰</a:t>
-            </a:r>
-          </a:p>
-        </p:txBody>
-      </p:sp>
-      <p:sp>
-        <p:nvSpPr>
-          <p:cNvPr id="6" name="Text 6"/>
-          <p:cNvSpPr txBox="1"/>
-          <p:nvPr/>
-        </p:nvSpPr>
-        <p:spPr>
-          <a:xfrm>
-            <a:off x="2999232" y="1060704"/>
-            <a:ext cx="5120640" cy="310896"/>
-          </a:xfrm>
-          <a:noFill/>
-          <a:ln>
-            <a:noFill/>
-          </a:ln>
-        </p:spPr>
-        <p:txBody>
-          <a:bodyPr wrap="square" lIns="0" rIns="0" tIns="0" bIns="0" anchor="t"/>
-          <a:lstStyle/>
-          <a:p>
-            <a:pPr algn="l"/>
-            <a:r>
-              <a:rPr lang="it-IT" sz="1720" b="1" i="0">
+              <a:rPr lang="it-IT" sz="1299" b="1" i="0">
                 <a:solidFill>
                   <a:srgbClr val="0B5FA5"/>
                 </a:solidFill>
                 <a:latin typeface="Aptos"/>
               </a:rPr>
-              <a:t>Canali di fondo storici e nuovi</a:t>
-            </a:r>
-          </a:p>
-        </p:txBody>
-      </p:sp>
-      <p:sp>
-        <p:nvSpPr>
-          <p:cNvPr id="7" name="Text 7"/>
-          <p:cNvSpPr txBox="1"/>
-          <p:nvPr/>
-        </p:nvSpPr>
-        <p:spPr>
-          <a:xfrm>
-            <a:off x="2999232" y="1444752"/>
-            <a:ext cx="5303520" cy="1490472"/>
-          </a:xfrm>
-          <a:noFill/>
-          <a:ln>
-            <a:noFill/>
-          </a:ln>
-        </p:spPr>
-        <p:txBody>
-          <a:bodyPr wrap="square" lIns="0" rIns="0" tIns="0" bIns="0" anchor="t"/>
-          <a:lstStyle/>
-          <a:p>
-            <a:pPr algn="l"/>
-            <a:r>
-              <a:rPr lang="it-IT" sz="1720" b="0" i="0">
-                <a:solidFill>
-                  <a:srgbClr val="112642"/>
-                </a:solidFill>
-                <a:latin typeface="Aptos"/>
-              </a:rPr>
-              <a:t>π⁰π⁰    3π⁰    4π⁰</a:t>
-            </a:r>
-          </a:p>
-          <a:p>
-            <a:pPr algn="l"/>
-            <a:r>
-              <a:rPr lang="it-IT" sz="1720" b="0" i="0">
-                <a:solidFill>
-                  <a:srgbClr val="112642"/>
-                </a:solidFill>
-                <a:latin typeface="Aptos"/>
-              </a:rPr>
-              <a:t>η → 3π⁰    ηπ⁰ con η → 3π⁰</a:t>
-            </a:r>
-          </a:p>
-          <a:p>
-            <a:pPr algn="l"/>
-            <a:r>
-              <a:rPr lang="it-IT" sz="1720" b="0" i="0">
-                <a:solidFill>
-                  <a:srgbClr val="112642"/>
-                </a:solidFill>
-                <a:latin typeface="Aptos"/>
-              </a:rPr>
-              <a:t>η2π⁰    ωπ⁰    η′</a:t>
-            </a:r>
-          </a:p>
-        </p:txBody>
-      </p:sp>
-      <p:sp>
-        <p:nvSpPr>
-          <p:cNvPr id="8" name="Text 8"/>
-          <p:cNvSpPr txBox="1"/>
-          <p:nvPr/>
-        </p:nvSpPr>
-        <p:spPr>
-          <a:xfrm>
-            <a:off x="685800" y="3072384"/>
-            <a:ext cx="7680960" cy="365760"/>
-          </a:xfrm>
-          <a:noFill/>
-          <a:ln>
-            <a:noFill/>
-          </a:ln>
-        </p:spPr>
-        <p:txBody>
-          <a:bodyPr wrap="square" lIns="0" rIns="0" tIns="0" bIns="0" anchor="t"/>
-          <a:lstStyle/>
-          <a:p>
-            <a:pPr algn="l"/>
-            <a:r>
-              <a:rPr lang="it-IT" sz="1978" b="1" i="0">
-                <a:solidFill>
-                  <a:srgbClr val="0B5FA5"/>
-                </a:solidFill>
-                <a:latin typeface="Aptos"/>
-              </a:rPr>
-              <a:t>VIS: 6/9 canali</a:t>
-            </a:r>
-          </a:p>
-        </p:txBody>
-      </p:sp>
-      <p:sp>
-        <p:nvSpPr>
-          <p:cNvPr id="9" name="Text 9"/>
-          <p:cNvSpPr txBox="1"/>
-          <p:nvPr/>
-        </p:nvSpPr>
-        <p:spPr>
-          <a:xfrm>
-            <a:off x="685800" y="3502152"/>
-            <a:ext cx="7772400" cy="438912"/>
-          </a:xfrm>
-          <a:noFill/>
-          <a:ln>
-            <a:noFill/>
-          </a:ln>
-        </p:spPr>
-        <p:txBody>
-          <a:bodyPr wrap="square" lIns="0" rIns="0" tIns="0" bIns="0" anchor="t"/>
-          <a:lstStyle/>
-          <a:p>
-            <a:pPr algn="l"/>
-            <a:r>
-              <a:rPr lang="it-IT" sz="1548" b="0" i="0">
-                <a:solidFill>
-                  <a:srgbClr val="112642"/>
-                </a:solidFill>
-                <a:latin typeface="Aptos"/>
-              </a:rPr>
-              <a:t>ηπ⁰, π⁰π⁰, 3π⁰, 4π⁰, η → 3π⁰, ηπ⁰ con η → 3π⁰.</a:t>
-            </a:r>
-          </a:p>
-        </p:txBody>
-      </p:sp>
-      <p:sp>
-        <p:nvSpPr>
-          <p:cNvPr id="10" name="Text 10"/>
-          <p:cNvSpPr txBox="1"/>
-          <p:nvPr/>
-        </p:nvSpPr>
-        <p:spPr>
-          <a:xfrm>
-            <a:off x="685800" y="4078224"/>
-            <a:ext cx="7772400" cy="457200"/>
-          </a:xfrm>
-          <a:noFill/>
-          <a:ln>
-            <a:noFill/>
-          </a:ln>
-        </p:spPr>
-        <p:txBody>
-          <a:bodyPr wrap="square" lIns="0" rIns="0" tIns="0" bIns="0" anchor="t"/>
-          <a:lstStyle/>
-          <a:p>
-            <a:pPr algn="l"/>
-            <a:r>
-              <a:rPr lang="it-IT" sz="1419" b="0" i="0">
-                <a:solidFill>
-                  <a:srgbClr val="52657B"/>
-                </a:solidFill>
-                <a:latin typeface="Aptos"/>
-              </a:rPr>
-              <a:t>Le soglie di η2π⁰, ωπ⁰ ed η′ superano 1,10 GeV. Questi canali restano nel catalogo UV, ma non nel campione VIS.</a:t>
-            </a:r>
-          </a:p>
-        </p:txBody>
-      </p:sp>
-      <p:sp>
-        <p:nvSpPr>
-          <p:cNvPr id="11" name="Fill 11"/>
+              <a:t>Nel VIS restano accessibili 6 dei 9 canali: il segnale e i cinque fondi dei primi due gruppi.</a:t>
+            </a:r>
+          </a:p>
+        </p:txBody>
+      </p:sp>
+      <p:sp>
+        <p:nvSpPr>
+          <p:cNvPr id="15" name="Fill 15"/>
           <p:cNvSpPr/>
           <p:nvPr/>
         </p:nvSpPr>
@@ -12540,7 +13070,7 @@
       </p:sp>
       <p:sp>
         <p:nvSpPr>
-          <p:cNvPr id="12" name="Fill 12"/>
+          <p:cNvPr id="16" name="Fill 16"/>
           <p:cNvSpPr/>
           <p:nvPr/>
         </p:nvSpPr>
@@ -12562,7 +13092,7 @@
       </p:sp>
       <p:sp>
         <p:nvSpPr>
-          <p:cNvPr id="13" name="Text 13"/>
+          <p:cNvPr id="17" name="Text 17"/>
           <p:cNvSpPr txBox="1"/>
           <p:nvPr/>
         </p:nvSpPr>
@@ -12595,7 +13125,7 @@
       </p:sp>
       <p:sp>
         <p:nvSpPr>
-          <p:cNvPr id="14" name="Fill 14"/>
+          <p:cNvPr id="18" name="Fill 18"/>
           <p:cNvSpPr/>
           <p:nvPr/>
         </p:nvSpPr>
@@ -12617,7 +13147,7 @@
       </p:sp>
       <p:sp>
         <p:nvSpPr>
-          <p:cNvPr id="15" name="Fill 15"/>
+          <p:cNvPr id="19" name="Fill 19"/>
           <p:cNvSpPr/>
           <p:nvPr/>
         </p:nvSpPr>
@@ -12639,7 +13169,7 @@
       </p:sp>
       <p:sp>
         <p:nvSpPr>
-          <p:cNvPr id="16" name="Text 16"/>
+          <p:cNvPr id="20" name="Text 20"/>
           <p:cNvSpPr txBox="1"/>
           <p:nvPr/>
         </p:nvSpPr>
@@ -12672,7 +13202,7 @@
       </p:sp>
       <p:sp>
         <p:nvSpPr>
-          <p:cNvPr id="17" name="Text 17"/>
+          <p:cNvPr id="21" name="Text 21"/>
           <p:cNvSpPr txBox="1"/>
           <p:nvPr/>
         </p:nvSpPr>

</xml_diff>

<commit_message>
docs: quantify MC beam and detector response
</commit_message>
<xml_diff>
--- a/presentations/graal_analysis_framework_asimmetrie.pptx
+++ b/presentations/graal_analysis_framework_asimmetrie.pptx
@@ -11936,7 +11936,7 @@
                 </a:solidFill>
                 <a:latin typeface="Aptos"/>
               </a:rPr>
-              <a:t>L'energia parte dalla soglia calcolata con le masse finali. Il limite predefinito è 1,75 GeV; la finestra VIS si ferma a 1,10 GeV.</a:t>
+              <a:t>Estraiamo l'energia uniformemente dalla soglia fisica a 1,75 GeV (limite predefinito); la finestra VIS si ferma a 1,10 GeV.</a:t>
             </a:r>
           </a:p>
         </p:txBody>
@@ -12252,13 +12252,13 @@
           <a:p>
             <a:pPr algn="l"/>
             <a:r>
-              <a:rPr lang="it-IT" sz="1360" b="0" i="0">
+              <a:rPr lang="it-IT" sz="1280" b="0" i="0">
                 <a:solidFill>
                   <a:srgbClr val="112642"/>
                 </a:solidFill>
                 <a:latin typeface="Aptos"/>
               </a:rPr>
-              <a:t>Smearing gaussiano per fotoni e protone; il tagger usa una risoluzione FWHM di 16 MeV.</a:t>
+              <a:t>Per i fotoni assumiamo 10% in energia e 5°/3° negli angoli; per il protone 4% nell'impulso e 3°/2°. Il tagger ha FWHM 16 MeV.</a:t>
             </a:r>
           </a:p>
         </p:txBody>

</xml_diff>

<commit_message>
Update BDT slides with sourced overview and MC results
</commit_message>
<xml_diff>
--- a/presentations/graal_analysis_framework_asimmetrie.pptx
+++ b/presentations/graal_analysis_framework_asimmetrie.pptx
@@ -22,7 +22,6 @@
     <p:sldId id="270" r:id="rId16"/>
     <p:sldId id="271" r:id="rId17"/>
     <p:sldId id="272" r:id="rId18"/>
-    <p:sldId id="273" r:id="rId19"/>
   </p:sldIdLst>
   <p:sldSz cx="9144000" cy="5143500" type="screen16x9"/>
   <p:notesSz cx="6858000" cy="9144000"/>
@@ -3278,7 +3277,7 @@
         <p:spPr>
           <a:xfrm>
             <a:off x="0" y="0"/>
-            <a:ext cx="508000" cy="260604"/>
+            <a:ext cx="537882" cy="260604"/>
           </a:xfrm>
           <a:prstGeom prst="rect">
             <a:avLst/>
@@ -3355,7 +3354,7 @@
         <p:spPr>
           <a:xfrm>
             <a:off x="0" y="4882896"/>
-            <a:ext cx="508000" cy="260604"/>
+            <a:ext cx="537882" cy="260604"/>
           </a:xfrm>
           <a:prstGeom prst="rect">
             <a:avLst/>
@@ -3429,7 +3428,7 @@
                 </a:solidFill>
                 <a:latin typeface="Aptos"/>
               </a:rPr>
-              <a:t>01/18</a:t>
+              <a:t>01/17</a:t>
             </a:r>
           </a:p>
         </p:txBody>
@@ -3495,7 +3494,7 @@
                 </a:solidFill>
                 <a:latin typeface="Aptos"/>
               </a:rPr>
-              <a:t>Risultati del BDT</a:t>
+              <a:t>Calibrazione dei flussi</a:t>
             </a:r>
           </a:p>
         </p:txBody>
@@ -3528,7 +3527,7 @@
                 </a:solidFill>
                 <a:latin typeface="Aptos"/>
               </a:rPr>
-              <a:t>Fonte: results/test_data/uv|vis/bdt/artifacts/stage1/stage1_metrics.txt</a:t>
+              <a:t>Fonte: wiki/06-calibration.md; config/run_manifest.csv</a:t>
             </a:r>
           </a:p>
         </p:txBody>
@@ -3541,8 +3540,8 @@
         </p:nvSpPr>
         <p:spPr>
           <a:xfrm>
-            <a:off x="768096" y="1033272"/>
-            <a:ext cx="3657600" cy="365760"/>
+            <a:off x="694944" y="1060704"/>
+            <a:ext cx="3291840" cy="365760"/>
           </a:xfrm>
           <a:noFill/>
           <a:ln>
@@ -3555,13 +3554,13 @@
           <a:p>
             <a:pPr algn="l"/>
             <a:r>
-              <a:rPr lang="it-IT" sz="1892" b="1" i="0">
+              <a:rPr lang="it-IT" sz="1978" b="1" i="0">
                 <a:solidFill>
                   <a:srgbClr val="0B5FA5"/>
                 </a:solidFill>
                 <a:latin typeface="Aptos"/>
               </a:rPr>
-              <a:t>UV  AUC 0,9975</a:t>
+              <a:t>Run manifest</a:t>
             </a:r>
           </a:p>
         </p:txBody>
@@ -3574,8 +3573,8 @@
         </p:nvSpPr>
         <p:spPr>
           <a:xfrm>
-            <a:off x="4690872" y="1033272"/>
-            <a:ext cx="3657600" cy="365760"/>
+            <a:off x="694944" y="1453896"/>
+            <a:ext cx="7543800" cy="411480"/>
           </a:xfrm>
           <a:noFill/>
           <a:ln>
@@ -3588,65 +3587,83 @@
           <a:p>
             <a:pPr algn="l"/>
             <a:r>
-              <a:rPr lang="it-IT" sz="1892" b="1" i="0">
+              <a:rPr lang="it-IT" sz="1548" b="0" i="0">
+                <a:solidFill>
+                  <a:srgbClr val="112642"/>
+                </a:solidFill>
+                <a:latin typeface="Aptos"/>
+              </a:rPr>
+              <a:t>Il manifest assegna a ogni run il target, la regione UV o VIS e lo stato di polarizzazione.</a:t>
+            </a:r>
+          </a:p>
+        </p:txBody>
+      </p:sp>
+      <p:sp>
+        <p:nvSpPr>
+          <p:cNvPr id="6" name="Text 6"/>
+          <p:cNvSpPr txBox="1"/>
+          <p:nvPr/>
+        </p:nvSpPr>
+        <p:spPr>
+          <a:xfrm>
+            <a:off x="694944" y="2002536"/>
+            <a:ext cx="3840480" cy="365760"/>
+          </a:xfrm>
+          <a:noFill/>
+          <a:ln>
+            <a:noFill/>
+          </a:ln>
+        </p:spPr>
+        <p:txBody>
+          <a:bodyPr wrap="square" lIns="0" rIns="0" tIns="0" bIns="0" anchor="t"/>
+          <a:lstStyle/>
+          <a:p>
+            <a:pPr algn="l"/>
+            <a:r>
+              <a:rPr lang="it-IT" sz="1978" b="1" i="0">
                 <a:solidFill>
                   <a:srgbClr val="0B5FA5"/>
                 </a:solidFill>
                 <a:latin typeface="Aptos"/>
               </a:rPr>
-              <a:t>VIS  AUC 0,9995</a:t>
-            </a:r>
-          </a:p>
-        </p:txBody>
-      </p:sp>
-      <p:pic>
-        <p:nvPicPr>
-          <p:cNvPr id="6" name="roc_uv.png" descr="roc_uv.png"/>
-          <p:cNvPicPr>
-            <a:picLocks noChangeAspect="1" noGrp="1"/>
-          </p:cNvPicPr>
-          <p:nvPr/>
-        </p:nvPicPr>
-        <p:blipFill>
-          <a:blip r:embed="rId2"/>
-          <a:stretch>
-            <a:fillRect/>
-          </a:stretch>
-        </p:blipFill>
-        <p:spPr>
-          <a:xfrm>
-            <a:off x="975360" y="1435608"/>
-            <a:ext cx="3316224" cy="2487168"/>
-          </a:xfrm>
-          <a:prstGeom prst="rect">
-            <a:avLst/>
-          </a:prstGeom>
-        </p:spPr>
-      </p:pic>
-      <p:pic>
-        <p:nvPicPr>
-          <p:cNvPr id="7" name="roc_vis.png" descr="roc_vis.png"/>
-          <p:cNvPicPr>
-            <a:picLocks noChangeAspect="1" noGrp="1"/>
-          </p:cNvPicPr>
-          <p:nvPr/>
-        </p:nvPicPr>
-        <p:blipFill>
-          <a:blip r:embed="rId3"/>
-          <a:stretch>
-            <a:fillRect/>
-          </a:stretch>
-        </p:blipFill>
-        <p:spPr>
-          <a:xfrm>
-            <a:off x="4916424" y="1435608"/>
-            <a:ext cx="3316224" cy="2487168"/>
-          </a:xfrm>
-          <a:prstGeom prst="rect">
-            <a:avLst/>
-          </a:prstGeom>
-        </p:spPr>
-      </p:pic>
+              <a:t>h80 + flux ROOT</a:t>
+            </a:r>
+          </a:p>
+        </p:txBody>
+      </p:sp>
+      <p:sp>
+        <p:nvSpPr>
+          <p:cNvPr id="7" name="Text 7"/>
+          <p:cNvSpPr txBox="1"/>
+          <p:nvPr/>
+        </p:nvSpPr>
+        <p:spPr>
+          <a:xfrm>
+            <a:off x="694944" y="2395728"/>
+            <a:ext cx="7543800" cy="438912"/>
+          </a:xfrm>
+          <a:noFill/>
+          <a:ln>
+            <a:noFill/>
+          </a:ln>
+        </p:spPr>
+        <p:txBody>
+          <a:bodyPr wrap="square" lIns="0" rIns="0" tIns="0" bIns="0" anchor="t"/>
+          <a:lstStyle/>
+          <a:p>
+            <a:pPr algn="l"/>
+            <a:r>
+              <a:rPr lang="it-IT" sz="1548" b="0" i="0">
+                <a:solidFill>
+                  <a:srgbClr val="112642"/>
+                </a:solidFill>
+                <a:latin typeface="Aptos"/>
+              </a:rPr>
+              <a:t>Calibriamo l'energia delle strip 1–128 con la mediana misurata per run e polarizzazione.</a:t>
+            </a:r>
+          </a:p>
+        </p:txBody>
+      </p:sp>
       <p:sp>
         <p:nvSpPr>
           <p:cNvPr id="8" name="Text 8"/>
@@ -3655,8 +3672,8 @@
         </p:nvSpPr>
         <p:spPr>
           <a:xfrm>
-            <a:off x="740664" y="3931920"/>
-            <a:ext cx="3767328" cy="292608"/>
+            <a:off x="694944" y="2971800"/>
+            <a:ext cx="6309360" cy="365760"/>
           </a:xfrm>
           <a:noFill/>
           <a:ln>
@@ -3669,86 +3686,119 @@
           <a:p>
             <a:pPr algn="l"/>
             <a:r>
+              <a:rPr lang="it-IT" sz="1978" b="1" i="0">
+                <a:solidFill>
+                  <a:srgbClr val="0B5FA5"/>
+                </a:solidFill>
+                <a:latin typeface="Aptos"/>
+              </a:rPr>
+              <a:t>POL1 · POL2 · BREM</a:t>
+            </a:r>
+          </a:p>
+        </p:txBody>
+      </p:sp>
+      <p:sp>
+        <p:nvSpPr>
+          <p:cNvPr id="9" name="Text 9"/>
+          <p:cNvSpPr txBox="1"/>
+          <p:nvPr/>
+        </p:nvSpPr>
+        <p:spPr>
+          <a:xfrm>
+            <a:off x="694944" y="3364992"/>
+            <a:ext cx="7543800" cy="411480"/>
+          </a:xfrm>
+          <a:noFill/>
+          <a:ln>
+            <a:noFill/>
+          </a:ln>
+        </p:spPr>
+        <p:txBody>
+          <a:bodyPr wrap="square" lIns="0" rIns="0" tIns="0" bIns="0" anchor="t"/>
+          <a:lstStyle/>
+          <a:p>
+            <a:pPr algn="l"/>
+            <a:r>
+              <a:rPr lang="it-IT" sz="1548" b="0" i="0">
+                <a:solidFill>
+                  <a:srgbClr val="112642"/>
+                </a:solidFill>
+                <a:latin typeface="Aptos"/>
+              </a:rPr>
+              <a:t>Per usare un run servono tutti e tre i flussi. Se ne manca uno, escludiamo il run.</a:t>
+            </a:r>
+          </a:p>
+        </p:txBody>
+      </p:sp>
+      <p:sp>
+        <p:nvSpPr>
+          <p:cNvPr id="10" name="Text 10"/>
+          <p:cNvSpPr txBox="1"/>
+          <p:nvPr/>
+        </p:nvSpPr>
+        <p:spPr>
+          <a:xfrm>
+            <a:off x="694944" y="3968496"/>
+            <a:ext cx="5486400" cy="384048"/>
+          </a:xfrm>
+          <a:noFill/>
+          <a:ln>
+            <a:noFill/>
+          </a:ln>
+        </p:spPr>
+        <p:txBody>
+          <a:bodyPr wrap="square" lIns="0" rIns="0" tIns="0" bIns="0" anchor="t"/>
+          <a:lstStyle/>
+          <a:p>
+            <a:pPr algn="l"/>
+            <a:r>
+              <a:rPr lang="it-IT" sz="2150" b="1" i="0">
+                <a:solidFill>
+                  <a:srgbClr val="0B5FA5"/>
+                </a:solidFill>
+                <a:latin typeface="Aptos"/>
+              </a:rPr>
+              <a:t>flux_calibrated.root</a:t>
+            </a:r>
+          </a:p>
+        </p:txBody>
+      </p:sp>
+      <p:sp>
+        <p:nvSpPr>
+          <p:cNvPr id="11" name="Text 11"/>
+          <p:cNvSpPr txBox="1"/>
+          <p:nvPr/>
+        </p:nvSpPr>
+        <p:spPr>
+          <a:xfrm>
+            <a:off x="694944" y="4343400"/>
+            <a:ext cx="7498080" cy="246888"/>
+          </a:xfrm>
+          <a:noFill/>
+          <a:ln>
+            <a:noFill/>
+          </a:ln>
+        </p:spPr>
+        <p:txBody>
+          <a:bodyPr wrap="square" lIns="0" rIns="0" tIns="0" bIns="0" anchor="t"/>
+          <a:lstStyle/>
+          <a:p>
+            <a:pPr algn="l"/>
+            <a:r>
               <a:rPr lang="it-IT" sz="1376" b="0" i="0">
                 <a:solidFill>
-                  <a:srgbClr val="112642"/>
-                </a:solidFill>
-                <a:latin typeface="Aptos"/>
-              </a:rPr>
-              <a:t>F1 0,9842 · soglia 0,1233</a:t>
-            </a:r>
-          </a:p>
-        </p:txBody>
-      </p:sp>
-      <p:sp>
-        <p:nvSpPr>
-          <p:cNvPr id="9" name="Text 9"/>
-          <p:cNvSpPr txBox="1"/>
-          <p:nvPr/>
-        </p:nvSpPr>
-        <p:spPr>
-          <a:xfrm>
-            <a:off x="4663440" y="3931920"/>
-            <a:ext cx="3767328" cy="292608"/>
-          </a:xfrm>
-          <a:noFill/>
-          <a:ln>
-            <a:noFill/>
-          </a:ln>
-        </p:spPr>
-        <p:txBody>
-          <a:bodyPr wrap="square" lIns="0" rIns="0" tIns="0" bIns="0" anchor="t"/>
-          <a:lstStyle/>
-          <a:p>
-            <a:pPr algn="l"/>
-            <a:r>
-              <a:rPr lang="it-IT" sz="1376" b="0" i="0">
-                <a:solidFill>
-                  <a:srgbClr val="112642"/>
-                </a:solidFill>
-                <a:latin typeface="Aptos"/>
-              </a:rPr>
-              <a:t>F1 0,9956 · soglia 0,0740</a:t>
-            </a:r>
-          </a:p>
-        </p:txBody>
-      </p:sp>
-      <p:sp>
-        <p:nvSpPr>
-          <p:cNvPr id="10" name="Text 10"/>
-          <p:cNvSpPr txBox="1"/>
-          <p:nvPr/>
-        </p:nvSpPr>
-        <p:spPr>
-          <a:xfrm>
-            <a:off x="694944" y="4334256"/>
-            <a:ext cx="7772400" cy="228600"/>
-          </a:xfrm>
-          <a:noFill/>
-          <a:ln>
-            <a:noFill/>
-          </a:ln>
-        </p:spPr>
-        <p:txBody>
-          <a:bodyPr wrap="square" lIns="0" rIns="0" tIns="0" bIns="0" anchor="t"/>
-          <a:lstStyle/>
-          <a:p>
-            <a:pPr algn="l"/>
-            <a:r>
-              <a:rPr lang="it-IT" sz="1450" b="0" i="0">
-                <a:solidFill>
                   <a:srgbClr val="52657B"/>
                 </a:solidFill>
                 <a:latin typeface="Aptos"/>
               </a:rPr>
-              <a:t>Queste metriche vengono dal MC di prova: l'AUC non indica la purezza del campione reale.</a:t>
-            </a:r>
-          </a:p>
-        </p:txBody>
-      </p:sp>
-      <p:sp>
-        <p:nvSpPr>
-          <p:cNvPr id="11" name="Fill 11"/>
+              <a:t>Il file finale conserva gli assi energetici calibrati e viene scritto in modo atomico.</a:t>
+            </a:r>
+          </a:p>
+        </p:txBody>
+      </p:sp>
+      <p:sp>
+        <p:nvSpPr>
+          <p:cNvPr id="12" name="Fill 12"/>
           <p:cNvSpPr/>
           <p:nvPr/>
         </p:nvSpPr>
@@ -3770,14 +3820,14 @@
       </p:sp>
       <p:sp>
         <p:nvSpPr>
-          <p:cNvPr id="12" name="Fill 12"/>
+          <p:cNvPr id="13" name="Fill 13"/>
           <p:cNvSpPr/>
           <p:nvPr/>
         </p:nvSpPr>
         <p:spPr>
           <a:xfrm>
             <a:off x="0" y="0"/>
-            <a:ext cx="5080000" cy="260604"/>
+            <a:ext cx="5378824" cy="260604"/>
           </a:xfrm>
           <a:prstGeom prst="rect">
             <a:avLst/>
@@ -3792,7 +3842,7 @@
       </p:sp>
       <p:sp>
         <p:nvSpPr>
-          <p:cNvPr id="13" name="Text 13"/>
+          <p:cNvPr id="14" name="Text 14"/>
           <p:cNvSpPr txBox="1"/>
           <p:nvPr/>
         </p:nvSpPr>
@@ -3825,7 +3875,7 @@
       </p:sp>
       <p:sp>
         <p:nvSpPr>
-          <p:cNvPr id="14" name="Fill 14"/>
+          <p:cNvPr id="15" name="Fill 15"/>
           <p:cNvSpPr/>
           <p:nvPr/>
         </p:nvSpPr>
@@ -3847,14 +3897,14 @@
       </p:sp>
       <p:sp>
         <p:nvSpPr>
-          <p:cNvPr id="15" name="Fill 15"/>
+          <p:cNvPr id="16" name="Fill 16"/>
           <p:cNvSpPr/>
           <p:nvPr/>
         </p:nvSpPr>
         <p:spPr>
           <a:xfrm>
             <a:off x="0" y="4882896"/>
-            <a:ext cx="5080000" cy="260604"/>
+            <a:ext cx="5378824" cy="260604"/>
           </a:xfrm>
           <a:prstGeom prst="rect">
             <a:avLst/>
@@ -3869,7 +3919,7 @@
       </p:sp>
       <p:sp>
         <p:nvSpPr>
-          <p:cNvPr id="16" name="Text 16"/>
+          <p:cNvPr id="17" name="Text 17"/>
           <p:cNvSpPr txBox="1"/>
           <p:nvPr/>
         </p:nvSpPr>
@@ -3895,14 +3945,14 @@
                 </a:solidFill>
                 <a:latin typeface="Aptos"/>
               </a:rPr>
-              <a:t>BDT</a:t>
-            </a:r>
-          </a:p>
-        </p:txBody>
-      </p:sp>
-      <p:sp>
-        <p:nvSpPr>
-          <p:cNvPr id="17" name="Text 17"/>
+              <a:t>CALIBRAZIONE</a:t>
+            </a:r>
+          </a:p>
+        </p:txBody>
+      </p:sp>
+      <p:sp>
+        <p:nvSpPr>
+          <p:cNvPr id="18" name="Text 18"/>
           <p:cNvSpPr txBox="1"/>
           <p:nvPr/>
         </p:nvSpPr>
@@ -3928,7 +3978,7 @@
                 </a:solidFill>
                 <a:latin typeface="Aptos"/>
               </a:rPr>
-              <a:t>10/18</a:t>
+              <a:t>10/17</a:t>
             </a:r>
           </a:p>
         </p:txBody>
@@ -3994,7 +4044,7 @@
                 </a:solidFill>
                 <a:latin typeface="Aptos"/>
               </a:rPr>
-              <a:t>Calibrazione dei flussi</a:t>
+              <a:t>Estrazione dell'asimmetria</a:t>
             </a:r>
           </a:p>
         </p:txBody>
@@ -4027,7 +4077,7 @@
                 </a:solidFill>
                 <a:latin typeface="Aptos"/>
               </a:rPr>
-              <a:t>Fonte: wiki/06-calibration.md; config/run_manifest.csv</a:t>
+              <a:t>Fonte: wiki/07-beam-asymmetry-estimators.md</a:t>
             </a:r>
           </a:p>
         </p:txBody>
@@ -4040,8 +4090,8 @@
         </p:nvSpPr>
         <p:spPr>
           <a:xfrm>
-            <a:off x="694944" y="1060704"/>
-            <a:ext cx="3291840" cy="365760"/>
+            <a:off x="685800" y="1024128"/>
+            <a:ext cx="1097280" cy="786384"/>
           </a:xfrm>
           <a:noFill/>
           <a:ln>
@@ -4054,13 +4104,13 @@
           <a:p>
             <a:pPr algn="l"/>
             <a:r>
-              <a:rPr lang="it-IT" sz="1978" b="1" i="0">
+              <a:rPr lang="it-IT" sz="5160" b="1" i="0">
                 <a:solidFill>
                   <a:srgbClr val="0B5FA5"/>
                 </a:solidFill>
                 <a:latin typeface="Aptos"/>
               </a:rPr>
-              <a:t>Run manifest</a:t>
+              <a:t>Σ</a:t>
             </a:r>
           </a:p>
         </p:txBody>
@@ -4073,8 +4123,8 @@
         </p:nvSpPr>
         <p:spPr>
           <a:xfrm>
-            <a:off x="694944" y="1453896"/>
-            <a:ext cx="7543800" cy="411480"/>
+            <a:off x="1737360" y="1124712"/>
+            <a:ext cx="6629400" cy="804672"/>
           </a:xfrm>
           <a:noFill/>
           <a:ln>
@@ -4087,13 +4137,13 @@
           <a:p>
             <a:pPr algn="l"/>
             <a:r>
-              <a:rPr lang="it-IT" sz="1548" b="0" i="0">
+              <a:rPr lang="it-IT" sz="1892" b="0" i="0">
                 <a:solidFill>
                   <a:srgbClr val="112642"/>
                 </a:solidFill>
                 <a:latin typeface="Aptos"/>
               </a:rPr>
-              <a:t>Il manifest assegna a ogni run il target, la regione UV o VIS e lo stato di polarizzazione.</a:t>
+              <a:t>Con un fascio polarizzato linearmente, Σ descrive la modulazione azimutale.</a:t>
             </a:r>
           </a:p>
         </p:txBody>
@@ -4106,8 +4156,8 @@
         </p:nvSpPr>
         <p:spPr>
           <a:xfrm>
-            <a:off x="694944" y="2002536"/>
-            <a:ext cx="3840480" cy="365760"/>
+            <a:off x="704088" y="2139696"/>
+            <a:ext cx="7772400" cy="475488"/>
           </a:xfrm>
           <a:noFill/>
           <a:ln>
@@ -4120,13 +4170,13 @@
           <a:p>
             <a:pPr algn="l"/>
             <a:r>
-              <a:rPr lang="it-IT" sz="1978" b="1" i="0">
+              <a:rPr lang="it-IT" sz="2322" b="1" i="0">
                 <a:solidFill>
                   <a:srgbClr val="0B5FA5"/>
                 </a:solidFill>
                 <a:latin typeface="Aptos"/>
               </a:rPr>
-              <a:t>h80 + flux ROOT</a:t>
+              <a:t>R(φ) = (yV − yH) / (PH yV + PV yH)</a:t>
             </a:r>
           </a:p>
         </p:txBody>
@@ -4139,8 +4189,8 @@
         </p:nvSpPr>
         <p:spPr>
           <a:xfrm>
-            <a:off x="694944" y="2395728"/>
-            <a:ext cx="7543800" cy="438912"/>
+            <a:off x="722376" y="2679192"/>
+            <a:ext cx="7589520" cy="365760"/>
           </a:xfrm>
           <a:noFill/>
           <a:ln>
@@ -4153,13 +4203,13 @@
           <a:p>
             <a:pPr algn="l"/>
             <a:r>
-              <a:rPr lang="it-IT" sz="1548" b="0" i="0">
+              <a:rPr lang="it-IT" sz="1806" b="0" i="0">
                 <a:solidFill>
                   <a:srgbClr val="112642"/>
                 </a:solidFill>
                 <a:latin typeface="Aptos"/>
               </a:rPr>
-              <a:t>Calibriamo l'energia delle strip 1–128 con la mediana misurata per run e polarizzazione.</a:t>
+              <a:t>yV = NV / FV       yH = NH / FH</a:t>
             </a:r>
           </a:p>
         </p:txBody>
@@ -4172,8 +4222,8 @@
         </p:nvSpPr>
         <p:spPr>
           <a:xfrm>
-            <a:off x="694944" y="2971800"/>
-            <a:ext cx="6309360" cy="365760"/>
+            <a:off x="713232" y="3282696"/>
+            <a:ext cx="7818120" cy="420624"/>
           </a:xfrm>
           <a:noFill/>
           <a:ln>
@@ -4186,13 +4236,13 @@
           <a:p>
             <a:pPr algn="l"/>
             <a:r>
-              <a:rPr lang="it-IT" sz="1978" b="1" i="0">
-                <a:solidFill>
-                  <a:srgbClr val="0B5FA5"/>
-                </a:solidFill>
-                <a:latin typeface="Aptos"/>
-              </a:rPr>
-              <a:t>POL1 · POL2 · BREM</a:t>
+              <a:rPr lang="it-IT" sz="1720" b="0" i="0">
+                <a:solidFill>
+                  <a:srgbClr val="112642"/>
+                </a:solidFill>
+                <a:latin typeface="Aptos"/>
+              </a:rPr>
+              <a:t>Ricaviamo Σ dalla componente cos(2φ) di R(φ).</a:t>
             </a:r>
           </a:p>
         </p:txBody>
@@ -4205,8 +4255,8 @@
         </p:nvSpPr>
         <p:spPr>
           <a:xfrm>
-            <a:off x="694944" y="3364992"/>
-            <a:ext cx="7543800" cy="411480"/>
+            <a:off x="713232" y="3776472"/>
+            <a:ext cx="7818120" cy="420624"/>
           </a:xfrm>
           <a:noFill/>
           <a:ln>
@@ -4219,13 +4269,13 @@
           <a:p>
             <a:pPr algn="l"/>
             <a:r>
-              <a:rPr lang="it-IT" sz="1548" b="0" i="0">
+              <a:rPr lang="it-IT" sz="1505" b="0" i="0">
                 <a:solidFill>
                   <a:srgbClr val="112642"/>
                 </a:solidFill>
                 <a:latin typeface="Aptos"/>
               </a:rPr>
-              <a:t>Per usare un run servono tutti e tre i flussi. Se ne manca uno, escludiamo il run.</a:t>
+              <a:t>Controlliamo il risultato con una likelihood condizionale e usiamo flussi e polarizzazioni specifici di run e strip.</a:t>
             </a:r>
           </a:p>
         </p:txBody>
@@ -4238,8 +4288,8 @@
         </p:nvSpPr>
         <p:spPr>
           <a:xfrm>
-            <a:off x="694944" y="3968496"/>
-            <a:ext cx="5486400" cy="384048"/>
+            <a:off x="713232" y="4279392"/>
+            <a:ext cx="7818120" cy="256032"/>
           </a:xfrm>
           <a:noFill/>
           <a:ln>
@@ -4252,53 +4302,20 @@
           <a:p>
             <a:pPr algn="l"/>
             <a:r>
-              <a:rPr lang="it-IT" sz="2150" b="1" i="0">
-                <a:solidFill>
-                  <a:srgbClr val="0B5FA5"/>
-                </a:solidFill>
-                <a:latin typeface="Aptos"/>
-              </a:rPr>
-              <a:t>flux_calibrated.root</a:t>
-            </a:r>
-          </a:p>
-        </p:txBody>
-      </p:sp>
-      <p:sp>
-        <p:nvSpPr>
-          <p:cNvPr id="11" name="Text 11"/>
-          <p:cNvSpPr txBox="1"/>
-          <p:nvPr/>
-        </p:nvSpPr>
-        <p:spPr>
-          <a:xfrm>
-            <a:off x="694944" y="4343400"/>
-            <a:ext cx="7498080" cy="246888"/>
-          </a:xfrm>
-          <a:noFill/>
-          <a:ln>
-            <a:noFill/>
-          </a:ln>
-        </p:spPr>
-        <p:txBody>
-          <a:bodyPr wrap="square" lIns="0" rIns="0" tIns="0" bIns="0" anchor="t"/>
-          <a:lstStyle/>
-          <a:p>
-            <a:pPr algn="l"/>
-            <a:r>
-              <a:rPr lang="it-IT" sz="1376" b="0" i="0">
+              <a:rPr lang="it-IT" sz="1333" b="0" i="0">
                 <a:solidFill>
                   <a:srgbClr val="52657B"/>
                 </a:solidFill>
                 <a:latin typeface="Aptos"/>
               </a:rPr>
-              <a:t>Il file finale conserva gli assi energetici calibrati e viene scritto in modo atomico.</a:t>
-            </a:r>
-          </a:p>
-        </p:txBody>
-      </p:sp>
-      <p:sp>
-        <p:nvSpPr>
-          <p:cNvPr id="12" name="Fill 12"/>
+              <a:t>L'analisi usa 12 intervalli in φ e 10 in massa per ciascuno dei tre sottosistemi.</a:t>
+            </a:r>
+          </a:p>
+        </p:txBody>
+      </p:sp>
+      <p:sp>
+        <p:nvSpPr>
+          <p:cNvPr id="11" name="Fill 11"/>
           <p:cNvSpPr/>
           <p:nvPr/>
         </p:nvSpPr>
@@ -4320,14 +4337,14 @@
       </p:sp>
       <p:sp>
         <p:nvSpPr>
-          <p:cNvPr id="13" name="Fill 13"/>
+          <p:cNvPr id="12" name="Fill 12"/>
           <p:cNvSpPr/>
           <p:nvPr/>
         </p:nvSpPr>
         <p:spPr>
           <a:xfrm>
             <a:off x="0" y="0"/>
-            <a:ext cx="5588000" cy="260604"/>
+            <a:ext cx="5916706" cy="260604"/>
           </a:xfrm>
           <a:prstGeom prst="rect">
             <a:avLst/>
@@ -4342,7 +4359,7 @@
       </p:sp>
       <p:sp>
         <p:nvSpPr>
-          <p:cNvPr id="14" name="Text 14"/>
+          <p:cNvPr id="13" name="Text 13"/>
           <p:cNvSpPr txBox="1"/>
           <p:nvPr/>
         </p:nvSpPr>
@@ -4375,7 +4392,7 @@
       </p:sp>
       <p:sp>
         <p:nvSpPr>
-          <p:cNvPr id="15" name="Fill 15"/>
+          <p:cNvPr id="14" name="Fill 14"/>
           <p:cNvSpPr/>
           <p:nvPr/>
         </p:nvSpPr>
@@ -4397,14 +4414,14 @@
       </p:sp>
       <p:sp>
         <p:nvSpPr>
-          <p:cNvPr id="16" name="Fill 16"/>
+          <p:cNvPr id="15" name="Fill 15"/>
           <p:cNvSpPr/>
           <p:nvPr/>
         </p:nvSpPr>
         <p:spPr>
           <a:xfrm>
             <a:off x="0" y="4882896"/>
-            <a:ext cx="5588000" cy="260604"/>
+            <a:ext cx="5916706" cy="260604"/>
           </a:xfrm>
           <a:prstGeom prst="rect">
             <a:avLst/>
@@ -4419,7 +4436,7 @@
       </p:sp>
       <p:sp>
         <p:nvSpPr>
-          <p:cNvPr id="17" name="Text 17"/>
+          <p:cNvPr id="16" name="Text 16"/>
           <p:cNvSpPr txBox="1"/>
           <p:nvPr/>
         </p:nvSpPr>
@@ -4445,14 +4462,14 @@
                 </a:solidFill>
                 <a:latin typeface="Aptos"/>
               </a:rPr>
-              <a:t>CALIBRAZIONE</a:t>
-            </a:r>
-          </a:p>
-        </p:txBody>
-      </p:sp>
-      <p:sp>
-        <p:nvSpPr>
-          <p:cNvPr id="18" name="Text 18"/>
+              <a:t>ASIMMETRIE</a:t>
+            </a:r>
+          </a:p>
+        </p:txBody>
+      </p:sp>
+      <p:sp>
+        <p:nvSpPr>
+          <p:cNvPr id="17" name="Text 17"/>
           <p:cNvSpPr txBox="1"/>
           <p:nvPr/>
         </p:nvSpPr>
@@ -4478,7 +4495,7 @@
                 </a:solidFill>
                 <a:latin typeface="Aptos"/>
               </a:rPr>
-              <a:t>11/18</a:t>
+              <a:t>11/17</a:t>
             </a:r>
           </a:p>
         </p:txBody>
@@ -4544,7 +4561,7 @@
                 </a:solidFill>
                 <a:latin typeface="Aptos"/>
               </a:rPr>
-              <a:t>Estrazione dell'asimmetria</a:t>
+              <a:t>Prime asimmetrie UV</a:t>
             </a:r>
           </a:p>
         </p:txBody>
@@ -4577,7 +4594,7 @@
                 </a:solidFill>
                 <a:latin typeface="Aptos"/>
               </a:rPr>
-              <a:t>Fonte: wiki/07-beam-asymmetry-estimators.md</a:t>
+              <a:t>Fonte: results/test_data/combined/figure4_experimental.pdf; run locale</a:t>
             </a:r>
           </a:p>
         </p:txBody>
@@ -4590,8 +4607,8 @@
         </p:nvSpPr>
         <p:spPr>
           <a:xfrm>
-            <a:off x="685800" y="1024128"/>
-            <a:ext cx="1097280" cy="786384"/>
+            <a:off x="713232" y="1005840"/>
+            <a:ext cx="7726680" cy="347472"/>
           </a:xfrm>
           <a:noFill/>
           <a:ln>
@@ -4604,27 +4621,51 @@
           <a:p>
             <a:pPr algn="l"/>
             <a:r>
-              <a:rPr lang="it-IT" sz="5160" b="1" i="0">
+              <a:rPr lang="it-IT" sz="1634" b="1" i="0">
                 <a:solidFill>
                   <a:srgbClr val="0B5FA5"/>
                 </a:solidFill>
                 <a:latin typeface="Aptos"/>
               </a:rPr>
-              <a:t>Σ</a:t>
-            </a:r>
-          </a:p>
-        </p:txBody>
-      </p:sp>
-      <p:sp>
-        <p:nvSpPr>
-          <p:cNvPr id="5" name="Text 5"/>
-          <p:cNvSpPr txBox="1"/>
-          <p:nvPr/>
-        </p:nvSpPr>
-        <p:spPr>
-          <a:xfrm>
-            <a:off x="1737360" y="1124712"/>
-            <a:ext cx="6629400" cy="804672"/>
+              <a:t>1,30–1,40 GeV · pπ⁰, pη, ηπ⁰</a:t>
+            </a:r>
+          </a:p>
+        </p:txBody>
+      </p:sp>
+      <p:pic>
+        <p:nvPicPr>
+          <p:cNvPr id="5" name="sigma_uv.png" descr="sigma_uv.png"/>
+          <p:cNvPicPr>
+            <a:picLocks noChangeAspect="1" noGrp="1"/>
+          </p:cNvPicPr>
+          <p:nvPr/>
+        </p:nvPicPr>
+        <p:blipFill>
+          <a:blip r:embed="rId2"/>
+          <a:stretch>
+            <a:fillRect/>
+          </a:stretch>
+        </p:blipFill>
+        <p:spPr>
+          <a:xfrm>
+            <a:off x="493776" y="1529116"/>
+            <a:ext cx="8211312" cy="2208711"/>
+          </a:xfrm>
+          <a:prstGeom prst="rect">
+            <a:avLst/>
+          </a:prstGeom>
+        </p:spPr>
+      </p:pic>
+      <p:sp>
+        <p:nvSpPr>
+          <p:cNvPr id="6" name="Text 6"/>
+          <p:cNvSpPr txBox="1"/>
+          <p:nvPr/>
+        </p:nvSpPr>
+        <p:spPr>
+          <a:xfrm>
+            <a:off x="713232" y="4050792"/>
+            <a:ext cx="7726680" cy="484632"/>
           </a:xfrm>
           <a:noFill/>
           <a:ln>
@@ -4637,185 +4678,20 @@
           <a:p>
             <a:pPr algn="l"/>
             <a:r>
-              <a:rPr lang="it-IT" sz="1892" b="0" i="0">
+              <a:rPr lang="it-IT" sz="1462" b="0" i="0">
                 <a:solidFill>
                   <a:srgbClr val="112642"/>
                 </a:solidFill>
                 <a:latin typeface="Aptos"/>
               </a:rPr>
-              <a:t>Con un fascio polarizzato linearmente, Σ descrive la modulazione azimutale.</a:t>
-            </a:r>
-          </a:p>
-        </p:txBody>
-      </p:sp>
-      <p:sp>
-        <p:nvSpPr>
-          <p:cNvPr id="6" name="Text 6"/>
-          <p:cNvSpPr txBox="1"/>
-          <p:nvPr/>
-        </p:nvSpPr>
-        <p:spPr>
-          <a:xfrm>
-            <a:off x="704088" y="2139696"/>
-            <a:ext cx="7772400" cy="475488"/>
-          </a:xfrm>
-          <a:noFill/>
-          <a:ln>
-            <a:noFill/>
-          </a:ln>
-        </p:spPr>
-        <p:txBody>
-          <a:bodyPr wrap="square" lIns="0" rIns="0" tIns="0" bIns="0" anchor="t"/>
-          <a:lstStyle/>
-          <a:p>
-            <a:pPr algn="l"/>
-            <a:r>
-              <a:rPr lang="it-IT" sz="2322" b="1" i="0">
-                <a:solidFill>
-                  <a:srgbClr val="0B5FA5"/>
-                </a:solidFill>
-                <a:latin typeface="Aptos"/>
-              </a:rPr>
-              <a:t>R(φ) = (yV − yH) / (PH yV + PV yH)</a:t>
-            </a:r>
-          </a:p>
-        </p:txBody>
-      </p:sp>
-      <p:sp>
-        <p:nvSpPr>
-          <p:cNvPr id="7" name="Text 7"/>
-          <p:cNvSpPr txBox="1"/>
-          <p:nvPr/>
-        </p:nvSpPr>
-        <p:spPr>
-          <a:xfrm>
-            <a:off x="722376" y="2679192"/>
-            <a:ext cx="7589520" cy="365760"/>
-          </a:xfrm>
-          <a:noFill/>
-          <a:ln>
-            <a:noFill/>
-          </a:ln>
-        </p:spPr>
-        <p:txBody>
-          <a:bodyPr wrap="square" lIns="0" rIns="0" tIns="0" bIns="0" anchor="t"/>
-          <a:lstStyle/>
-          <a:p>
-            <a:pPr algn="l"/>
-            <a:r>
-              <a:rPr lang="it-IT" sz="1806" b="0" i="0">
-                <a:solidFill>
-                  <a:srgbClr val="112642"/>
-                </a:solidFill>
-                <a:latin typeface="Aptos"/>
-              </a:rPr>
-              <a:t>yV = NV / FV       yH = NH / FH</a:t>
-            </a:r>
-          </a:p>
-        </p:txBody>
-      </p:sp>
-      <p:sp>
-        <p:nvSpPr>
-          <p:cNvPr id="8" name="Text 8"/>
-          <p:cNvSpPr txBox="1"/>
-          <p:nvPr/>
-        </p:nvSpPr>
-        <p:spPr>
-          <a:xfrm>
-            <a:off x="713232" y="3282696"/>
-            <a:ext cx="7818120" cy="420624"/>
-          </a:xfrm>
-          <a:noFill/>
-          <a:ln>
-            <a:noFill/>
-          </a:ln>
-        </p:spPr>
-        <p:txBody>
-          <a:bodyPr wrap="square" lIns="0" rIns="0" tIns="0" bIns="0" anchor="t"/>
-          <a:lstStyle/>
-          <a:p>
-            <a:pPr algn="l"/>
-            <a:r>
-              <a:rPr lang="it-IT" sz="1720" b="0" i="0">
-                <a:solidFill>
-                  <a:srgbClr val="112642"/>
-                </a:solidFill>
-                <a:latin typeface="Aptos"/>
-              </a:rPr>
-              <a:t>Ricaviamo Σ dalla componente cos(2φ) di R(φ).</a:t>
-            </a:r>
-          </a:p>
-        </p:txBody>
-      </p:sp>
-      <p:sp>
-        <p:nvSpPr>
-          <p:cNvPr id="9" name="Text 9"/>
-          <p:cNvSpPr txBox="1"/>
-          <p:nvPr/>
-        </p:nvSpPr>
-        <p:spPr>
-          <a:xfrm>
-            <a:off x="713232" y="3776472"/>
-            <a:ext cx="7818120" cy="420624"/>
-          </a:xfrm>
-          <a:noFill/>
-          <a:ln>
-            <a:noFill/>
-          </a:ln>
-        </p:spPr>
-        <p:txBody>
-          <a:bodyPr wrap="square" lIns="0" rIns="0" tIns="0" bIns="0" anchor="t"/>
-          <a:lstStyle/>
-          <a:p>
-            <a:pPr algn="l"/>
-            <a:r>
-              <a:rPr lang="it-IT" sz="1505" b="0" i="0">
-                <a:solidFill>
-                  <a:srgbClr val="112642"/>
-                </a:solidFill>
-                <a:latin typeface="Aptos"/>
-              </a:rPr>
-              <a:t>Controlliamo il risultato con una likelihood condizionale e usiamo flussi e polarizzazioni specifici di run e strip.</a:t>
-            </a:r>
-          </a:p>
-        </p:txBody>
-      </p:sp>
-      <p:sp>
-        <p:nvSpPr>
-          <p:cNvPr id="10" name="Text 10"/>
-          <p:cNvSpPr txBox="1"/>
-          <p:nvPr/>
-        </p:nvSpPr>
-        <p:spPr>
-          <a:xfrm>
-            <a:off x="713232" y="4279392"/>
-            <a:ext cx="7818120" cy="256032"/>
-          </a:xfrm>
-          <a:noFill/>
-          <a:ln>
-            <a:noFill/>
-          </a:ln>
-        </p:spPr>
-        <p:txBody>
-          <a:bodyPr wrap="square" lIns="0" rIns="0" tIns="0" bIns="0" anchor="t"/>
-          <a:lstStyle/>
-          <a:p>
-            <a:pPr algn="l"/>
-            <a:r>
-              <a:rPr lang="it-IT" sz="1333" b="0" i="0">
-                <a:solidFill>
-                  <a:srgbClr val="52657B"/>
-                </a:solidFill>
-                <a:latin typeface="Aptos"/>
-              </a:rPr>
-              <a:t>L'analisi usa 12 intervalli in φ e 10 in massa per ciascuno dei tre sottosistemi.</a:t>
-            </a:r>
-          </a:p>
-        </p:txBody>
-      </p:sp>
-      <p:sp>
-        <p:nvSpPr>
-          <p:cNvPr id="11" name="Fill 11"/>
+              <a:t>Nel sottosistema pη osserviamo valori negativi in diversi intervalli di massa. La figura mostra solo gli errori statistici.</a:t>
+            </a:r>
+          </a:p>
+        </p:txBody>
+      </p:sp>
+      <p:sp>
+        <p:nvSpPr>
+          <p:cNvPr id="7" name="Fill 7"/>
           <p:cNvSpPr/>
           <p:nvPr/>
         </p:nvSpPr>
@@ -4837,14 +4713,14 @@
       </p:sp>
       <p:sp>
         <p:nvSpPr>
-          <p:cNvPr id="12" name="Fill 12"/>
+          <p:cNvPr id="8" name="Fill 8"/>
           <p:cNvSpPr/>
           <p:nvPr/>
         </p:nvSpPr>
         <p:spPr>
           <a:xfrm>
             <a:off x="0" y="0"/>
-            <a:ext cx="6096000" cy="260604"/>
+            <a:ext cx="6454588" cy="260604"/>
           </a:xfrm>
           <a:prstGeom prst="rect">
             <a:avLst/>
@@ -4859,7 +4735,7 @@
       </p:sp>
       <p:sp>
         <p:nvSpPr>
-          <p:cNvPr id="13" name="Text 13"/>
+          <p:cNvPr id="9" name="Text 9"/>
           <p:cNvSpPr txBox="1"/>
           <p:nvPr/>
         </p:nvSpPr>
@@ -4892,7 +4768,7 @@
       </p:sp>
       <p:sp>
         <p:nvSpPr>
-          <p:cNvPr id="14" name="Fill 14"/>
+          <p:cNvPr id="10" name="Fill 10"/>
           <p:cNvSpPr/>
           <p:nvPr/>
         </p:nvSpPr>
@@ -4914,14 +4790,14 @@
       </p:sp>
       <p:sp>
         <p:nvSpPr>
-          <p:cNvPr id="15" name="Fill 15"/>
+          <p:cNvPr id="11" name="Fill 11"/>
           <p:cNvSpPr/>
           <p:nvPr/>
         </p:nvSpPr>
         <p:spPr>
           <a:xfrm>
             <a:off x="0" y="4882896"/>
-            <a:ext cx="6096000" cy="260604"/>
+            <a:ext cx="6454588" cy="260604"/>
           </a:xfrm>
           <a:prstGeom prst="rect">
             <a:avLst/>
@@ -4936,7 +4812,7 @@
       </p:sp>
       <p:sp>
         <p:nvSpPr>
-          <p:cNvPr id="16" name="Text 16"/>
+          <p:cNvPr id="12" name="Text 12"/>
           <p:cNvSpPr txBox="1"/>
           <p:nvPr/>
         </p:nvSpPr>
@@ -4962,14 +4838,14 @@
                 </a:solidFill>
                 <a:latin typeface="Aptos"/>
               </a:rPr>
-              <a:t>ASIMMETRIE</a:t>
-            </a:r>
-          </a:p>
-        </p:txBody>
-      </p:sp>
-      <p:sp>
-        <p:nvSpPr>
-          <p:cNvPr id="17" name="Text 17"/>
+              <a:t>RISULTATI</a:t>
+            </a:r>
+          </a:p>
+        </p:txBody>
+      </p:sp>
+      <p:sp>
+        <p:nvSpPr>
+          <p:cNvPr id="13" name="Text 13"/>
           <p:cNvSpPr txBox="1"/>
           <p:nvPr/>
         </p:nvSpPr>
@@ -4995,7 +4871,7 @@
                 </a:solidFill>
                 <a:latin typeface="Aptos"/>
               </a:rPr>
-              <a:t>12/18</a:t>
+              <a:t>12/17</a:t>
             </a:r>
           </a:p>
         </p:txBody>
@@ -5061,7 +4937,7 @@
                 </a:solidFill>
                 <a:latin typeface="Aptos"/>
               </a:rPr>
-              <a:t>Prime asimmetrie UV</a:t>
+              <a:t>Confronto con Ajaka</a:t>
             </a:r>
           </a:p>
         </p:txBody>
@@ -5094,7 +4970,7 @@
                 </a:solidFill>
                 <a:latin typeface="Aptos"/>
               </a:rPr>
-              <a:t>Fonte: results/test_data/combined/figure4_experimental.pdf; run locale</a:t>
+              <a:t>Fonte: Ajaka et al. (2008); digitizzazione versionata; run locale</a:t>
             </a:r>
           </a:p>
         </p:txBody>
@@ -5107,8 +4983,8 @@
         </p:nvSpPr>
         <p:spPr>
           <a:xfrm>
-            <a:off x="713232" y="1005840"/>
-            <a:ext cx="7726680" cy="347472"/>
+            <a:off x="704088" y="996696"/>
+            <a:ext cx="7772400" cy="347472"/>
           </a:xfrm>
           <a:noFill/>
           <a:ln>
@@ -5121,20 +4997,20 @@
           <a:p>
             <a:pPr algn="l"/>
             <a:r>
-              <a:rPr lang="it-IT" sz="1634" b="1" i="0">
+              <a:rPr lang="it-IT" sz="1548" b="1" i="0">
                 <a:solidFill>
                   <a:srgbClr val="0B5FA5"/>
                 </a:solidFill>
                 <a:latin typeface="Aptos"/>
               </a:rPr>
-              <a:t>1,30–1,40 GeV · pπ⁰, pη, ηπ⁰</a:t>
+              <a:t>Tra 1,40 e 1,50 GeV: questa analisi in nero, Ajaka et al. in rosso</a:t>
             </a:r>
           </a:p>
         </p:txBody>
       </p:sp>
       <p:pic>
         <p:nvPicPr>
-          <p:cNvPr id="5" name="sigma_uv.png" descr="sigma_uv.png"/>
+          <p:cNvPr id="5" name="ajaka_uv.png" descr="ajaka_uv.png"/>
           <p:cNvPicPr>
             <a:picLocks noChangeAspect="1" noGrp="1"/>
           </p:cNvPicPr>
@@ -5148,8 +5024,8 @@
         </p:blipFill>
         <p:spPr>
           <a:xfrm>
-            <a:off x="493776" y="1529116"/>
-            <a:ext cx="8211312" cy="2208711"/>
+            <a:off x="493776" y="1486858"/>
+            <a:ext cx="8211312" cy="2265795"/>
           </a:xfrm>
           <a:prstGeom prst="rect">
             <a:avLst/>
@@ -5164,8 +5040,8 @@
         </p:nvSpPr>
         <p:spPr>
           <a:xfrm>
-            <a:off x="713232" y="4050792"/>
-            <a:ext cx="7726680" cy="484632"/>
+            <a:off x="704088" y="4041648"/>
+            <a:ext cx="7754112" cy="493776"/>
           </a:xfrm>
           <a:noFill/>
           <a:ln>
@@ -5178,13 +5054,13 @@
           <a:p>
             <a:pPr algn="l"/>
             <a:r>
-              <a:rPr lang="it-IT" sz="1462" b="0" i="0">
+              <a:rPr lang="it-IT" sz="1419" b="0" i="0">
                 <a:solidFill>
                   <a:srgbClr val="112642"/>
                 </a:solidFill>
                 <a:latin typeface="Aptos"/>
               </a:rPr>
-              <a:t>Nel sottosistema pη osserviamo valori negativi in diversi intervalli di massa. La figura mostra solo gli errori statistici.</a:t>
+              <a:t>L'accordo cambia con la massa e con il sottosistema. Servono ancora controlli sistematici prima di trarre conclusioni quantitative.</a:t>
             </a:r>
           </a:p>
         </p:txBody>
@@ -5220,7 +5096,7 @@
         <p:spPr>
           <a:xfrm>
             <a:off x="0" y="0"/>
-            <a:ext cx="6604000" cy="260604"/>
+            <a:ext cx="6992471" cy="260604"/>
           </a:xfrm>
           <a:prstGeom prst="rect">
             <a:avLst/>
@@ -5297,7 +5173,7 @@
         <p:spPr>
           <a:xfrm>
             <a:off x="0" y="4882896"/>
-            <a:ext cx="6604000" cy="260604"/>
+            <a:ext cx="6992471" cy="260604"/>
           </a:xfrm>
           <a:prstGeom prst="rect">
             <a:avLst/>
@@ -5371,7 +5247,7 @@
                 </a:solidFill>
                 <a:latin typeface="Aptos"/>
               </a:rPr>
-              <a:t>13/18</a:t>
+              <a:t>13/17</a:t>
             </a:r>
           </a:p>
         </p:txBody>
@@ -5437,7 +5313,7 @@
                 </a:solidFill>
                 <a:latin typeface="Aptos"/>
               </a:rPr>
-              <a:t>Confronto con Ajaka</a:t>
+              <a:t>VIS vicino alla soglia</a:t>
             </a:r>
           </a:p>
         </p:txBody>
@@ -5470,7 +5346,7 @@
                 </a:solidFill>
                 <a:latin typeface="Aptos"/>
               </a:rPr>
-              <a:t>Fonte: Ajaka et al. (2008); digitizzazione versionata; run locale</a:t>
+              <a:t>Fonte: results/test_data/combined/figure4_experimental.pdf; run locale</a:t>
             </a:r>
           </a:p>
         </p:txBody>
@@ -5483,8 +5359,8 @@
         </p:nvSpPr>
         <p:spPr>
           <a:xfrm>
-            <a:off x="704088" y="996696"/>
-            <a:ext cx="7772400" cy="347472"/>
+            <a:off x="713232" y="987552"/>
+            <a:ext cx="7772400" cy="438912"/>
           </a:xfrm>
           <a:noFill/>
           <a:ln>
@@ -5497,20 +5373,20 @@
           <a:p>
             <a:pPr algn="l"/>
             <a:r>
-              <a:rPr lang="it-IT" sz="1548" b="1" i="0">
+              <a:rPr lang="it-IT" sz="1720" b="1" i="0">
                 <a:solidFill>
                   <a:srgbClr val="0B5FA5"/>
                 </a:solidFill>
                 <a:latin typeface="Aptos"/>
               </a:rPr>
-              <a:t>Tra 1,40 e 1,50 GeV: questa analisi in nero, Ajaka et al. in rosso</a:t>
+              <a:t>Abbiamo esteso la figura combinata alla regione 0,9313–1,10 GeV</a:t>
             </a:r>
           </a:p>
         </p:txBody>
       </p:sp>
       <p:pic>
         <p:nvPicPr>
-          <p:cNvPr id="5" name="ajaka_uv.png" descr="ajaka_uv.png"/>
+          <p:cNvPr id="5" name="sigma_vis.png" descr="sigma_vis.png"/>
           <p:cNvPicPr>
             <a:picLocks noChangeAspect="1" noGrp="1"/>
           </p:cNvPicPr>
@@ -5524,8 +5400,8 @@
         </p:blipFill>
         <p:spPr>
           <a:xfrm>
-            <a:off x="493776" y="1486858"/>
-            <a:ext cx="8211312" cy="2265795"/>
+            <a:off x="493776" y="1570264"/>
+            <a:ext cx="8211312" cy="2208711"/>
           </a:xfrm>
           <a:prstGeom prst="rect">
             <a:avLst/>
@@ -5540,8 +5416,8 @@
         </p:nvSpPr>
         <p:spPr>
           <a:xfrm>
-            <a:off x="704088" y="4041648"/>
-            <a:ext cx="7754112" cy="493776"/>
+            <a:off x="713232" y="4069080"/>
+            <a:ext cx="7726680" cy="466344"/>
           </a:xfrm>
           <a:noFill/>
           <a:ln>
@@ -5560,7 +5436,7 @@
                 </a:solidFill>
                 <a:latin typeface="Aptos"/>
               </a:rPr>
-              <a:t>L'accordo cambia con la massa e con il sottosistema. Servono ancora controlli sistematici prima di trarre conclusioni quantitative.</a:t>
+              <a:t>Nel campione VIS, Σ tende a valori negativi per pη e diventa positiva in alcuni intervalli di ηπ⁰. Il risultato è preliminare.</a:t>
             </a:r>
           </a:p>
         </p:txBody>
@@ -5596,7 +5472,7 @@
         <p:spPr>
           <a:xfrm>
             <a:off x="0" y="0"/>
-            <a:ext cx="7112000" cy="260604"/>
+            <a:ext cx="7530353" cy="260604"/>
           </a:xfrm>
           <a:prstGeom prst="rect">
             <a:avLst/>
@@ -5673,7 +5549,7 @@
         <p:spPr>
           <a:xfrm>
             <a:off x="0" y="4882896"/>
-            <a:ext cx="7112000" cy="260604"/>
+            <a:ext cx="7530353" cy="260604"/>
           </a:xfrm>
           <a:prstGeom prst="rect">
             <a:avLst/>
@@ -5747,7 +5623,7 @@
                 </a:solidFill>
                 <a:latin typeface="Aptos"/>
               </a:rPr>
-              <a:t>14/18</a:t>
+              <a:t>14/17</a:t>
             </a:r>
           </a:p>
         </p:txBody>
@@ -5813,7 +5689,7 @@
                 </a:solidFill>
                 <a:latin typeface="Aptos"/>
               </a:rPr>
-              <a:t>VIS vicino alla soglia</a:t>
+              <a:t>Perché il VIS è interessante</a:t>
             </a:r>
           </a:p>
         </p:txBody>
@@ -5846,7 +5722,7 @@
                 </a:solidFill>
                 <a:latin typeface="Aptos"/>
               </a:rPr>
-              <a:t>Fonte: results/test_data/combined/figure4_experimental.pdf; run locale</a:t>
+              <a:t>Fonte: wiki/compton-beam-and-polarization.md; ipotesi da verificare</a:t>
             </a:r>
           </a:p>
         </p:txBody>
@@ -5859,8 +5735,8 @@
         </p:nvSpPr>
         <p:spPr>
           <a:xfrm>
-            <a:off x="713232" y="987552"/>
-            <a:ext cx="7772400" cy="438912"/>
+            <a:off x="694944" y="1069848"/>
+            <a:ext cx="3977640" cy="393192"/>
           </a:xfrm>
           <a:noFill/>
           <a:ln>
@@ -5873,20 +5749,152 @@
           <a:p>
             <a:pPr algn="l"/>
             <a:r>
-              <a:rPr lang="it-IT" sz="1720" b="1" i="0">
+              <a:rPr lang="it-IT" sz="1978" b="1" i="0">
                 <a:solidFill>
                   <a:srgbClr val="0B5FA5"/>
                 </a:solidFill>
                 <a:latin typeface="Aptos"/>
               </a:rPr>
-              <a:t>Abbiamo esteso la figura combinata alla regione 0,9313–1,10 GeV</a:t>
+              <a:t>VIS: polarizzazione alta</a:t>
+            </a:r>
+          </a:p>
+        </p:txBody>
+      </p:sp>
+      <p:sp>
+        <p:nvSpPr>
+          <p:cNvPr id="5" name="Text 5"/>
+          <p:cNvSpPr txBox="1"/>
+          <p:nvPr/>
+        </p:nvSpPr>
+        <p:spPr>
+          <a:xfrm>
+            <a:off x="694944" y="1517904"/>
+            <a:ext cx="3813048" cy="960120"/>
+          </a:xfrm>
+          <a:noFill/>
+          <a:ln>
+            <a:noFill/>
+          </a:ln>
+        </p:spPr>
+        <p:txBody>
+          <a:bodyPr wrap="square" lIns="0" rIns="0" tIns="0" bIns="0" anchor="t"/>
+          <a:lstStyle/>
+          <a:p>
+            <a:pPr algn="l"/>
+            <a:r>
+              <a:rPr lang="it-IT" sz="1505" b="0" i="0">
+                <a:solidFill>
+                  <a:srgbClr val="112642"/>
+                </a:solidFill>
+                <a:latin typeface="Aptos"/>
+              </a:rPr>
+              <a:t>Con il laser a 514 nm, la polarizzazione si avvicina al 100% al bordo Compton. Nella regione VIS dipende dall'energia del fotone.</a:t>
+            </a:r>
+          </a:p>
+        </p:txBody>
+      </p:sp>
+      <p:sp>
+        <p:nvSpPr>
+          <p:cNvPr id="6" name="Text 6"/>
+          <p:cNvSpPr txBox="1"/>
+          <p:nvPr/>
+        </p:nvSpPr>
+        <p:spPr>
+          <a:xfrm>
+            <a:off x="694944" y="2734056"/>
+            <a:ext cx="3749040" cy="347472"/>
+          </a:xfrm>
+          <a:noFill/>
+          <a:ln>
+            <a:noFill/>
+          </a:ln>
+        </p:spPr>
+        <p:txBody>
+          <a:bodyPr wrap="square" lIns="0" rIns="0" tIns="0" bIns="0" anchor="t"/>
+          <a:lstStyle/>
+          <a:p>
+            <a:pPr algn="l"/>
+            <a:r>
+              <a:rPr lang="it-IT" sz="1892" b="1" i="0">
+                <a:solidFill>
+                  <a:srgbClr val="0B5FA5"/>
+                </a:solidFill>
+                <a:latin typeface="Aptos"/>
+              </a:rPr>
+              <a:t>Ipotesi fisica</a:t>
+            </a:r>
+          </a:p>
+        </p:txBody>
+      </p:sp>
+      <p:sp>
+        <p:nvSpPr>
+          <p:cNvPr id="7" name="Text 7"/>
+          <p:cNvSpPr txBox="1"/>
+          <p:nvPr/>
+        </p:nvSpPr>
+        <p:spPr>
+          <a:xfrm>
+            <a:off x="694944" y="3118104"/>
+            <a:ext cx="3822192" cy="969264"/>
+          </a:xfrm>
+          <a:noFill/>
+          <a:ln>
+            <a:noFill/>
+          </a:ln>
+        </p:spPr>
+        <p:txBody>
+          <a:bodyPr wrap="square" lIns="0" rIns="0" tIns="0" bIns="0" anchor="t"/>
+          <a:lstStyle/>
+          <a:p>
+            <a:pPr algn="l"/>
+            <a:r>
+              <a:rPr lang="it-IT" sz="1505" b="0" i="0">
+                <a:solidFill>
+                  <a:srgbClr val="112642"/>
+                </a:solidFill>
+                <a:latin typeface="Aptos"/>
+              </a:rPr>
+              <a:t>Anche vicino alla soglia, le code di risonanze ampie e intense possono interferire tra loro e produrre un'asimmetria che varia con la massa.</a:t>
+            </a:r>
+          </a:p>
+        </p:txBody>
+      </p:sp>
+      <p:sp>
+        <p:nvSpPr>
+          <p:cNvPr id="8" name="Text 8"/>
+          <p:cNvSpPr txBox="1"/>
+          <p:nvPr/>
+        </p:nvSpPr>
+        <p:spPr>
+          <a:xfrm>
+            <a:off x="694944" y="4187952"/>
+            <a:ext cx="3813048" cy="365760"/>
+          </a:xfrm>
+          <a:noFill/>
+          <a:ln>
+            <a:noFill/>
+          </a:ln>
+        </p:spPr>
+        <p:txBody>
+          <a:bodyPr wrap="square" lIns="0" rIns="0" tIns="0" bIns="0" anchor="t"/>
+          <a:lstStyle/>
+          <a:p>
+            <a:pPr algn="l"/>
+            <a:r>
+              <a:rPr lang="it-IT" sz="1333" b="0" i="0">
+                <a:solidFill>
+                  <a:srgbClr val="52657B"/>
+                </a:solidFill>
+                <a:latin typeface="Aptos"/>
+              </a:rPr>
+              <a:t>Stiamo verificando questa interpretazione con i modelli teorici.</a:t>
             </a:r>
           </a:p>
         </p:txBody>
       </p:sp>
       <p:pic>
         <p:nvPicPr>
-          <p:cNvPr id="5" name="sigma_vis.png" descr="sigma_vis.png"/>
+          <p:cNvPr id="9" name="polarization.png" descr="polarization.png"/>
           <p:cNvPicPr>
             <a:picLocks noChangeAspect="1" noGrp="1"/>
           </p:cNvPicPr>
@@ -5900,8 +5908,8 @@
         </p:blipFill>
         <p:spPr>
           <a:xfrm>
-            <a:off x="493776" y="1570264"/>
-            <a:ext cx="8211312" cy="2208711"/>
+            <a:off x="4572000" y="1365044"/>
+            <a:ext cx="3849624" cy="2884328"/>
           </a:xfrm>
           <a:prstGeom prst="rect">
             <a:avLst/>
@@ -5910,40 +5918,7 @@
       </p:pic>
       <p:sp>
         <p:nvSpPr>
-          <p:cNvPr id="6" name="Text 6"/>
-          <p:cNvSpPr txBox="1"/>
-          <p:nvPr/>
-        </p:nvSpPr>
-        <p:spPr>
-          <a:xfrm>
-            <a:off x="713232" y="4069080"/>
-            <a:ext cx="7726680" cy="466344"/>
-          </a:xfrm>
-          <a:noFill/>
-          <a:ln>
-            <a:noFill/>
-          </a:ln>
-        </p:spPr>
-        <p:txBody>
-          <a:bodyPr wrap="square" lIns="0" rIns="0" tIns="0" bIns="0" anchor="t"/>
-          <a:lstStyle/>
-          <a:p>
-            <a:pPr algn="l"/>
-            <a:r>
-              <a:rPr lang="it-IT" sz="1419" b="0" i="0">
-                <a:solidFill>
-                  <a:srgbClr val="112642"/>
-                </a:solidFill>
-                <a:latin typeface="Aptos"/>
-              </a:rPr>
-              <a:t>Nel campione VIS, Σ tende a valori negativi per pη e diventa positiva in alcuni intervalli di ηπ⁰. Il risultato è preliminare.</a:t>
-            </a:r>
-          </a:p>
-        </p:txBody>
-      </p:sp>
-      <p:sp>
-        <p:nvSpPr>
-          <p:cNvPr id="7" name="Fill 7"/>
+          <p:cNvPr id="10" name="Fill 10"/>
           <p:cNvSpPr/>
           <p:nvPr/>
         </p:nvSpPr>
@@ -5965,14 +5940,14 @@
       </p:sp>
       <p:sp>
         <p:nvSpPr>
-          <p:cNvPr id="8" name="Fill 8"/>
+          <p:cNvPr id="11" name="Fill 11"/>
           <p:cNvSpPr/>
           <p:nvPr/>
         </p:nvSpPr>
         <p:spPr>
           <a:xfrm>
             <a:off x="0" y="0"/>
-            <a:ext cx="7620000" cy="260604"/>
+            <a:ext cx="8068235" cy="260604"/>
           </a:xfrm>
           <a:prstGeom prst="rect">
             <a:avLst/>
@@ -5987,7 +5962,7 @@
       </p:sp>
       <p:sp>
         <p:nvSpPr>
-          <p:cNvPr id="9" name="Text 9"/>
+          <p:cNvPr id="12" name="Text 12"/>
           <p:cNvSpPr txBox="1"/>
           <p:nvPr/>
         </p:nvSpPr>
@@ -6020,7 +5995,7 @@
       </p:sp>
       <p:sp>
         <p:nvSpPr>
-          <p:cNvPr id="10" name="Fill 10"/>
+          <p:cNvPr id="13" name="Fill 13"/>
           <p:cNvSpPr/>
           <p:nvPr/>
         </p:nvSpPr>
@@ -6042,14 +6017,14 @@
       </p:sp>
       <p:sp>
         <p:nvSpPr>
-          <p:cNvPr id="11" name="Fill 11"/>
+          <p:cNvPr id="14" name="Fill 14"/>
           <p:cNvSpPr/>
           <p:nvPr/>
         </p:nvSpPr>
         <p:spPr>
           <a:xfrm>
             <a:off x="0" y="4882896"/>
-            <a:ext cx="7620000" cy="260604"/>
+            <a:ext cx="8068235" cy="260604"/>
           </a:xfrm>
           <a:prstGeom prst="rect">
             <a:avLst/>
@@ -6064,7 +6039,7 @@
       </p:sp>
       <p:sp>
         <p:nvSpPr>
-          <p:cNvPr id="12" name="Text 12"/>
+          <p:cNvPr id="15" name="Text 15"/>
           <p:cNvSpPr txBox="1"/>
           <p:nvPr/>
         </p:nvSpPr>
@@ -6090,14 +6065,14 @@
                 </a:solidFill>
                 <a:latin typeface="Aptos"/>
               </a:rPr>
-              <a:t>RISULTATI</a:t>
-            </a:r>
-          </a:p>
-        </p:txBody>
-      </p:sp>
-      <p:sp>
-        <p:nvSpPr>
-          <p:cNvPr id="13" name="Text 13"/>
+              <a:t>INTERPRETAZIONE</a:t>
+            </a:r>
+          </a:p>
+        </p:txBody>
+      </p:sp>
+      <p:sp>
+        <p:nvSpPr>
+          <p:cNvPr id="16" name="Text 16"/>
           <p:cNvSpPr txBox="1"/>
           <p:nvPr/>
         </p:nvSpPr>
@@ -6123,7 +6098,7 @@
                 </a:solidFill>
                 <a:latin typeface="Aptos"/>
               </a:rPr>
-              <a:t>15/18</a:t>
+              <a:t>15/17</a:t>
             </a:r>
           </a:p>
         </p:txBody>
@@ -6189,7 +6164,7 @@
                 </a:solidFill>
                 <a:latin typeface="Aptos"/>
               </a:rPr>
-              <a:t>Perché il VIS è interessante</a:t>
+              <a:t>Verifiche ancora aperte</a:t>
             </a:r>
           </a:p>
         </p:txBody>
@@ -6222,7 +6197,7 @@
                 </a:solidFill>
                 <a:latin typeface="Aptos"/>
               </a:rPr>
-              <a:t>Fonte: wiki/compton-beam-and-polarization.md; ipotesi da verificare</a:t>
+              <a:t>Fonte: wiki/known-limitations.md; direttive del progetto</a:t>
             </a:r>
           </a:p>
         </p:txBody>
@@ -6235,8 +6210,8 @@
         </p:nvSpPr>
         <p:spPr>
           <a:xfrm>
-            <a:off x="694944" y="1069848"/>
-            <a:ext cx="3977640" cy="393192"/>
+            <a:off x="704088" y="1069848"/>
+            <a:ext cx="731520" cy="429768"/>
           </a:xfrm>
           <a:noFill/>
           <a:ln>
@@ -6249,13 +6224,13 @@
           <a:p>
             <a:pPr algn="l"/>
             <a:r>
-              <a:rPr lang="it-IT" sz="1978" b="1" i="0">
+              <a:rPr lang="it-IT" sz="2494" b="1" i="0">
                 <a:solidFill>
                   <a:srgbClr val="0B5FA5"/>
                 </a:solidFill>
                 <a:latin typeface="Aptos"/>
               </a:rPr>
-              <a:t>VIS: polarizzazione alta</a:t>
+              <a:t>01</a:t>
             </a:r>
           </a:p>
         </p:txBody>
@@ -6268,8 +6243,8 @@
         </p:nvSpPr>
         <p:spPr>
           <a:xfrm>
-            <a:off x="694944" y="1517904"/>
-            <a:ext cx="3813048" cy="960120"/>
+            <a:off x="1417320" y="1088136"/>
+            <a:ext cx="6903720" cy="365760"/>
           </a:xfrm>
           <a:noFill/>
           <a:ln>
@@ -6282,13 +6257,13 @@
           <a:p>
             <a:pPr algn="l"/>
             <a:r>
-              <a:rPr lang="it-IT" sz="1505" b="0" i="0">
+              <a:rPr lang="it-IT" sz="1677" b="1" i="0">
                 <a:solidFill>
                   <a:srgbClr val="112642"/>
                 </a:solidFill>
                 <a:latin typeface="Aptos"/>
               </a:rPr>
-              <a:t>Con il laser a 514 nm, la polarizzazione si avvicina al 100% al bordo Compton. Nella regione VIS dipende dall'energia del fotone.</a:t>
+              <a:t>Codici storici: mergedateu e wnorm</a:t>
             </a:r>
           </a:p>
         </p:txBody>
@@ -6301,8 +6276,8 @@
         </p:nvSpPr>
         <p:spPr>
           <a:xfrm>
-            <a:off x="694944" y="2734056"/>
-            <a:ext cx="3749040" cy="347472"/>
+            <a:off x="1417320" y="1444752"/>
+            <a:ext cx="6903720" cy="301752"/>
           </a:xfrm>
           <a:noFill/>
           <a:ln>
@@ -6315,27 +6290,60 @@
           <a:p>
             <a:pPr algn="l"/>
             <a:r>
-              <a:rPr lang="it-IT" sz="1892" b="1" i="0">
+              <a:rPr lang="it-IT" sz="1376" b="0" i="0">
+                <a:solidFill>
+                  <a:srgbClr val="112642"/>
+                </a:solidFill>
+                <a:latin typeface="Aptos"/>
+              </a:rPr>
+              <a:t>Confronteremo flussi calibrati e Σ per ogni run e intervallo di energia.</a:t>
+            </a:r>
+          </a:p>
+        </p:txBody>
+      </p:sp>
+      <p:sp>
+        <p:nvSpPr>
+          <p:cNvPr id="7" name="Text 7"/>
+          <p:cNvSpPr txBox="1"/>
+          <p:nvPr/>
+        </p:nvSpPr>
+        <p:spPr>
+          <a:xfrm>
+            <a:off x="704088" y="1947672"/>
+            <a:ext cx="731520" cy="429768"/>
+          </a:xfrm>
+          <a:noFill/>
+          <a:ln>
+            <a:noFill/>
+          </a:ln>
+        </p:spPr>
+        <p:txBody>
+          <a:bodyPr wrap="square" lIns="0" rIns="0" tIns="0" bIns="0" anchor="t"/>
+          <a:lstStyle/>
+          <a:p>
+            <a:pPr algn="l"/>
+            <a:r>
+              <a:rPr lang="it-IT" sz="2494" b="1" i="0">
                 <a:solidFill>
                   <a:srgbClr val="0B5FA5"/>
                 </a:solidFill>
                 <a:latin typeface="Aptos"/>
               </a:rPr>
-              <a:t>Ipotesi fisica</a:t>
-            </a:r>
-          </a:p>
-        </p:txBody>
-      </p:sp>
-      <p:sp>
-        <p:nvSpPr>
-          <p:cNvPr id="7" name="Text 7"/>
-          <p:cNvSpPr txBox="1"/>
-          <p:nvPr/>
-        </p:nvSpPr>
-        <p:spPr>
-          <a:xfrm>
-            <a:off x="694944" y="3118104"/>
-            <a:ext cx="3822192" cy="969264"/>
+              <a:t>02</a:t>
+            </a:r>
+          </a:p>
+        </p:txBody>
+      </p:sp>
+      <p:sp>
+        <p:nvSpPr>
+          <p:cNvPr id="8" name="Text 8"/>
+          <p:cNvSpPr txBox="1"/>
+          <p:nvPr/>
+        </p:nvSpPr>
+        <p:spPr>
+          <a:xfrm>
+            <a:off x="1417320" y="1965960"/>
+            <a:ext cx="6903720" cy="365760"/>
           </a:xfrm>
           <a:noFill/>
           <a:ln>
@@ -6348,27 +6356,27 @@
           <a:p>
             <a:pPr algn="l"/>
             <a:r>
-              <a:rPr lang="it-IT" sz="1505" b="0" i="0">
+              <a:rPr lang="it-IT" sz="1677" b="1" i="0">
                 <a:solidFill>
                   <a:srgbClr val="112642"/>
                 </a:solidFill>
                 <a:latin typeface="Aptos"/>
               </a:rPr>
-              <a:t>Anche vicino alla soglia, le code di risonanze ampie e intense possono interferire tra loro e produrre un'asimmetria che varia con la massa.</a:t>
-            </a:r>
-          </a:p>
-        </p:txBody>
-      </p:sp>
-      <p:sp>
-        <p:nvSpPr>
-          <p:cNvPr id="8" name="Text 8"/>
-          <p:cNvSpPr txBox="1"/>
-          <p:nvPr/>
-        </p:nvSpPr>
-        <p:spPr>
-          <a:xfrm>
-            <a:off x="694944" y="4187952"/>
-            <a:ext cx="3813048" cy="365760"/>
+              <a:t>Asimmetria del fondo</a:t>
+            </a:r>
+          </a:p>
+        </p:txBody>
+      </p:sp>
+      <p:sp>
+        <p:nvSpPr>
+          <p:cNvPr id="9" name="Text 9"/>
+          <p:cNvSpPr txBox="1"/>
+          <p:nvPr/>
+        </p:nvSpPr>
+        <p:spPr>
+          <a:xfrm>
+            <a:off x="1417320" y="2322576"/>
+            <a:ext cx="6903720" cy="301752"/>
           </a:xfrm>
           <a:noFill/>
           <a:ln>
@@ -6381,44 +6389,218 @@
           <a:p>
             <a:pPr algn="l"/>
             <a:r>
-              <a:rPr lang="it-IT" sz="1333" b="0" i="0">
-                <a:solidFill>
-                  <a:srgbClr val="52657B"/>
-                </a:solidFill>
-                <a:latin typeface="Aptos"/>
-              </a:rPr>
-              <a:t>Stiamo verificando questa interpretazione con i modelli teorici.</a:t>
-            </a:r>
-          </a:p>
-        </p:txBody>
-      </p:sp>
-      <p:pic>
-        <p:nvPicPr>
-          <p:cNvPr id="9" name="polarization.png" descr="polarization.png"/>
-          <p:cNvPicPr>
-            <a:picLocks noChangeAspect="1" noGrp="1"/>
-          </p:cNvPicPr>
-          <p:nvPr/>
-        </p:nvPicPr>
-        <p:blipFill>
-          <a:blip r:embed="rId2"/>
-          <a:stretch>
-            <a:fillRect/>
-          </a:stretch>
-        </p:blipFill>
-        <p:spPr>
-          <a:xfrm>
-            <a:off x="4572000" y="1365044"/>
-            <a:ext cx="3849624" cy="2884328"/>
-          </a:xfrm>
-          <a:prstGeom prst="rect">
-            <a:avLst/>
-          </a:prstGeom>
-        </p:spPr>
-      </p:pic>
-      <p:sp>
-        <p:nvSpPr>
-          <p:cNvPr id="10" name="Fill 10"/>
+              <a:rPr lang="it-IT" sz="1376" b="0" i="0">
+                <a:solidFill>
+                  <a:srgbClr val="112642"/>
+                </a:solidFill>
+                <a:latin typeface="Aptos"/>
+              </a:rPr>
+              <a:t>Misureremo la modulazione nelle sideband di massa per controllare il fondo.</a:t>
+            </a:r>
+          </a:p>
+        </p:txBody>
+      </p:sp>
+      <p:sp>
+        <p:nvSpPr>
+          <p:cNvPr id="10" name="Text 10"/>
+          <p:cNvSpPr txBox="1"/>
+          <p:nvPr/>
+        </p:nvSpPr>
+        <p:spPr>
+          <a:xfrm>
+            <a:off x="704088" y="2825496"/>
+            <a:ext cx="731520" cy="429768"/>
+          </a:xfrm>
+          <a:noFill/>
+          <a:ln>
+            <a:noFill/>
+          </a:ln>
+        </p:spPr>
+        <p:txBody>
+          <a:bodyPr wrap="square" lIns="0" rIns="0" tIns="0" bIns="0" anchor="t"/>
+          <a:lstStyle/>
+          <a:p>
+            <a:pPr algn="l"/>
+            <a:r>
+              <a:rPr lang="it-IT" sz="2494" b="1" i="0">
+                <a:solidFill>
+                  <a:srgbClr val="0B5FA5"/>
+                </a:solidFill>
+                <a:latin typeface="Aptos"/>
+              </a:rPr>
+              <a:t>03</a:t>
+            </a:r>
+          </a:p>
+        </p:txBody>
+      </p:sp>
+      <p:sp>
+        <p:nvSpPr>
+          <p:cNvPr id="11" name="Text 11"/>
+          <p:cNvSpPr txBox="1"/>
+          <p:nvPr/>
+        </p:nvSpPr>
+        <p:spPr>
+          <a:xfrm>
+            <a:off x="1417320" y="2843784"/>
+            <a:ext cx="6903720" cy="365760"/>
+          </a:xfrm>
+          <a:noFill/>
+          <a:ln>
+            <a:noFill/>
+          </a:ln>
+        </p:spPr>
+        <p:txBody>
+          <a:bodyPr wrap="square" lIns="0" rIns="0" tIns="0" bIns="0" anchor="t"/>
+          <a:lstStyle/>
+          <a:p>
+            <a:pPr algn="l"/>
+            <a:r>
+              <a:rPr lang="it-IT" sz="1677" b="1" i="0">
+                <a:solidFill>
+                  <a:srgbClr val="112642"/>
+                </a:solidFill>
+                <a:latin typeface="Aptos"/>
+              </a:rPr>
+              <a:t>MC con Σ piatta iniettata</a:t>
+            </a:r>
+          </a:p>
+        </p:txBody>
+      </p:sp>
+      <p:sp>
+        <p:nvSpPr>
+          <p:cNvPr id="12" name="Text 12"/>
+          <p:cNvSpPr txBox="1"/>
+          <p:nvPr/>
+        </p:nvSpPr>
+        <p:spPr>
+          <a:xfrm>
+            <a:off x="1417320" y="3200400"/>
+            <a:ext cx="6903720" cy="301752"/>
+          </a:xfrm>
+          <a:noFill/>
+          <a:ln>
+            <a:noFill/>
+          </a:ln>
+        </p:spPr>
+        <p:txBody>
+          <a:bodyPr wrap="square" lIns="0" rIns="0" tIns="0" bIns="0" anchor="t"/>
+          <a:lstStyle/>
+          <a:p>
+            <a:pPr algn="l"/>
+            <a:r>
+              <a:rPr lang="it-IT" sz="1376" b="0" i="0">
+                <a:solidFill>
+                  <a:srgbClr val="112642"/>
+                </a:solidFill>
+                <a:latin typeface="Aptos"/>
+              </a:rPr>
+              <a:t>Rieseguiremo l'analisi sul MC per verificare che recuperi l'asimmetria iniettata.</a:t>
+            </a:r>
+          </a:p>
+        </p:txBody>
+      </p:sp>
+      <p:sp>
+        <p:nvSpPr>
+          <p:cNvPr id="13" name="Text 13"/>
+          <p:cNvSpPr txBox="1"/>
+          <p:nvPr/>
+        </p:nvSpPr>
+        <p:spPr>
+          <a:xfrm>
+            <a:off x="704088" y="3703320"/>
+            <a:ext cx="731520" cy="429768"/>
+          </a:xfrm>
+          <a:noFill/>
+          <a:ln>
+            <a:noFill/>
+          </a:ln>
+        </p:spPr>
+        <p:txBody>
+          <a:bodyPr wrap="square" lIns="0" rIns="0" tIns="0" bIns="0" anchor="t"/>
+          <a:lstStyle/>
+          <a:p>
+            <a:pPr algn="l"/>
+            <a:r>
+              <a:rPr lang="it-IT" sz="2494" b="1" i="0">
+                <a:solidFill>
+                  <a:srgbClr val="0B5FA5"/>
+                </a:solidFill>
+                <a:latin typeface="Aptos"/>
+              </a:rPr>
+              <a:t>04</a:t>
+            </a:r>
+          </a:p>
+        </p:txBody>
+      </p:sp>
+      <p:sp>
+        <p:nvSpPr>
+          <p:cNvPr id="14" name="Text 14"/>
+          <p:cNvSpPr txBox="1"/>
+          <p:nvPr/>
+        </p:nvSpPr>
+        <p:spPr>
+          <a:xfrm>
+            <a:off x="1417320" y="3721608"/>
+            <a:ext cx="6903720" cy="365760"/>
+          </a:xfrm>
+          <a:noFill/>
+          <a:ln>
+            <a:noFill/>
+          </a:ln>
+        </p:spPr>
+        <p:txBody>
+          <a:bodyPr wrap="square" lIns="0" rIns="0" tIns="0" bIns="0" anchor="t"/>
+          <a:lstStyle/>
+          <a:p>
+            <a:pPr algn="l"/>
+            <a:r>
+              <a:rPr lang="it-IT" sz="1677" b="1" i="0">
+                <a:solidFill>
+                  <a:srgbClr val="112642"/>
+                </a:solidFill>
+                <a:latin typeface="Aptos"/>
+              </a:rPr>
+              <a:t>Sistematiche</a:t>
+            </a:r>
+          </a:p>
+        </p:txBody>
+      </p:sp>
+      <p:sp>
+        <p:nvSpPr>
+          <p:cNvPr id="15" name="Text 15"/>
+          <p:cNvSpPr txBox="1"/>
+          <p:nvPr/>
+        </p:nvSpPr>
+        <p:spPr>
+          <a:xfrm>
+            <a:off x="1417320" y="4078224"/>
+            <a:ext cx="6903720" cy="384048"/>
+          </a:xfrm>
+          <a:noFill/>
+          <a:ln>
+            <a:noFill/>
+          </a:ln>
+        </p:spPr>
+        <p:txBody>
+          <a:bodyPr wrap="square" lIns="0" rIns="0" tIns="0" bIns="0" anchor="t"/>
+          <a:lstStyle/>
+          <a:p>
+            <a:pPr algn="l"/>
+            <a:r>
+              <a:rPr lang="it-IT" sz="1376" b="0" i="0">
+                <a:solidFill>
+                  <a:srgbClr val="112642"/>
+                </a:solidFill>
+                <a:latin typeface="Aptos"/>
+              </a:rPr>
+              <a:t>Studieremo l'effetto di flussi, polarizzazione, soglia BDT ed estimatore sul risultato finale.</a:t>
+            </a:r>
+          </a:p>
+        </p:txBody>
+      </p:sp>
+      <p:sp>
+        <p:nvSpPr>
+          <p:cNvPr id="16" name="Fill 16"/>
           <p:cNvSpPr/>
           <p:nvPr/>
         </p:nvSpPr>
@@ -6440,14 +6622,14 @@
       </p:sp>
       <p:sp>
         <p:nvSpPr>
-          <p:cNvPr id="11" name="Fill 11"/>
+          <p:cNvPr id="17" name="Fill 17"/>
           <p:cNvSpPr/>
           <p:nvPr/>
         </p:nvSpPr>
         <p:spPr>
           <a:xfrm>
             <a:off x="0" y="0"/>
-            <a:ext cx="8128000" cy="260604"/>
+            <a:ext cx="8606118" cy="260604"/>
           </a:xfrm>
           <a:prstGeom prst="rect">
             <a:avLst/>
@@ -6462,7 +6644,7 @@
       </p:sp>
       <p:sp>
         <p:nvSpPr>
-          <p:cNvPr id="12" name="Text 12"/>
+          <p:cNvPr id="18" name="Text 18"/>
           <p:cNvSpPr txBox="1"/>
           <p:nvPr/>
         </p:nvSpPr>
@@ -6495,7 +6677,7 @@
       </p:sp>
       <p:sp>
         <p:nvSpPr>
-          <p:cNvPr id="13" name="Fill 13"/>
+          <p:cNvPr id="19" name="Fill 19"/>
           <p:cNvSpPr/>
           <p:nvPr/>
         </p:nvSpPr>
@@ -6517,14 +6699,14 @@
       </p:sp>
       <p:sp>
         <p:nvSpPr>
-          <p:cNvPr id="14" name="Fill 14"/>
+          <p:cNvPr id="20" name="Fill 20"/>
           <p:cNvSpPr/>
           <p:nvPr/>
         </p:nvSpPr>
         <p:spPr>
           <a:xfrm>
             <a:off x="0" y="4882896"/>
-            <a:ext cx="8128000" cy="260604"/>
+            <a:ext cx="8606118" cy="260604"/>
           </a:xfrm>
           <a:prstGeom prst="rect">
             <a:avLst/>
@@ -6539,7 +6721,7 @@
       </p:sp>
       <p:sp>
         <p:nvSpPr>
-          <p:cNvPr id="15" name="Text 15"/>
+          <p:cNvPr id="21" name="Text 21"/>
           <p:cNvSpPr txBox="1"/>
           <p:nvPr/>
         </p:nvSpPr>
@@ -6565,14 +6747,14 @@
                 </a:solidFill>
                 <a:latin typeface="Aptos"/>
               </a:rPr>
-              <a:t>INTERPRETAZIONE</a:t>
-            </a:r>
-          </a:p>
-        </p:txBody>
-      </p:sp>
-      <p:sp>
-        <p:nvSpPr>
-          <p:cNvPr id="16" name="Text 16"/>
+              <a:t>VERIFICHE</a:t>
+            </a:r>
+          </a:p>
+        </p:txBody>
+      </p:sp>
+      <p:sp>
+        <p:nvSpPr>
+          <p:cNvPr id="22" name="Text 22"/>
           <p:cNvSpPr txBox="1"/>
           <p:nvPr/>
         </p:nvSpPr>
@@ -6598,7 +6780,7 @@
                 </a:solidFill>
                 <a:latin typeface="Aptos"/>
               </a:rPr>
-              <a:t>16/18</a:t>
+              <a:t>16/17</a:t>
             </a:r>
           </a:p>
         </p:txBody>
@@ -6612,688 +6794,6 @@
 </file>
 
 <file path=ppt/slides/slide17.xml><?xml version="1.0" encoding="utf-8"?>
-<p:sld xmlns:p="http://schemas.openxmlformats.org/presentationml/2006/main" xmlns:a="http://schemas.openxmlformats.org/drawingml/2006/main" xmlns:r="http://schemas.openxmlformats.org/officeDocument/2006/relationships">
-  <p:cSld>
-    <p:bg>
-      <p:bgPr>
-        <a:solidFill>
-          <a:srgbClr val="FFFFFF"/>
-        </a:solidFill>
-        <a:effectLst/>
-      </p:bgPr>
-    </p:bg>
-    <p:spTree>
-      <p:nvGrpSpPr>
-        <p:cNvPr id="1" name=""/>
-        <p:cNvGrpSpPr/>
-        <p:nvPr/>
-      </p:nvGrpSpPr>
-      <p:grpSpPr>
-        <a:xfrm>
-          <a:off x="0" y="0"/>
-          <a:ext cx="0" cy="0"/>
-          <a:chOff x="0" y="0"/>
-          <a:chExt cx="0" cy="0"/>
-        </a:xfrm>
-      </p:grpSpPr>
-      <p:sp>
-        <p:nvSpPr>
-          <p:cNvPr id="2" name="Text 2"/>
-          <p:cNvSpPr txBox="1"/>
-          <p:nvPr/>
-        </p:nvSpPr>
-        <p:spPr>
-          <a:xfrm>
-            <a:off x="566928" y="347472"/>
-            <a:ext cx="8046720" cy="475488"/>
-          </a:xfrm>
-          <a:noFill/>
-          <a:ln>
-            <a:noFill/>
-          </a:ln>
-        </p:spPr>
-        <p:txBody>
-          <a:bodyPr wrap="square" lIns="0" rIns="0" tIns="0" bIns="0" anchor="t"/>
-          <a:lstStyle/>
-          <a:p>
-            <a:pPr algn="l"/>
-            <a:r>
-              <a:rPr lang="it-IT" sz="2752" b="1" i="0">
-                <a:solidFill>
-                  <a:srgbClr val="071E42"/>
-                </a:solidFill>
-                <a:latin typeface="Aptos"/>
-              </a:rPr>
-              <a:t>Verifiche ancora aperte</a:t>
-            </a:r>
-          </a:p>
-        </p:txBody>
-      </p:sp>
-      <p:sp>
-        <p:nvSpPr>
-          <p:cNvPr id="3" name="Text 3"/>
-          <p:cNvSpPr txBox="1"/>
-          <p:nvPr/>
-        </p:nvSpPr>
-        <p:spPr>
-          <a:xfrm>
-            <a:off x="585216" y="4645152"/>
-            <a:ext cx="7955280" cy="146304"/>
-          </a:xfrm>
-          <a:noFill/>
-          <a:ln>
-            <a:noFill/>
-          </a:ln>
-        </p:spPr>
-        <p:txBody>
-          <a:bodyPr wrap="square" lIns="0" rIns="0" tIns="0" bIns="0" anchor="t"/>
-          <a:lstStyle/>
-          <a:p>
-            <a:pPr algn="l"/>
-            <a:r>
-              <a:rPr lang="it-IT" sz="850" b="0" i="0">
-                <a:solidFill>
-                  <a:srgbClr val="52657B"/>
-                </a:solidFill>
-                <a:latin typeface="Aptos"/>
-              </a:rPr>
-              <a:t>Fonte: wiki/known-limitations.md; direttive del progetto</a:t>
-            </a:r>
-          </a:p>
-        </p:txBody>
-      </p:sp>
-      <p:sp>
-        <p:nvSpPr>
-          <p:cNvPr id="4" name="Text 4"/>
-          <p:cNvSpPr txBox="1"/>
-          <p:nvPr/>
-        </p:nvSpPr>
-        <p:spPr>
-          <a:xfrm>
-            <a:off x="704088" y="1069848"/>
-            <a:ext cx="731520" cy="429768"/>
-          </a:xfrm>
-          <a:noFill/>
-          <a:ln>
-            <a:noFill/>
-          </a:ln>
-        </p:spPr>
-        <p:txBody>
-          <a:bodyPr wrap="square" lIns="0" rIns="0" tIns="0" bIns="0" anchor="t"/>
-          <a:lstStyle/>
-          <a:p>
-            <a:pPr algn="l"/>
-            <a:r>
-              <a:rPr lang="it-IT" sz="2494" b="1" i="0">
-                <a:solidFill>
-                  <a:srgbClr val="0B5FA5"/>
-                </a:solidFill>
-                <a:latin typeface="Aptos"/>
-              </a:rPr>
-              <a:t>01</a:t>
-            </a:r>
-          </a:p>
-        </p:txBody>
-      </p:sp>
-      <p:sp>
-        <p:nvSpPr>
-          <p:cNvPr id="5" name="Text 5"/>
-          <p:cNvSpPr txBox="1"/>
-          <p:nvPr/>
-        </p:nvSpPr>
-        <p:spPr>
-          <a:xfrm>
-            <a:off x="1417320" y="1088136"/>
-            <a:ext cx="6903720" cy="365760"/>
-          </a:xfrm>
-          <a:noFill/>
-          <a:ln>
-            <a:noFill/>
-          </a:ln>
-        </p:spPr>
-        <p:txBody>
-          <a:bodyPr wrap="square" lIns="0" rIns="0" tIns="0" bIns="0" anchor="t"/>
-          <a:lstStyle/>
-          <a:p>
-            <a:pPr algn="l"/>
-            <a:r>
-              <a:rPr lang="it-IT" sz="1677" b="1" i="0">
-                <a:solidFill>
-                  <a:srgbClr val="112642"/>
-                </a:solidFill>
-                <a:latin typeface="Aptos"/>
-              </a:rPr>
-              <a:t>Codici storici: mergedateu e wnorm</a:t>
-            </a:r>
-          </a:p>
-        </p:txBody>
-      </p:sp>
-      <p:sp>
-        <p:nvSpPr>
-          <p:cNvPr id="6" name="Text 6"/>
-          <p:cNvSpPr txBox="1"/>
-          <p:nvPr/>
-        </p:nvSpPr>
-        <p:spPr>
-          <a:xfrm>
-            <a:off x="1417320" y="1444752"/>
-            <a:ext cx="6903720" cy="301752"/>
-          </a:xfrm>
-          <a:noFill/>
-          <a:ln>
-            <a:noFill/>
-          </a:ln>
-        </p:spPr>
-        <p:txBody>
-          <a:bodyPr wrap="square" lIns="0" rIns="0" tIns="0" bIns="0" anchor="t"/>
-          <a:lstStyle/>
-          <a:p>
-            <a:pPr algn="l"/>
-            <a:r>
-              <a:rPr lang="it-IT" sz="1376" b="0" i="0">
-                <a:solidFill>
-                  <a:srgbClr val="112642"/>
-                </a:solidFill>
-                <a:latin typeface="Aptos"/>
-              </a:rPr>
-              <a:t>Confronteremo flussi calibrati e Σ per ogni run e intervallo di energia.</a:t>
-            </a:r>
-          </a:p>
-        </p:txBody>
-      </p:sp>
-      <p:sp>
-        <p:nvSpPr>
-          <p:cNvPr id="7" name="Text 7"/>
-          <p:cNvSpPr txBox="1"/>
-          <p:nvPr/>
-        </p:nvSpPr>
-        <p:spPr>
-          <a:xfrm>
-            <a:off x="704088" y="1947672"/>
-            <a:ext cx="731520" cy="429768"/>
-          </a:xfrm>
-          <a:noFill/>
-          <a:ln>
-            <a:noFill/>
-          </a:ln>
-        </p:spPr>
-        <p:txBody>
-          <a:bodyPr wrap="square" lIns="0" rIns="0" tIns="0" bIns="0" anchor="t"/>
-          <a:lstStyle/>
-          <a:p>
-            <a:pPr algn="l"/>
-            <a:r>
-              <a:rPr lang="it-IT" sz="2494" b="1" i="0">
-                <a:solidFill>
-                  <a:srgbClr val="0B5FA5"/>
-                </a:solidFill>
-                <a:latin typeface="Aptos"/>
-              </a:rPr>
-              <a:t>02</a:t>
-            </a:r>
-          </a:p>
-        </p:txBody>
-      </p:sp>
-      <p:sp>
-        <p:nvSpPr>
-          <p:cNvPr id="8" name="Text 8"/>
-          <p:cNvSpPr txBox="1"/>
-          <p:nvPr/>
-        </p:nvSpPr>
-        <p:spPr>
-          <a:xfrm>
-            <a:off x="1417320" y="1965960"/>
-            <a:ext cx="6903720" cy="365760"/>
-          </a:xfrm>
-          <a:noFill/>
-          <a:ln>
-            <a:noFill/>
-          </a:ln>
-        </p:spPr>
-        <p:txBody>
-          <a:bodyPr wrap="square" lIns="0" rIns="0" tIns="0" bIns="0" anchor="t"/>
-          <a:lstStyle/>
-          <a:p>
-            <a:pPr algn="l"/>
-            <a:r>
-              <a:rPr lang="it-IT" sz="1677" b="1" i="0">
-                <a:solidFill>
-                  <a:srgbClr val="112642"/>
-                </a:solidFill>
-                <a:latin typeface="Aptos"/>
-              </a:rPr>
-              <a:t>Asimmetria del fondo</a:t>
-            </a:r>
-          </a:p>
-        </p:txBody>
-      </p:sp>
-      <p:sp>
-        <p:nvSpPr>
-          <p:cNvPr id="9" name="Text 9"/>
-          <p:cNvSpPr txBox="1"/>
-          <p:nvPr/>
-        </p:nvSpPr>
-        <p:spPr>
-          <a:xfrm>
-            <a:off x="1417320" y="2322576"/>
-            <a:ext cx="6903720" cy="301752"/>
-          </a:xfrm>
-          <a:noFill/>
-          <a:ln>
-            <a:noFill/>
-          </a:ln>
-        </p:spPr>
-        <p:txBody>
-          <a:bodyPr wrap="square" lIns="0" rIns="0" tIns="0" bIns="0" anchor="t"/>
-          <a:lstStyle/>
-          <a:p>
-            <a:pPr algn="l"/>
-            <a:r>
-              <a:rPr lang="it-IT" sz="1376" b="0" i="0">
-                <a:solidFill>
-                  <a:srgbClr val="112642"/>
-                </a:solidFill>
-                <a:latin typeface="Aptos"/>
-              </a:rPr>
-              <a:t>Misureremo la modulazione nelle sideband di massa per controllare il fondo.</a:t>
-            </a:r>
-          </a:p>
-        </p:txBody>
-      </p:sp>
-      <p:sp>
-        <p:nvSpPr>
-          <p:cNvPr id="10" name="Text 10"/>
-          <p:cNvSpPr txBox="1"/>
-          <p:nvPr/>
-        </p:nvSpPr>
-        <p:spPr>
-          <a:xfrm>
-            <a:off x="704088" y="2825496"/>
-            <a:ext cx="731520" cy="429768"/>
-          </a:xfrm>
-          <a:noFill/>
-          <a:ln>
-            <a:noFill/>
-          </a:ln>
-        </p:spPr>
-        <p:txBody>
-          <a:bodyPr wrap="square" lIns="0" rIns="0" tIns="0" bIns="0" anchor="t"/>
-          <a:lstStyle/>
-          <a:p>
-            <a:pPr algn="l"/>
-            <a:r>
-              <a:rPr lang="it-IT" sz="2494" b="1" i="0">
-                <a:solidFill>
-                  <a:srgbClr val="0B5FA5"/>
-                </a:solidFill>
-                <a:latin typeface="Aptos"/>
-              </a:rPr>
-              <a:t>03</a:t>
-            </a:r>
-          </a:p>
-        </p:txBody>
-      </p:sp>
-      <p:sp>
-        <p:nvSpPr>
-          <p:cNvPr id="11" name="Text 11"/>
-          <p:cNvSpPr txBox="1"/>
-          <p:nvPr/>
-        </p:nvSpPr>
-        <p:spPr>
-          <a:xfrm>
-            <a:off x="1417320" y="2843784"/>
-            <a:ext cx="6903720" cy="365760"/>
-          </a:xfrm>
-          <a:noFill/>
-          <a:ln>
-            <a:noFill/>
-          </a:ln>
-        </p:spPr>
-        <p:txBody>
-          <a:bodyPr wrap="square" lIns="0" rIns="0" tIns="0" bIns="0" anchor="t"/>
-          <a:lstStyle/>
-          <a:p>
-            <a:pPr algn="l"/>
-            <a:r>
-              <a:rPr lang="it-IT" sz="1677" b="1" i="0">
-                <a:solidFill>
-                  <a:srgbClr val="112642"/>
-                </a:solidFill>
-                <a:latin typeface="Aptos"/>
-              </a:rPr>
-              <a:t>MC con Σ piatta iniettata</a:t>
-            </a:r>
-          </a:p>
-        </p:txBody>
-      </p:sp>
-      <p:sp>
-        <p:nvSpPr>
-          <p:cNvPr id="12" name="Text 12"/>
-          <p:cNvSpPr txBox="1"/>
-          <p:nvPr/>
-        </p:nvSpPr>
-        <p:spPr>
-          <a:xfrm>
-            <a:off x="1417320" y="3200400"/>
-            <a:ext cx="6903720" cy="301752"/>
-          </a:xfrm>
-          <a:noFill/>
-          <a:ln>
-            <a:noFill/>
-          </a:ln>
-        </p:spPr>
-        <p:txBody>
-          <a:bodyPr wrap="square" lIns="0" rIns="0" tIns="0" bIns="0" anchor="t"/>
-          <a:lstStyle/>
-          <a:p>
-            <a:pPr algn="l"/>
-            <a:r>
-              <a:rPr lang="it-IT" sz="1376" b="0" i="0">
-                <a:solidFill>
-                  <a:srgbClr val="112642"/>
-                </a:solidFill>
-                <a:latin typeface="Aptos"/>
-              </a:rPr>
-              <a:t>Rieseguiremo l'analisi sul MC per verificare che recuperi l'asimmetria iniettata.</a:t>
-            </a:r>
-          </a:p>
-        </p:txBody>
-      </p:sp>
-      <p:sp>
-        <p:nvSpPr>
-          <p:cNvPr id="13" name="Text 13"/>
-          <p:cNvSpPr txBox="1"/>
-          <p:nvPr/>
-        </p:nvSpPr>
-        <p:spPr>
-          <a:xfrm>
-            <a:off x="704088" y="3703320"/>
-            <a:ext cx="731520" cy="429768"/>
-          </a:xfrm>
-          <a:noFill/>
-          <a:ln>
-            <a:noFill/>
-          </a:ln>
-        </p:spPr>
-        <p:txBody>
-          <a:bodyPr wrap="square" lIns="0" rIns="0" tIns="0" bIns="0" anchor="t"/>
-          <a:lstStyle/>
-          <a:p>
-            <a:pPr algn="l"/>
-            <a:r>
-              <a:rPr lang="it-IT" sz="2494" b="1" i="0">
-                <a:solidFill>
-                  <a:srgbClr val="0B5FA5"/>
-                </a:solidFill>
-                <a:latin typeface="Aptos"/>
-              </a:rPr>
-              <a:t>04</a:t>
-            </a:r>
-          </a:p>
-        </p:txBody>
-      </p:sp>
-      <p:sp>
-        <p:nvSpPr>
-          <p:cNvPr id="14" name="Text 14"/>
-          <p:cNvSpPr txBox="1"/>
-          <p:nvPr/>
-        </p:nvSpPr>
-        <p:spPr>
-          <a:xfrm>
-            <a:off x="1417320" y="3721608"/>
-            <a:ext cx="6903720" cy="365760"/>
-          </a:xfrm>
-          <a:noFill/>
-          <a:ln>
-            <a:noFill/>
-          </a:ln>
-        </p:spPr>
-        <p:txBody>
-          <a:bodyPr wrap="square" lIns="0" rIns="0" tIns="0" bIns="0" anchor="t"/>
-          <a:lstStyle/>
-          <a:p>
-            <a:pPr algn="l"/>
-            <a:r>
-              <a:rPr lang="it-IT" sz="1677" b="1" i="0">
-                <a:solidFill>
-                  <a:srgbClr val="112642"/>
-                </a:solidFill>
-                <a:latin typeface="Aptos"/>
-              </a:rPr>
-              <a:t>Sistematiche</a:t>
-            </a:r>
-          </a:p>
-        </p:txBody>
-      </p:sp>
-      <p:sp>
-        <p:nvSpPr>
-          <p:cNvPr id="15" name="Text 15"/>
-          <p:cNvSpPr txBox="1"/>
-          <p:nvPr/>
-        </p:nvSpPr>
-        <p:spPr>
-          <a:xfrm>
-            <a:off x="1417320" y="4078224"/>
-            <a:ext cx="6903720" cy="384048"/>
-          </a:xfrm>
-          <a:noFill/>
-          <a:ln>
-            <a:noFill/>
-          </a:ln>
-        </p:spPr>
-        <p:txBody>
-          <a:bodyPr wrap="square" lIns="0" rIns="0" tIns="0" bIns="0" anchor="t"/>
-          <a:lstStyle/>
-          <a:p>
-            <a:pPr algn="l"/>
-            <a:r>
-              <a:rPr lang="it-IT" sz="1376" b="0" i="0">
-                <a:solidFill>
-                  <a:srgbClr val="112642"/>
-                </a:solidFill>
-                <a:latin typeface="Aptos"/>
-              </a:rPr>
-              <a:t>Studieremo l'effetto di flussi, polarizzazione, soglia BDT ed estimatore sul risultato finale.</a:t>
-            </a:r>
-          </a:p>
-        </p:txBody>
-      </p:sp>
-      <p:sp>
-        <p:nvSpPr>
-          <p:cNvPr id="16" name="Fill 16"/>
-          <p:cNvSpPr/>
-          <p:nvPr/>
-        </p:nvSpPr>
-        <p:spPr>
-          <a:xfrm>
-            <a:off x="0" y="0"/>
-            <a:ext cx="9144000" cy="260604"/>
-          </a:xfrm>
-          <a:prstGeom prst="rect">
-            <a:avLst/>
-          </a:prstGeom>
-          <a:solidFill>
-            <a:srgbClr val="071E42"/>
-          </a:solidFill>
-          <a:ln>
-            <a:noFill/>
-          </a:ln>
-        </p:spPr>
-      </p:sp>
-      <p:sp>
-        <p:nvSpPr>
-          <p:cNvPr id="17" name="Fill 17"/>
-          <p:cNvSpPr/>
-          <p:nvPr/>
-        </p:nvSpPr>
-        <p:spPr>
-          <a:xfrm>
-            <a:off x="0" y="0"/>
-            <a:ext cx="8636000" cy="260604"/>
-          </a:xfrm>
-          <a:prstGeom prst="rect">
-            <a:avLst/>
-          </a:prstGeom>
-          <a:solidFill>
-            <a:srgbClr val="0877C7"/>
-          </a:solidFill>
-          <a:ln>
-            <a:noFill/>
-          </a:ln>
-        </p:spPr>
-      </p:sp>
-      <p:sp>
-        <p:nvSpPr>
-          <p:cNvPr id="18" name="Text 18"/>
-          <p:cNvSpPr txBox="1"/>
-          <p:nvPr/>
-        </p:nvSpPr>
-        <p:spPr>
-          <a:xfrm>
-            <a:off x="566928" y="0"/>
-            <a:ext cx="4937760" cy="260604"/>
-          </a:xfrm>
-          <a:noFill/>
-          <a:ln>
-            <a:noFill/>
-          </a:ln>
-        </p:spPr>
-        <p:txBody>
-          <a:bodyPr wrap="square" lIns="0" rIns="0" tIns="0" bIns="0" anchor="ctr"/>
-          <a:lstStyle/>
-          <a:p>
-            <a:pPr algn="l"/>
-            <a:r>
-              <a:rPr lang="it-IT" sz="900" b="1" i="0">
-                <a:solidFill>
-                  <a:srgbClr val="FFFFFF"/>
-                </a:solidFill>
-                <a:latin typeface="Aptos"/>
-              </a:rPr>
-              <a:t>GRAAL ANALYSIS</a:t>
-            </a:r>
-          </a:p>
-        </p:txBody>
-      </p:sp>
-      <p:sp>
-        <p:nvSpPr>
-          <p:cNvPr id="19" name="Fill 19"/>
-          <p:cNvSpPr/>
-          <p:nvPr/>
-        </p:nvSpPr>
-        <p:spPr>
-          <a:xfrm>
-            <a:off x="0" y="4882896"/>
-            <a:ext cx="9144000" cy="260604"/>
-          </a:xfrm>
-          <a:prstGeom prst="rect">
-            <a:avLst/>
-          </a:prstGeom>
-          <a:solidFill>
-            <a:srgbClr val="071E42"/>
-          </a:solidFill>
-          <a:ln>
-            <a:noFill/>
-          </a:ln>
-        </p:spPr>
-      </p:sp>
-      <p:sp>
-        <p:nvSpPr>
-          <p:cNvPr id="20" name="Fill 20"/>
-          <p:cNvSpPr/>
-          <p:nvPr/>
-        </p:nvSpPr>
-        <p:spPr>
-          <a:xfrm>
-            <a:off x="0" y="4882896"/>
-            <a:ext cx="8636000" cy="260604"/>
-          </a:xfrm>
-          <a:prstGeom prst="rect">
-            <a:avLst/>
-          </a:prstGeom>
-          <a:solidFill>
-            <a:srgbClr val="0877C7"/>
-          </a:solidFill>
-          <a:ln>
-            <a:noFill/>
-          </a:ln>
-        </p:spPr>
-      </p:sp>
-      <p:sp>
-        <p:nvSpPr>
-          <p:cNvPr id="21" name="Text 21"/>
-          <p:cNvSpPr txBox="1"/>
-          <p:nvPr/>
-        </p:nvSpPr>
-        <p:spPr>
-          <a:xfrm>
-            <a:off x="566928" y="4882896"/>
-            <a:ext cx="5120640" cy="260604"/>
-          </a:xfrm>
-          <a:noFill/>
-          <a:ln>
-            <a:noFill/>
-          </a:ln>
-        </p:spPr>
-        <p:txBody>
-          <a:bodyPr wrap="square" lIns="0" rIns="0" tIns="0" bIns="0" anchor="ctr"/>
-          <a:lstStyle/>
-          <a:p>
-            <a:pPr algn="l"/>
-            <a:r>
-              <a:rPr lang="it-IT" sz="900" b="1" i="0">
-                <a:solidFill>
-                  <a:srgbClr val="FFFFFF"/>
-                </a:solidFill>
-                <a:latin typeface="Aptos"/>
-              </a:rPr>
-              <a:t>VERIFICHE</a:t>
-            </a:r>
-          </a:p>
-        </p:txBody>
-      </p:sp>
-      <p:sp>
-        <p:nvSpPr>
-          <p:cNvPr id="22" name="Text 22"/>
-          <p:cNvSpPr txBox="1"/>
-          <p:nvPr/>
-        </p:nvSpPr>
-        <p:spPr>
-          <a:xfrm>
-            <a:off x="8083296" y="4882896"/>
-            <a:ext cx="493776" cy="260604"/>
-          </a:xfrm>
-          <a:noFill/>
-          <a:ln>
-            <a:noFill/>
-          </a:ln>
-        </p:spPr>
-        <p:txBody>
-          <a:bodyPr wrap="square" lIns="0" rIns="0" tIns="0" bIns="0" anchor="ctr"/>
-          <a:lstStyle/>
-          <a:p>
-            <a:pPr algn="r"/>
-            <a:r>
-              <a:rPr lang="it-IT" sz="1000" b="1" i="0">
-                <a:solidFill>
-                  <a:srgbClr val="FFFFFF"/>
-                </a:solidFill>
-                <a:latin typeface="Aptos"/>
-              </a:rPr>
-              <a:t>17/18</a:t>
-            </a:r>
-          </a:p>
-        </p:txBody>
-      </p:sp>
-    </p:spTree>
-  </p:cSld>
-  <p:clrMapOvr>
-    <a:masterClrMapping/>
-  </p:clrMapOvr>
-</p:sld>
-</file>
-
-<file path=ppt/slides/slide18.xml><?xml version="1.0" encoding="utf-8"?>
 <p:sld xmlns:p="http://schemas.openxmlformats.org/presentationml/2006/main" xmlns:a="http://schemas.openxmlformats.org/drawingml/2006/main" xmlns:r="http://schemas.openxmlformats.org/officeDocument/2006/relationships">
   <p:cSld>
     <p:bg>
@@ -7830,7 +7330,7 @@
                 </a:solidFill>
                 <a:latin typeface="Aptos"/>
               </a:rPr>
-              <a:t>18/18</a:t>
+              <a:t>17/17</a:t>
             </a:r>
           </a:p>
         </p:txBody>
@@ -8302,7 +7802,7 @@
         <p:spPr>
           <a:xfrm>
             <a:off x="0" y="0"/>
-            <a:ext cx="1016000" cy="260604"/>
+            <a:ext cx="1075765" cy="260604"/>
           </a:xfrm>
           <a:prstGeom prst="rect">
             <a:avLst/>
@@ -8379,7 +7879,7 @@
         <p:spPr>
           <a:xfrm>
             <a:off x="0" y="4882896"/>
-            <a:ext cx="1016000" cy="260604"/>
+            <a:ext cx="1075765" cy="260604"/>
           </a:xfrm>
           <a:prstGeom prst="rect">
             <a:avLst/>
@@ -8453,7 +7953,7 @@
                 </a:solidFill>
                 <a:latin typeface="Aptos"/>
               </a:rPr>
-              <a:t>02/18</a:t>
+              <a:t>02/17</a:t>
             </a:r>
           </a:p>
         </p:txBody>
@@ -9875,7 +9375,7 @@
         <p:spPr>
           <a:xfrm>
             <a:off x="0" y="0"/>
-            <a:ext cx="1524000" cy="260604"/>
+            <a:ext cx="1613647" cy="260604"/>
           </a:xfrm>
           <a:prstGeom prst="rect">
             <a:avLst/>
@@ -9952,7 +9452,7 @@
         <p:spPr>
           <a:xfrm>
             <a:off x="0" y="4882896"/>
-            <a:ext cx="1524000" cy="260604"/>
+            <a:ext cx="1613647" cy="260604"/>
           </a:xfrm>
           <a:prstGeom prst="rect">
             <a:avLst/>
@@ -10026,7 +9526,7 @@
                 </a:solidFill>
                 <a:latin typeface="Aptos"/>
               </a:rPr>
-              <a:t>03/18</a:t>
+              <a:t>03/17</a:t>
             </a:r>
           </a:p>
         </p:txBody>
@@ -10678,7 +10178,7 @@
         <p:spPr>
           <a:xfrm>
             <a:off x="0" y="0"/>
-            <a:ext cx="2032000" cy="260604"/>
+            <a:ext cx="2151529" cy="260604"/>
           </a:xfrm>
           <a:prstGeom prst="rect">
             <a:avLst/>
@@ -10755,7 +10255,7 @@
         <p:spPr>
           <a:xfrm>
             <a:off x="0" y="4882896"/>
-            <a:ext cx="2032000" cy="260604"/>
+            <a:ext cx="2151529" cy="260604"/>
           </a:xfrm>
           <a:prstGeom prst="rect">
             <a:avLst/>
@@ -10829,7 +10329,7 @@
                 </a:solidFill>
                 <a:latin typeface="Aptos"/>
               </a:rPr>
-              <a:t>04/18</a:t>
+              <a:t>04/17</a:t>
             </a:r>
           </a:p>
         </p:txBody>
@@ -11486,7 +10986,7 @@
         <p:spPr>
           <a:xfrm>
             <a:off x="0" y="0"/>
-            <a:ext cx="2540000" cy="260604"/>
+            <a:ext cx="2689412" cy="260604"/>
           </a:xfrm>
           <a:prstGeom prst="rect">
             <a:avLst/>
@@ -11563,7 +11063,7 @@
         <p:spPr>
           <a:xfrm>
             <a:off x="0" y="4882896"/>
-            <a:ext cx="2540000" cy="260604"/>
+            <a:ext cx="2689412" cy="260604"/>
           </a:xfrm>
           <a:prstGeom prst="rect">
             <a:avLst/>
@@ -11637,7 +11137,7 @@
                 </a:solidFill>
                 <a:latin typeface="Aptos"/>
               </a:rPr>
-              <a:t>05/18</a:t>
+              <a:t>05/17</a:t>
             </a:r>
           </a:p>
         </p:txBody>
@@ -12461,7 +11961,7 @@
         <p:spPr>
           <a:xfrm>
             <a:off x="0" y="0"/>
-            <a:ext cx="3048000" cy="260604"/>
+            <a:ext cx="3227294" cy="260604"/>
           </a:xfrm>
           <a:prstGeom prst="rect">
             <a:avLst/>
@@ -12538,7 +12038,7 @@
         <p:spPr>
           <a:xfrm>
             <a:off x="0" y="4882896"/>
-            <a:ext cx="3048000" cy="260604"/>
+            <a:ext cx="3227294" cy="260604"/>
           </a:xfrm>
           <a:prstGeom prst="rect">
             <a:avLst/>
@@ -12612,7 +12112,7 @@
                 </a:solidFill>
                 <a:latin typeface="Aptos"/>
               </a:rPr>
-              <a:t>06/18</a:t>
+              <a:t>06/17</a:t>
             </a:r>
           </a:p>
         </p:txBody>
@@ -13077,7 +12577,7 @@
         <p:spPr>
           <a:xfrm>
             <a:off x="0" y="0"/>
-            <a:ext cx="3556000" cy="260604"/>
+            <a:ext cx="3765176" cy="260604"/>
           </a:xfrm>
           <a:prstGeom prst="rect">
             <a:avLst/>
@@ -13154,7 +12654,7 @@
         <p:spPr>
           <a:xfrm>
             <a:off x="0" y="4882896"/>
-            <a:ext cx="3556000" cy="260604"/>
+            <a:ext cx="3765176" cy="260604"/>
           </a:xfrm>
           <a:prstGeom prst="rect">
             <a:avLst/>
@@ -13228,7 +12728,7 @@
                 </a:solidFill>
                 <a:latin typeface="Aptos"/>
               </a:rPr>
-              <a:t>07/18</a:t>
+              <a:t>07/17</a:t>
             </a:r>
           </a:p>
         </p:txBody>
@@ -13294,7 +12794,7 @@
                 </a:solidFill>
                 <a:latin typeface="Aptos"/>
               </a:rPr>
-              <a:t>Come funziona il BDT</a:t>
+              <a:t>Che cos'è un BDT</a:t>
             </a:r>
           </a:p>
         </p:txBody>
@@ -13327,7 +12827,7 @@
                 </a:solidFill>
                 <a:latin typeface="Aptos"/>
               </a:rPr>
-              <a:t>Fonte: wiki/04-bdt-training.md; artifacts/stage1</a:t>
+              <a:t>Fonte: XGBoost, Introduction to Boosted Trees; ROOT/TMVA Users Guide §8.13; schema DMLC, Apache 2.0</a:t>
             </a:r>
           </a:p>
         </p:txBody>
@@ -13340,8 +12840,8 @@
         </p:nvSpPr>
         <p:spPr>
           <a:xfrm>
-            <a:off x="685800" y="1042416"/>
-            <a:ext cx="2926080" cy="667512"/>
+            <a:off x="676656" y="950976"/>
+            <a:ext cx="7790688" cy="466344"/>
           </a:xfrm>
           <a:noFill/>
           <a:ln>
@@ -13354,119 +12854,20 @@
           <a:p>
             <a:pPr algn="l"/>
             <a:r>
-              <a:rPr lang="it-IT" sz="4214" b="1" i="0">
-                <a:solidFill>
-                  <a:srgbClr val="0B5FA5"/>
-                </a:solidFill>
-                <a:latin typeface="Aptos"/>
-              </a:rPr>
-              <a:t>BDT</a:t>
-            </a:r>
-          </a:p>
-        </p:txBody>
-      </p:sp>
-      <p:sp>
-        <p:nvSpPr>
-          <p:cNvPr id="5" name="Text 5"/>
-          <p:cNvSpPr txBox="1"/>
-          <p:nvPr/>
-        </p:nvSpPr>
-        <p:spPr>
-          <a:xfrm>
-            <a:off x="685800" y="1819656"/>
-            <a:ext cx="3685032" cy="749808"/>
-          </a:xfrm>
-          <a:noFill/>
-          <a:ln>
-            <a:noFill/>
-          </a:ln>
-        </p:spPr>
-        <p:txBody>
-          <a:bodyPr wrap="square" lIns="0" rIns="0" tIns="0" bIns="0" anchor="t"/>
-          <a:lstStyle/>
-          <a:p>
-            <a:pPr algn="l"/>
-            <a:r>
-              <a:rPr lang="it-IT" sz="1634" b="0" i="0">
+              <a:rPr lang="it-IT" sz="1462" b="0" i="0">
                 <a:solidFill>
                   <a:srgbClr val="112642"/>
                 </a:solidFill>
                 <a:latin typeface="Aptos"/>
               </a:rPr>
-              <a:t>Alleniamo XGBoost sul MC per distinguere il segnale dai canali di fondo.</a:t>
-            </a:r>
-          </a:p>
-        </p:txBody>
-      </p:sp>
-      <p:sp>
-        <p:nvSpPr>
-          <p:cNvPr id="6" name="Text 6"/>
-          <p:cNvSpPr txBox="1"/>
-          <p:nvPr/>
-        </p:nvSpPr>
-        <p:spPr>
-          <a:xfrm>
-            <a:off x="685800" y="2688336"/>
-            <a:ext cx="3730752" cy="1033272"/>
-          </a:xfrm>
-          <a:noFill/>
-          <a:ln>
-            <a:noFill/>
-          </a:ln>
-        </p:spPr>
-        <p:txBody>
-          <a:bodyPr wrap="square" lIns="0" rIns="0" tIns="0" bIns="0" anchor="t"/>
-          <a:lstStyle/>
-          <a:p>
-            <a:pPr algn="l"/>
-            <a:r>
-              <a:rPr lang="it-IT" sz="1505" b="0" i="0">
-                <a:solidFill>
-                  <a:srgbClr val="112642"/>
-                </a:solidFill>
-                <a:latin typeface="Aptos"/>
-              </a:rPr>
-              <a:t>Il modello usa 26 variabili, tra cui masse γγ, massa mancante, energia e angoli. Le calcoliamo allo stesso modo anche sui dati.</a:t>
-            </a:r>
-          </a:p>
-        </p:txBody>
-      </p:sp>
-      <p:sp>
-        <p:nvSpPr>
-          <p:cNvPr id="7" name="Text 7"/>
-          <p:cNvSpPr txBox="1"/>
-          <p:nvPr/>
-        </p:nvSpPr>
-        <p:spPr>
-          <a:xfrm>
-            <a:off x="685800" y="3767328"/>
-            <a:ext cx="3703320" cy="731520"/>
-          </a:xfrm>
-          <a:noFill/>
-          <a:ln>
-            <a:noFill/>
-          </a:ln>
-        </p:spPr>
-        <p:txBody>
-          <a:bodyPr wrap="square" lIns="0" rIns="0" tIns="0" bIns="0" anchor="t"/>
-          <a:lstStyle/>
-          <a:p>
-            <a:pPr algn="l"/>
-            <a:r>
-              <a:rPr lang="it-IT" sz="1419" b="0" i="0">
-                <a:solidFill>
-                  <a:srgbClr val="52657B"/>
-                </a:solidFill>
-                <a:latin typeface="Aptos"/>
-              </a:rPr>
-              <a:t>Nel training bilanciamo le classi e rimescoliamo l'ordine dei fotoni, così il modello non impara scorciatoie spurie.</a:t>
+              <a:t>Un Boosted Decision Tree (BDT) combina alberi: ognuno pone domande sulle variabili e assegna un punteggio alle foglie.</a:t>
             </a:r>
           </a:p>
         </p:txBody>
       </p:sp>
       <p:pic>
         <p:nvPicPr>
-          <p:cNvPr id="8" name="score_uv.png" descr="score_uv.png"/>
+          <p:cNvPr id="5" name="xgboost_two_trees.png" descr="xgboost_two_trees.png"/>
           <p:cNvPicPr>
             <a:picLocks noChangeAspect="1" noGrp="1"/>
           </p:cNvPicPr>
@@ -13480,8 +12881,8 @@
         </p:blipFill>
         <p:spPr>
           <a:xfrm>
-            <a:off x="4517136" y="1328166"/>
-            <a:ext cx="3931920" cy="2948940"/>
+            <a:off x="753287" y="1563624"/>
+            <a:ext cx="4793643" cy="2423160"/>
           </a:xfrm>
           <a:prstGeom prst="rect">
             <a:avLst/>
@@ -13490,7 +12891,172 @@
       </p:pic>
       <p:sp>
         <p:nvSpPr>
-          <p:cNvPr id="9" name="Fill 9"/>
+          <p:cNvPr id="6" name="Text 6"/>
+          <p:cNvSpPr txBox="1"/>
+          <p:nvPr/>
+        </p:nvSpPr>
+        <p:spPr>
+          <a:xfrm>
+            <a:off x="5715000" y="1572768"/>
+            <a:ext cx="2743200" cy="274320"/>
+          </a:xfrm>
+          <a:noFill/>
+          <a:ln>
+            <a:noFill/>
+          </a:ln>
+        </p:spPr>
+        <p:txBody>
+          <a:bodyPr wrap="square" lIns="0" rIns="0" tIns="0" bIns="0" anchor="t"/>
+          <a:lstStyle/>
+          <a:p>
+            <a:pPr algn="l"/>
+            <a:r>
+              <a:rPr lang="it-IT" sz="1393" b="1" i="0">
+                <a:solidFill>
+                  <a:srgbClr val="0B5FA5"/>
+                </a:solidFill>
+                <a:latin typeface="Aptos"/>
+              </a:rPr>
+              <a:t>1  Alberi successivi</a:t>
+            </a:r>
+          </a:p>
+        </p:txBody>
+      </p:sp>
+      <p:sp>
+        <p:nvSpPr>
+          <p:cNvPr id="7" name="Text 7"/>
+          <p:cNvSpPr txBox="1"/>
+          <p:nvPr/>
+        </p:nvSpPr>
+        <p:spPr>
+          <a:xfrm>
+            <a:off x="5715000" y="1892808"/>
+            <a:ext cx="2743200" cy="530352"/>
+          </a:xfrm>
+          <a:noFill/>
+          <a:ln>
+            <a:noFill/>
+          </a:ln>
+        </p:spPr>
+        <p:txBody>
+          <a:bodyPr wrap="square" lIns="0" rIns="0" tIns="0" bIns="0" anchor="t"/>
+          <a:lstStyle/>
+          <a:p>
+            <a:pPr algn="l"/>
+            <a:r>
+              <a:rPr lang="it-IT" sz="1400" b="0" i="0">
+                <a:solidFill>
+                  <a:srgbClr val="112642"/>
+                </a:solidFill>
+                <a:latin typeface="Aptos"/>
+              </a:rPr>
+              <a:t>Nel boosting, ogni nuovo albero corregge gli errori accumulati.</a:t>
+            </a:r>
+          </a:p>
+        </p:txBody>
+      </p:sp>
+      <p:sp>
+        <p:nvSpPr>
+          <p:cNvPr id="8" name="Text 8"/>
+          <p:cNvSpPr txBox="1"/>
+          <p:nvPr/>
+        </p:nvSpPr>
+        <p:spPr>
+          <a:xfrm>
+            <a:off x="5715000" y="2642616"/>
+            <a:ext cx="2743200" cy="274320"/>
+          </a:xfrm>
+          <a:noFill/>
+          <a:ln>
+            <a:noFill/>
+          </a:ln>
+        </p:spPr>
+        <p:txBody>
+          <a:bodyPr wrap="square" lIns="0" rIns="0" tIns="0" bIns="0" anchor="t"/>
+          <a:lstStyle/>
+          <a:p>
+            <a:pPr algn="l"/>
+            <a:r>
+              <a:rPr lang="it-IT" sz="1393" b="1" i="0">
+                <a:solidFill>
+                  <a:srgbClr val="0B5FA5"/>
+                </a:solidFill>
+                <a:latin typeface="Aptos"/>
+              </a:rPr>
+              <a:t>2  Punteggi sommati</a:t>
+            </a:r>
+          </a:p>
+        </p:txBody>
+      </p:sp>
+      <p:sp>
+        <p:nvSpPr>
+          <p:cNvPr id="9" name="Text 9"/>
+          <p:cNvSpPr txBox="1"/>
+          <p:nvPr/>
+        </p:nvSpPr>
+        <p:spPr>
+          <a:xfrm>
+            <a:off x="5715000" y="2962656"/>
+            <a:ext cx="2743200" cy="530352"/>
+          </a:xfrm>
+          <a:noFill/>
+          <a:ln>
+            <a:noFill/>
+          </a:ln>
+        </p:spPr>
+        <p:txBody>
+          <a:bodyPr wrap="square" lIns="0" rIns="0" tIns="0" bIns="0" anchor="t"/>
+          <a:lstStyle/>
+          <a:p>
+            <a:pPr algn="l"/>
+            <a:r>
+              <a:rPr lang="it-IT" sz="1400" b="0" i="0">
+                <a:solidFill>
+                  <a:srgbClr val="112642"/>
+                </a:solidFill>
+                <a:latin typeface="Aptos"/>
+              </a:rPr>
+              <a:t>Sommiamo i punteggi delle foglie attraversate per ottenere lo score.</a:t>
+            </a:r>
+          </a:p>
+        </p:txBody>
+      </p:sp>
+      <p:sp>
+        <p:nvSpPr>
+          <p:cNvPr id="10" name="Text 10"/>
+          <p:cNvSpPr txBox="1"/>
+          <p:nvPr/>
+        </p:nvSpPr>
+        <p:spPr>
+          <a:xfrm>
+            <a:off x="694944" y="4096512"/>
+            <a:ext cx="7772400" cy="402336"/>
+          </a:xfrm>
+          <a:noFill/>
+          <a:ln>
+            <a:noFill/>
+          </a:ln>
+        </p:spPr>
+        <p:txBody>
+          <a:bodyPr wrap="square" lIns="0" rIns="0" tIns="0" bIns="0" anchor="t"/>
+          <a:lstStyle/>
+          <a:p>
+            <a:pPr algn="l"/>
+            <a:r>
+              <a:rPr lang="it-IT" sz="1376" b="0" i="0">
+                <a:solidFill>
+                  <a:srgbClr val="112642"/>
+                </a:solidFill>
+                <a:latin typeface="Aptos"/>
+              </a:rPr>
+              <a:t>Variando la soglia sullo score scegliamo quanta parte del segnale conservare e quanto fondo accettare.</a:t>
+            </a:r>
+          </a:p>
+        </p:txBody>
+      </p:sp>
+      <p:sp>
+        <p:nvSpPr>
+          <p:cNvPr id="11" name="Fill 11"/>
           <p:cNvSpPr/>
           <p:nvPr/>
         </p:nvSpPr>
@@ -13512,14 +13078,14 @@
       </p:sp>
       <p:sp>
         <p:nvSpPr>
-          <p:cNvPr id="10" name="Fill 10"/>
+          <p:cNvPr id="12" name="Fill 12"/>
           <p:cNvSpPr/>
           <p:nvPr/>
         </p:nvSpPr>
         <p:spPr>
           <a:xfrm>
             <a:off x="0" y="0"/>
-            <a:ext cx="4064000" cy="260604"/>
+            <a:ext cx="4303059" cy="260604"/>
           </a:xfrm>
           <a:prstGeom prst="rect">
             <a:avLst/>
@@ -13534,7 +13100,7 @@
       </p:sp>
       <p:sp>
         <p:nvSpPr>
-          <p:cNvPr id="11" name="Text 11"/>
+          <p:cNvPr id="13" name="Text 13"/>
           <p:cNvSpPr txBox="1"/>
           <p:nvPr/>
         </p:nvSpPr>
@@ -13567,7 +13133,7 @@
       </p:sp>
       <p:sp>
         <p:nvSpPr>
-          <p:cNvPr id="12" name="Fill 12"/>
+          <p:cNvPr id="14" name="Fill 14"/>
           <p:cNvSpPr/>
           <p:nvPr/>
         </p:nvSpPr>
@@ -13589,14 +13155,14 @@
       </p:sp>
       <p:sp>
         <p:nvSpPr>
-          <p:cNvPr id="13" name="Fill 13"/>
+          <p:cNvPr id="15" name="Fill 15"/>
           <p:cNvSpPr/>
           <p:nvPr/>
         </p:nvSpPr>
         <p:spPr>
           <a:xfrm>
             <a:off x="0" y="4882896"/>
-            <a:ext cx="4064000" cy="260604"/>
+            <a:ext cx="4303059" cy="260604"/>
           </a:xfrm>
           <a:prstGeom prst="rect">
             <a:avLst/>
@@ -13611,7 +13177,7 @@
       </p:sp>
       <p:sp>
         <p:nvSpPr>
-          <p:cNvPr id="14" name="Text 14"/>
+          <p:cNvPr id="16" name="Text 16"/>
           <p:cNvSpPr txBox="1"/>
           <p:nvPr/>
         </p:nvSpPr>
@@ -13644,7 +13210,7 @@
       </p:sp>
       <p:sp>
         <p:nvSpPr>
-          <p:cNvPr id="15" name="Text 15"/>
+          <p:cNvPr id="17" name="Text 17"/>
           <p:cNvSpPr txBox="1"/>
           <p:nvPr/>
         </p:nvSpPr>
@@ -13670,7 +13236,7 @@
                 </a:solidFill>
                 <a:latin typeface="Aptos"/>
               </a:rPr>
-              <a:t>08/18</a:t>
+              <a:t>08/17</a:t>
             </a:r>
           </a:p>
         </p:txBody>
@@ -13736,7 +13302,7 @@
                 </a:solidFill>
                 <a:latin typeface="Aptos"/>
               </a:rPr>
-              <a:t>Dal MC ai dati</a:t>
+              <a:t>Il nostro BDT: metodo e risultati</a:t>
             </a:r>
           </a:p>
         </p:txBody>
@@ -13769,21 +13335,45 @@
                 </a:solidFill>
                 <a:latin typeface="Aptos"/>
               </a:rPr>
-              <a:t>Fonte: wiki/04-bdt-training.md; wiki/05-stage1-gate.md</a:t>
-            </a:r>
-          </a:p>
-        </p:txBody>
-      </p:sp>
-      <p:sp>
-        <p:nvSpPr>
-          <p:cNvPr id="4" name="Text 4"/>
-          <p:cNvSpPr txBox="1"/>
-          <p:nvPr/>
-        </p:nvSpPr>
-        <p:spPr>
-          <a:xfrm>
-            <a:off x="713232" y="1078992"/>
-            <a:ext cx="502920" cy="539496"/>
+              <a:t>Fonte: 00_common/stage1/features.py; wiki/04-bdt-training.md; results/production-20261006-113738</a:t>
+            </a:r>
+          </a:p>
+        </p:txBody>
+      </p:sp>
+      <p:pic>
+        <p:nvPicPr>
+          <p:cNvPr id="4" name="score_uv_production.png" descr="score_uv_production.png"/>
+          <p:cNvPicPr>
+            <a:picLocks noChangeAspect="1" noGrp="1"/>
+          </p:cNvPicPr>
+          <p:nvPr/>
+        </p:nvPicPr>
+        <p:blipFill>
+          <a:blip r:embed="rId2"/>
+          <a:stretch>
+            <a:fillRect/>
+          </a:stretch>
+        </p:blipFill>
+        <p:spPr>
+          <a:xfrm>
+            <a:off x="717804" y="1152144"/>
+            <a:ext cx="4206240" cy="3154680"/>
+          </a:xfrm>
+          <a:prstGeom prst="rect">
+            <a:avLst/>
+          </a:prstGeom>
+        </p:spPr>
+      </p:pic>
+      <p:sp>
+        <p:nvSpPr>
+          <p:cNvPr id="5" name="Text 5"/>
+          <p:cNvSpPr txBox="1"/>
+          <p:nvPr/>
+        </p:nvSpPr>
+        <p:spPr>
+          <a:xfrm>
+            <a:off x="676656" y="4297680"/>
+            <a:ext cx="4389120" cy="301752"/>
           </a:xfrm>
           <a:noFill/>
           <a:ln>
@@ -13796,27 +13386,72 @@
           <a:p>
             <a:pPr algn="l"/>
             <a:r>
-              <a:rPr lang="it-IT" sz="3354" b="1" i="0">
+              <a:rPr lang="it-IT" sz="1050" b="0" i="0">
+                <a:solidFill>
+                  <a:srgbClr val="52657B"/>
+                </a:solidFill>
+                <a:latin typeface="Aptos"/>
+              </a:rPr>
+              <a:t>Score UV: 0 ≈ fondo, 1 ≈ segnale; densità per classe.</a:t>
+            </a:r>
+          </a:p>
+          <a:p>
+            <a:pPr algn="l"/>
+            <a:r>
+              <a:rPr lang="it-IT" sz="1050" b="0" i="0">
+                <a:solidFill>
+                  <a:srgbClr val="52657B"/>
+                </a:solidFill>
+                <a:latin typeface="Aptos"/>
+              </a:rPr>
+              <a:t>Linea rossa: soglia 0,394.</a:t>
+            </a:r>
+          </a:p>
+        </p:txBody>
+      </p:sp>
+      <p:sp>
+        <p:nvSpPr>
+          <p:cNvPr id="6" name="Text 6"/>
+          <p:cNvSpPr txBox="1"/>
+          <p:nvPr/>
+        </p:nvSpPr>
+        <p:spPr>
+          <a:xfrm>
+            <a:off x="5093208" y="987552"/>
+            <a:ext cx="3337560" cy="283464"/>
+          </a:xfrm>
+          <a:noFill/>
+          <a:ln>
+            <a:noFill/>
+          </a:ln>
+        </p:spPr>
+        <p:txBody>
+          <a:bodyPr wrap="square" lIns="0" rIns="0" tIns="0" bIns="0" anchor="t"/>
+          <a:lstStyle/>
+          <a:p>
+            <a:pPr algn="l"/>
+            <a:r>
+              <a:rPr lang="it-IT" sz="1462" b="1" i="0">
                 <a:solidFill>
                   <a:srgbClr val="0B5FA5"/>
                 </a:solidFill>
                 <a:latin typeface="Aptos"/>
               </a:rPr>
-              <a:t>1</a:t>
-            </a:r>
-          </a:p>
-        </p:txBody>
-      </p:sp>
-      <p:sp>
-        <p:nvSpPr>
-          <p:cNvPr id="5" name="Text 5"/>
-          <p:cNvSpPr txBox="1"/>
-          <p:nvPr/>
-        </p:nvSpPr>
-        <p:spPr>
-          <a:xfrm>
-            <a:off x="1371600" y="1088136"/>
-            <a:ext cx="6766560" cy="365760"/>
+              <a:t>Training e selezione</a:t>
+            </a:r>
+          </a:p>
+        </p:txBody>
+      </p:sp>
+      <p:sp>
+        <p:nvSpPr>
+          <p:cNvPr id="7" name="Text 7"/>
+          <p:cNvSpPr txBox="1"/>
+          <p:nvPr/>
+        </p:nvSpPr>
+        <p:spPr>
+          <a:xfrm>
+            <a:off x="5093208" y="1316736"/>
+            <a:ext cx="3355848" cy="813816"/>
           </a:xfrm>
           <a:noFill/>
           <a:ln>
@@ -13829,27 +13464,27 @@
           <a:p>
             <a:pPr algn="l"/>
             <a:r>
-              <a:rPr lang="it-IT" sz="1806" b="1" i="0">
+              <a:rPr lang="it-IT" sz="1250" b="0" i="0">
                 <a:solidFill>
                   <a:srgbClr val="112642"/>
                 </a:solidFill>
                 <a:latin typeface="Aptos"/>
               </a:rPr>
-              <a:t>Spettro misurato e pesi</a:t>
-            </a:r>
-          </a:p>
-        </p:txBody>
-      </p:sp>
-      <p:sp>
-        <p:nvSpPr>
-          <p:cNvPr id="6" name="Text 6"/>
-          <p:cNvSpPr txBox="1"/>
-          <p:nvPr/>
-        </p:nvSpPr>
-        <p:spPr>
-          <a:xfrm>
-            <a:off x="1371600" y="1453896"/>
-            <a:ext cx="6793992" cy="338328"/>
+              <a:t>MC di nove canali: accettanza simulata, quattro fotoni osservati, pesi per fascio e canale. Dividiamo il campione 80/20; usiamo modelli UV/VIS e le stesse variabili sui dati.</a:t>
+            </a:r>
+          </a:p>
+        </p:txBody>
+      </p:sp>
+      <p:sp>
+        <p:nvSpPr>
+          <p:cNvPr id="8" name="Text 8"/>
+          <p:cNvSpPr txBox="1"/>
+          <p:nvPr/>
+        </p:nvSpPr>
+        <p:spPr>
+          <a:xfrm>
+            <a:off x="5093208" y="2203704"/>
+            <a:ext cx="3337560" cy="283464"/>
           </a:xfrm>
           <a:noFill/>
           <a:ln>
@@ -13862,27 +13497,60 @@
           <a:p>
             <a:pPr algn="l"/>
             <a:r>
-              <a:rPr lang="it-IT" sz="1419" b="0" i="0">
+              <a:rPr lang="it-IT" sz="1462" b="1" i="0">
+                <a:solidFill>
+                  <a:srgbClr val="0B5FA5"/>
+                </a:solidFill>
+                <a:latin typeface="Aptos"/>
+              </a:rPr>
+              <a:t>Le 26 variabili</a:t>
+            </a:r>
+          </a:p>
+        </p:txBody>
+      </p:sp>
+      <p:sp>
+        <p:nvSpPr>
+          <p:cNvPr id="9" name="Text 9"/>
+          <p:cNvSpPr txBox="1"/>
+          <p:nvPr/>
+        </p:nvSpPr>
+        <p:spPr>
+          <a:xfrm>
+            <a:off x="5093208" y="2532888"/>
+            <a:ext cx="3355848" cy="594360"/>
+          </a:xfrm>
+          <a:noFill/>
+          <a:ln>
+            <a:noFill/>
+          </a:ln>
+        </p:spPr>
+        <p:txBody>
+          <a:bodyPr wrap="square" lIns="0" rIns="0" tIns="0" bIns="0" anchor="t"/>
+          <a:lstStyle/>
+          <a:p>
+            <a:pPr algn="l"/>
+            <a:r>
+              <a:rPr lang="it-IT" sz="1250" b="0" i="0">
                 <a:solidFill>
                   <a:srgbClr val="112642"/>
                 </a:solidFill>
                 <a:latin typeface="Aptos"/>
               </a:rPr>
-              <a:t>Pesiamo il MC con il flusso del tagger, la sezione d'urto e l'accettanza.</a:t>
-            </a:r>
-          </a:p>
-        </p:txBody>
-      </p:sp>
-      <p:sp>
-        <p:nvSpPr>
-          <p:cNvPr id="7" name="Text 7"/>
-          <p:cNvSpPr txBox="1"/>
-          <p:nvPr/>
-        </p:nvSpPr>
-        <p:spPr>
-          <a:xfrm>
-            <a:off x="713232" y="1956816"/>
-            <a:ext cx="502920" cy="539496"/>
+              <a:t>6 masse γγ; 2 conteggi vicino a η/π⁰ e χ² del pairing; 4 variabili mancanti; 9 misure di fotoni/fascio; 2 del protone; 2 dei mesoni.</a:t>
+            </a:r>
+          </a:p>
+        </p:txBody>
+      </p:sp>
+      <p:sp>
+        <p:nvSpPr>
+          <p:cNvPr id="10" name="Text 10"/>
+          <p:cNvSpPr txBox="1"/>
+          <p:nvPr/>
+        </p:nvSpPr>
+        <p:spPr>
+          <a:xfrm>
+            <a:off x="5093208" y="3200400"/>
+            <a:ext cx="3355848" cy="283464"/>
           </a:xfrm>
           <a:noFill/>
           <a:ln>
@@ -13895,27 +13563,27 @@
           <a:p>
             <a:pPr algn="l"/>
             <a:r>
-              <a:rPr lang="it-IT" sz="3354" b="1" i="0">
+              <a:rPr lang="it-IT" sz="1462" b="1" i="0">
                 <a:solidFill>
                   <a:srgbClr val="0B5FA5"/>
                 </a:solidFill>
                 <a:latin typeface="Aptos"/>
               </a:rPr>
-              <a:t>2</a:t>
-            </a:r>
-          </a:p>
-        </p:txBody>
-      </p:sp>
-      <p:sp>
-        <p:nvSpPr>
-          <p:cNvPr id="8" name="Text 8"/>
-          <p:cNvSpPr txBox="1"/>
-          <p:nvPr/>
-        </p:nvSpPr>
-        <p:spPr>
-          <a:xfrm>
-            <a:off x="1371600" y="1965960"/>
-            <a:ext cx="6766560" cy="365760"/>
+              <a:t>Risultati sul MC di validazione</a:t>
+            </a:r>
+          </a:p>
+        </p:txBody>
+      </p:sp>
+      <p:sp>
+        <p:nvSpPr>
+          <p:cNvPr id="11" name="Text 11"/>
+          <p:cNvSpPr txBox="1"/>
+          <p:nvPr/>
+        </p:nvSpPr>
+        <p:spPr>
+          <a:xfrm>
+            <a:off x="5093208" y="3529584"/>
+            <a:ext cx="3355848" cy="411480"/>
           </a:xfrm>
           <a:noFill/>
           <a:ln>
@@ -13928,27 +13596,39 @@
           <a:p>
             <a:pPr algn="l"/>
             <a:r>
-              <a:rPr lang="it-IT" sz="1806" b="1" i="0">
+              <a:rPr lang="it-IT" sz="1250" b="0" i="0">
                 <a:solidFill>
                   <a:srgbClr val="112642"/>
                 </a:solidFill>
                 <a:latin typeface="Aptos"/>
               </a:rPr>
-              <a:t>Quattro fotoni osservati</a:t>
-            </a:r>
-          </a:p>
-        </p:txBody>
-      </p:sp>
-      <p:sp>
-        <p:nvSpPr>
-          <p:cNvPr id="9" name="Text 9"/>
-          <p:cNvSpPr txBox="1"/>
-          <p:nvPr/>
-        </p:nvSpPr>
-        <p:spPr>
-          <a:xfrm>
-            <a:off x="1371600" y="2331720"/>
-            <a:ext cx="6793992" cy="338328"/>
+              <a:t>UV: AUC 0,9979; F1 0,9855; soglia 0,394.</a:t>
+            </a:r>
+          </a:p>
+          <a:p>
+            <a:pPr algn="l"/>
+            <a:r>
+              <a:rPr lang="it-IT" sz="1250" b="0" i="0">
+                <a:solidFill>
+                  <a:srgbClr val="112642"/>
+                </a:solidFill>
+                <a:latin typeface="Aptos"/>
+              </a:rPr>
+              <a:t>VIS: AUC 0,9997; F1 0,9962; soglia 0,291.</a:t>
+            </a:r>
+          </a:p>
+        </p:txBody>
+      </p:sp>
+      <p:sp>
+        <p:nvSpPr>
+          <p:cNvPr id="12" name="Text 12"/>
+          <p:cNvSpPr txBox="1"/>
+          <p:nvPr/>
+        </p:nvSpPr>
+        <p:spPr>
+          <a:xfrm>
+            <a:off x="5093208" y="3995928"/>
+            <a:ext cx="3355848" cy="594360"/>
           </a:xfrm>
           <a:noFill/>
           <a:ln>
@@ -13961,218 +13641,20 @@
           <a:p>
             <a:pPr algn="l"/>
             <a:r>
-              <a:rPr lang="it-IT" sz="1419" b="0" i="0">
-                <a:solidFill>
-                  <a:srgbClr val="112642"/>
-                </a:solidFill>
-                <a:latin typeface="Aptos"/>
-              </a:rPr>
-              <a:t>Applichiamo a segnale e fondi la perdita di fotoni e il loro rimescolamento.</a:t>
-            </a:r>
-          </a:p>
-        </p:txBody>
-      </p:sp>
-      <p:sp>
-        <p:nvSpPr>
-          <p:cNvPr id="10" name="Text 10"/>
-          <p:cNvSpPr txBox="1"/>
-          <p:nvPr/>
-        </p:nvSpPr>
-        <p:spPr>
-          <a:xfrm>
-            <a:off x="713232" y="2834640"/>
-            <a:ext cx="502920" cy="539496"/>
-          </a:xfrm>
-          <a:noFill/>
-          <a:ln>
-            <a:noFill/>
-          </a:ln>
-        </p:spPr>
-        <p:txBody>
-          <a:bodyPr wrap="square" lIns="0" rIns="0" tIns="0" bIns="0" anchor="t"/>
-          <a:lstStyle/>
-          <a:p>
-            <a:pPr algn="l"/>
-            <a:r>
-              <a:rPr lang="it-IT" sz="3354" b="1" i="0">
-                <a:solidFill>
-                  <a:srgbClr val="0B5FA5"/>
-                </a:solidFill>
-                <a:latin typeface="Aptos"/>
-              </a:rPr>
-              <a:t>3</a:t>
-            </a:r>
-          </a:p>
-        </p:txBody>
-      </p:sp>
-      <p:sp>
-        <p:nvSpPr>
-          <p:cNvPr id="11" name="Text 11"/>
-          <p:cNvSpPr txBox="1"/>
-          <p:nvPr/>
-        </p:nvSpPr>
-        <p:spPr>
-          <a:xfrm>
-            <a:off x="1371600" y="2843784"/>
-            <a:ext cx="6766560" cy="365760"/>
-          </a:xfrm>
-          <a:noFill/>
-          <a:ln>
-            <a:noFill/>
-          </a:ln>
-        </p:spPr>
-        <p:txBody>
-          <a:bodyPr wrap="square" lIns="0" rIns="0" tIns="0" bIns="0" anchor="t"/>
-          <a:lstStyle/>
-          <a:p>
-            <a:pPr algn="l"/>
-            <a:r>
-              <a:rPr lang="it-IT" sz="1806" b="1" i="0">
-                <a:solidFill>
-                  <a:srgbClr val="112642"/>
-                </a:solidFill>
-                <a:latin typeface="Aptos"/>
-              </a:rPr>
-              <a:t>Due modelli per UV e VIS</a:t>
-            </a:r>
-          </a:p>
-        </p:txBody>
-      </p:sp>
-      <p:sp>
-        <p:nvSpPr>
-          <p:cNvPr id="12" name="Text 12"/>
-          <p:cNvSpPr txBox="1"/>
-          <p:nvPr/>
-        </p:nvSpPr>
-        <p:spPr>
-          <a:xfrm>
-            <a:off x="1371600" y="3209544"/>
-            <a:ext cx="6793992" cy="338328"/>
-          </a:xfrm>
-          <a:noFill/>
-          <a:ln>
-            <a:noFill/>
-          </a:ln>
-        </p:spPr>
-        <p:txBody>
-          <a:bodyPr wrap="square" lIns="0" rIns="0" tIns="0" bIns="0" anchor="t"/>
-          <a:lstStyle/>
-          <a:p>
-            <a:pPr algn="l"/>
-            <a:r>
-              <a:rPr lang="it-IT" sz="1419" b="0" i="0">
-                <a:solidFill>
-                  <a:srgbClr val="112642"/>
-                </a:solidFill>
-                <a:latin typeface="Aptos"/>
-              </a:rPr>
-              <a:t>Per ogni regione salviamo insieme il modello, la soglia e la provenienza.</a:t>
-            </a:r>
-          </a:p>
-        </p:txBody>
-      </p:sp>
-      <p:sp>
-        <p:nvSpPr>
-          <p:cNvPr id="13" name="Text 13"/>
-          <p:cNvSpPr txBox="1"/>
-          <p:nvPr/>
-        </p:nvSpPr>
-        <p:spPr>
-          <a:xfrm>
-            <a:off x="713232" y="3712464"/>
-            <a:ext cx="502920" cy="539496"/>
-          </a:xfrm>
-          <a:noFill/>
-          <a:ln>
-            <a:noFill/>
-          </a:ln>
-        </p:spPr>
-        <p:txBody>
-          <a:bodyPr wrap="square" lIns="0" rIns="0" tIns="0" bIns="0" anchor="t"/>
-          <a:lstStyle/>
-          <a:p>
-            <a:pPr algn="l"/>
-            <a:r>
-              <a:rPr lang="it-IT" sz="3354" b="1" i="0">
-                <a:solidFill>
-                  <a:srgbClr val="0B5FA5"/>
-                </a:solidFill>
-                <a:latin typeface="Aptos"/>
-              </a:rPr>
-              <a:t>4</a:t>
-            </a:r>
-          </a:p>
-        </p:txBody>
-      </p:sp>
-      <p:sp>
-        <p:nvSpPr>
-          <p:cNvPr id="14" name="Text 14"/>
-          <p:cNvSpPr txBox="1"/>
-          <p:nvPr/>
-        </p:nvSpPr>
-        <p:spPr>
-          <a:xfrm>
-            <a:off x="1371600" y="3721608"/>
-            <a:ext cx="6766560" cy="365760"/>
-          </a:xfrm>
-          <a:noFill/>
-          <a:ln>
-            <a:noFill/>
-          </a:ln>
-        </p:spPr>
-        <p:txBody>
-          <a:bodyPr wrap="square" lIns="0" rIns="0" tIns="0" bIns="0" anchor="t"/>
-          <a:lstStyle/>
-          <a:p>
-            <a:pPr algn="l"/>
-            <a:r>
-              <a:rPr lang="it-IT" sz="1806" b="1" i="0">
-                <a:solidFill>
-                  <a:srgbClr val="112642"/>
-                </a:solidFill>
-                <a:latin typeface="Aptos"/>
-              </a:rPr>
-              <a:t>Selezione dei dati</a:t>
-            </a:r>
-          </a:p>
-        </p:txBody>
-      </p:sp>
-      <p:sp>
-        <p:nvSpPr>
-          <p:cNvPr id="15" name="Text 15"/>
-          <p:cNvSpPr txBox="1"/>
-          <p:nvPr/>
-        </p:nvSpPr>
-        <p:spPr>
-          <a:xfrm>
-            <a:off x="1371600" y="4087368"/>
-            <a:ext cx="6793992" cy="338328"/>
-          </a:xfrm>
-          <a:noFill/>
-          <a:ln>
-            <a:noFill/>
-          </a:ln>
-        </p:spPr>
-        <p:txBody>
-          <a:bodyPr wrap="square" lIns="0" rIns="0" tIns="0" bIns="0" anchor="t"/>
-          <a:lstStyle/>
-          <a:p>
-            <a:pPr algn="l"/>
-            <a:r>
-              <a:rPr lang="it-IT" sz="1419" b="0" i="0">
-                <a:solidFill>
-                  <a:srgbClr val="112642"/>
-                </a:solidFill>
-                <a:latin typeface="Aptos"/>
-              </a:rPr>
-              <a:t>Dopo il filtro BDT, ricostruiamo gli eventi con la stessa ipotesi e lo stesso pairing χ².</a:t>
-            </a:r>
-          </a:p>
-        </p:txBody>
-      </p:sp>
-      <p:sp>
-        <p:nvSpPr>
-          <p:cNvPr id="16" name="Fill 16"/>
+              <a:rPr lang="it-IT" sz="1150" b="0" i="0">
+                <a:solidFill>
+                  <a:srgbClr val="52657B"/>
+                </a:solidFill>
+                <a:latin typeface="Aptos"/>
+              </a:rPr>
+              <a:t>AUC pesata misura la separazione a tutte le soglie (1 è ideale). F1 pesato combina precisione e richiamo; scegliamo la soglia massimizzandolo sulla stessa validazione MC. Non misura la purezza dei dati.</a:t>
+            </a:r>
+          </a:p>
+        </p:txBody>
+      </p:sp>
+      <p:sp>
+        <p:nvSpPr>
+          <p:cNvPr id="13" name="Fill 13"/>
           <p:cNvSpPr/>
           <p:nvPr/>
         </p:nvSpPr>
@@ -14194,14 +13676,14 @@
       </p:sp>
       <p:sp>
         <p:nvSpPr>
-          <p:cNvPr id="17" name="Fill 17"/>
+          <p:cNvPr id="14" name="Fill 14"/>
           <p:cNvSpPr/>
           <p:nvPr/>
         </p:nvSpPr>
         <p:spPr>
           <a:xfrm>
             <a:off x="0" y="0"/>
-            <a:ext cx="4572000" cy="260604"/>
+            <a:ext cx="4840941" cy="260604"/>
           </a:xfrm>
           <a:prstGeom prst="rect">
             <a:avLst/>
@@ -14216,7 +13698,7 @@
       </p:sp>
       <p:sp>
         <p:nvSpPr>
-          <p:cNvPr id="18" name="Text 18"/>
+          <p:cNvPr id="15" name="Text 15"/>
           <p:cNvSpPr txBox="1"/>
           <p:nvPr/>
         </p:nvSpPr>
@@ -14249,7 +13731,7 @@
       </p:sp>
       <p:sp>
         <p:nvSpPr>
-          <p:cNvPr id="19" name="Fill 19"/>
+          <p:cNvPr id="16" name="Fill 16"/>
           <p:cNvSpPr/>
           <p:nvPr/>
         </p:nvSpPr>
@@ -14271,14 +13753,14 @@
       </p:sp>
       <p:sp>
         <p:nvSpPr>
-          <p:cNvPr id="20" name="Fill 20"/>
+          <p:cNvPr id="17" name="Fill 17"/>
           <p:cNvSpPr/>
           <p:nvPr/>
         </p:nvSpPr>
         <p:spPr>
           <a:xfrm>
             <a:off x="0" y="4882896"/>
-            <a:ext cx="4572000" cy="260604"/>
+            <a:ext cx="4840941" cy="260604"/>
           </a:xfrm>
           <a:prstGeom prst="rect">
             <a:avLst/>
@@ -14293,7 +13775,7 @@
       </p:sp>
       <p:sp>
         <p:nvSpPr>
-          <p:cNvPr id="21" name="Text 21"/>
+          <p:cNvPr id="18" name="Text 18"/>
           <p:cNvSpPr txBox="1"/>
           <p:nvPr/>
         </p:nvSpPr>
@@ -14326,7 +13808,7 @@
       </p:sp>
       <p:sp>
         <p:nvSpPr>
-          <p:cNvPr id="22" name="Text 22"/>
+          <p:cNvPr id="19" name="Text 19"/>
           <p:cNvSpPr txBox="1"/>
           <p:nvPr/>
         </p:nvSpPr>
@@ -14352,7 +13834,7 @@
                 </a:solidFill>
                 <a:latin typeface="Aptos"/>
               </a:rPr>
-              <a:t>09/18</a:t>
+              <a:t>09/17</a:t>
             </a:r>
           </a:p>
         </p:txBody>

</xml_diff>

<commit_message>
Expand BDT introduction from Nayak slides
</commit_message>
<xml_diff>
--- a/presentations/graal_analysis_framework_asimmetrie.pptx
+++ b/presentations/graal_analysis_framework_asimmetrie.pptx
@@ -12827,7 +12827,7 @@
                 </a:solidFill>
                 <a:latin typeface="Aptos"/>
               </a:rPr>
-              <a:t>Fonte: XGBoost, Introduction to Boosted Trees; ROOT/TMVA Users Guide §8.13; schema DMLC, Apache 2.0</a:t>
+              <a:t>Fonte: A. Nayak, BDT (2024), pp. 10–11; schema dalla stessa presentazione</a:t>
             </a:r>
           </a:p>
         </p:txBody>
@@ -12840,8 +12840,8 @@
         </p:nvSpPr>
         <p:spPr>
           <a:xfrm>
-            <a:off x="676656" y="950976"/>
-            <a:ext cx="7790688" cy="466344"/>
+            <a:off x="676656" y="960120"/>
+            <a:ext cx="4846320" cy="603504"/>
           </a:xfrm>
           <a:noFill/>
           <a:ln>
@@ -12854,20 +12854,152 @@
           <a:p>
             <a:pPr algn="l"/>
             <a:r>
-              <a:rPr lang="it-IT" sz="1462" b="0" i="0">
+              <a:rPr lang="it-IT" sz="1376" b="0" i="0">
                 <a:solidFill>
                   <a:srgbClr val="112642"/>
                 </a:solidFill>
                 <a:latin typeface="Aptos"/>
               </a:rPr>
-              <a:t>Un Boosted Decision Tree (BDT) combina alberi: ognuno pone domande sulle variabili e assegna un punteggio alle foglie.</a:t>
+              <a:t>Il BDT impara da eventi etichettati come segnale o fondo. Ogni evento è descritto da variabili e può avere un peso.</a:t>
+            </a:r>
+          </a:p>
+        </p:txBody>
+      </p:sp>
+      <p:sp>
+        <p:nvSpPr>
+          <p:cNvPr id="5" name="Text 5"/>
+          <p:cNvSpPr txBox="1"/>
+          <p:nvPr/>
+        </p:nvSpPr>
+        <p:spPr>
+          <a:xfrm>
+            <a:off x="676656" y="1728216"/>
+            <a:ext cx="4709160" cy="292608"/>
+          </a:xfrm>
+          <a:noFill/>
+          <a:ln>
+            <a:noFill/>
+          </a:ln>
+        </p:spPr>
+        <p:txBody>
+          <a:bodyPr wrap="square" lIns="0" rIns="0" tIns="0" bIns="0" anchor="t"/>
+          <a:lstStyle/>
+          <a:p>
+            <a:pPr algn="l"/>
+            <a:r>
+              <a:rPr lang="it-IT" sz="1548" b="1" i="0">
+                <a:solidFill>
+                  <a:srgbClr val="0B5FA5"/>
+                </a:solidFill>
+                <a:latin typeface="Aptos"/>
+              </a:rPr>
+              <a:t>Dalla radice ai rami</a:t>
+            </a:r>
+          </a:p>
+        </p:txBody>
+      </p:sp>
+      <p:sp>
+        <p:nvSpPr>
+          <p:cNvPr id="6" name="Text 6"/>
+          <p:cNvSpPr txBox="1"/>
+          <p:nvPr/>
+        </p:nvSpPr>
+        <p:spPr>
+          <a:xfrm>
+            <a:off x="676656" y="2048256"/>
+            <a:ext cx="4754880" cy="749808"/>
+          </a:xfrm>
+          <a:noFill/>
+          <a:ln>
+            <a:noFill/>
+          </a:ln>
+        </p:spPr>
+        <p:txBody>
+          <a:bodyPr wrap="square" lIns="0" rIns="0" tIns="0" bIns="0" anchor="t"/>
+          <a:lstStyle/>
+          <a:p>
+            <a:pPr algn="l"/>
+            <a:r>
+              <a:rPr lang="it-IT" sz="1400" b="0" i="0">
+                <a:solidFill>
+                  <a:srgbClr val="112642"/>
+                </a:solidFill>
+                <a:latin typeface="Aptos"/>
+              </a:rPr>
+              <a:t>Partendo da tutti gli eventi, l'algoritmo prova variabili e soglie e sceglie la divisione che separa meglio le due classi. A ogni nodo può riusare una variabile già scelta.</a:t>
+            </a:r>
+          </a:p>
+        </p:txBody>
+      </p:sp>
+      <p:sp>
+        <p:nvSpPr>
+          <p:cNvPr id="7" name="Text 7"/>
+          <p:cNvSpPr txBox="1"/>
+          <p:nvPr/>
+        </p:nvSpPr>
+        <p:spPr>
+          <a:xfrm>
+            <a:off x="676656" y="2834640"/>
+            <a:ext cx="4709160" cy="292608"/>
+          </a:xfrm>
+          <a:noFill/>
+          <a:ln>
+            <a:noFill/>
+          </a:ln>
+        </p:spPr>
+        <p:txBody>
+          <a:bodyPr wrap="square" lIns="0" rIns="0" tIns="0" bIns="0" anchor="t"/>
+          <a:lstStyle/>
+          <a:p>
+            <a:pPr algn="l"/>
+            <a:r>
+              <a:rPr lang="it-IT" sz="1548" b="1" i="0">
+                <a:solidFill>
+                  <a:srgbClr val="0B5FA5"/>
+                </a:solidFill>
+                <a:latin typeface="Aptos"/>
+              </a:rPr>
+              <a:t>Dai rami alle foglie</a:t>
+            </a:r>
+          </a:p>
+        </p:txBody>
+      </p:sp>
+      <p:sp>
+        <p:nvSpPr>
+          <p:cNvPr id="8" name="Text 8"/>
+          <p:cNvSpPr txBox="1"/>
+          <p:nvPr/>
+        </p:nvSpPr>
+        <p:spPr>
+          <a:xfrm>
+            <a:off x="676656" y="3154680"/>
+            <a:ext cx="4754880" cy="704088"/>
+          </a:xfrm>
+          <a:noFill/>
+          <a:ln>
+            <a:noFill/>
+          </a:ln>
+        </p:spPr>
+        <p:txBody>
+          <a:bodyPr wrap="square" lIns="0" rIns="0" tIns="0" bIns="0" anchor="t"/>
+          <a:lstStyle/>
+          <a:p>
+            <a:pPr algn="l"/>
+            <a:r>
+              <a:rPr lang="it-IT" sz="1400" b="0" i="0">
+                <a:solidFill>
+                  <a:srgbClr val="112642"/>
+                </a:solidFill>
+                <a:latin typeface="Aptos"/>
+              </a:rPr>
+              <a:t>Ripete la divisione finché raggiunge la profondità massima o non migliora più la separazione. Le foglie indicano la classe; nel BDT contribuiscono allo score finale.</a:t>
             </a:r>
           </a:p>
         </p:txBody>
       </p:sp>
       <p:pic>
         <p:nvPicPr>
-          <p:cNvPr id="5" name="xgboost_two_trees.png" descr="xgboost_two_trees.png"/>
+          <p:cNvPr id="9" name="decision_tree_nayak.png" descr="decision_tree_nayak.png"/>
           <p:cNvPicPr>
             <a:picLocks noChangeAspect="1" noGrp="1"/>
           </p:cNvPicPr>
@@ -12881,8 +13013,8 @@
         </p:blipFill>
         <p:spPr>
           <a:xfrm>
-            <a:off x="753287" y="1563624"/>
-            <a:ext cx="4793643" cy="2423160"/>
+            <a:off x="5626248" y="1033272"/>
+            <a:ext cx="2975567" cy="3255264"/>
           </a:xfrm>
           <a:prstGeom prst="rect">
             <a:avLst/>
@@ -12891,14 +13023,14 @@
       </p:pic>
       <p:sp>
         <p:nvSpPr>
-          <p:cNvPr id="6" name="Text 6"/>
-          <p:cNvSpPr txBox="1"/>
-          <p:nvPr/>
-        </p:nvSpPr>
-        <p:spPr>
-          <a:xfrm>
-            <a:off x="5715000" y="1572768"/>
-            <a:ext cx="2743200" cy="274320"/>
+          <p:cNvPr id="10" name="Text 10"/>
+          <p:cNvSpPr txBox="1"/>
+          <p:nvPr/>
+        </p:nvSpPr>
+        <p:spPr>
+          <a:xfrm>
+            <a:off x="5742432" y="4325112"/>
+            <a:ext cx="2743200" cy="219456"/>
           </a:xfrm>
           <a:noFill/>
           <a:ln>
@@ -12909,29 +13041,29 @@
           <a:bodyPr wrap="square" lIns="0" rIns="0" tIns="0" bIns="0" anchor="t"/>
           <a:lstStyle/>
           <a:p>
-            <a:pPr algn="l"/>
-            <a:r>
-              <a:rPr lang="it-IT" sz="1393" b="1" i="0">
-                <a:solidFill>
-                  <a:srgbClr val="0B5FA5"/>
-                </a:solidFill>
-                <a:latin typeface="Aptos"/>
-              </a:rPr>
-              <a:t>1  Alberi successivi</a:t>
-            </a:r>
-          </a:p>
-        </p:txBody>
-      </p:sp>
-      <p:sp>
-        <p:nvSpPr>
-          <p:cNvPr id="7" name="Text 7"/>
-          <p:cNvSpPr txBox="1"/>
-          <p:nvPr/>
-        </p:nvSpPr>
-        <p:spPr>
-          <a:xfrm>
-            <a:off x="5715000" y="1892808"/>
-            <a:ext cx="2743200" cy="530352"/>
+            <a:pPr algn="ctr"/>
+            <a:r>
+              <a:rPr lang="it-IT" sz="1160" b="0" i="0">
+                <a:solidFill>
+                  <a:srgbClr val="52657B"/>
+                </a:solidFill>
+                <a:latin typeface="Aptos"/>
+              </a:rPr>
+              <a:t>B = fondo     S = segnale</a:t>
+            </a:r>
+          </a:p>
+        </p:txBody>
+      </p:sp>
+      <p:sp>
+        <p:nvSpPr>
+          <p:cNvPr id="11" name="Text 11"/>
+          <p:cNvSpPr txBox="1"/>
+          <p:nvPr/>
+        </p:nvSpPr>
+        <p:spPr>
+          <a:xfrm>
+            <a:off x="685800" y="3995928"/>
+            <a:ext cx="4828032" cy="566928"/>
           </a:xfrm>
           <a:noFill/>
           <a:ln>
@@ -12944,119 +13076,20 @@
           <a:p>
             <a:pPr algn="l"/>
             <a:r>
-              <a:rPr lang="it-IT" sz="1400" b="0" i="0">
+              <a:rPr lang="it-IT" sz="1280" b="0" i="0">
                 <a:solidFill>
                   <a:srgbClr val="112642"/>
                 </a:solidFill>
                 <a:latin typeface="Aptos"/>
               </a:rPr>
-              <a:t>Nel boosting, ogni nuovo albero corregge gli errori accumulati.</a:t>
-            </a:r>
-          </a:p>
-        </p:txBody>
-      </p:sp>
-      <p:sp>
-        <p:nvSpPr>
-          <p:cNvPr id="8" name="Text 8"/>
-          <p:cNvSpPr txBox="1"/>
-          <p:nvPr/>
-        </p:nvSpPr>
-        <p:spPr>
-          <a:xfrm>
-            <a:off x="5715000" y="2642616"/>
-            <a:ext cx="2743200" cy="274320"/>
-          </a:xfrm>
-          <a:noFill/>
-          <a:ln>
-            <a:noFill/>
-          </a:ln>
-        </p:spPr>
-        <p:txBody>
-          <a:bodyPr wrap="square" lIns="0" rIns="0" tIns="0" bIns="0" anchor="t"/>
-          <a:lstStyle/>
-          <a:p>
-            <a:pPr algn="l"/>
-            <a:r>
-              <a:rPr lang="it-IT" sz="1393" b="1" i="0">
-                <a:solidFill>
-                  <a:srgbClr val="0B5FA5"/>
-                </a:solidFill>
-                <a:latin typeface="Aptos"/>
-              </a:rPr>
-              <a:t>2  Punteggi sommati</a:t>
-            </a:r>
-          </a:p>
-        </p:txBody>
-      </p:sp>
-      <p:sp>
-        <p:nvSpPr>
-          <p:cNvPr id="9" name="Text 9"/>
-          <p:cNvSpPr txBox="1"/>
-          <p:nvPr/>
-        </p:nvSpPr>
-        <p:spPr>
-          <a:xfrm>
-            <a:off x="5715000" y="2962656"/>
-            <a:ext cx="2743200" cy="530352"/>
-          </a:xfrm>
-          <a:noFill/>
-          <a:ln>
-            <a:noFill/>
-          </a:ln>
-        </p:spPr>
-        <p:txBody>
-          <a:bodyPr wrap="square" lIns="0" rIns="0" tIns="0" bIns="0" anchor="t"/>
-          <a:lstStyle/>
-          <a:p>
-            <a:pPr algn="l"/>
-            <a:r>
-              <a:rPr lang="it-IT" sz="1400" b="0" i="0">
-                <a:solidFill>
-                  <a:srgbClr val="112642"/>
-                </a:solidFill>
-                <a:latin typeface="Aptos"/>
-              </a:rPr>
-              <a:t>Sommiamo i punteggi delle foglie attraversate per ottenere lo score.</a:t>
-            </a:r>
-          </a:p>
-        </p:txBody>
-      </p:sp>
-      <p:sp>
-        <p:nvSpPr>
-          <p:cNvPr id="10" name="Text 10"/>
-          <p:cNvSpPr txBox="1"/>
-          <p:nvPr/>
-        </p:nvSpPr>
-        <p:spPr>
-          <a:xfrm>
-            <a:off x="694944" y="4096512"/>
-            <a:ext cx="7772400" cy="402336"/>
-          </a:xfrm>
-          <a:noFill/>
-          <a:ln>
-            <a:noFill/>
-          </a:ln>
-        </p:spPr>
-        <p:txBody>
-          <a:bodyPr wrap="square" lIns="0" rIns="0" tIns="0" bIns="0" anchor="t"/>
-          <a:lstStyle/>
-          <a:p>
-            <a:pPr algn="l"/>
-            <a:r>
-              <a:rPr lang="it-IT" sz="1376" b="0" i="0">
-                <a:solidFill>
-                  <a:srgbClr val="112642"/>
-                </a:solidFill>
-                <a:latin typeface="Aptos"/>
-              </a:rPr>
-              <a:t>Variando la soglia sullo score scegliamo quanta parte del segnale conservare e quanto fondo accettare.</a:t>
-            </a:r>
-          </a:p>
-        </p:txBody>
-      </p:sp>
-      <p:sp>
-        <p:nvSpPr>
-          <p:cNvPr id="11" name="Fill 11"/>
+              <a:t>Invece di essere scartato da un singolo taglio, l'evento percorre un ramo a ogni risposta. Più alberi formano lo score; la sua soglia regola segnale e fondo.</a:t>
+            </a:r>
+          </a:p>
+        </p:txBody>
+      </p:sp>
+      <p:sp>
+        <p:nvSpPr>
+          <p:cNvPr id="12" name="Fill 12"/>
           <p:cNvSpPr/>
           <p:nvPr/>
         </p:nvSpPr>
@@ -13078,7 +13111,7 @@
       </p:sp>
       <p:sp>
         <p:nvSpPr>
-          <p:cNvPr id="12" name="Fill 12"/>
+          <p:cNvPr id="13" name="Fill 13"/>
           <p:cNvSpPr/>
           <p:nvPr/>
         </p:nvSpPr>
@@ -13100,7 +13133,7 @@
       </p:sp>
       <p:sp>
         <p:nvSpPr>
-          <p:cNvPr id="13" name="Text 13"/>
+          <p:cNvPr id="14" name="Text 14"/>
           <p:cNvSpPr txBox="1"/>
           <p:nvPr/>
         </p:nvSpPr>
@@ -13133,7 +13166,7 @@
       </p:sp>
       <p:sp>
         <p:nvSpPr>
-          <p:cNvPr id="14" name="Fill 14"/>
+          <p:cNvPr id="15" name="Fill 15"/>
           <p:cNvSpPr/>
           <p:nvPr/>
         </p:nvSpPr>
@@ -13155,7 +13188,7 @@
       </p:sp>
       <p:sp>
         <p:nvSpPr>
-          <p:cNvPr id="15" name="Fill 15"/>
+          <p:cNvPr id="16" name="Fill 16"/>
           <p:cNvSpPr/>
           <p:nvPr/>
         </p:nvSpPr>
@@ -13177,7 +13210,7 @@
       </p:sp>
       <p:sp>
         <p:nvSpPr>
-          <p:cNvPr id="16" name="Text 16"/>
+          <p:cNvPr id="17" name="Text 17"/>
           <p:cNvSpPr txBox="1"/>
           <p:nvPr/>
         </p:nvSpPr>
@@ -13210,7 +13243,7 @@
       </p:sp>
       <p:sp>
         <p:nvSpPr>
-          <p:cNvPr id="17" name="Text 17"/>
+          <p:cNvPr id="18" name="Text 18"/>
           <p:cNvSpPr txBox="1"/>
           <p:nvPr/>
         </p:nvSpPr>

</xml_diff>

<commit_message>
Clarify flux calibration slide from repository code
</commit_message>
<xml_diff>
--- a/presentations/graal_analysis_framework_asimmetrie.pptx
+++ b/presentations/graal_analysis_framework_asimmetrie.pptx
@@ -3527,7 +3527,7 @@
                 </a:solidFill>
                 <a:latin typeface="Aptos"/>
               </a:rPr>
-              <a:t>Fonte: wiki/06-calibration.md; config/run_manifest.csv</a:t>
+              <a:t>Fonte: estratti semplificati da 06_calibration/build_strip_energy_flux.py e run_manifest.py</a:t>
             </a:r>
           </a:p>
         </p:txBody>
@@ -3540,8 +3540,8 @@
         </p:nvSpPr>
         <p:spPr>
           <a:xfrm>
-            <a:off x="694944" y="1060704"/>
-            <a:ext cx="3291840" cy="365760"/>
+            <a:off x="676656" y="941832"/>
+            <a:ext cx="7818120" cy="393192"/>
           </a:xfrm>
           <a:noFill/>
           <a:ln>
@@ -3554,251 +3554,640 @@
           <a:p>
             <a:pPr algn="l"/>
             <a:r>
-              <a:rPr lang="it-IT" sz="1978" b="1" i="0">
+              <a:rPr lang="it-IT" sz="1376" b="0" i="0">
+                <a:solidFill>
+                  <a:srgbClr val="112642"/>
+                </a:solidFill>
+                <a:latin typeface="Aptos"/>
+              </a:rPr>
+              <a:t>Per ogni run usiamo le energie del fascio in h80 per calibrare l'asse dei flussi esterni.</a:t>
+            </a:r>
+          </a:p>
+        </p:txBody>
+      </p:sp>
+      <p:sp>
+        <p:nvSpPr>
+          <p:cNvPr id="5" name="Fill 5"/>
+          <p:cNvSpPr/>
+          <p:nvPr/>
+        </p:nvSpPr>
+        <p:spPr>
+          <a:xfrm>
+            <a:off x="667512" y="1472184"/>
+            <a:ext cx="3657600" cy="667512"/>
+          </a:xfrm>
+          <a:prstGeom prst="roundRect">
+            <a:avLst/>
+          </a:prstGeom>
+          <a:solidFill>
+            <a:srgbClr val="071E42"/>
+          </a:solidFill>
+          <a:ln>
+            <a:noFill/>
+          </a:ln>
+        </p:spPr>
+      </p:sp>
+      <p:sp>
+        <p:nvSpPr>
+          <p:cNvPr id="6" name="Text 6"/>
+          <p:cNvSpPr txBox="1"/>
+          <p:nvPr/>
+        </p:nvSpPr>
+        <p:spPr>
+          <a:xfrm>
+            <a:off x="832104" y="1572768"/>
+            <a:ext cx="3337560" cy="466344"/>
+          </a:xfrm>
+          <a:noFill/>
+          <a:ln>
+            <a:noFill/>
+          </a:ln>
+        </p:spPr>
+        <p:txBody>
+          <a:bodyPr wrap="square" lIns="0" rIns="0" tIns="0" bIns="0" anchor="ctr"/>
+          <a:lstStyle/>
+          <a:p>
+            <a:pPr algn="l"/>
+            <a:r>
+              <a:rPr lang="it-IT" sz="1230" b="0" i="0">
+                <a:solidFill>
+                  <a:srgbClr val="FFFFFF"/>
+                </a:solidFill>
+                <a:latin typeface="Aptos"/>
+              </a:rPr>
+              <a:t>all_records = validate_manifest(</a:t>
+            </a:r>
+          </a:p>
+          <a:p>
+            <a:pPr algn="l"/>
+            <a:r>
+              <a:rPr lang="it-IT" sz="1230" b="0" i="0">
+                <a:solidFill>
+                  <a:srgbClr val="FFFFFF"/>
+                </a:solidFill>
+                <a:latin typeface="Aptos"/>
+              </a:rPr>
+              <a:t>    args.manifest)</a:t>
+            </a:r>
+          </a:p>
+        </p:txBody>
+      </p:sp>
+      <p:sp>
+        <p:nvSpPr>
+          <p:cNvPr id="7" name="Text 7"/>
+          <p:cNvSpPr txBox="1"/>
+          <p:nvPr/>
+        </p:nvSpPr>
+        <p:spPr>
+          <a:xfrm>
+            <a:off x="4389120" y="1536192"/>
+            <a:ext cx="338328" cy="530352"/>
+          </a:xfrm>
+          <a:noFill/>
+          <a:ln>
+            <a:noFill/>
+          </a:ln>
+        </p:spPr>
+        <p:txBody>
+          <a:bodyPr wrap="square" lIns="0" rIns="0" tIns="0" bIns="0" anchor="ctr"/>
+          <a:lstStyle/>
+          <a:p>
+            <a:pPr algn="ctr"/>
+            <a:r>
+              <a:rPr lang="it-IT" sz="2236" b="1" i="0">
                 <a:solidFill>
                   <a:srgbClr val="0B5FA5"/>
                 </a:solidFill>
                 <a:latin typeface="Aptos"/>
               </a:rPr>
-              <a:t>Run manifest</a:t>
-            </a:r>
-          </a:p>
-        </p:txBody>
-      </p:sp>
-      <p:sp>
-        <p:nvSpPr>
-          <p:cNvPr id="5" name="Text 5"/>
-          <p:cNvSpPr txBox="1"/>
-          <p:nvPr/>
-        </p:nvSpPr>
-        <p:spPr>
-          <a:xfrm>
-            <a:off x="694944" y="1453896"/>
-            <a:ext cx="7543800" cy="411480"/>
-          </a:xfrm>
-          <a:noFill/>
-          <a:ln>
-            <a:noFill/>
-          </a:ln>
-        </p:spPr>
-        <p:txBody>
-          <a:bodyPr wrap="square" lIns="0" rIns="0" tIns="0" bIns="0" anchor="t"/>
-          <a:lstStyle/>
-          <a:p>
-            <a:pPr algn="l"/>
-            <a:r>
-              <a:rPr lang="it-IT" sz="1548" b="0" i="0">
+              <a:t>→</a:t>
+            </a:r>
+          </a:p>
+        </p:txBody>
+      </p:sp>
+      <p:sp>
+        <p:nvSpPr>
+          <p:cNvPr id="8" name="Fill 8"/>
+          <p:cNvSpPr/>
+          <p:nvPr/>
+        </p:nvSpPr>
+        <p:spPr>
+          <a:xfrm>
+            <a:off x="4773168" y="1472184"/>
+            <a:ext cx="3694176" cy="667512"/>
+          </a:xfrm>
+          <a:prstGeom prst="roundRect">
+            <a:avLst/>
+          </a:prstGeom>
+          <a:solidFill>
+            <a:srgbClr val="DDEFFA"/>
+          </a:solidFill>
+          <a:ln>
+            <a:noFill/>
+          </a:ln>
+        </p:spPr>
+      </p:sp>
+      <p:sp>
+        <p:nvSpPr>
+          <p:cNvPr id="9" name="Text 9"/>
+          <p:cNvSpPr txBox="1"/>
+          <p:nvPr/>
+        </p:nvSpPr>
+        <p:spPr>
+          <a:xfrm>
+            <a:off x="4919472" y="1527048"/>
+            <a:ext cx="3401568" cy="566928"/>
+          </a:xfrm>
+          <a:noFill/>
+          <a:ln>
+            <a:noFill/>
+          </a:ln>
+        </p:spPr>
+        <p:txBody>
+          <a:bodyPr wrap="square" lIns="0" rIns="0" tIns="0" bIns="0" anchor="ctr"/>
+          <a:lstStyle/>
+          <a:p>
+            <a:pPr algn="l"/>
+            <a:r>
+              <a:rPr lang="it-IT" sz="1310" b="0" i="0">
                 <a:solidFill>
                   <a:srgbClr val="112642"/>
                 </a:solidFill>
                 <a:latin typeface="Aptos"/>
               </a:rPr>
-              <a:t>Il manifest assegna a ogni run il target, la regione UV o VIS e lo stato di polarizzazione.</a:t>
-            </a:r>
-          </a:p>
-        </p:txBody>
-      </p:sp>
-      <p:sp>
-        <p:nvSpPr>
-          <p:cNvPr id="6" name="Text 6"/>
-          <p:cNvSpPr txBox="1"/>
-          <p:nvPr/>
-        </p:nvSpPr>
-        <p:spPr>
-          <a:xfrm>
-            <a:off x="694944" y="2002536"/>
-            <a:ext cx="3840480" cy="365760"/>
-          </a:xfrm>
-          <a:noFill/>
-          <a:ln>
-            <a:noFill/>
-          </a:ln>
-        </p:spPr>
-        <p:txBody>
-          <a:bodyPr wrap="square" lIns="0" rIns="0" tIns="0" bIns="0" anchor="t"/>
-          <a:lstStyle/>
-          <a:p>
-            <a:pPr algn="l"/>
-            <a:r>
-              <a:rPr lang="it-IT" sz="1978" b="1" i="0">
+              <a:t>Il CSV identifica run, target P/D e fascio UV/VIS. La polarizzazione viene dagli eventi h80.</a:t>
+            </a:r>
+          </a:p>
+        </p:txBody>
+      </p:sp>
+      <p:sp>
+        <p:nvSpPr>
+          <p:cNvPr id="10" name="Fill 10"/>
+          <p:cNvSpPr/>
+          <p:nvPr/>
+        </p:nvSpPr>
+        <p:spPr>
+          <a:xfrm>
+            <a:off x="667512" y="2240280"/>
+            <a:ext cx="3657600" cy="667512"/>
+          </a:xfrm>
+          <a:prstGeom prst="roundRect">
+            <a:avLst/>
+          </a:prstGeom>
+          <a:solidFill>
+            <a:srgbClr val="071E42"/>
+          </a:solidFill>
+          <a:ln>
+            <a:noFill/>
+          </a:ln>
+        </p:spPr>
+      </p:sp>
+      <p:sp>
+        <p:nvSpPr>
+          <p:cNvPr id="11" name="Text 11"/>
+          <p:cNvSpPr txBox="1"/>
+          <p:nvPr/>
+        </p:nvSpPr>
+        <p:spPr>
+          <a:xfrm>
+            <a:off x="832104" y="2331720"/>
+            <a:ext cx="3337560" cy="475488"/>
+          </a:xfrm>
+          <a:noFill/>
+          <a:ln>
+            <a:noFill/>
+          </a:ln>
+        </p:spPr>
+        <p:txBody>
+          <a:bodyPr wrap="square" lIns="0" rIns="0" tIns="0" bIns="0" anchor="ctr"/>
+          <a:lstStyle/>
+          <a:p>
+            <a:pPr algn="l"/>
+            <a:r>
+              <a:rPr lang="it-IT" sz="1230" b="0" i="0">
+                <a:solidFill>
+                  <a:srgbClr val="FFFFFF"/>
+                </a:solidFill>
+                <a:latin typeface="Aptos"/>
+              </a:rPr>
+              <a:t>read_h80_lookup(...)</a:t>
+            </a:r>
+          </a:p>
+          <a:p>
+            <a:pPr algn="l"/>
+            <a:r>
+              <a:rPr lang="it-IT" sz="1230" b="0" i="0">
+                <a:solidFill>
+                  <a:srgbClr val="FFFFFF"/>
+                </a:solidFill>
+                <a:latin typeface="Aptos"/>
+              </a:rPr>
+              <a:t>read_calibration_cells(...)</a:t>
+            </a:r>
+          </a:p>
+        </p:txBody>
+      </p:sp>
+      <p:sp>
+        <p:nvSpPr>
+          <p:cNvPr id="12" name="Text 12"/>
+          <p:cNvSpPr txBox="1"/>
+          <p:nvPr/>
+        </p:nvSpPr>
+        <p:spPr>
+          <a:xfrm>
+            <a:off x="4389120" y="2304288"/>
+            <a:ext cx="338328" cy="530352"/>
+          </a:xfrm>
+          <a:noFill/>
+          <a:ln>
+            <a:noFill/>
+          </a:ln>
+        </p:spPr>
+        <p:txBody>
+          <a:bodyPr wrap="square" lIns="0" rIns="0" tIns="0" bIns="0" anchor="ctr"/>
+          <a:lstStyle/>
+          <a:p>
+            <a:pPr algn="ctr"/>
+            <a:r>
+              <a:rPr lang="it-IT" sz="2236" b="1" i="0">
                 <a:solidFill>
                   <a:srgbClr val="0B5FA5"/>
                 </a:solidFill>
                 <a:latin typeface="Aptos"/>
               </a:rPr>
-              <a:t>h80 + flux ROOT</a:t>
-            </a:r>
-          </a:p>
-        </p:txBody>
-      </p:sp>
-      <p:sp>
-        <p:nvSpPr>
-          <p:cNvPr id="7" name="Text 7"/>
-          <p:cNvSpPr txBox="1"/>
-          <p:nvPr/>
-        </p:nvSpPr>
-        <p:spPr>
-          <a:xfrm>
-            <a:off x="694944" y="2395728"/>
-            <a:ext cx="7543800" cy="438912"/>
-          </a:xfrm>
-          <a:noFill/>
-          <a:ln>
-            <a:noFill/>
-          </a:ln>
-        </p:spPr>
-        <p:txBody>
-          <a:bodyPr wrap="square" lIns="0" rIns="0" tIns="0" bIns="0" anchor="t"/>
-          <a:lstStyle/>
-          <a:p>
-            <a:pPr algn="l"/>
-            <a:r>
-              <a:rPr lang="it-IT" sz="1548" b="0" i="0">
+              <a:t>→</a:t>
+            </a:r>
+          </a:p>
+        </p:txBody>
+      </p:sp>
+      <p:sp>
+        <p:nvSpPr>
+          <p:cNvPr id="13" name="Fill 13"/>
+          <p:cNvSpPr/>
+          <p:nvPr/>
+        </p:nvSpPr>
+        <p:spPr>
+          <a:xfrm>
+            <a:off x="4773168" y="2240280"/>
+            <a:ext cx="3694176" cy="667512"/>
+          </a:xfrm>
+          <a:prstGeom prst="roundRect">
+            <a:avLst/>
+          </a:prstGeom>
+          <a:solidFill>
+            <a:srgbClr val="DDEFFA"/>
+          </a:solidFill>
+          <a:ln>
+            <a:noFill/>
+          </a:ln>
+        </p:spPr>
+      </p:sp>
+      <p:sp>
+        <p:nvSpPr>
+          <p:cNvPr id="14" name="Text 14"/>
+          <p:cNvSpPr txBox="1"/>
+          <p:nvPr/>
+        </p:nvSpPr>
+        <p:spPr>
+          <a:xfrm>
+            <a:off x="4919472" y="2295144"/>
+            <a:ext cx="3401568" cy="566928"/>
+          </a:xfrm>
+          <a:noFill/>
+          <a:ln>
+            <a:noFill/>
+          </a:ln>
+        </p:spPr>
+        <p:txBody>
+          <a:bodyPr wrap="square" lIns="0" rIns="0" tIns="0" bIns="0" anchor="ctr"/>
+          <a:lstStyle/>
+          <a:p>
+            <a:pPr algn="l"/>
+            <a:r>
+              <a:rPr lang="it-IT" sz="1290" b="0" i="0">
                 <a:solidFill>
                   <a:srgbClr val="112642"/>
                 </a:solidFill>
                 <a:latin typeface="Aptos"/>
               </a:rPr>
-              <a:t>Calibriamo l'energia delle strip 1–128 con la mediana misurata per run e polarizzazione.</a:t>
-            </a:r>
-          </a:p>
-        </p:txBody>
-      </p:sp>
-      <p:sp>
-        <p:nvSpPr>
-          <p:cNvPr id="8" name="Text 8"/>
-          <p:cNvSpPr txBox="1"/>
-          <p:nvPr/>
-        </p:nvSpPr>
-        <p:spPr>
-          <a:xfrm>
-            <a:off x="694944" y="2971800"/>
-            <a:ext cx="6309360" cy="365760"/>
-          </a:xfrm>
-          <a:noFill/>
-          <a:ln>
-            <a:noFill/>
-          </a:ln>
-        </p:spPr>
-        <p:txBody>
-          <a:bodyPr wrap="square" lIns="0" rIns="0" tIns="0" bIns="0" anchor="t"/>
-          <a:lstStyle/>
-          <a:p>
-            <a:pPr algn="l"/>
-            <a:r>
-              <a:rPr lang="it-IT" sz="1978" b="1" i="0">
+              <a:t>Da Eγ e Xstrip otteniamo la mediana per run/strip e la media per run/polarizzazione/strip usata nel fit.</a:t>
+            </a:r>
+          </a:p>
+        </p:txBody>
+      </p:sp>
+      <p:sp>
+        <p:nvSpPr>
+          <p:cNvPr id="15" name="Fill 15"/>
+          <p:cNvSpPr/>
+          <p:nvPr/>
+        </p:nvSpPr>
+        <p:spPr>
+          <a:xfrm>
+            <a:off x="667512" y="3008376"/>
+            <a:ext cx="3657600" cy="667512"/>
+          </a:xfrm>
+          <a:prstGeom prst="roundRect">
+            <a:avLst/>
+          </a:prstGeom>
+          <a:solidFill>
+            <a:srgbClr val="071E42"/>
+          </a:solidFill>
+          <a:ln>
+            <a:noFill/>
+          </a:ln>
+        </p:spPr>
+      </p:sp>
+      <p:sp>
+        <p:nvSpPr>
+          <p:cNvPr id="16" name="Text 16"/>
+          <p:cNvSpPr txBox="1"/>
+          <p:nvPr/>
+        </p:nvSpPr>
+        <p:spPr>
+          <a:xfrm>
+            <a:off x="832104" y="3099816"/>
+            <a:ext cx="3337560" cy="475488"/>
+          </a:xfrm>
+          <a:noFill/>
+          <a:ln>
+            <a:noFill/>
+          </a:ln>
+        </p:spPr>
+        <p:txBody>
+          <a:bodyPr wrap="square" lIns="0" rIns="0" tIns="0" bIns="0" anchor="ctr"/>
+          <a:lstStyle/>
+          <a:p>
+            <a:pPr algn="l"/>
+            <a:r>
+              <a:rPr lang="it-IT" sz="1200" b="0" i="0">
+                <a:solidFill>
+                  <a:srgbClr val="FFFFFF"/>
+                </a:solidFill>
+                <a:latin typeface="Aptos"/>
+              </a:rPr>
+              <a:t>_FLUX_SUFFIXES = ("POL1", "POL2",</a:t>
+            </a:r>
+          </a:p>
+          <a:p>
+            <a:pPr algn="l"/>
+            <a:r>
+              <a:rPr lang="it-IT" sz="1200" b="0" i="0">
+                <a:solidFill>
+                  <a:srgbClr val="FFFFFF"/>
+                </a:solidFill>
+                <a:latin typeface="Aptos"/>
+              </a:rPr>
+              <a:t>                  "BREM")</a:t>
+            </a:r>
+          </a:p>
+        </p:txBody>
+      </p:sp>
+      <p:sp>
+        <p:nvSpPr>
+          <p:cNvPr id="17" name="Text 17"/>
+          <p:cNvSpPr txBox="1"/>
+          <p:nvPr/>
+        </p:nvSpPr>
+        <p:spPr>
+          <a:xfrm>
+            <a:off x="4389120" y="3072384"/>
+            <a:ext cx="338328" cy="530352"/>
+          </a:xfrm>
+          <a:noFill/>
+          <a:ln>
+            <a:noFill/>
+          </a:ln>
+        </p:spPr>
+        <p:txBody>
+          <a:bodyPr wrap="square" lIns="0" rIns="0" tIns="0" bIns="0" anchor="ctr"/>
+          <a:lstStyle/>
+          <a:p>
+            <a:pPr algn="ctr"/>
+            <a:r>
+              <a:rPr lang="it-IT" sz="2236" b="1" i="0">
                 <a:solidFill>
                   <a:srgbClr val="0B5FA5"/>
                 </a:solidFill>
                 <a:latin typeface="Aptos"/>
               </a:rPr>
-              <a:t>POL1 · POL2 · BREM</a:t>
-            </a:r>
-          </a:p>
-        </p:txBody>
-      </p:sp>
-      <p:sp>
-        <p:nvSpPr>
-          <p:cNvPr id="9" name="Text 9"/>
-          <p:cNvSpPr txBox="1"/>
-          <p:nvPr/>
-        </p:nvSpPr>
-        <p:spPr>
-          <a:xfrm>
-            <a:off x="694944" y="3364992"/>
-            <a:ext cx="7543800" cy="411480"/>
-          </a:xfrm>
-          <a:noFill/>
-          <a:ln>
-            <a:noFill/>
-          </a:ln>
-        </p:spPr>
-        <p:txBody>
-          <a:bodyPr wrap="square" lIns="0" rIns="0" tIns="0" bIns="0" anchor="t"/>
-          <a:lstStyle/>
-          <a:p>
-            <a:pPr algn="l"/>
-            <a:r>
-              <a:rPr lang="it-IT" sz="1548" b="0" i="0">
+              <a:t>→</a:t>
+            </a:r>
+          </a:p>
+        </p:txBody>
+      </p:sp>
+      <p:sp>
+        <p:nvSpPr>
+          <p:cNvPr id="18" name="Fill 18"/>
+          <p:cNvSpPr/>
+          <p:nvPr/>
+        </p:nvSpPr>
+        <p:spPr>
+          <a:xfrm>
+            <a:off x="4773168" y="3008376"/>
+            <a:ext cx="3694176" cy="667512"/>
+          </a:xfrm>
+          <a:prstGeom prst="roundRect">
+            <a:avLst/>
+          </a:prstGeom>
+          <a:solidFill>
+            <a:srgbClr val="DDEFFA"/>
+          </a:solidFill>
+          <a:ln>
+            <a:noFill/>
+          </a:ln>
+        </p:spPr>
+      </p:sp>
+      <p:sp>
+        <p:nvSpPr>
+          <p:cNvPr id="19" name="Text 19"/>
+          <p:cNvSpPr txBox="1"/>
+          <p:nvPr/>
+        </p:nvSpPr>
+        <p:spPr>
+          <a:xfrm>
+            <a:off x="4919472" y="3063240"/>
+            <a:ext cx="3401568" cy="566928"/>
+          </a:xfrm>
+          <a:noFill/>
+          <a:ln>
+            <a:noFill/>
+          </a:ln>
+        </p:spPr>
+        <p:txBody>
+          <a:bodyPr wrap="square" lIns="0" rIns="0" tIns="0" bIns="0" anchor="ctr"/>
+          <a:lstStyle/>
+          <a:p>
+            <a:pPr algn="l"/>
+            <a:r>
+              <a:rPr lang="it-IT" sz="1270" b="0" i="0">
                 <a:solidFill>
                   <a:srgbClr val="112642"/>
                 </a:solidFill>
                 <a:latin typeface="Aptos"/>
               </a:rPr>
-              <a:t>Per usare un run servono tutti e tre i flussi. Se ne manca uno, escludiamo il run.</a:t>
-            </a:r>
-          </a:p>
-        </p:txBody>
-      </p:sp>
-      <p:sp>
-        <p:nvSpPr>
-          <p:cNvPr id="10" name="Text 10"/>
-          <p:cNvSpPr txBox="1"/>
-          <p:nvPr/>
-        </p:nvSpPr>
-        <p:spPr>
-          <a:xfrm>
-            <a:off x="694944" y="3968496"/>
-            <a:ext cx="5486400" cy="384048"/>
-          </a:xfrm>
-          <a:noFill/>
-          <a:ln>
-            <a:noFill/>
-          </a:ln>
-        </p:spPr>
-        <p:txBody>
-          <a:bodyPr wrap="square" lIns="0" rIns="0" tIns="0" bIns="0" anchor="t"/>
-          <a:lstStyle/>
-          <a:p>
-            <a:pPr algn="l"/>
-            <a:r>
-              <a:rPr lang="it-IT" sz="2150" b="1" i="0">
+              <a:t>Ogni run richiede il tripletto completo. Se manca un flusso, la lettura si arresta; BREM resta un controllo separato.</a:t>
+            </a:r>
+          </a:p>
+        </p:txBody>
+      </p:sp>
+      <p:sp>
+        <p:nvSpPr>
+          <p:cNvPr id="20" name="Fill 20"/>
+          <p:cNvSpPr/>
+          <p:nvPr/>
+        </p:nvSpPr>
+        <p:spPr>
+          <a:xfrm>
+            <a:off x="667512" y="3776472"/>
+            <a:ext cx="3657600" cy="667512"/>
+          </a:xfrm>
+          <a:prstGeom prst="roundRect">
+            <a:avLst/>
+          </a:prstGeom>
+          <a:solidFill>
+            <a:srgbClr val="071E42"/>
+          </a:solidFill>
+          <a:ln>
+            <a:noFill/>
+          </a:ln>
+        </p:spPr>
+      </p:sp>
+      <p:sp>
+        <p:nvSpPr>
+          <p:cNvPr id="21" name="Text 21"/>
+          <p:cNvSpPr txBox="1"/>
+          <p:nvPr/>
+        </p:nvSpPr>
+        <p:spPr>
+          <a:xfrm>
+            <a:off x="832104" y="3867912"/>
+            <a:ext cx="3337560" cy="475488"/>
+          </a:xfrm>
+          <a:noFill/>
+          <a:ln>
+            <a:noFill/>
+          </a:ln>
+        </p:spPr>
+        <p:txBody>
+          <a:bodyPr wrap="square" lIns="0" rIns="0" tIns="0" bIns="0" anchor="ctr"/>
+          <a:lstStyle/>
+          <a:p>
+            <a:pPr algn="l"/>
+            <a:r>
+              <a:rPr lang="it-IT" sz="1180" b="0" i="0">
+                <a:solidFill>
+                  <a:srgbClr val="FFFFFF"/>
+                </a:solidFill>
+                <a:latin typeface="Aptos"/>
+              </a:rPr>
+              <a:t>fit = root.TF1(..., "pol4", 0.5, 128.5)</a:t>
+            </a:r>
+          </a:p>
+          <a:p>
+            <a:pPr algn="l"/>
+            <a:r>
+              <a:rPr lang="it-IT" sz="1180" b="0" i="0">
+                <a:solidFill>
+                  <a:srgbClr val="FFFFFF"/>
+                </a:solidFill>
+                <a:latin typeface="Aptos"/>
+              </a:rPr>
+              <a:t>profile.Fit(fit, "QSWN")</a:t>
+            </a:r>
+          </a:p>
+        </p:txBody>
+      </p:sp>
+      <p:sp>
+        <p:nvSpPr>
+          <p:cNvPr id="22" name="Text 22"/>
+          <p:cNvSpPr txBox="1"/>
+          <p:nvPr/>
+        </p:nvSpPr>
+        <p:spPr>
+          <a:xfrm>
+            <a:off x="4389120" y="3840480"/>
+            <a:ext cx="338328" cy="530352"/>
+          </a:xfrm>
+          <a:noFill/>
+          <a:ln>
+            <a:noFill/>
+          </a:ln>
+        </p:spPr>
+        <p:txBody>
+          <a:bodyPr wrap="square" lIns="0" rIns="0" tIns="0" bIns="0" anchor="ctr"/>
+          <a:lstStyle/>
+          <a:p>
+            <a:pPr algn="ctr"/>
+            <a:r>
+              <a:rPr lang="it-IT" sz="2236" b="1" i="0">
                 <a:solidFill>
                   <a:srgbClr val="0B5FA5"/>
                 </a:solidFill>
                 <a:latin typeface="Aptos"/>
               </a:rPr>
-              <a:t>flux_calibrated.root</a:t>
-            </a:r>
-          </a:p>
-        </p:txBody>
-      </p:sp>
-      <p:sp>
-        <p:nvSpPr>
-          <p:cNvPr id="11" name="Text 11"/>
-          <p:cNvSpPr txBox="1"/>
-          <p:nvPr/>
-        </p:nvSpPr>
-        <p:spPr>
-          <a:xfrm>
-            <a:off x="694944" y="4343400"/>
-            <a:ext cx="7498080" cy="246888"/>
-          </a:xfrm>
-          <a:noFill/>
-          <a:ln>
-            <a:noFill/>
-          </a:ln>
-        </p:spPr>
-        <p:txBody>
-          <a:bodyPr wrap="square" lIns="0" rIns="0" tIns="0" bIns="0" anchor="t"/>
-          <a:lstStyle/>
-          <a:p>
-            <a:pPr algn="l"/>
-            <a:r>
-              <a:rPr lang="it-IT" sz="1376" b="0" i="0">
-                <a:solidFill>
-                  <a:srgbClr val="52657B"/>
-                </a:solidFill>
-                <a:latin typeface="Aptos"/>
-              </a:rPr>
-              <a:t>Il file finale conserva gli assi energetici calibrati e viene scritto in modo atomico.</a:t>
-            </a:r>
-          </a:p>
-        </p:txBody>
-      </p:sp>
-      <p:sp>
-        <p:nvSpPr>
-          <p:cNvPr id="12" name="Fill 12"/>
+              <a:t>→</a:t>
+            </a:r>
+          </a:p>
+        </p:txBody>
+      </p:sp>
+      <p:sp>
+        <p:nvSpPr>
+          <p:cNvPr id="23" name="Fill 23"/>
+          <p:cNvSpPr/>
+          <p:nvPr/>
+        </p:nvSpPr>
+        <p:spPr>
+          <a:xfrm>
+            <a:off x="4773168" y="3776472"/>
+            <a:ext cx="3694176" cy="667512"/>
+          </a:xfrm>
+          <a:prstGeom prst="roundRect">
+            <a:avLst/>
+          </a:prstGeom>
+          <a:solidFill>
+            <a:srgbClr val="DDEFFA"/>
+          </a:solidFill>
+          <a:ln>
+            <a:noFill/>
+          </a:ln>
+        </p:spPr>
+      </p:sp>
+      <p:sp>
+        <p:nvSpPr>
+          <p:cNvPr id="24" name="Text 24"/>
+          <p:cNvSpPr txBox="1"/>
+          <p:nvPr/>
+        </p:nvSpPr>
+        <p:spPr>
+          <a:xfrm>
+            <a:off x="4919472" y="3831336"/>
+            <a:ext cx="3401568" cy="566928"/>
+          </a:xfrm>
+          <a:noFill/>
+          <a:ln>
+            <a:noFill/>
+          </a:ln>
+        </p:spPr>
+        <p:txBody>
+          <a:bodyPr wrap="square" lIns="0" rIns="0" tIns="0" bIns="0" anchor="ctr"/>
+          <a:lstStyle/>
+          <a:p>
+            <a:pPr algn="l"/>
+            <a:r>
+              <a:rPr lang="it-IT" sz="1260" b="0" i="0">
+                <a:solidFill>
+                  <a:srgbClr val="112642"/>
+                </a:solidFill>
+                <a:latin typeface="Aptos"/>
+              </a:rPr>
+              <a:t>Il fit monotono richiede ≥5 strip e gli estremi 1/128. Riscrive gli assi Eγ in flux_calibrated.root, in modo atomico.</a:t>
+            </a:r>
+          </a:p>
+        </p:txBody>
+      </p:sp>
+      <p:sp>
+        <p:nvSpPr>
+          <p:cNvPr id="25" name="Fill 25"/>
           <p:cNvSpPr/>
           <p:nvPr/>
         </p:nvSpPr>
@@ -3820,7 +4209,7 @@
       </p:sp>
       <p:sp>
         <p:nvSpPr>
-          <p:cNvPr id="13" name="Fill 13"/>
+          <p:cNvPr id="26" name="Fill 26"/>
           <p:cNvSpPr/>
           <p:nvPr/>
         </p:nvSpPr>
@@ -3842,7 +4231,7 @@
       </p:sp>
       <p:sp>
         <p:nvSpPr>
-          <p:cNvPr id="14" name="Text 14"/>
+          <p:cNvPr id="27" name="Text 27"/>
           <p:cNvSpPr txBox="1"/>
           <p:nvPr/>
         </p:nvSpPr>
@@ -3875,7 +4264,7 @@
       </p:sp>
       <p:sp>
         <p:nvSpPr>
-          <p:cNvPr id="15" name="Fill 15"/>
+          <p:cNvPr id="28" name="Fill 28"/>
           <p:cNvSpPr/>
           <p:nvPr/>
         </p:nvSpPr>
@@ -3897,7 +4286,7 @@
       </p:sp>
       <p:sp>
         <p:nvSpPr>
-          <p:cNvPr id="16" name="Fill 16"/>
+          <p:cNvPr id="29" name="Fill 29"/>
           <p:cNvSpPr/>
           <p:nvPr/>
         </p:nvSpPr>
@@ -3919,7 +4308,7 @@
       </p:sp>
       <p:sp>
         <p:nvSpPr>
-          <p:cNvPr id="17" name="Text 17"/>
+          <p:cNvPr id="30" name="Text 30"/>
           <p:cNvSpPr txBox="1"/>
           <p:nvPr/>
         </p:nvSpPr>
@@ -3952,7 +4341,7 @@
       </p:sp>
       <p:sp>
         <p:nvSpPr>
-          <p:cNvPr id="18" name="Text 18"/>
+          <p:cNvPr id="31" name="Text 31"/>
           <p:cNvSpPr txBox="1"/>
           <p:nvPr/>
         </p:nvSpPr>

</xml_diff>

<commit_message>
feat(tests): add tests for decuplet rescattering and Figure 4 integration
- Implement tests for k_sigma_eq26 near threshold radial log convergence and recoil root mapping in test_decuplet_rescattering.py.
- Enhance test coverage for Figure 4 integration, including binwise certification and assembly, ensuring cross-bin covariance preservation.
- Introduce validation for Figure 18 mass density predictions and comparisons against independent readings in new validation files.
- Establish a coherent model for density predictions to eliminate redundant global azimuth contributions.
</commit_message>
<xml_diff>
--- a/presentations/graal_analysis_framework_asimmetrie.pptx
+++ b/presentations/graal_analysis_framework_asimmetrie.pptx
@@ -1,9 +1,12 @@
 
 <file path=ppt/presentation.xml><?xml version="1.0" encoding="utf-8"?>
-<p:presentation xmlns:a="http://schemas.openxmlformats.org/drawingml/2006/main" xmlns:p="http://schemas.openxmlformats.org/presentationml/2006/main" xmlns:r="http://schemas.openxmlformats.org/officeDocument/2006/relationships" autoCompressPictures="0" saveSubsetFonts="1">
+<p:presentation xmlns:a="http://schemas.openxmlformats.org/drawingml/2006/main" xmlns:r="http://schemas.openxmlformats.org/officeDocument/2006/relationships" xmlns:p="http://schemas.openxmlformats.org/presentationml/2006/main" saveSubsetFonts="1" autoCompressPictures="0">
   <p:sldMasterIdLst>
     <p:sldMasterId id="2147483648" r:id="rId1"/>
   </p:sldMasterIdLst>
+  <p:notesMasterIdLst>
+    <p:notesMasterId r:id="rId19"/>
+  </p:notesMasterIdLst>
   <p:sldIdLst>
     <p:sldId id="256" r:id="rId2"/>
     <p:sldId id="257" r:id="rId3"/>
@@ -29,8 +32,8 @@
     <a:defPPr>
       <a:defRPr lang="en-US"/>
     </a:defPPr>
-    <a:lvl1pPr algn="l" defTabSz="457200" eaLnBrk="1" hangingPunct="1" latinLnBrk="0" marL="0" rtl="0">
-      <a:defRPr kern="1200" sz="1800">
+    <a:lvl1pPr marL="0" algn="l" defTabSz="457200" rtl="0" eaLnBrk="1" latinLnBrk="0" hangingPunct="1">
+      <a:defRPr sz="1800" kern="1200">
         <a:solidFill>
           <a:schemeClr val="tx1"/>
         </a:solidFill>
@@ -39,8 +42,8 @@
         <a:cs typeface="+mn-cs"/>
       </a:defRPr>
     </a:lvl1pPr>
-    <a:lvl2pPr algn="l" defTabSz="457200" eaLnBrk="1" hangingPunct="1" latinLnBrk="0" marL="457200" rtl="0">
-      <a:defRPr kern="1200" sz="1800">
+    <a:lvl2pPr marL="457200" algn="l" defTabSz="457200" rtl="0" eaLnBrk="1" latinLnBrk="0" hangingPunct="1">
+      <a:defRPr sz="1800" kern="1200">
         <a:solidFill>
           <a:schemeClr val="tx1"/>
         </a:solidFill>
@@ -49,8 +52,8 @@
         <a:cs typeface="+mn-cs"/>
       </a:defRPr>
     </a:lvl2pPr>
-    <a:lvl3pPr algn="l" defTabSz="457200" eaLnBrk="1" hangingPunct="1" latinLnBrk="0" marL="914400" rtl="0">
-      <a:defRPr kern="1200" sz="1800">
+    <a:lvl3pPr marL="914400" algn="l" defTabSz="457200" rtl="0" eaLnBrk="1" latinLnBrk="0" hangingPunct="1">
+      <a:defRPr sz="1800" kern="1200">
         <a:solidFill>
           <a:schemeClr val="tx1"/>
         </a:solidFill>
@@ -59,8 +62,8 @@
         <a:cs typeface="+mn-cs"/>
       </a:defRPr>
     </a:lvl3pPr>
-    <a:lvl4pPr algn="l" defTabSz="457200" eaLnBrk="1" hangingPunct="1" latinLnBrk="0" marL="1371600" rtl="0">
-      <a:defRPr kern="1200" sz="1800">
+    <a:lvl4pPr marL="1371600" algn="l" defTabSz="457200" rtl="0" eaLnBrk="1" latinLnBrk="0" hangingPunct="1">
+      <a:defRPr sz="1800" kern="1200">
         <a:solidFill>
           <a:schemeClr val="tx1"/>
         </a:solidFill>
@@ -69,8 +72,8 @@
         <a:cs typeface="+mn-cs"/>
       </a:defRPr>
     </a:lvl4pPr>
-    <a:lvl5pPr algn="l" defTabSz="457200" eaLnBrk="1" hangingPunct="1" latinLnBrk="0" marL="1828800" rtl="0">
-      <a:defRPr kern="1200" sz="1800">
+    <a:lvl5pPr marL="1828800" algn="l" defTabSz="457200" rtl="0" eaLnBrk="1" latinLnBrk="0" hangingPunct="1">
+      <a:defRPr sz="1800" kern="1200">
         <a:solidFill>
           <a:schemeClr val="tx1"/>
         </a:solidFill>
@@ -79,8 +82,8 @@
         <a:cs typeface="+mn-cs"/>
       </a:defRPr>
     </a:lvl5pPr>
-    <a:lvl6pPr algn="l" defTabSz="457200" eaLnBrk="1" hangingPunct="1" latinLnBrk="0" marL="2286000" rtl="0">
-      <a:defRPr kern="1200" sz="1800">
+    <a:lvl6pPr marL="2286000" algn="l" defTabSz="457200" rtl="0" eaLnBrk="1" latinLnBrk="0" hangingPunct="1">
+      <a:defRPr sz="1800" kern="1200">
         <a:solidFill>
           <a:schemeClr val="tx1"/>
         </a:solidFill>
@@ -89,8 +92,8 @@
         <a:cs typeface="+mn-cs"/>
       </a:defRPr>
     </a:lvl6pPr>
-    <a:lvl7pPr algn="l" defTabSz="457200" eaLnBrk="1" hangingPunct="1" latinLnBrk="0" marL="2743200" rtl="0">
-      <a:defRPr kern="1200" sz="1800">
+    <a:lvl7pPr marL="2743200" algn="l" defTabSz="457200" rtl="0" eaLnBrk="1" latinLnBrk="0" hangingPunct="1">
+      <a:defRPr sz="1800" kern="1200">
         <a:solidFill>
           <a:schemeClr val="tx1"/>
         </a:solidFill>
@@ -99,8 +102,8 @@
         <a:cs typeface="+mn-cs"/>
       </a:defRPr>
     </a:lvl7pPr>
-    <a:lvl8pPr algn="l" defTabSz="457200" eaLnBrk="1" hangingPunct="1" latinLnBrk="0" marL="3200400" rtl="0">
-      <a:defRPr kern="1200" sz="1800">
+    <a:lvl8pPr marL="3200400" algn="l" defTabSz="457200" rtl="0" eaLnBrk="1" latinLnBrk="0" hangingPunct="1">
+      <a:defRPr sz="1800" kern="1200">
         <a:solidFill>
           <a:schemeClr val="tx1"/>
         </a:solidFill>
@@ -109,8 +112,8 @@
         <a:cs typeface="+mn-cs"/>
       </a:defRPr>
     </a:lvl8pPr>
-    <a:lvl9pPr algn="l" defTabSz="457200" eaLnBrk="1" hangingPunct="1" latinLnBrk="0" marL="3657600" rtl="0">
-      <a:defRPr kern="1200" sz="1800">
+    <a:lvl9pPr marL="3657600" algn="l" defTabSz="457200" rtl="0" eaLnBrk="1" latinLnBrk="0" hangingPunct="1">
+      <a:defRPr sz="1800" kern="1200">
         <a:solidFill>
           <a:schemeClr val="tx1"/>
         </a:solidFill>
@@ -139,6 +142,440 @@
 </p:presentation>
 </file>
 
+<file path=ppt/notesMasters/notesMaster1.xml><?xml version="1.0" encoding="utf-8"?>
+<p:notesMaster xmlns:a="http://schemas.openxmlformats.org/drawingml/2006/main" xmlns:r="http://schemas.openxmlformats.org/officeDocument/2006/relationships" xmlns:p="http://schemas.openxmlformats.org/presentationml/2006/main">
+  <p:cSld>
+    <p:bg>
+      <p:bgRef idx="1001">
+        <a:schemeClr val="bg1"/>
+      </p:bgRef>
+    </p:bg>
+    <p:spTree>
+      <p:nvGrpSpPr>
+        <p:cNvPr id="1" name=""/>
+        <p:cNvGrpSpPr/>
+        <p:nvPr/>
+      </p:nvGrpSpPr>
+      <p:grpSpPr>
+        <a:xfrm>
+          <a:off x="0" y="0"/>
+          <a:ext cx="0" cy="0"/>
+          <a:chOff x="0" y="0"/>
+          <a:chExt cx="0" cy="0"/>
+        </a:xfrm>
+      </p:grpSpPr>
+      <p:sp>
+        <p:nvSpPr>
+          <p:cNvPr id="2" name="Header Placeholder 1"/>
+          <p:cNvSpPr>
+            <a:spLocks noGrp="1"/>
+          </p:cNvSpPr>
+          <p:nvPr>
+            <p:ph type="hdr" sz="quarter"/>
+          </p:nvPr>
+        </p:nvSpPr>
+        <p:spPr>
+          <a:xfrm>
+            <a:off x="0" y="0"/>
+            <a:ext cx="2971800" cy="458788"/>
+          </a:xfrm>
+          <a:prstGeom prst="rect">
+            <a:avLst/>
+          </a:prstGeom>
+        </p:spPr>
+        <p:txBody>
+          <a:bodyPr vert="horz" lIns="91440" tIns="45720" rIns="91440" bIns="45720" rtlCol="0"/>
+          <a:lstStyle>
+            <a:lvl1pPr algn="l">
+              <a:defRPr sz="1200"/>
+            </a:lvl1pPr>
+          </a:lstStyle>
+          <a:p>
+            <a:endParaRPr lang="en-IT"/>
+          </a:p>
+        </p:txBody>
+      </p:sp>
+      <p:sp>
+        <p:nvSpPr>
+          <p:cNvPr id="3" name="Date Placeholder 2"/>
+          <p:cNvSpPr>
+            <a:spLocks noGrp="1"/>
+          </p:cNvSpPr>
+          <p:nvPr>
+            <p:ph type="dt" idx="1"/>
+          </p:nvPr>
+        </p:nvSpPr>
+        <p:spPr>
+          <a:xfrm>
+            <a:off x="3884613" y="0"/>
+            <a:ext cx="2971800" cy="458788"/>
+          </a:xfrm>
+          <a:prstGeom prst="rect">
+            <a:avLst/>
+          </a:prstGeom>
+        </p:spPr>
+        <p:txBody>
+          <a:bodyPr vert="horz" lIns="91440" tIns="45720" rIns="91440" bIns="45720" rtlCol="0"/>
+          <a:lstStyle>
+            <a:lvl1pPr algn="r">
+              <a:defRPr sz="1200"/>
+            </a:lvl1pPr>
+          </a:lstStyle>
+          <a:p>
+            <a:fld id="{C307D8E1-7F65-B246-988C-ACD65CF75BAF}" type="datetimeFigureOut">
+              <a:rPr lang="en-IT" smtClean="0"/>
+              <a:t>06/10/2026</a:t>
+            </a:fld>
+            <a:endParaRPr lang="en-IT"/>
+          </a:p>
+        </p:txBody>
+      </p:sp>
+      <p:sp>
+        <p:nvSpPr>
+          <p:cNvPr id="4" name="Slide Image Placeholder 3"/>
+          <p:cNvSpPr>
+            <a:spLocks noGrp="1" noRot="1" noChangeAspect="1"/>
+          </p:cNvSpPr>
+          <p:nvPr>
+            <p:ph type="sldImg" idx="2"/>
+          </p:nvPr>
+        </p:nvSpPr>
+        <p:spPr>
+          <a:xfrm>
+            <a:off x="685800" y="1143000"/>
+            <a:ext cx="5486400" cy="3086100"/>
+          </a:xfrm>
+          <a:prstGeom prst="rect">
+            <a:avLst/>
+          </a:prstGeom>
+          <a:noFill/>
+          <a:ln w="12700">
+            <a:solidFill>
+              <a:prstClr val="black"/>
+            </a:solidFill>
+          </a:ln>
+        </p:spPr>
+        <p:txBody>
+          <a:bodyPr vert="horz" lIns="91440" tIns="45720" rIns="91440" bIns="45720" rtlCol="0" anchor="ctr"/>
+          <a:lstStyle/>
+          <a:p>
+            <a:endParaRPr lang="en-IT"/>
+          </a:p>
+        </p:txBody>
+      </p:sp>
+      <p:sp>
+        <p:nvSpPr>
+          <p:cNvPr id="5" name="Notes Placeholder 4"/>
+          <p:cNvSpPr>
+            <a:spLocks noGrp="1"/>
+          </p:cNvSpPr>
+          <p:nvPr>
+            <p:ph type="body" sz="quarter" idx="3"/>
+          </p:nvPr>
+        </p:nvSpPr>
+        <p:spPr>
+          <a:xfrm>
+            <a:off x="685800" y="4400550"/>
+            <a:ext cx="5486400" cy="3600450"/>
+          </a:xfrm>
+          <a:prstGeom prst="rect">
+            <a:avLst/>
+          </a:prstGeom>
+        </p:spPr>
+        <p:txBody>
+          <a:bodyPr vert="horz" lIns="91440" tIns="45720" rIns="91440" bIns="45720" rtlCol="0"/>
+          <a:lstStyle/>
+          <a:p>
+            <a:pPr lvl="0"/>
+            <a:r>
+              <a:rPr lang="en-GB"/>
+              <a:t>Click to edit Master text styles</a:t>
+            </a:r>
+          </a:p>
+          <a:p>
+            <a:pPr lvl="1"/>
+            <a:r>
+              <a:rPr lang="en-GB"/>
+              <a:t>Second level</a:t>
+            </a:r>
+          </a:p>
+          <a:p>
+            <a:pPr lvl="2"/>
+            <a:r>
+              <a:rPr lang="en-GB"/>
+              <a:t>Third level</a:t>
+            </a:r>
+          </a:p>
+          <a:p>
+            <a:pPr lvl="3"/>
+            <a:r>
+              <a:rPr lang="en-GB"/>
+              <a:t>Fourth level</a:t>
+            </a:r>
+          </a:p>
+          <a:p>
+            <a:pPr lvl="4"/>
+            <a:r>
+              <a:rPr lang="en-GB"/>
+              <a:t>Fifth level</a:t>
+            </a:r>
+            <a:endParaRPr lang="en-IT"/>
+          </a:p>
+        </p:txBody>
+      </p:sp>
+      <p:sp>
+        <p:nvSpPr>
+          <p:cNvPr id="6" name="Footer Placeholder 5"/>
+          <p:cNvSpPr>
+            <a:spLocks noGrp="1"/>
+          </p:cNvSpPr>
+          <p:nvPr>
+            <p:ph type="ftr" sz="quarter" idx="4"/>
+          </p:nvPr>
+        </p:nvSpPr>
+        <p:spPr>
+          <a:xfrm>
+            <a:off x="0" y="8685213"/>
+            <a:ext cx="2971800" cy="458787"/>
+          </a:xfrm>
+          <a:prstGeom prst="rect">
+            <a:avLst/>
+          </a:prstGeom>
+        </p:spPr>
+        <p:txBody>
+          <a:bodyPr vert="horz" lIns="91440" tIns="45720" rIns="91440" bIns="45720" rtlCol="0" anchor="b"/>
+          <a:lstStyle>
+            <a:lvl1pPr algn="l">
+              <a:defRPr sz="1200"/>
+            </a:lvl1pPr>
+          </a:lstStyle>
+          <a:p>
+            <a:endParaRPr lang="en-IT"/>
+          </a:p>
+        </p:txBody>
+      </p:sp>
+      <p:sp>
+        <p:nvSpPr>
+          <p:cNvPr id="7" name="Slide Number Placeholder 6"/>
+          <p:cNvSpPr>
+            <a:spLocks noGrp="1"/>
+          </p:cNvSpPr>
+          <p:nvPr>
+            <p:ph type="sldNum" sz="quarter" idx="5"/>
+          </p:nvPr>
+        </p:nvSpPr>
+        <p:spPr>
+          <a:xfrm>
+            <a:off x="3884613" y="8685213"/>
+            <a:ext cx="2971800" cy="458787"/>
+          </a:xfrm>
+          <a:prstGeom prst="rect">
+            <a:avLst/>
+          </a:prstGeom>
+        </p:spPr>
+        <p:txBody>
+          <a:bodyPr vert="horz" lIns="91440" tIns="45720" rIns="91440" bIns="45720" rtlCol="0" anchor="b"/>
+          <a:lstStyle>
+            <a:lvl1pPr algn="r">
+              <a:defRPr sz="1200"/>
+            </a:lvl1pPr>
+          </a:lstStyle>
+          <a:p>
+            <a:fld id="{1A6A805C-1B62-4B47-A4BE-B4A6928E57EF}" type="slidenum">
+              <a:rPr lang="en-IT" smtClean="0"/>
+              <a:t>‹#›</a:t>
+            </a:fld>
+            <a:endParaRPr lang="en-IT"/>
+          </a:p>
+        </p:txBody>
+      </p:sp>
+    </p:spTree>
+    <p:extLst>
+      <p:ext uri="{BB962C8B-B14F-4D97-AF65-F5344CB8AC3E}">
+        <p14:creationId xmlns:p14="http://schemas.microsoft.com/office/powerpoint/2010/main" val="2316418771"/>
+      </p:ext>
+    </p:extLst>
+  </p:cSld>
+  <p:clrMap bg1="lt1" tx1="dk1" bg2="lt2" tx2="dk2" accent1="accent1" accent2="accent2" accent3="accent3" accent4="accent4" accent5="accent5" accent6="accent6" hlink="hlink" folHlink="folHlink"/>
+  <p:notesStyle>
+    <a:lvl1pPr marL="0" algn="l" defTabSz="914400" rtl="0" eaLnBrk="1" latinLnBrk="0" hangingPunct="1">
+      <a:defRPr sz="1200" kern="1200">
+        <a:solidFill>
+          <a:schemeClr val="tx1"/>
+        </a:solidFill>
+        <a:latin typeface="+mn-lt"/>
+        <a:ea typeface="+mn-ea"/>
+        <a:cs typeface="+mn-cs"/>
+      </a:defRPr>
+    </a:lvl1pPr>
+    <a:lvl2pPr marL="457200" algn="l" defTabSz="914400" rtl="0" eaLnBrk="1" latinLnBrk="0" hangingPunct="1">
+      <a:defRPr sz="1200" kern="1200">
+        <a:solidFill>
+          <a:schemeClr val="tx1"/>
+        </a:solidFill>
+        <a:latin typeface="+mn-lt"/>
+        <a:ea typeface="+mn-ea"/>
+        <a:cs typeface="+mn-cs"/>
+      </a:defRPr>
+    </a:lvl2pPr>
+    <a:lvl3pPr marL="914400" algn="l" defTabSz="914400" rtl="0" eaLnBrk="1" latinLnBrk="0" hangingPunct="1">
+      <a:defRPr sz="1200" kern="1200">
+        <a:solidFill>
+          <a:schemeClr val="tx1"/>
+        </a:solidFill>
+        <a:latin typeface="+mn-lt"/>
+        <a:ea typeface="+mn-ea"/>
+        <a:cs typeface="+mn-cs"/>
+      </a:defRPr>
+    </a:lvl3pPr>
+    <a:lvl4pPr marL="1371600" algn="l" defTabSz="914400" rtl="0" eaLnBrk="1" latinLnBrk="0" hangingPunct="1">
+      <a:defRPr sz="1200" kern="1200">
+        <a:solidFill>
+          <a:schemeClr val="tx1"/>
+        </a:solidFill>
+        <a:latin typeface="+mn-lt"/>
+        <a:ea typeface="+mn-ea"/>
+        <a:cs typeface="+mn-cs"/>
+      </a:defRPr>
+    </a:lvl4pPr>
+    <a:lvl5pPr marL="1828800" algn="l" defTabSz="914400" rtl="0" eaLnBrk="1" latinLnBrk="0" hangingPunct="1">
+      <a:defRPr sz="1200" kern="1200">
+        <a:solidFill>
+          <a:schemeClr val="tx1"/>
+        </a:solidFill>
+        <a:latin typeface="+mn-lt"/>
+        <a:ea typeface="+mn-ea"/>
+        <a:cs typeface="+mn-cs"/>
+      </a:defRPr>
+    </a:lvl5pPr>
+    <a:lvl6pPr marL="2286000" algn="l" defTabSz="914400" rtl="0" eaLnBrk="1" latinLnBrk="0" hangingPunct="1">
+      <a:defRPr sz="1200" kern="1200">
+        <a:solidFill>
+          <a:schemeClr val="tx1"/>
+        </a:solidFill>
+        <a:latin typeface="+mn-lt"/>
+        <a:ea typeface="+mn-ea"/>
+        <a:cs typeface="+mn-cs"/>
+      </a:defRPr>
+    </a:lvl6pPr>
+    <a:lvl7pPr marL="2743200" algn="l" defTabSz="914400" rtl="0" eaLnBrk="1" latinLnBrk="0" hangingPunct="1">
+      <a:defRPr sz="1200" kern="1200">
+        <a:solidFill>
+          <a:schemeClr val="tx1"/>
+        </a:solidFill>
+        <a:latin typeface="+mn-lt"/>
+        <a:ea typeface="+mn-ea"/>
+        <a:cs typeface="+mn-cs"/>
+      </a:defRPr>
+    </a:lvl7pPr>
+    <a:lvl8pPr marL="3200400" algn="l" defTabSz="914400" rtl="0" eaLnBrk="1" latinLnBrk="0" hangingPunct="1">
+      <a:defRPr sz="1200" kern="1200">
+        <a:solidFill>
+          <a:schemeClr val="tx1"/>
+        </a:solidFill>
+        <a:latin typeface="+mn-lt"/>
+        <a:ea typeface="+mn-ea"/>
+        <a:cs typeface="+mn-cs"/>
+      </a:defRPr>
+    </a:lvl8pPr>
+    <a:lvl9pPr marL="3657600" algn="l" defTabSz="914400" rtl="0" eaLnBrk="1" latinLnBrk="0" hangingPunct="1">
+      <a:defRPr sz="1200" kern="1200">
+        <a:solidFill>
+          <a:schemeClr val="tx1"/>
+        </a:solidFill>
+        <a:latin typeface="+mn-lt"/>
+        <a:ea typeface="+mn-ea"/>
+        <a:cs typeface="+mn-cs"/>
+      </a:defRPr>
+    </a:lvl9pPr>
+  </p:notesStyle>
+</p:notesMaster>
+</file>
+
+<file path=ppt/notesSlides/notesSlide1.xml><?xml version="1.0" encoding="utf-8"?>
+<p:notes xmlns:a="http://schemas.openxmlformats.org/drawingml/2006/main" xmlns:r="http://schemas.openxmlformats.org/officeDocument/2006/relationships" xmlns:p="http://schemas.openxmlformats.org/presentationml/2006/main">
+  <p:cSld>
+    <p:spTree>
+      <p:nvGrpSpPr>
+        <p:cNvPr id="1" name=""/>
+        <p:cNvGrpSpPr/>
+        <p:nvPr/>
+      </p:nvGrpSpPr>
+      <p:grpSpPr>
+        <a:xfrm>
+          <a:off x="0" y="0"/>
+          <a:ext cx="0" cy="0"/>
+          <a:chOff x="0" y="0"/>
+          <a:chExt cx="0" cy="0"/>
+        </a:xfrm>
+      </p:grpSpPr>
+      <p:sp>
+        <p:nvSpPr>
+          <p:cNvPr id="2" name="Slide Image Placeholder 1"/>
+          <p:cNvSpPr>
+            <a:spLocks noGrp="1" noRot="1" noChangeAspect="1"/>
+          </p:cNvSpPr>
+          <p:nvPr>
+            <p:ph type="sldImg"/>
+          </p:nvPr>
+        </p:nvSpPr>
+        <p:spPr/>
+      </p:sp>
+      <p:sp>
+        <p:nvSpPr>
+          <p:cNvPr id="3" name="Notes Placeholder 2"/>
+          <p:cNvSpPr>
+            <a:spLocks noGrp="1"/>
+          </p:cNvSpPr>
+          <p:nvPr>
+            <p:ph type="body" idx="1"/>
+          </p:nvPr>
+        </p:nvSpPr>
+        <p:spPr/>
+        <p:txBody>
+          <a:bodyPr/>
+          <a:lstStyle/>
+          <a:p>
+            <a:endParaRPr lang="en-IT" dirty="0"/>
+          </a:p>
+        </p:txBody>
+      </p:sp>
+      <p:sp>
+        <p:nvSpPr>
+          <p:cNvPr id="4" name="Slide Number Placeholder 3"/>
+          <p:cNvSpPr>
+            <a:spLocks noGrp="1"/>
+          </p:cNvSpPr>
+          <p:nvPr>
+            <p:ph type="sldNum" sz="quarter" idx="5"/>
+          </p:nvPr>
+        </p:nvSpPr>
+        <p:spPr/>
+        <p:txBody>
+          <a:bodyPr/>
+          <a:lstStyle/>
+          <a:p>
+            <a:fld id="{1A6A805C-1B62-4B47-A4BE-B4A6928E57EF}" type="slidenum">
+              <a:rPr lang="en-IT" smtClean="0"/>
+              <a:t>7</a:t>
+            </a:fld>
+            <a:endParaRPr lang="en-IT"/>
+          </a:p>
+        </p:txBody>
+      </p:sp>
+    </p:spTree>
+    <p:extLst>
+      <p:ext uri="{BB962C8B-B14F-4D97-AF65-F5344CB8AC3E}">
+        <p14:creationId xmlns:p14="http://schemas.microsoft.com/office/powerpoint/2010/main" val="2069457094"/>
+      </p:ext>
+    </p:extLst>
+  </p:cSld>
+  <p:clrMapOvr>
+    <a:masterClrMapping/>
+  </p:clrMapOvr>
+</p:notes>
+</file>
+
 <file path=ppt/slideLayouts/slideLayout1.xml><?xml version="1.0" encoding="utf-8"?>
 <p:sldLayout xmlns:a="http://schemas.openxmlformats.org/drawingml/2006/main" xmlns:r="http://schemas.openxmlformats.org/officeDocument/2006/relationships" xmlns:p="http://schemas.openxmlformats.org/presentationml/2006/main" type="title" preserve="1">
   <p:cSld name="Title Slide">
@@ -318,7 +755,7 @@
           <a:p>
             <a:fld id="{241EB5C9-1307-BA42-ABA2-0BC069CD8E7F}" type="datetimeFigureOut">
               <a:rPr lang="en-US" smtClean="0"/>
-              <a:t>1/2/22</a:t>
+              <a:t>10/6/26</a:t>
             </a:fld>
             <a:endParaRPr lang="en-US"/>
           </a:p>
@@ -486,7 +923,7 @@
           <a:p>
             <a:fld id="{241EB5C9-1307-BA42-ABA2-0BC069CD8E7F}" type="datetimeFigureOut">
               <a:rPr lang="en-US" smtClean="0"/>
-              <a:t>1/2/22</a:t>
+              <a:t>10/6/26</a:t>
             </a:fld>
             <a:endParaRPr lang="en-US"/>
           </a:p>
@@ -664,7 +1101,7 @@
           <a:p>
             <a:fld id="{241EB5C9-1307-BA42-ABA2-0BC069CD8E7F}" type="datetimeFigureOut">
               <a:rPr lang="en-US" smtClean="0"/>
-              <a:t>1/2/22</a:t>
+              <a:t>10/6/26</a:t>
             </a:fld>
             <a:endParaRPr lang="en-US"/>
           </a:p>
@@ -832,7 +1269,7 @@
           <a:p>
             <a:fld id="{241EB5C9-1307-BA42-ABA2-0BC069CD8E7F}" type="datetimeFigureOut">
               <a:rPr lang="en-US" smtClean="0"/>
-              <a:t>1/2/22</a:t>
+              <a:t>10/6/26</a:t>
             </a:fld>
             <a:endParaRPr lang="en-US"/>
           </a:p>
@@ -1077,7 +1514,7 @@
           <a:p>
             <a:fld id="{241EB5C9-1307-BA42-ABA2-0BC069CD8E7F}" type="datetimeFigureOut">
               <a:rPr lang="en-US" smtClean="0"/>
-              <a:t>1/2/22</a:t>
+              <a:t>10/6/26</a:t>
             </a:fld>
             <a:endParaRPr lang="en-US"/>
           </a:p>
@@ -1362,7 +1799,7 @@
           <a:p>
             <a:fld id="{241EB5C9-1307-BA42-ABA2-0BC069CD8E7F}" type="datetimeFigureOut">
               <a:rPr lang="en-US" smtClean="0"/>
-              <a:t>1/2/22</a:t>
+              <a:t>10/6/26</a:t>
             </a:fld>
             <a:endParaRPr lang="en-US"/>
           </a:p>
@@ -1781,7 +2218,7 @@
           <a:p>
             <a:fld id="{241EB5C9-1307-BA42-ABA2-0BC069CD8E7F}" type="datetimeFigureOut">
               <a:rPr lang="en-US" smtClean="0"/>
-              <a:t>1/2/22</a:t>
+              <a:t>10/6/26</a:t>
             </a:fld>
             <a:endParaRPr lang="en-US"/>
           </a:p>
@@ -1898,7 +2335,7 @@
           <a:p>
             <a:fld id="{241EB5C9-1307-BA42-ABA2-0BC069CD8E7F}" type="datetimeFigureOut">
               <a:rPr lang="en-US" smtClean="0"/>
-              <a:t>1/2/22</a:t>
+              <a:t>10/6/26</a:t>
             </a:fld>
             <a:endParaRPr lang="en-US"/>
           </a:p>
@@ -1993,7 +2430,7 @@
           <a:p>
             <a:fld id="{241EB5C9-1307-BA42-ABA2-0BC069CD8E7F}" type="datetimeFigureOut">
               <a:rPr lang="en-US" smtClean="0"/>
-              <a:t>1/2/22</a:t>
+              <a:t>10/6/26</a:t>
             </a:fld>
             <a:endParaRPr lang="en-US"/>
           </a:p>
@@ -2268,7 +2705,7 @@
           <a:p>
             <a:fld id="{241EB5C9-1307-BA42-ABA2-0BC069CD8E7F}" type="datetimeFigureOut">
               <a:rPr lang="en-US" smtClean="0"/>
-              <a:t>1/2/22</a:t>
+              <a:t>10/6/26</a:t>
             </a:fld>
             <a:endParaRPr lang="en-US"/>
           </a:p>
@@ -2520,7 +2957,7 @@
           <a:p>
             <a:fld id="{241EB5C9-1307-BA42-ABA2-0BC069CD8E7F}" type="datetimeFigureOut">
               <a:rPr lang="en-US" smtClean="0"/>
-              <a:t>1/2/22</a:t>
+              <a:t>10/6/26</a:t>
             </a:fld>
             <a:endParaRPr lang="en-US"/>
           </a:p>
@@ -2582,7 +3019,7 @@
 </file>
 
 <file path=ppt/slideMasters/slideMaster1.xml><?xml version="1.0" encoding="utf-8"?>
-<p:sldMaster xmlns:a="http://schemas.openxmlformats.org/drawingml/2006/main" xmlns:p="http://schemas.openxmlformats.org/presentationml/2006/main" xmlns:r="http://schemas.openxmlformats.org/officeDocument/2006/relationships">
+<p:sldMaster xmlns:a="http://schemas.openxmlformats.org/drawingml/2006/main" xmlns:r="http://schemas.openxmlformats.org/officeDocument/2006/relationships" xmlns:p="http://schemas.openxmlformats.org/presentationml/2006/main">
   <p:cSld>
     <p:bg>
       <p:bgRef idx="1001">
@@ -2623,7 +3060,7 @@
           </a:prstGeom>
         </p:spPr>
         <p:txBody>
-          <a:bodyPr anchor="ctr" bIns="45720" lIns="91440" rIns="91440" rtlCol="0" tIns="45720" vert="horz">
+          <a:bodyPr vert="horz" lIns="91440" tIns="45720" rIns="91440" bIns="45720" rtlCol="0" anchor="ctr">
             <a:normAutofit/>
           </a:bodyPr>
           <a:lstStyle/>
@@ -2642,7 +3079,7 @@
             <a:spLocks noGrp="1"/>
           </p:cNvSpPr>
           <p:nvPr>
-            <p:ph idx="1" type="body"/>
+            <p:ph type="body" idx="1"/>
           </p:nvPr>
         </p:nvSpPr>
         <p:spPr>
@@ -2655,7 +3092,7 @@
           </a:prstGeom>
         </p:spPr>
         <p:txBody>
-          <a:bodyPr bIns="45720" lIns="91440" rIns="91440" rtlCol="0" tIns="45720" vert="horz">
+          <a:bodyPr vert="horz" lIns="91440" tIns="45720" rIns="91440" bIns="45720" rtlCol="0">
             <a:normAutofit/>
           </a:bodyPr>
           <a:lstStyle/>
@@ -2703,7 +3140,7 @@
             <a:spLocks noGrp="1"/>
           </p:cNvSpPr>
           <p:nvPr>
-            <p:ph idx="2" sz="half" type="dt"/>
+            <p:ph type="dt" sz="half" idx="2"/>
           </p:nvPr>
         </p:nvSpPr>
         <p:spPr>
@@ -2716,7 +3153,7 @@
           </a:prstGeom>
         </p:spPr>
         <p:txBody>
-          <a:bodyPr anchor="ctr" bIns="45720" lIns="91440" rIns="91440" rtlCol="0" tIns="45720" vert="horz"/>
+          <a:bodyPr vert="horz" lIns="91440" tIns="45720" rIns="91440" bIns="45720" rtlCol="0" anchor="ctr"/>
           <a:lstStyle>
             <a:lvl1pPr algn="l">
               <a:defRPr sz="900">
@@ -2731,7 +3168,7 @@
           <a:p>
             <a:fld id="{241EB5C9-1307-BA42-ABA2-0BC069CD8E7F}" type="datetimeFigureOut">
               <a:rPr lang="en-US" smtClean="0"/>
-              <a:t>1/2/22</a:t>
+              <a:t>10/6/26</a:t>
             </a:fld>
             <a:endParaRPr lang="en-US"/>
           </a:p>
@@ -2744,7 +3181,7 @@
             <a:spLocks noGrp="1"/>
           </p:cNvSpPr>
           <p:nvPr>
-            <p:ph idx="3" sz="quarter" type="ftr"/>
+            <p:ph type="ftr" sz="quarter" idx="3"/>
           </p:nvPr>
         </p:nvSpPr>
         <p:spPr>
@@ -2757,7 +3194,7 @@
           </a:prstGeom>
         </p:spPr>
         <p:txBody>
-          <a:bodyPr anchor="ctr" bIns="45720" lIns="91440" rIns="91440" rtlCol="0" tIns="45720" vert="horz"/>
+          <a:bodyPr vert="horz" lIns="91440" tIns="45720" rIns="91440" bIns="45720" rtlCol="0" anchor="ctr"/>
           <a:lstStyle>
             <a:lvl1pPr algn="ctr">
               <a:defRPr sz="900">
@@ -2781,7 +3218,7 @@
             <a:spLocks noGrp="1"/>
           </p:cNvSpPr>
           <p:nvPr>
-            <p:ph idx="4" sz="quarter" type="sldNum"/>
+            <p:ph type="sldNum" sz="quarter" idx="4"/>
           </p:nvPr>
         </p:nvSpPr>
         <p:spPr>
@@ -2794,7 +3231,7 @@
           </a:prstGeom>
         </p:spPr>
         <p:txBody>
-          <a:bodyPr anchor="ctr" bIns="45720" lIns="91440" rIns="91440" rtlCol="0" tIns="45720" vert="horz"/>
+          <a:bodyPr vert="horz" lIns="91440" tIns="45720" rIns="91440" bIns="45720" rtlCol="0" anchor="ctr"/>
           <a:lstStyle>
             <a:lvl1pPr algn="r">
               <a:defRPr sz="900">
@@ -2822,7 +3259,7 @@
       </p:ext>
     </p:extLst>
   </p:cSld>
-  <p:clrMap accent1="accent1" accent2="accent2" accent3="accent3" accent4="accent4" accent5="accent5" accent6="accent6" bg1="lt1" bg2="lt2" folHlink="folHlink" hlink="hlink" tx1="dk1" tx2="dk2"/>
+  <p:clrMap bg1="lt1" tx1="dk1" bg2="lt2" tx2="dk2" accent1="accent1" accent2="accent2" accent3="accent3" accent4="accent4" accent5="accent5" accent6="accent6" hlink="hlink" folHlink="folHlink"/>
   <p:sldLayoutIdLst>
     <p:sldLayoutId id="2147483649" r:id="rId1"/>
     <p:sldLayoutId id="2147483650" r:id="rId2"/>
@@ -2838,12 +3275,12 @@
   </p:sldLayoutIdLst>
   <p:txStyles>
     <p:titleStyle>
-      <a:lvl1pPr algn="ctr" defTabSz="342900" eaLnBrk="1" hangingPunct="1" latinLnBrk="0" rtl="0">
+      <a:lvl1pPr algn="ctr" defTabSz="342900" rtl="0" eaLnBrk="1" latinLnBrk="0" hangingPunct="1">
         <a:spcBef>
           <a:spcPct val="0"/>
         </a:spcBef>
         <a:buNone/>
-        <a:defRPr kern="1200" sz="3300">
+        <a:defRPr sz="3300" kern="1200">
           <a:solidFill>
             <a:schemeClr val="tx1"/>
           </a:solidFill>
@@ -2854,13 +3291,13 @@
       </a:lvl1pPr>
     </p:titleStyle>
     <p:bodyStyle>
-      <a:lvl1pPr algn="l" defTabSz="342900" eaLnBrk="1" hangingPunct="1" indent="-342900" latinLnBrk="0" marL="342900" rtl="0">
+      <a:lvl1pPr marL="342900" indent="-342900" algn="l" defTabSz="342900" rtl="0" eaLnBrk="1" latinLnBrk="0" hangingPunct="1">
         <a:spcBef>
           <a:spcPct val="20000"/>
         </a:spcBef>
         <a:buFont typeface="Arial"/>
         <a:buChar char="•"/>
-        <a:defRPr kern="1200" sz="2400">
+        <a:defRPr sz="2400" kern="1200">
           <a:solidFill>
             <a:schemeClr val="tx1"/>
           </a:solidFill>
@@ -2869,13 +3306,13 @@
           <a:cs typeface="+mn-cs"/>
         </a:defRPr>
       </a:lvl1pPr>
-      <a:lvl2pPr algn="l" defTabSz="342900" eaLnBrk="1" hangingPunct="1" indent="-342900" latinLnBrk="0" marL="685800" rtl="0">
+      <a:lvl2pPr marL="685800" indent="-342900" algn="l" defTabSz="342900" rtl="0" eaLnBrk="1" latinLnBrk="0" hangingPunct="1">
         <a:spcBef>
           <a:spcPct val="20000"/>
         </a:spcBef>
         <a:buFont typeface="Arial"/>
         <a:buChar char="–"/>
-        <a:defRPr kern="1200" sz="2100">
+        <a:defRPr sz="2100" kern="1200">
           <a:solidFill>
             <a:schemeClr val="tx1"/>
           </a:solidFill>
@@ -2884,13 +3321,13 @@
           <a:cs typeface="+mn-cs"/>
         </a:defRPr>
       </a:lvl2pPr>
-      <a:lvl3pPr algn="l" defTabSz="342900" eaLnBrk="1" hangingPunct="1" indent="-342900" latinLnBrk="0" marL="1028700" rtl="0">
+      <a:lvl3pPr marL="1028700" indent="-342900" algn="l" defTabSz="342900" rtl="0" eaLnBrk="1" latinLnBrk="0" hangingPunct="1">
         <a:spcBef>
           <a:spcPct val="20000"/>
         </a:spcBef>
         <a:buFont typeface="Arial"/>
         <a:buChar char="•"/>
-        <a:defRPr kern="1200" sz="1800">
+        <a:defRPr sz="1800" kern="1200">
           <a:solidFill>
             <a:schemeClr val="tx1"/>
           </a:solidFill>
@@ -2899,13 +3336,13 @@
           <a:cs typeface="+mn-cs"/>
         </a:defRPr>
       </a:lvl3pPr>
-      <a:lvl4pPr algn="l" defTabSz="342900" eaLnBrk="1" hangingPunct="1" indent="-342900" latinLnBrk="0" marL="1371600" rtl="0">
+      <a:lvl4pPr marL="1371600" indent="-342900" algn="l" defTabSz="342900" rtl="0" eaLnBrk="1" latinLnBrk="0" hangingPunct="1">
         <a:spcBef>
           <a:spcPct val="20000"/>
         </a:spcBef>
         <a:buFont typeface="Arial"/>
         <a:buChar char="–"/>
-        <a:defRPr kern="1200" sz="1500">
+        <a:defRPr sz="1500" kern="1200">
           <a:solidFill>
             <a:schemeClr val="tx1"/>
           </a:solidFill>
@@ -2914,13 +3351,13 @@
           <a:cs typeface="+mn-cs"/>
         </a:defRPr>
       </a:lvl4pPr>
-      <a:lvl5pPr algn="l" defTabSz="342900" eaLnBrk="1" hangingPunct="1" indent="-342900" latinLnBrk="0" marL="1714500" rtl="0">
+      <a:lvl5pPr marL="1714500" indent="-342900" algn="l" defTabSz="342900" rtl="0" eaLnBrk="1" latinLnBrk="0" hangingPunct="1">
         <a:spcBef>
           <a:spcPct val="20000"/>
         </a:spcBef>
         <a:buFont typeface="Arial"/>
         <a:buChar char="»"/>
-        <a:defRPr kern="1200" sz="1500">
+        <a:defRPr sz="1500" kern="1200">
           <a:solidFill>
             <a:schemeClr val="tx1"/>
           </a:solidFill>
@@ -2929,13 +3366,13 @@
           <a:cs typeface="+mn-cs"/>
         </a:defRPr>
       </a:lvl5pPr>
-      <a:lvl6pPr algn="l" defTabSz="342900" eaLnBrk="1" hangingPunct="1" indent="-342900" latinLnBrk="0" marL="2057400" rtl="0">
+      <a:lvl6pPr marL="2057400" indent="-342900" algn="l" defTabSz="342900" rtl="0" eaLnBrk="1" latinLnBrk="0" hangingPunct="1">
         <a:spcBef>
           <a:spcPct val="20000"/>
         </a:spcBef>
         <a:buFont typeface="Arial"/>
         <a:buChar char="•"/>
-        <a:defRPr kern="1200" sz="1500">
+        <a:defRPr sz="1500" kern="1200">
           <a:solidFill>
             <a:schemeClr val="tx1"/>
           </a:solidFill>
@@ -2944,13 +3381,13 @@
           <a:cs typeface="+mn-cs"/>
         </a:defRPr>
       </a:lvl6pPr>
-      <a:lvl7pPr algn="l" defTabSz="342900" eaLnBrk="1" hangingPunct="1" indent="-342900" latinLnBrk="0" marL="2400300" rtl="0">
+      <a:lvl7pPr marL="2400300" indent="-342900" algn="l" defTabSz="342900" rtl="0" eaLnBrk="1" latinLnBrk="0" hangingPunct="1">
         <a:spcBef>
           <a:spcPct val="20000"/>
         </a:spcBef>
         <a:buFont typeface="Arial"/>
         <a:buChar char="•"/>
-        <a:defRPr kern="1200" sz="1500">
+        <a:defRPr sz="1500" kern="1200">
           <a:solidFill>
             <a:schemeClr val="tx1"/>
           </a:solidFill>
@@ -2959,13 +3396,13 @@
           <a:cs typeface="+mn-cs"/>
         </a:defRPr>
       </a:lvl7pPr>
-      <a:lvl8pPr algn="l" defTabSz="342900" eaLnBrk="1" hangingPunct="1" indent="-342900" latinLnBrk="0" marL="2743200" rtl="0">
+      <a:lvl8pPr marL="2743200" indent="-342900" algn="l" defTabSz="342900" rtl="0" eaLnBrk="1" latinLnBrk="0" hangingPunct="1">
         <a:spcBef>
           <a:spcPct val="20000"/>
         </a:spcBef>
         <a:buFont typeface="Arial"/>
         <a:buChar char="•"/>
-        <a:defRPr kern="1200" sz="1500">
+        <a:defRPr sz="1500" kern="1200">
           <a:solidFill>
             <a:schemeClr val="tx1"/>
           </a:solidFill>
@@ -2974,13 +3411,13 @@
           <a:cs typeface="+mn-cs"/>
         </a:defRPr>
       </a:lvl8pPr>
-      <a:lvl9pPr algn="l" defTabSz="342900" eaLnBrk="1" hangingPunct="1" indent="-342900" latinLnBrk="0" marL="3086100" rtl="0">
+      <a:lvl9pPr marL="3086100" indent="-342900" algn="l" defTabSz="342900" rtl="0" eaLnBrk="1" latinLnBrk="0" hangingPunct="1">
         <a:spcBef>
           <a:spcPct val="20000"/>
         </a:spcBef>
         <a:buFont typeface="Arial"/>
         <a:buChar char="•"/>
-        <a:defRPr kern="1200" sz="1500">
+        <a:defRPr sz="1500" kern="1200">
           <a:solidFill>
             <a:schemeClr val="tx1"/>
           </a:solidFill>
@@ -2994,8 +3431,8 @@
       <a:defPPr>
         <a:defRPr lang="en-US"/>
       </a:defPPr>
-      <a:lvl1pPr algn="l" defTabSz="342900" eaLnBrk="1" hangingPunct="1" latinLnBrk="0" marL="0" rtl="0">
-        <a:defRPr kern="1200" sz="1350">
+      <a:lvl1pPr marL="0" algn="l" defTabSz="342900" rtl="0" eaLnBrk="1" latinLnBrk="0" hangingPunct="1">
+        <a:defRPr sz="1350" kern="1200">
           <a:solidFill>
             <a:schemeClr val="tx1"/>
           </a:solidFill>
@@ -3004,8 +3441,8 @@
           <a:cs typeface="+mn-cs"/>
         </a:defRPr>
       </a:lvl1pPr>
-      <a:lvl2pPr algn="l" defTabSz="342900" eaLnBrk="1" hangingPunct="1" latinLnBrk="0" marL="342900" rtl="0">
-        <a:defRPr kern="1200" sz="1350">
+      <a:lvl2pPr marL="342900" algn="l" defTabSz="342900" rtl="0" eaLnBrk="1" latinLnBrk="0" hangingPunct="1">
+        <a:defRPr sz="1350" kern="1200">
           <a:solidFill>
             <a:schemeClr val="tx1"/>
           </a:solidFill>
@@ -3014,8 +3451,8 @@
           <a:cs typeface="+mn-cs"/>
         </a:defRPr>
       </a:lvl2pPr>
-      <a:lvl3pPr algn="l" defTabSz="342900" eaLnBrk="1" hangingPunct="1" latinLnBrk="0" marL="685800" rtl="0">
-        <a:defRPr kern="1200" sz="1350">
+      <a:lvl3pPr marL="685800" algn="l" defTabSz="342900" rtl="0" eaLnBrk="1" latinLnBrk="0" hangingPunct="1">
+        <a:defRPr sz="1350" kern="1200">
           <a:solidFill>
             <a:schemeClr val="tx1"/>
           </a:solidFill>
@@ -3024,8 +3461,8 @@
           <a:cs typeface="+mn-cs"/>
         </a:defRPr>
       </a:lvl3pPr>
-      <a:lvl4pPr algn="l" defTabSz="342900" eaLnBrk="1" hangingPunct="1" latinLnBrk="0" marL="1028700" rtl="0">
-        <a:defRPr kern="1200" sz="1350">
+      <a:lvl4pPr marL="1028700" algn="l" defTabSz="342900" rtl="0" eaLnBrk="1" latinLnBrk="0" hangingPunct="1">
+        <a:defRPr sz="1350" kern="1200">
           <a:solidFill>
             <a:schemeClr val="tx1"/>
           </a:solidFill>
@@ -3034,8 +3471,8 @@
           <a:cs typeface="+mn-cs"/>
         </a:defRPr>
       </a:lvl4pPr>
-      <a:lvl5pPr algn="l" defTabSz="342900" eaLnBrk="1" hangingPunct="1" latinLnBrk="0" marL="1371600" rtl="0">
-        <a:defRPr kern="1200" sz="1350">
+      <a:lvl5pPr marL="1371600" algn="l" defTabSz="342900" rtl="0" eaLnBrk="1" latinLnBrk="0" hangingPunct="1">
+        <a:defRPr sz="1350" kern="1200">
           <a:solidFill>
             <a:schemeClr val="tx1"/>
           </a:solidFill>
@@ -3044,8 +3481,8 @@
           <a:cs typeface="+mn-cs"/>
         </a:defRPr>
       </a:lvl5pPr>
-      <a:lvl6pPr algn="l" defTabSz="342900" eaLnBrk="1" hangingPunct="1" latinLnBrk="0" marL="1714500" rtl="0">
-        <a:defRPr kern="1200" sz="1350">
+      <a:lvl6pPr marL="1714500" algn="l" defTabSz="342900" rtl="0" eaLnBrk="1" latinLnBrk="0" hangingPunct="1">
+        <a:defRPr sz="1350" kern="1200">
           <a:solidFill>
             <a:schemeClr val="tx1"/>
           </a:solidFill>
@@ -3054,8 +3491,8 @@
           <a:cs typeface="+mn-cs"/>
         </a:defRPr>
       </a:lvl6pPr>
-      <a:lvl7pPr algn="l" defTabSz="342900" eaLnBrk="1" hangingPunct="1" latinLnBrk="0" marL="2057400" rtl="0">
-        <a:defRPr kern="1200" sz="1350">
+      <a:lvl7pPr marL="2057400" algn="l" defTabSz="342900" rtl="0" eaLnBrk="1" latinLnBrk="0" hangingPunct="1">
+        <a:defRPr sz="1350" kern="1200">
           <a:solidFill>
             <a:schemeClr val="tx1"/>
           </a:solidFill>
@@ -3064,8 +3501,8 @@
           <a:cs typeface="+mn-cs"/>
         </a:defRPr>
       </a:lvl7pPr>
-      <a:lvl8pPr algn="l" defTabSz="342900" eaLnBrk="1" hangingPunct="1" latinLnBrk="0" marL="2400300" rtl="0">
-        <a:defRPr kern="1200" sz="1350">
+      <a:lvl8pPr marL="2400300" algn="l" defTabSz="342900" rtl="0" eaLnBrk="1" latinLnBrk="0" hangingPunct="1">
+        <a:defRPr sz="1350" kern="1200">
           <a:solidFill>
             <a:schemeClr val="tx1"/>
           </a:solidFill>
@@ -3074,8 +3511,8 @@
           <a:cs typeface="+mn-cs"/>
         </a:defRPr>
       </a:lvl8pPr>
-      <a:lvl9pPr algn="l" defTabSz="342900" eaLnBrk="1" hangingPunct="1" latinLnBrk="0" marL="2743200" rtl="0">
-        <a:defRPr kern="1200" sz="1350">
+      <a:lvl9pPr marL="2743200" algn="l" defTabSz="342900" rtl="0" eaLnBrk="1" latinLnBrk="0" hangingPunct="1">
+        <a:defRPr sz="1350" kern="1200">
           <a:solidFill>
             <a:schemeClr val="tx1"/>
           </a:solidFill>
@@ -3090,7 +3527,7 @@
 </file>
 
 <file path=ppt/slides/slide1.xml><?xml version="1.0" encoding="utf-8"?>
-<p:sld xmlns:p="http://schemas.openxmlformats.org/presentationml/2006/main" xmlns:a="http://schemas.openxmlformats.org/drawingml/2006/main" xmlns:r="http://schemas.openxmlformats.org/officeDocument/2006/relationships">
+<p:sld xmlns:a="http://schemas.openxmlformats.org/drawingml/2006/main" xmlns:r="http://schemas.openxmlformats.org/officeDocument/2006/relationships" xmlns:p="http://schemas.openxmlformats.org/presentationml/2006/main">
   <p:cSld>
     <p:bg>
       <p:bgPr>
@@ -3131,7 +3568,7 @@
           </a:ln>
         </p:spPr>
         <p:txBody>
-          <a:bodyPr wrap="square" lIns="0" rIns="0" tIns="0" bIns="0" anchor="t"/>
+          <a:bodyPr wrap="square" lIns="0" tIns="0" rIns="0" bIns="0" anchor="t"/>
           <a:lstStyle/>
           <a:p>
             <a:pPr algn="l"/>
@@ -3164,7 +3601,7 @@
           </a:ln>
         </p:spPr>
         <p:txBody>
-          <a:bodyPr wrap="square" lIns="0" rIns="0" tIns="0" bIns="0" anchor="t"/>
+          <a:bodyPr wrap="square" lIns="0" tIns="0" rIns="0" bIns="0" anchor="t"/>
           <a:lstStyle/>
           <a:p>
             <a:pPr algn="l"/>
@@ -3197,7 +3634,7 @@
           </a:ln>
         </p:spPr>
         <p:txBody>
-          <a:bodyPr wrap="square" lIns="0" rIns="0" tIns="0" bIns="0" anchor="t"/>
+          <a:bodyPr wrap="square" lIns="0" tIns="0" rIns="0" bIns="0" anchor="t"/>
           <a:lstStyle/>
           <a:p>
             <a:pPr algn="r"/>
@@ -3230,7 +3667,7 @@
           </a:ln>
         </p:spPr>
         <p:txBody>
-          <a:bodyPr wrap="square" lIns="0" rIns="0" tIns="0" bIns="0" anchor="t"/>
+          <a:bodyPr wrap="square" lIns="0" tIns="0" rIns="0" bIns="0" anchor="t"/>
           <a:lstStyle/>
           <a:p>
             <a:pPr algn="l"/>
@@ -3307,7 +3744,7 @@
           </a:ln>
         </p:spPr>
         <p:txBody>
-          <a:bodyPr wrap="square" lIns="0" rIns="0" tIns="0" bIns="0" anchor="ctr"/>
+          <a:bodyPr wrap="square" lIns="0" tIns="0" rIns="0" bIns="0" anchor="ctr"/>
           <a:lstStyle/>
           <a:p>
             <a:pPr algn="l"/>
@@ -3384,7 +3821,7 @@
           </a:ln>
         </p:spPr>
         <p:txBody>
-          <a:bodyPr wrap="square" lIns="0" rIns="0" tIns="0" bIns="0" anchor="ctr"/>
+          <a:bodyPr wrap="square" lIns="0" tIns="0" rIns="0" bIns="0" anchor="ctr"/>
           <a:lstStyle/>
           <a:p>
             <a:pPr algn="l"/>
@@ -3417,7 +3854,7 @@
           </a:ln>
         </p:spPr>
         <p:txBody>
-          <a:bodyPr wrap="square" lIns="0" rIns="0" tIns="0" bIns="0" anchor="ctr"/>
+          <a:bodyPr wrap="square" lIns="0" tIns="0" rIns="0" bIns="0" anchor="ctr"/>
           <a:lstStyle/>
           <a:p>
             <a:pPr algn="r"/>
@@ -3442,7 +3879,7 @@
 </file>
 
 <file path=ppt/slides/slide10.xml><?xml version="1.0" encoding="utf-8"?>
-<p:sld xmlns:p="http://schemas.openxmlformats.org/presentationml/2006/main" xmlns:a="http://schemas.openxmlformats.org/drawingml/2006/main" xmlns:r="http://schemas.openxmlformats.org/officeDocument/2006/relationships">
+<p:sld xmlns:a="http://schemas.openxmlformats.org/drawingml/2006/main" xmlns:r="http://schemas.openxmlformats.org/officeDocument/2006/relationships" xmlns:p="http://schemas.openxmlformats.org/presentationml/2006/main">
   <p:cSld>
     <p:bg>
       <p:bgPr>
@@ -3483,7 +3920,7 @@
           </a:ln>
         </p:spPr>
         <p:txBody>
-          <a:bodyPr wrap="square" lIns="0" rIns="0" tIns="0" bIns="0" anchor="t"/>
+          <a:bodyPr wrap="square" lIns="0" tIns="0" rIns="0" bIns="0" anchor="t"/>
           <a:lstStyle/>
           <a:p>
             <a:pPr algn="l"/>
@@ -3516,7 +3953,7 @@
           </a:ln>
         </p:spPr>
         <p:txBody>
-          <a:bodyPr wrap="square" lIns="0" rIns="0" tIns="0" bIns="0" anchor="t"/>
+          <a:bodyPr wrap="square" lIns="0" tIns="0" rIns="0" bIns="0" anchor="t"/>
           <a:lstStyle/>
           <a:p>
             <a:pPr algn="l"/>
@@ -3549,18 +3986,36 @@
           </a:ln>
         </p:spPr>
         <p:txBody>
-          <a:bodyPr wrap="square" lIns="0" rIns="0" tIns="0" bIns="0" anchor="t"/>
-          <a:lstStyle/>
-          <a:p>
-            <a:pPr algn="l"/>
-            <a:r>
-              <a:rPr lang="it-IT" sz="1376" b="0" i="0">
+          <a:bodyPr wrap="square" lIns="0" tIns="0" rIns="0" bIns="0" anchor="t"/>
+          <a:lstStyle/>
+          <a:p>
+            <a:pPr algn="l"/>
+            <a:r>
+              <a:rPr lang="it-IT" sz="1376" b="0" i="0" dirty="0">
                 <a:solidFill>
                   <a:srgbClr val="112642"/>
                 </a:solidFill>
                 <a:latin typeface="Aptos"/>
               </a:rPr>
-              <a:t>Per ogni run usiamo le energie del fascio in h80 per calibrare l'asse dei flussi esterni.</a:t>
+              <a:t>Per ogni </a:t>
+            </a:r>
+            <a:r>
+              <a:rPr lang="it-IT" sz="1376" b="0" i="0" dirty="0" err="1">
+                <a:solidFill>
+                  <a:srgbClr val="112642"/>
+                </a:solidFill>
+                <a:latin typeface="Aptos"/>
+              </a:rPr>
+              <a:t>run</a:t>
+            </a:r>
+            <a:r>
+              <a:rPr lang="it-IT" sz="1376" b="0" i="0" dirty="0">
+                <a:solidFill>
+                  <a:srgbClr val="112642"/>
+                </a:solidFill>
+                <a:latin typeface="Aptos"/>
+              </a:rPr>
+              <a:t> usiamo le energie del fascio per calibrare l'asse dei flussi esterni.</a:t>
             </a:r>
           </a:p>
         </p:txBody>
@@ -3604,7 +4059,7 @@
           </a:ln>
         </p:spPr>
         <p:txBody>
-          <a:bodyPr wrap="square" lIns="0" rIns="0" tIns="0" bIns="0" anchor="ctr"/>
+          <a:bodyPr wrap="square" lIns="0" tIns="0" rIns="0" bIns="0" anchor="ctr"/>
           <a:lstStyle/>
           <a:p>
             <a:pPr algn="l"/>
@@ -3649,7 +4104,7 @@
           </a:ln>
         </p:spPr>
         <p:txBody>
-          <a:bodyPr wrap="square" lIns="0" rIns="0" tIns="0" bIns="0" anchor="ctr"/>
+          <a:bodyPr wrap="square" lIns="0" tIns="0" rIns="0" bIns="0" anchor="ctr"/>
           <a:lstStyle/>
           <a:p>
             <a:pPr algn="ctr"/>
@@ -3704,7 +4159,7 @@
           </a:ln>
         </p:spPr>
         <p:txBody>
-          <a:bodyPr wrap="square" lIns="0" rIns="0" tIns="0" bIns="0" anchor="ctr"/>
+          <a:bodyPr wrap="square" lIns="0" tIns="0" rIns="0" bIns="0" anchor="ctr"/>
           <a:lstStyle/>
           <a:p>
             <a:pPr algn="l"/>
@@ -3759,7 +4214,7 @@
           </a:ln>
         </p:spPr>
         <p:txBody>
-          <a:bodyPr wrap="square" lIns="0" rIns="0" tIns="0" bIns="0" anchor="ctr"/>
+          <a:bodyPr wrap="square" lIns="0" tIns="0" rIns="0" bIns="0" anchor="ctr"/>
           <a:lstStyle/>
           <a:p>
             <a:pPr algn="l"/>
@@ -3804,7 +4259,7 @@
           </a:ln>
         </p:spPr>
         <p:txBody>
-          <a:bodyPr wrap="square" lIns="0" rIns="0" tIns="0" bIns="0" anchor="ctr"/>
+          <a:bodyPr wrap="square" lIns="0" tIns="0" rIns="0" bIns="0" anchor="ctr"/>
           <a:lstStyle/>
           <a:p>
             <a:pPr algn="ctr"/>
@@ -3859,18 +4314,108 @@
           </a:ln>
         </p:spPr>
         <p:txBody>
-          <a:bodyPr wrap="square" lIns="0" rIns="0" tIns="0" bIns="0" anchor="ctr"/>
-          <a:lstStyle/>
-          <a:p>
-            <a:pPr algn="l"/>
-            <a:r>
-              <a:rPr lang="it-IT" sz="1290" b="0" i="0">
+          <a:bodyPr wrap="square" lIns="0" tIns="0" rIns="0" bIns="0" anchor="ctr"/>
+          <a:lstStyle/>
+          <a:p>
+            <a:pPr algn="l"/>
+            <a:r>
+              <a:rPr lang="it-IT" sz="1290" b="0" i="0" dirty="0">
                 <a:solidFill>
                   <a:srgbClr val="112642"/>
                 </a:solidFill>
                 <a:latin typeface="Aptos"/>
               </a:rPr>
-              <a:t>Da Eγ e Xstrip otteniamo la mediana per run/strip e la media per run/polarizzazione/strip usata nel fit.</a:t>
+              <a:t>Da </a:t>
+            </a:r>
+            <a:r>
+              <a:rPr lang="it-IT" sz="1290" b="0" i="0" dirty="0" err="1">
+                <a:solidFill>
+                  <a:srgbClr val="112642"/>
+                </a:solidFill>
+                <a:latin typeface="Aptos"/>
+              </a:rPr>
+              <a:t>Eγ</a:t>
+            </a:r>
+            <a:r>
+              <a:rPr lang="it-IT" sz="1290" b="0" i="0" dirty="0">
+                <a:solidFill>
+                  <a:srgbClr val="112642"/>
+                </a:solidFill>
+                <a:latin typeface="Aptos"/>
+              </a:rPr>
+              <a:t> e </a:t>
+            </a:r>
+            <a:r>
+              <a:rPr lang="it-IT" sz="1290" b="0" i="0" dirty="0" err="1">
+                <a:solidFill>
+                  <a:srgbClr val="112642"/>
+                </a:solidFill>
+                <a:latin typeface="Aptos"/>
+              </a:rPr>
+              <a:t>Xstrip</a:t>
+            </a:r>
+            <a:r>
+              <a:rPr lang="it-IT" sz="1290" b="0" i="0" dirty="0">
+                <a:solidFill>
+                  <a:srgbClr val="112642"/>
+                </a:solidFill>
+                <a:latin typeface="Aptos"/>
+              </a:rPr>
+              <a:t> otteniamo la mediana per </a:t>
+            </a:r>
+            <a:r>
+              <a:rPr lang="it-IT" sz="1290" b="0" i="0" dirty="0" err="1">
+                <a:solidFill>
+                  <a:srgbClr val="112642"/>
+                </a:solidFill>
+                <a:latin typeface="Aptos"/>
+              </a:rPr>
+              <a:t>run</a:t>
+            </a:r>
+            <a:r>
+              <a:rPr lang="it-IT" sz="1290" b="0" i="0" dirty="0">
+                <a:solidFill>
+                  <a:srgbClr val="112642"/>
+                </a:solidFill>
+                <a:latin typeface="Aptos"/>
+              </a:rPr>
+              <a:t>/strip e la media per </a:t>
+            </a:r>
+            <a:r>
+              <a:rPr lang="it-IT" sz="1290" b="0" i="0" dirty="0" err="1">
+                <a:solidFill>
+                  <a:srgbClr val="112642"/>
+                </a:solidFill>
+                <a:latin typeface="Aptos"/>
+              </a:rPr>
+              <a:t>run</a:t>
+            </a:r>
+            <a:r>
+              <a:rPr lang="it-IT" sz="1290" b="0" i="0" dirty="0">
+                <a:solidFill>
+                  <a:srgbClr val="112642"/>
+                </a:solidFill>
+                <a:latin typeface="Aptos"/>
+              </a:rPr>
+              <a:t>/polarizzazione/strip usata nel </a:t>
+            </a:r>
+            <a:r>
+              <a:rPr lang="it-IT" sz="1290" b="0" i="0" dirty="0" err="1">
+                <a:solidFill>
+                  <a:srgbClr val="112642"/>
+                </a:solidFill>
+                <a:latin typeface="Aptos"/>
+              </a:rPr>
+              <a:t>fit</a:t>
+            </a:r>
+            <a:r>
+              <a:rPr lang="it-IT" sz="1290" b="0" i="0" dirty="0">
+                <a:solidFill>
+                  <a:srgbClr val="112642"/>
+                </a:solidFill>
+                <a:latin typeface="Aptos"/>
+              </a:rPr>
+              <a:t>.</a:t>
             </a:r>
           </a:p>
         </p:txBody>
@@ -3914,7 +4459,7 @@
           </a:ln>
         </p:spPr>
         <p:txBody>
-          <a:bodyPr wrap="square" lIns="0" rIns="0" tIns="0" bIns="0" anchor="ctr"/>
+          <a:bodyPr wrap="square" lIns="0" tIns="0" rIns="0" bIns="0" anchor="ctr"/>
           <a:lstStyle/>
           <a:p>
             <a:pPr algn="l"/>
@@ -3959,7 +4504,7 @@
           </a:ln>
         </p:spPr>
         <p:txBody>
-          <a:bodyPr wrap="square" lIns="0" rIns="0" tIns="0" bIns="0" anchor="ctr"/>
+          <a:bodyPr wrap="square" lIns="0" tIns="0" rIns="0" bIns="0" anchor="ctr"/>
           <a:lstStyle/>
           <a:p>
             <a:pPr algn="ctr"/>
@@ -4014,18 +4559,36 @@
           </a:ln>
         </p:spPr>
         <p:txBody>
-          <a:bodyPr wrap="square" lIns="0" rIns="0" tIns="0" bIns="0" anchor="ctr"/>
-          <a:lstStyle/>
-          <a:p>
-            <a:pPr algn="l"/>
-            <a:r>
-              <a:rPr lang="it-IT" sz="1270" b="0" i="0">
+          <a:bodyPr wrap="square" lIns="0" tIns="0" rIns="0" bIns="0" anchor="ctr"/>
+          <a:lstStyle/>
+          <a:p>
+            <a:pPr algn="l"/>
+            <a:r>
+              <a:rPr lang="it-IT" sz="1270" b="0" i="0" dirty="0">
                 <a:solidFill>
                   <a:srgbClr val="112642"/>
                 </a:solidFill>
                 <a:latin typeface="Aptos"/>
               </a:rPr>
-              <a:t>Ogni run richiede il tripletto completo. Se manca un flusso, la lettura si arresta; BREM resta un controllo separato.</a:t>
+              <a:t>Ogni </a:t>
+            </a:r>
+            <a:r>
+              <a:rPr lang="it-IT" sz="1270" b="0" i="0" dirty="0" err="1">
+                <a:solidFill>
+                  <a:srgbClr val="112642"/>
+                </a:solidFill>
+                <a:latin typeface="Aptos"/>
+              </a:rPr>
+              <a:t>run</a:t>
+            </a:r>
+            <a:r>
+              <a:rPr lang="it-IT" sz="1270" b="0" i="0" dirty="0">
+                <a:solidFill>
+                  <a:srgbClr val="112642"/>
+                </a:solidFill>
+                <a:latin typeface="Aptos"/>
+              </a:rPr>
+              <a:t> richiede il tripletto completo. Se manca un flusso, la lettura si arresta</a:t>
             </a:r>
           </a:p>
         </p:txBody>
@@ -4069,7 +4632,7 @@
           </a:ln>
         </p:spPr>
         <p:txBody>
-          <a:bodyPr wrap="square" lIns="0" rIns="0" tIns="0" bIns="0" anchor="ctr"/>
+          <a:bodyPr wrap="square" lIns="0" tIns="0" rIns="0" bIns="0" anchor="ctr"/>
           <a:lstStyle/>
           <a:p>
             <a:pPr algn="l"/>
@@ -4114,7 +4677,7 @@
           </a:ln>
         </p:spPr>
         <p:txBody>
-          <a:bodyPr wrap="square" lIns="0" rIns="0" tIns="0" bIns="0" anchor="ctr"/>
+          <a:bodyPr wrap="square" lIns="0" tIns="0" rIns="0" bIns="0" anchor="ctr"/>
           <a:lstStyle/>
           <a:p>
             <a:pPr algn="ctr"/>
@@ -4169,19 +4732,70 @@
           </a:ln>
         </p:spPr>
         <p:txBody>
-          <a:bodyPr wrap="square" lIns="0" rIns="0" tIns="0" bIns="0" anchor="ctr"/>
-          <a:lstStyle/>
-          <a:p>
-            <a:pPr algn="l"/>
-            <a:r>
-              <a:rPr lang="it-IT" sz="1260" b="0" i="0">
+          <a:bodyPr wrap="square" lIns="0" tIns="0" rIns="0" bIns="0" anchor="ctr"/>
+          <a:lstStyle/>
+          <a:p>
+            <a:pPr algn="l"/>
+            <a:r>
+              <a:rPr lang="it-IT" sz="1260" b="0" i="0" dirty="0">
                 <a:solidFill>
                   <a:srgbClr val="112642"/>
                 </a:solidFill>
                 <a:latin typeface="Aptos"/>
               </a:rPr>
-              <a:t>Il fit monotono richiede ≥5 strip e gli estremi 1/128. Riscrive gli assi Eγ in flux_calibrated.root, in modo atomico.</a:t>
-            </a:r>
+              <a:t>Il </a:t>
+            </a:r>
+            <a:r>
+              <a:rPr lang="it-IT" sz="1260" b="0" i="0" dirty="0" err="1">
+                <a:solidFill>
+                  <a:srgbClr val="112642"/>
+                </a:solidFill>
+                <a:latin typeface="Aptos"/>
+              </a:rPr>
+              <a:t>fit</a:t>
+            </a:r>
+            <a:r>
+              <a:rPr lang="it-IT" sz="1260" b="0" i="0" dirty="0">
+                <a:solidFill>
+                  <a:srgbClr val="112642"/>
+                </a:solidFill>
+                <a:latin typeface="Aptos"/>
+              </a:rPr>
+              <a:t> richiede ≥5 strip e gli estremi 1/128. Riscrive gli assi </a:t>
+            </a:r>
+            <a:r>
+              <a:rPr lang="it-IT" sz="1260" b="0" i="0" dirty="0" err="1">
+                <a:solidFill>
+                  <a:srgbClr val="112642"/>
+                </a:solidFill>
+                <a:latin typeface="Aptos"/>
+              </a:rPr>
+              <a:t>Eγ</a:t>
+            </a:r>
+            <a:r>
+              <a:rPr lang="it-IT" sz="1260" b="0" i="0" dirty="0">
+                <a:solidFill>
+                  <a:srgbClr val="112642"/>
+                </a:solidFill>
+                <a:latin typeface="Aptos"/>
+              </a:rPr>
+              <a:t> in </a:t>
+            </a:r>
+            <a:r>
+              <a:rPr lang="it-IT" sz="1260" b="0" i="0" dirty="0" err="1">
+                <a:solidFill>
+                  <a:srgbClr val="112642"/>
+                </a:solidFill>
+                <a:latin typeface="Aptos"/>
+              </a:rPr>
+              <a:t>flux_calibrated.root</a:t>
+            </a:r>
+            <a:endParaRPr lang="it-IT" sz="1260" b="0" i="0" dirty="0">
+              <a:solidFill>
+                <a:srgbClr val="112642"/>
+              </a:solidFill>
+              <a:latin typeface="Aptos"/>
+            </a:endParaRPr>
           </a:p>
         </p:txBody>
       </p:sp>
@@ -4246,7 +4860,7 @@
           </a:ln>
         </p:spPr>
         <p:txBody>
-          <a:bodyPr wrap="square" lIns="0" rIns="0" tIns="0" bIns="0" anchor="ctr"/>
+          <a:bodyPr wrap="square" lIns="0" tIns="0" rIns="0" bIns="0" anchor="ctr"/>
           <a:lstStyle/>
           <a:p>
             <a:pPr algn="l"/>
@@ -4323,7 +4937,7 @@
           </a:ln>
         </p:spPr>
         <p:txBody>
-          <a:bodyPr wrap="square" lIns="0" rIns="0" tIns="0" bIns="0" anchor="ctr"/>
+          <a:bodyPr wrap="square" lIns="0" tIns="0" rIns="0" bIns="0" anchor="ctr"/>
           <a:lstStyle/>
           <a:p>
             <a:pPr algn="l"/>
@@ -4356,7 +4970,7 @@
           </a:ln>
         </p:spPr>
         <p:txBody>
-          <a:bodyPr wrap="square" lIns="0" rIns="0" tIns="0" bIns="0" anchor="ctr"/>
+          <a:bodyPr wrap="square" lIns="0" tIns="0" rIns="0" bIns="0" anchor="ctr"/>
           <a:lstStyle/>
           <a:p>
             <a:pPr algn="r"/>
@@ -4381,7 +4995,7 @@
 </file>
 
 <file path=ppt/slides/slide11.xml><?xml version="1.0" encoding="utf-8"?>
-<p:sld xmlns:p="http://schemas.openxmlformats.org/presentationml/2006/main" xmlns:a="http://schemas.openxmlformats.org/drawingml/2006/main" xmlns:r="http://schemas.openxmlformats.org/officeDocument/2006/relationships">
+<p:sld xmlns:a="http://schemas.openxmlformats.org/drawingml/2006/main" xmlns:r="http://schemas.openxmlformats.org/officeDocument/2006/relationships" xmlns:p="http://schemas.openxmlformats.org/presentationml/2006/main">
   <p:cSld>
     <p:bg>
       <p:bgPr>
@@ -4422,7 +5036,7 @@
           </a:ln>
         </p:spPr>
         <p:txBody>
-          <a:bodyPr wrap="square" lIns="0" rIns="0" tIns="0" bIns="0" anchor="t"/>
+          <a:bodyPr wrap="square" lIns="0" tIns="0" rIns="0" bIns="0" anchor="t"/>
           <a:lstStyle/>
           <a:p>
             <a:pPr algn="l"/>
@@ -4455,7 +5069,7 @@
           </a:ln>
         </p:spPr>
         <p:txBody>
-          <a:bodyPr wrap="square" lIns="0" rIns="0" tIns="0" bIns="0" anchor="t"/>
+          <a:bodyPr wrap="square" lIns="0" tIns="0" rIns="0" bIns="0" anchor="t"/>
           <a:lstStyle/>
           <a:p>
             <a:pPr algn="l"/>
@@ -4488,7 +5102,7 @@
           </a:ln>
         </p:spPr>
         <p:txBody>
-          <a:bodyPr wrap="square" lIns="0" rIns="0" tIns="0" bIns="0" anchor="t"/>
+          <a:bodyPr wrap="square" lIns="0" tIns="0" rIns="0" bIns="0" anchor="t"/>
           <a:lstStyle/>
           <a:p>
             <a:pPr algn="l"/>
@@ -4521,7 +5135,7 @@
           </a:ln>
         </p:spPr>
         <p:txBody>
-          <a:bodyPr wrap="square" lIns="0" rIns="0" tIns="0" bIns="0" anchor="t"/>
+          <a:bodyPr wrap="square" lIns="0" tIns="0" rIns="0" bIns="0" anchor="t"/>
           <a:lstStyle/>
           <a:p>
             <a:pPr algn="l"/>
@@ -4554,7 +5168,7 @@
           </a:ln>
         </p:spPr>
         <p:txBody>
-          <a:bodyPr wrap="square" lIns="0" rIns="0" tIns="0" bIns="0" anchor="t"/>
+          <a:bodyPr wrap="square" lIns="0" tIns="0" rIns="0" bIns="0" anchor="t"/>
           <a:lstStyle/>
           <a:p>
             <a:pPr algn="l"/>
@@ -4587,7 +5201,7 @@
           </a:ln>
         </p:spPr>
         <p:txBody>
-          <a:bodyPr wrap="square" lIns="0" rIns="0" tIns="0" bIns="0" anchor="t"/>
+          <a:bodyPr wrap="square" lIns="0" tIns="0" rIns="0" bIns="0" anchor="t"/>
           <a:lstStyle/>
           <a:p>
             <a:pPr algn="l"/>
@@ -4620,7 +5234,7 @@
           </a:ln>
         </p:spPr>
         <p:txBody>
-          <a:bodyPr wrap="square" lIns="0" rIns="0" tIns="0" bIns="0" anchor="t"/>
+          <a:bodyPr wrap="square" lIns="0" tIns="0" rIns="0" bIns="0" anchor="t"/>
           <a:lstStyle/>
           <a:p>
             <a:pPr algn="l"/>
@@ -4653,7 +5267,7 @@
           </a:ln>
         </p:spPr>
         <p:txBody>
-          <a:bodyPr wrap="square" lIns="0" rIns="0" tIns="0" bIns="0" anchor="t"/>
+          <a:bodyPr wrap="square" lIns="0" tIns="0" rIns="0" bIns="0" anchor="t"/>
           <a:lstStyle/>
           <a:p>
             <a:pPr algn="l"/>
@@ -4686,7 +5300,7 @@
           </a:ln>
         </p:spPr>
         <p:txBody>
-          <a:bodyPr wrap="square" lIns="0" rIns="0" tIns="0" bIns="0" anchor="t"/>
+          <a:bodyPr wrap="square" lIns="0" tIns="0" rIns="0" bIns="0" anchor="t"/>
           <a:lstStyle/>
           <a:p>
             <a:pPr algn="l"/>
@@ -4763,7 +5377,7 @@
           </a:ln>
         </p:spPr>
         <p:txBody>
-          <a:bodyPr wrap="square" lIns="0" rIns="0" tIns="0" bIns="0" anchor="ctr"/>
+          <a:bodyPr wrap="square" lIns="0" tIns="0" rIns="0" bIns="0" anchor="ctr"/>
           <a:lstStyle/>
           <a:p>
             <a:pPr algn="l"/>
@@ -4840,7 +5454,7 @@
           </a:ln>
         </p:spPr>
         <p:txBody>
-          <a:bodyPr wrap="square" lIns="0" rIns="0" tIns="0" bIns="0" anchor="ctr"/>
+          <a:bodyPr wrap="square" lIns="0" tIns="0" rIns="0" bIns="0" anchor="ctr"/>
           <a:lstStyle/>
           <a:p>
             <a:pPr algn="l"/>
@@ -4873,7 +5487,7 @@
           </a:ln>
         </p:spPr>
         <p:txBody>
-          <a:bodyPr wrap="square" lIns="0" rIns="0" tIns="0" bIns="0" anchor="ctr"/>
+          <a:bodyPr wrap="square" lIns="0" tIns="0" rIns="0" bIns="0" anchor="ctr"/>
           <a:lstStyle/>
           <a:p>
             <a:pPr algn="r"/>
@@ -4898,7 +5512,7 @@
 </file>
 
 <file path=ppt/slides/slide12.xml><?xml version="1.0" encoding="utf-8"?>
-<p:sld xmlns:p="http://schemas.openxmlformats.org/presentationml/2006/main" xmlns:a="http://schemas.openxmlformats.org/drawingml/2006/main" xmlns:r="http://schemas.openxmlformats.org/officeDocument/2006/relationships">
+<p:sld xmlns:a="http://schemas.openxmlformats.org/drawingml/2006/main" xmlns:r="http://schemas.openxmlformats.org/officeDocument/2006/relationships" xmlns:p="http://schemas.openxmlformats.org/presentationml/2006/main">
   <p:cSld>
     <p:bg>
       <p:bgPr>
@@ -4939,7 +5553,7 @@
           </a:ln>
         </p:spPr>
         <p:txBody>
-          <a:bodyPr wrap="square" lIns="0" rIns="0" tIns="0" bIns="0" anchor="t"/>
+          <a:bodyPr wrap="square" lIns="0" tIns="0" rIns="0" bIns="0" anchor="t"/>
           <a:lstStyle/>
           <a:p>
             <a:pPr algn="l"/>
@@ -4972,7 +5586,7 @@
           </a:ln>
         </p:spPr>
         <p:txBody>
-          <a:bodyPr wrap="square" lIns="0" rIns="0" tIns="0" bIns="0" anchor="t"/>
+          <a:bodyPr wrap="square" lIns="0" tIns="0" rIns="0" bIns="0" anchor="t"/>
           <a:lstStyle/>
           <a:p>
             <a:pPr algn="l"/>
@@ -5005,7 +5619,7 @@
           </a:ln>
         </p:spPr>
         <p:txBody>
-          <a:bodyPr wrap="square" lIns="0" rIns="0" tIns="0" bIns="0" anchor="t"/>
+          <a:bodyPr wrap="square" lIns="0" tIns="0" rIns="0" bIns="0" anchor="t"/>
           <a:lstStyle/>
           <a:p>
             <a:pPr algn="l"/>
@@ -5025,7 +5639,7 @@
         <p:nvPicPr>
           <p:cNvPr id="5" name="sigma_uv.png" descr="sigma_uv.png"/>
           <p:cNvPicPr>
-            <a:picLocks noChangeAspect="1" noGrp="1"/>
+            <a:picLocks noGrp="1" noChangeAspect="1"/>
           </p:cNvPicPr>
           <p:nvPr/>
         </p:nvPicPr>
@@ -5062,7 +5676,7 @@
           </a:ln>
         </p:spPr>
         <p:txBody>
-          <a:bodyPr wrap="square" lIns="0" rIns="0" tIns="0" bIns="0" anchor="t"/>
+          <a:bodyPr wrap="square" lIns="0" tIns="0" rIns="0" bIns="0" anchor="t"/>
           <a:lstStyle/>
           <a:p>
             <a:pPr algn="l"/>
@@ -5139,7 +5753,7 @@
           </a:ln>
         </p:spPr>
         <p:txBody>
-          <a:bodyPr wrap="square" lIns="0" rIns="0" tIns="0" bIns="0" anchor="ctr"/>
+          <a:bodyPr wrap="square" lIns="0" tIns="0" rIns="0" bIns="0" anchor="ctr"/>
           <a:lstStyle/>
           <a:p>
             <a:pPr algn="l"/>
@@ -5216,7 +5830,7 @@
           </a:ln>
         </p:spPr>
         <p:txBody>
-          <a:bodyPr wrap="square" lIns="0" rIns="0" tIns="0" bIns="0" anchor="ctr"/>
+          <a:bodyPr wrap="square" lIns="0" tIns="0" rIns="0" bIns="0" anchor="ctr"/>
           <a:lstStyle/>
           <a:p>
             <a:pPr algn="l"/>
@@ -5249,7 +5863,7 @@
           </a:ln>
         </p:spPr>
         <p:txBody>
-          <a:bodyPr wrap="square" lIns="0" rIns="0" tIns="0" bIns="0" anchor="ctr"/>
+          <a:bodyPr wrap="square" lIns="0" tIns="0" rIns="0" bIns="0" anchor="ctr"/>
           <a:lstStyle/>
           <a:p>
             <a:pPr algn="r"/>
@@ -5274,7 +5888,7 @@
 </file>
 
 <file path=ppt/slides/slide13.xml><?xml version="1.0" encoding="utf-8"?>
-<p:sld xmlns:p="http://schemas.openxmlformats.org/presentationml/2006/main" xmlns:a="http://schemas.openxmlformats.org/drawingml/2006/main" xmlns:r="http://schemas.openxmlformats.org/officeDocument/2006/relationships">
+<p:sld xmlns:a="http://schemas.openxmlformats.org/drawingml/2006/main" xmlns:r="http://schemas.openxmlformats.org/officeDocument/2006/relationships" xmlns:p="http://schemas.openxmlformats.org/presentationml/2006/main">
   <p:cSld>
     <p:bg>
       <p:bgPr>
@@ -5315,7 +5929,7 @@
           </a:ln>
         </p:spPr>
         <p:txBody>
-          <a:bodyPr wrap="square" lIns="0" rIns="0" tIns="0" bIns="0" anchor="t"/>
+          <a:bodyPr wrap="square" lIns="0" tIns="0" rIns="0" bIns="0" anchor="t"/>
           <a:lstStyle/>
           <a:p>
             <a:pPr algn="l"/>
@@ -5348,7 +5962,7 @@
           </a:ln>
         </p:spPr>
         <p:txBody>
-          <a:bodyPr wrap="square" lIns="0" rIns="0" tIns="0" bIns="0" anchor="t"/>
+          <a:bodyPr wrap="square" lIns="0" tIns="0" rIns="0" bIns="0" anchor="t"/>
           <a:lstStyle/>
           <a:p>
             <a:pPr algn="l"/>
@@ -5381,7 +5995,7 @@
           </a:ln>
         </p:spPr>
         <p:txBody>
-          <a:bodyPr wrap="square" lIns="0" rIns="0" tIns="0" bIns="0" anchor="t"/>
+          <a:bodyPr wrap="square" lIns="0" tIns="0" rIns="0" bIns="0" anchor="t"/>
           <a:lstStyle/>
           <a:p>
             <a:pPr algn="l"/>
@@ -5401,7 +6015,7 @@
         <p:nvPicPr>
           <p:cNvPr id="5" name="ajaka_uv.png" descr="ajaka_uv.png"/>
           <p:cNvPicPr>
-            <a:picLocks noChangeAspect="1" noGrp="1"/>
+            <a:picLocks noGrp="1" noChangeAspect="1"/>
           </p:cNvPicPr>
           <p:nvPr/>
         </p:nvPicPr>
@@ -5438,7 +6052,7 @@
           </a:ln>
         </p:spPr>
         <p:txBody>
-          <a:bodyPr wrap="square" lIns="0" rIns="0" tIns="0" bIns="0" anchor="t"/>
+          <a:bodyPr wrap="square" lIns="0" tIns="0" rIns="0" bIns="0" anchor="t"/>
           <a:lstStyle/>
           <a:p>
             <a:pPr algn="l"/>
@@ -5515,7 +6129,7 @@
           </a:ln>
         </p:spPr>
         <p:txBody>
-          <a:bodyPr wrap="square" lIns="0" rIns="0" tIns="0" bIns="0" anchor="ctr"/>
+          <a:bodyPr wrap="square" lIns="0" tIns="0" rIns="0" bIns="0" anchor="ctr"/>
           <a:lstStyle/>
           <a:p>
             <a:pPr algn="l"/>
@@ -5592,7 +6206,7 @@
           </a:ln>
         </p:spPr>
         <p:txBody>
-          <a:bodyPr wrap="square" lIns="0" rIns="0" tIns="0" bIns="0" anchor="ctr"/>
+          <a:bodyPr wrap="square" lIns="0" tIns="0" rIns="0" bIns="0" anchor="ctr"/>
           <a:lstStyle/>
           <a:p>
             <a:pPr algn="l"/>
@@ -5625,7 +6239,7 @@
           </a:ln>
         </p:spPr>
         <p:txBody>
-          <a:bodyPr wrap="square" lIns="0" rIns="0" tIns="0" bIns="0" anchor="ctr"/>
+          <a:bodyPr wrap="square" lIns="0" tIns="0" rIns="0" bIns="0" anchor="ctr"/>
           <a:lstStyle/>
           <a:p>
             <a:pPr algn="r"/>
@@ -5650,7 +6264,7 @@
 </file>
 
 <file path=ppt/slides/slide14.xml><?xml version="1.0" encoding="utf-8"?>
-<p:sld xmlns:p="http://schemas.openxmlformats.org/presentationml/2006/main" xmlns:a="http://schemas.openxmlformats.org/drawingml/2006/main" xmlns:r="http://schemas.openxmlformats.org/officeDocument/2006/relationships">
+<p:sld xmlns:a="http://schemas.openxmlformats.org/drawingml/2006/main" xmlns:r="http://schemas.openxmlformats.org/officeDocument/2006/relationships" xmlns:p="http://schemas.openxmlformats.org/presentationml/2006/main">
   <p:cSld>
     <p:bg>
       <p:bgPr>
@@ -5691,7 +6305,7 @@
           </a:ln>
         </p:spPr>
         <p:txBody>
-          <a:bodyPr wrap="square" lIns="0" rIns="0" tIns="0" bIns="0" anchor="t"/>
+          <a:bodyPr wrap="square" lIns="0" tIns="0" rIns="0" bIns="0" anchor="t"/>
           <a:lstStyle/>
           <a:p>
             <a:pPr algn="l"/>
@@ -5724,7 +6338,7 @@
           </a:ln>
         </p:spPr>
         <p:txBody>
-          <a:bodyPr wrap="square" lIns="0" rIns="0" tIns="0" bIns="0" anchor="t"/>
+          <a:bodyPr wrap="square" lIns="0" tIns="0" rIns="0" bIns="0" anchor="t"/>
           <a:lstStyle/>
           <a:p>
             <a:pPr algn="l"/>
@@ -5757,7 +6371,7 @@
           </a:ln>
         </p:spPr>
         <p:txBody>
-          <a:bodyPr wrap="square" lIns="0" rIns="0" tIns="0" bIns="0" anchor="t"/>
+          <a:bodyPr wrap="square" lIns="0" tIns="0" rIns="0" bIns="0" anchor="t"/>
           <a:lstStyle/>
           <a:p>
             <a:pPr algn="l"/>
@@ -5777,7 +6391,7 @@
         <p:nvPicPr>
           <p:cNvPr id="5" name="sigma_vis.png" descr="sigma_vis.png"/>
           <p:cNvPicPr>
-            <a:picLocks noChangeAspect="1" noGrp="1"/>
+            <a:picLocks noGrp="1" noChangeAspect="1"/>
           </p:cNvPicPr>
           <p:nvPr/>
         </p:nvPicPr>
@@ -5814,7 +6428,7 @@
           </a:ln>
         </p:spPr>
         <p:txBody>
-          <a:bodyPr wrap="square" lIns="0" rIns="0" tIns="0" bIns="0" anchor="t"/>
+          <a:bodyPr wrap="square" lIns="0" tIns="0" rIns="0" bIns="0" anchor="t"/>
           <a:lstStyle/>
           <a:p>
             <a:pPr algn="l"/>
@@ -5891,7 +6505,7 @@
           </a:ln>
         </p:spPr>
         <p:txBody>
-          <a:bodyPr wrap="square" lIns="0" rIns="0" tIns="0" bIns="0" anchor="ctr"/>
+          <a:bodyPr wrap="square" lIns="0" tIns="0" rIns="0" bIns="0" anchor="ctr"/>
           <a:lstStyle/>
           <a:p>
             <a:pPr algn="l"/>
@@ -5968,7 +6582,7 @@
           </a:ln>
         </p:spPr>
         <p:txBody>
-          <a:bodyPr wrap="square" lIns="0" rIns="0" tIns="0" bIns="0" anchor="ctr"/>
+          <a:bodyPr wrap="square" lIns="0" tIns="0" rIns="0" bIns="0" anchor="ctr"/>
           <a:lstStyle/>
           <a:p>
             <a:pPr algn="l"/>
@@ -6001,7 +6615,7 @@
           </a:ln>
         </p:spPr>
         <p:txBody>
-          <a:bodyPr wrap="square" lIns="0" rIns="0" tIns="0" bIns="0" anchor="ctr"/>
+          <a:bodyPr wrap="square" lIns="0" tIns="0" rIns="0" bIns="0" anchor="ctr"/>
           <a:lstStyle/>
           <a:p>
             <a:pPr algn="r"/>
@@ -6026,7 +6640,7 @@
 </file>
 
 <file path=ppt/slides/slide15.xml><?xml version="1.0" encoding="utf-8"?>
-<p:sld xmlns:p="http://schemas.openxmlformats.org/presentationml/2006/main" xmlns:a="http://schemas.openxmlformats.org/drawingml/2006/main" xmlns:r="http://schemas.openxmlformats.org/officeDocument/2006/relationships">
+<p:sld xmlns:a="http://schemas.openxmlformats.org/drawingml/2006/main" xmlns:r="http://schemas.openxmlformats.org/officeDocument/2006/relationships" xmlns:p="http://schemas.openxmlformats.org/presentationml/2006/main">
   <p:cSld>
     <p:bg>
       <p:bgPr>
@@ -6067,7 +6681,7 @@
           </a:ln>
         </p:spPr>
         <p:txBody>
-          <a:bodyPr wrap="square" lIns="0" rIns="0" tIns="0" bIns="0" anchor="t"/>
+          <a:bodyPr wrap="square" lIns="0" tIns="0" rIns="0" bIns="0" anchor="t"/>
           <a:lstStyle/>
           <a:p>
             <a:pPr algn="l"/>
@@ -6100,7 +6714,7 @@
           </a:ln>
         </p:spPr>
         <p:txBody>
-          <a:bodyPr wrap="square" lIns="0" rIns="0" tIns="0" bIns="0" anchor="t"/>
+          <a:bodyPr wrap="square" lIns="0" tIns="0" rIns="0" bIns="0" anchor="t"/>
           <a:lstStyle/>
           <a:p>
             <a:pPr algn="l"/>
@@ -6133,7 +6747,7 @@
           </a:ln>
         </p:spPr>
         <p:txBody>
-          <a:bodyPr wrap="square" lIns="0" rIns="0" tIns="0" bIns="0" anchor="t"/>
+          <a:bodyPr wrap="square" lIns="0" tIns="0" rIns="0" bIns="0" anchor="t"/>
           <a:lstStyle/>
           <a:p>
             <a:pPr algn="l"/>
@@ -6166,7 +6780,7 @@
           </a:ln>
         </p:spPr>
         <p:txBody>
-          <a:bodyPr wrap="square" lIns="0" rIns="0" tIns="0" bIns="0" anchor="t"/>
+          <a:bodyPr wrap="square" lIns="0" tIns="0" rIns="0" bIns="0" anchor="t"/>
           <a:lstStyle/>
           <a:p>
             <a:pPr algn="l"/>
@@ -6199,7 +6813,7 @@
           </a:ln>
         </p:spPr>
         <p:txBody>
-          <a:bodyPr wrap="square" lIns="0" rIns="0" tIns="0" bIns="0" anchor="t"/>
+          <a:bodyPr wrap="square" lIns="0" tIns="0" rIns="0" bIns="0" anchor="t"/>
           <a:lstStyle/>
           <a:p>
             <a:pPr algn="l"/>
@@ -6232,7 +6846,7 @@
           </a:ln>
         </p:spPr>
         <p:txBody>
-          <a:bodyPr wrap="square" lIns="0" rIns="0" tIns="0" bIns="0" anchor="t"/>
+          <a:bodyPr wrap="square" lIns="0" tIns="0" rIns="0" bIns="0" anchor="t"/>
           <a:lstStyle/>
           <a:p>
             <a:pPr algn="l"/>
@@ -6265,7 +6879,7 @@
           </a:ln>
         </p:spPr>
         <p:txBody>
-          <a:bodyPr wrap="square" lIns="0" rIns="0" tIns="0" bIns="0" anchor="t"/>
+          <a:bodyPr wrap="square" lIns="0" tIns="0" rIns="0" bIns="0" anchor="t"/>
           <a:lstStyle/>
           <a:p>
             <a:pPr algn="l"/>
@@ -6285,7 +6899,7 @@
         <p:nvPicPr>
           <p:cNvPr id="9" name="polarization.png" descr="polarization.png"/>
           <p:cNvPicPr>
-            <a:picLocks noChangeAspect="1" noGrp="1"/>
+            <a:picLocks noGrp="1" noChangeAspect="1"/>
           </p:cNvPicPr>
           <p:nvPr/>
         </p:nvPicPr>
@@ -6366,7 +6980,7 @@
           </a:ln>
         </p:spPr>
         <p:txBody>
-          <a:bodyPr wrap="square" lIns="0" rIns="0" tIns="0" bIns="0" anchor="ctr"/>
+          <a:bodyPr wrap="square" lIns="0" tIns="0" rIns="0" bIns="0" anchor="ctr"/>
           <a:lstStyle/>
           <a:p>
             <a:pPr algn="l"/>
@@ -6443,7 +7057,7 @@
           </a:ln>
         </p:spPr>
         <p:txBody>
-          <a:bodyPr wrap="square" lIns="0" rIns="0" tIns="0" bIns="0" anchor="ctr"/>
+          <a:bodyPr wrap="square" lIns="0" tIns="0" rIns="0" bIns="0" anchor="ctr"/>
           <a:lstStyle/>
           <a:p>
             <a:pPr algn="l"/>
@@ -6476,7 +7090,7 @@
           </a:ln>
         </p:spPr>
         <p:txBody>
-          <a:bodyPr wrap="square" lIns="0" rIns="0" tIns="0" bIns="0" anchor="ctr"/>
+          <a:bodyPr wrap="square" lIns="0" tIns="0" rIns="0" bIns="0" anchor="ctr"/>
           <a:lstStyle/>
           <a:p>
             <a:pPr algn="r"/>
@@ -6501,7 +7115,7 @@
 </file>
 
 <file path=ppt/slides/slide16.xml><?xml version="1.0" encoding="utf-8"?>
-<p:sld xmlns:p="http://schemas.openxmlformats.org/presentationml/2006/main" xmlns:a="http://schemas.openxmlformats.org/drawingml/2006/main" xmlns:r="http://schemas.openxmlformats.org/officeDocument/2006/relationships">
+<p:sld xmlns:a="http://schemas.openxmlformats.org/drawingml/2006/main" xmlns:r="http://schemas.openxmlformats.org/officeDocument/2006/relationships" xmlns:p="http://schemas.openxmlformats.org/presentationml/2006/main">
   <p:cSld>
     <p:bg>
       <p:bgPr>
@@ -6542,7 +7156,7 @@
           </a:ln>
         </p:spPr>
         <p:txBody>
-          <a:bodyPr wrap="square" lIns="0" rIns="0" tIns="0" bIns="0" anchor="t"/>
+          <a:bodyPr wrap="square" lIns="0" tIns="0" rIns="0" bIns="0" anchor="t"/>
           <a:lstStyle/>
           <a:p>
             <a:pPr algn="l"/>
@@ -6575,7 +7189,7 @@
           </a:ln>
         </p:spPr>
         <p:txBody>
-          <a:bodyPr wrap="square" lIns="0" rIns="0" tIns="0" bIns="0" anchor="t"/>
+          <a:bodyPr wrap="square" lIns="0" tIns="0" rIns="0" bIns="0" anchor="t"/>
           <a:lstStyle/>
           <a:p>
             <a:pPr algn="l"/>
@@ -6608,7 +7222,7 @@
           </a:ln>
         </p:spPr>
         <p:txBody>
-          <a:bodyPr wrap="square" lIns="0" rIns="0" tIns="0" bIns="0" anchor="t"/>
+          <a:bodyPr wrap="square" lIns="0" tIns="0" rIns="0" bIns="0" anchor="t"/>
           <a:lstStyle/>
           <a:p>
             <a:pPr algn="l"/>
@@ -6641,7 +7255,7 @@
           </a:ln>
         </p:spPr>
         <p:txBody>
-          <a:bodyPr wrap="square" lIns="0" rIns="0" tIns="0" bIns="0" anchor="t"/>
+          <a:bodyPr wrap="square" lIns="0" tIns="0" rIns="0" bIns="0" anchor="t"/>
           <a:lstStyle/>
           <a:p>
             <a:pPr algn="l"/>
@@ -6674,7 +7288,7 @@
           </a:ln>
         </p:spPr>
         <p:txBody>
-          <a:bodyPr wrap="square" lIns="0" rIns="0" tIns="0" bIns="0" anchor="t"/>
+          <a:bodyPr wrap="square" lIns="0" tIns="0" rIns="0" bIns="0" anchor="t"/>
           <a:lstStyle/>
           <a:p>
             <a:pPr algn="l"/>
@@ -6707,7 +7321,7 @@
           </a:ln>
         </p:spPr>
         <p:txBody>
-          <a:bodyPr wrap="square" lIns="0" rIns="0" tIns="0" bIns="0" anchor="t"/>
+          <a:bodyPr wrap="square" lIns="0" tIns="0" rIns="0" bIns="0" anchor="t"/>
           <a:lstStyle/>
           <a:p>
             <a:pPr algn="l"/>
@@ -6740,7 +7354,7 @@
           </a:ln>
         </p:spPr>
         <p:txBody>
-          <a:bodyPr wrap="square" lIns="0" rIns="0" tIns="0" bIns="0" anchor="t"/>
+          <a:bodyPr wrap="square" lIns="0" tIns="0" rIns="0" bIns="0" anchor="t"/>
           <a:lstStyle/>
           <a:p>
             <a:pPr algn="l"/>
@@ -6773,7 +7387,7 @@
           </a:ln>
         </p:spPr>
         <p:txBody>
-          <a:bodyPr wrap="square" lIns="0" rIns="0" tIns="0" bIns="0" anchor="t"/>
+          <a:bodyPr wrap="square" lIns="0" tIns="0" rIns="0" bIns="0" anchor="t"/>
           <a:lstStyle/>
           <a:p>
             <a:pPr algn="l"/>
@@ -6806,7 +7420,7 @@
           </a:ln>
         </p:spPr>
         <p:txBody>
-          <a:bodyPr wrap="square" lIns="0" rIns="0" tIns="0" bIns="0" anchor="t"/>
+          <a:bodyPr wrap="square" lIns="0" tIns="0" rIns="0" bIns="0" anchor="t"/>
           <a:lstStyle/>
           <a:p>
             <a:pPr algn="l"/>
@@ -6839,7 +7453,7 @@
           </a:ln>
         </p:spPr>
         <p:txBody>
-          <a:bodyPr wrap="square" lIns="0" rIns="0" tIns="0" bIns="0" anchor="t"/>
+          <a:bodyPr wrap="square" lIns="0" tIns="0" rIns="0" bIns="0" anchor="t"/>
           <a:lstStyle/>
           <a:p>
             <a:pPr algn="l"/>
@@ -6872,7 +7486,7 @@
           </a:ln>
         </p:spPr>
         <p:txBody>
-          <a:bodyPr wrap="square" lIns="0" rIns="0" tIns="0" bIns="0" anchor="t"/>
+          <a:bodyPr wrap="square" lIns="0" tIns="0" rIns="0" bIns="0" anchor="t"/>
           <a:lstStyle/>
           <a:p>
             <a:pPr algn="l"/>
@@ -6905,7 +7519,7 @@
           </a:ln>
         </p:spPr>
         <p:txBody>
-          <a:bodyPr wrap="square" lIns="0" rIns="0" tIns="0" bIns="0" anchor="t"/>
+          <a:bodyPr wrap="square" lIns="0" tIns="0" rIns="0" bIns="0" anchor="t"/>
           <a:lstStyle/>
           <a:p>
             <a:pPr algn="l"/>
@@ -6938,7 +7552,7 @@
           </a:ln>
         </p:spPr>
         <p:txBody>
-          <a:bodyPr wrap="square" lIns="0" rIns="0" tIns="0" bIns="0" anchor="t"/>
+          <a:bodyPr wrap="square" lIns="0" tIns="0" rIns="0" bIns="0" anchor="t"/>
           <a:lstStyle/>
           <a:p>
             <a:pPr algn="l"/>
@@ -6971,7 +7585,7 @@
           </a:ln>
         </p:spPr>
         <p:txBody>
-          <a:bodyPr wrap="square" lIns="0" rIns="0" tIns="0" bIns="0" anchor="t"/>
+          <a:bodyPr wrap="square" lIns="0" tIns="0" rIns="0" bIns="0" anchor="t"/>
           <a:lstStyle/>
           <a:p>
             <a:pPr algn="l"/>
@@ -7048,7 +7662,7 @@
           </a:ln>
         </p:spPr>
         <p:txBody>
-          <a:bodyPr wrap="square" lIns="0" rIns="0" tIns="0" bIns="0" anchor="ctr"/>
+          <a:bodyPr wrap="square" lIns="0" tIns="0" rIns="0" bIns="0" anchor="ctr"/>
           <a:lstStyle/>
           <a:p>
             <a:pPr algn="l"/>
@@ -7125,7 +7739,7 @@
           </a:ln>
         </p:spPr>
         <p:txBody>
-          <a:bodyPr wrap="square" lIns="0" rIns="0" tIns="0" bIns="0" anchor="ctr"/>
+          <a:bodyPr wrap="square" lIns="0" tIns="0" rIns="0" bIns="0" anchor="ctr"/>
           <a:lstStyle/>
           <a:p>
             <a:pPr algn="l"/>
@@ -7158,7 +7772,7 @@
           </a:ln>
         </p:spPr>
         <p:txBody>
-          <a:bodyPr wrap="square" lIns="0" rIns="0" tIns="0" bIns="0" anchor="ctr"/>
+          <a:bodyPr wrap="square" lIns="0" tIns="0" rIns="0" bIns="0" anchor="ctr"/>
           <a:lstStyle/>
           <a:p>
             <a:pPr algn="r"/>
@@ -7183,7 +7797,7 @@
 </file>
 
 <file path=ppt/slides/slide17.xml><?xml version="1.0" encoding="utf-8"?>
-<p:sld xmlns:p="http://schemas.openxmlformats.org/presentationml/2006/main" xmlns:a="http://schemas.openxmlformats.org/drawingml/2006/main" xmlns:r="http://schemas.openxmlformats.org/officeDocument/2006/relationships">
+<p:sld xmlns:a="http://schemas.openxmlformats.org/drawingml/2006/main" xmlns:r="http://schemas.openxmlformats.org/officeDocument/2006/relationships" xmlns:p="http://schemas.openxmlformats.org/presentationml/2006/main">
   <p:cSld>
     <p:bg>
       <p:bgPr>
@@ -7224,7 +7838,7 @@
           </a:ln>
         </p:spPr>
         <p:txBody>
-          <a:bodyPr wrap="square" lIns="0" rIns="0" tIns="0" bIns="0" anchor="t"/>
+          <a:bodyPr wrap="square" lIns="0" tIns="0" rIns="0" bIns="0" anchor="t"/>
           <a:lstStyle/>
           <a:p>
             <a:pPr algn="l"/>
@@ -7257,7 +7871,7 @@
           </a:ln>
         </p:spPr>
         <p:txBody>
-          <a:bodyPr wrap="square" lIns="0" rIns="0" tIns="0" bIns="0" anchor="t"/>
+          <a:bodyPr wrap="square" lIns="0" tIns="0" rIns="0" bIns="0" anchor="t"/>
           <a:lstStyle/>
           <a:p>
             <a:pPr algn="l"/>
@@ -7290,7 +7904,7 @@
           </a:ln>
         </p:spPr>
         <p:txBody>
-          <a:bodyPr wrap="square" lIns="0" rIns="0" tIns="0" bIns="0" anchor="t"/>
+          <a:bodyPr wrap="square" lIns="0" tIns="0" rIns="0" bIns="0" anchor="t"/>
           <a:lstStyle/>
           <a:p>
             <a:pPr algn="l"/>
@@ -7323,7 +7937,7 @@
           </a:ln>
         </p:spPr>
         <p:txBody>
-          <a:bodyPr wrap="square" lIns="0" rIns="0" tIns="0" bIns="0" anchor="t"/>
+          <a:bodyPr wrap="square" lIns="0" tIns="0" rIns="0" bIns="0" anchor="t"/>
           <a:lstStyle/>
           <a:p>
             <a:pPr algn="l"/>
@@ -7356,7 +7970,7 @@
           </a:ln>
         </p:spPr>
         <p:txBody>
-          <a:bodyPr wrap="square" lIns="0" rIns="0" tIns="0" bIns="0" anchor="t"/>
+          <a:bodyPr wrap="square" lIns="0" tIns="0" rIns="0" bIns="0" anchor="t"/>
           <a:lstStyle/>
           <a:p>
             <a:pPr algn="l"/>
@@ -7389,7 +8003,7 @@
           </a:ln>
         </p:spPr>
         <p:txBody>
-          <a:bodyPr wrap="square" lIns="0" rIns="0" tIns="0" bIns="0" anchor="t"/>
+          <a:bodyPr wrap="square" lIns="0" tIns="0" rIns="0" bIns="0" anchor="t"/>
           <a:lstStyle/>
           <a:p>
             <a:pPr algn="l"/>
@@ -7422,7 +8036,7 @@
           </a:ln>
         </p:spPr>
         <p:txBody>
-          <a:bodyPr wrap="square" lIns="0" rIns="0" tIns="0" bIns="0" anchor="t"/>
+          <a:bodyPr wrap="square" lIns="0" tIns="0" rIns="0" bIns="0" anchor="t"/>
           <a:lstStyle/>
           <a:p>
             <a:pPr algn="l"/>
@@ -7455,7 +8069,7 @@
           </a:ln>
         </p:spPr>
         <p:txBody>
-          <a:bodyPr wrap="square" lIns="0" rIns="0" tIns="0" bIns="0" anchor="t"/>
+          <a:bodyPr wrap="square" lIns="0" tIns="0" rIns="0" bIns="0" anchor="t"/>
           <a:lstStyle/>
           <a:p>
             <a:pPr algn="l"/>
@@ -7488,7 +8102,7 @@
           </a:ln>
         </p:spPr>
         <p:txBody>
-          <a:bodyPr wrap="square" lIns="0" rIns="0" tIns="0" bIns="0" anchor="t"/>
+          <a:bodyPr wrap="square" lIns="0" tIns="0" rIns="0" bIns="0" anchor="t"/>
           <a:lstStyle/>
           <a:p>
             <a:pPr algn="l"/>
@@ -7521,7 +8135,7 @@
           </a:ln>
         </p:spPr>
         <p:txBody>
-          <a:bodyPr wrap="square" lIns="0" rIns="0" tIns="0" bIns="0" anchor="t"/>
+          <a:bodyPr wrap="square" lIns="0" tIns="0" rIns="0" bIns="0" anchor="t"/>
           <a:lstStyle/>
           <a:p>
             <a:pPr algn="l"/>
@@ -7598,7 +8212,7 @@
           </a:ln>
         </p:spPr>
         <p:txBody>
-          <a:bodyPr wrap="square" lIns="0" rIns="0" tIns="0" bIns="0" anchor="ctr"/>
+          <a:bodyPr wrap="square" lIns="0" tIns="0" rIns="0" bIns="0" anchor="ctr"/>
           <a:lstStyle/>
           <a:p>
             <a:pPr algn="l"/>
@@ -7675,7 +8289,7 @@
           </a:ln>
         </p:spPr>
         <p:txBody>
-          <a:bodyPr wrap="square" lIns="0" rIns="0" tIns="0" bIns="0" anchor="ctr"/>
+          <a:bodyPr wrap="square" lIns="0" tIns="0" rIns="0" bIns="0" anchor="ctr"/>
           <a:lstStyle/>
           <a:p>
             <a:pPr algn="l"/>
@@ -7708,7 +8322,7 @@
           </a:ln>
         </p:spPr>
         <p:txBody>
-          <a:bodyPr wrap="square" lIns="0" rIns="0" tIns="0" bIns="0" anchor="ctr"/>
+          <a:bodyPr wrap="square" lIns="0" tIns="0" rIns="0" bIns="0" anchor="ctr"/>
           <a:lstStyle/>
           <a:p>
             <a:pPr algn="r"/>
@@ -8356,7 +8970,7 @@
 </file>
 
 <file path=ppt/slides/slide3.xml><?xml version="1.0" encoding="utf-8"?>
-<p:sld xmlns:p="http://schemas.openxmlformats.org/presentationml/2006/main" xmlns:a="http://schemas.openxmlformats.org/drawingml/2006/main" xmlns:r="http://schemas.openxmlformats.org/officeDocument/2006/relationships">
+<p:sld xmlns:a="http://schemas.openxmlformats.org/drawingml/2006/main" xmlns:r="http://schemas.openxmlformats.org/officeDocument/2006/relationships" xmlns:p="http://schemas.openxmlformats.org/presentationml/2006/main">
   <p:cSld>
     <p:bg>
       <p:bgPr>
@@ -8397,7 +9011,7 @@
           </a:ln>
         </p:spPr>
         <p:txBody>
-          <a:bodyPr wrap="square" lIns="0" rIns="0" tIns="0" bIns="0" anchor="t"/>
+          <a:bodyPr wrap="square" lIns="0" tIns="0" rIns="0" bIns="0" anchor="t"/>
           <a:lstStyle/>
           <a:p>
             <a:pPr algn="l"/>
@@ -8430,7 +9044,7 @@
           </a:ln>
         </p:spPr>
         <p:txBody>
-          <a:bodyPr wrap="square" lIns="0" rIns="0" tIns="0" bIns="0" anchor="t"/>
+          <a:bodyPr wrap="square" lIns="0" tIns="0" rIns="0" bIns="0" anchor="t"/>
           <a:lstStyle/>
           <a:p>
             <a:pPr algn="l"/>
@@ -8463,7 +9077,7 @@
           </a:ln>
         </p:spPr>
         <p:txBody>
-          <a:bodyPr wrap="square" lIns="0" rIns="0" tIns="0" bIns="0" anchor="t"/>
+          <a:bodyPr wrap="square" lIns="0" tIns="0" rIns="0" bIns="0" anchor="t"/>
           <a:lstStyle/>
           <a:p>
             <a:pPr algn="l"/>
@@ -8518,7 +9132,7 @@
           </a:ln>
         </p:spPr>
         <p:txBody>
-          <a:bodyPr wrap="square" lIns="0" rIns="0" tIns="0" bIns="0" anchor="ctr"/>
+          <a:bodyPr wrap="square" lIns="0" tIns="0" rIns="0" bIns="0" anchor="ctr"/>
           <a:lstStyle/>
           <a:p>
             <a:pPr algn="ctr"/>
@@ -8585,7 +9199,7 @@
           </a:ln>
         </p:spPr>
         <p:txBody>
-          <a:bodyPr wrap="square" lIns="0" rIns="0" tIns="0" bIns="0" anchor="ctr"/>
+          <a:bodyPr wrap="square" lIns="0" tIns="0" rIns="0" bIns="0" anchor="ctr"/>
           <a:lstStyle/>
           <a:p>
             <a:pPr algn="ctr"/>
@@ -8652,7 +9266,7 @@
           </a:ln>
         </p:spPr>
         <p:txBody>
-          <a:bodyPr wrap="square" lIns="0" rIns="0" tIns="0" bIns="0" anchor="ctr"/>
+          <a:bodyPr wrap="square" lIns="0" tIns="0" rIns="0" bIns="0" anchor="ctr"/>
           <a:lstStyle/>
           <a:p>
             <a:pPr algn="ctr"/>
@@ -8719,7 +9333,7 @@
           </a:ln>
         </p:spPr>
         <p:txBody>
-          <a:bodyPr wrap="square" lIns="0" rIns="0" tIns="0" bIns="0" anchor="ctr"/>
+          <a:bodyPr wrap="square" lIns="0" tIns="0" rIns="0" bIns="0" anchor="ctr"/>
           <a:lstStyle/>
           <a:p>
             <a:pPr algn="ctr"/>
@@ -8786,7 +9400,7 @@
           </a:ln>
         </p:spPr>
         <p:txBody>
-          <a:bodyPr wrap="square" lIns="0" rIns="0" tIns="0" bIns="0" anchor="ctr"/>
+          <a:bodyPr wrap="square" lIns="0" tIns="0" rIns="0" bIns="0" anchor="ctr"/>
           <a:lstStyle/>
           <a:p>
             <a:pPr algn="ctr"/>
@@ -8819,7 +9433,7 @@
           </a:ln>
         </p:spPr>
         <p:txBody>
-          <a:bodyPr wrap="square" lIns="0" rIns="0" tIns="0" bIns="0" anchor="ctr"/>
+          <a:bodyPr wrap="square" lIns="0" tIns="0" rIns="0" bIns="0" anchor="ctr"/>
           <a:lstStyle/>
           <a:p>
             <a:pPr algn="ctr"/>
@@ -8852,7 +9466,7 @@
           </a:ln>
         </p:spPr>
         <p:txBody>
-          <a:bodyPr wrap="square" lIns="0" rIns="0" tIns="0" bIns="0" anchor="ctr"/>
+          <a:bodyPr wrap="square" lIns="0" tIns="0" rIns="0" bIns="0" anchor="ctr"/>
           <a:lstStyle/>
           <a:p>
             <a:pPr algn="ctr"/>
@@ -8885,7 +9499,7 @@
           </a:ln>
         </p:spPr>
         <p:txBody>
-          <a:bodyPr wrap="square" lIns="0" rIns="0" tIns="0" bIns="0" anchor="ctr"/>
+          <a:bodyPr wrap="square" lIns="0" tIns="0" rIns="0" bIns="0" anchor="ctr"/>
           <a:lstStyle/>
           <a:p>
             <a:pPr algn="ctr"/>
@@ -8918,7 +9532,7 @@
           </a:ln>
         </p:spPr>
         <p:txBody>
-          <a:bodyPr wrap="square" lIns="0" rIns="0" tIns="0" bIns="0" anchor="ctr"/>
+          <a:bodyPr wrap="square" lIns="0" tIns="0" rIns="0" bIns="0" anchor="ctr"/>
           <a:lstStyle/>
           <a:p>
             <a:pPr algn="ctr"/>
@@ -8951,7 +9565,7 @@
           </a:ln>
         </p:spPr>
         <p:txBody>
-          <a:bodyPr wrap="square" lIns="0" rIns="0" tIns="0" bIns="0" anchor="t"/>
+          <a:bodyPr wrap="square" lIns="0" tIns="0" rIns="0" bIns="0" anchor="t"/>
           <a:lstStyle/>
           <a:p>
             <a:pPr algn="l"/>
@@ -8984,7 +9598,7 @@
           </a:ln>
         </p:spPr>
         <p:txBody>
-          <a:bodyPr wrap="square" lIns="0" rIns="0" tIns="0" bIns="0" anchor="t"/>
+          <a:bodyPr wrap="square" lIns="0" tIns="0" rIns="0" bIns="0" anchor="t"/>
           <a:lstStyle/>
           <a:p>
             <a:pPr algn="l"/>
@@ -9039,7 +9653,7 @@
           </a:ln>
         </p:spPr>
         <p:txBody>
-          <a:bodyPr wrap="square" lIns="0" rIns="0" tIns="0" bIns="0" anchor="ctr"/>
+          <a:bodyPr wrap="square" lIns="0" tIns="0" rIns="0" bIns="0" anchor="ctr"/>
           <a:lstStyle/>
           <a:p>
             <a:pPr algn="ctr"/>
@@ -9106,7 +9720,7 @@
           </a:ln>
         </p:spPr>
         <p:txBody>
-          <a:bodyPr wrap="square" lIns="0" rIns="0" tIns="0" bIns="0" anchor="ctr"/>
+          <a:bodyPr wrap="square" lIns="0" tIns="0" rIns="0" bIns="0" anchor="ctr"/>
           <a:lstStyle/>
           <a:p>
             <a:pPr algn="ctr"/>
@@ -9173,7 +9787,7 @@
           </a:ln>
         </p:spPr>
         <p:txBody>
-          <a:bodyPr wrap="square" lIns="0" rIns="0" tIns="0" bIns="0" anchor="ctr"/>
+          <a:bodyPr wrap="square" lIns="0" tIns="0" rIns="0" bIns="0" anchor="ctr"/>
           <a:lstStyle/>
           <a:p>
             <a:pPr algn="ctr"/>
@@ -9240,7 +9854,7 @@
           </a:ln>
         </p:spPr>
         <p:txBody>
-          <a:bodyPr wrap="square" lIns="0" rIns="0" tIns="0" bIns="0" anchor="ctr"/>
+          <a:bodyPr wrap="square" lIns="0" tIns="0" rIns="0" bIns="0" anchor="ctr"/>
           <a:lstStyle/>
           <a:p>
             <a:pPr algn="ctr"/>
@@ -9285,7 +9899,7 @@
           </a:ln>
         </p:spPr>
         <p:txBody>
-          <a:bodyPr wrap="square" lIns="0" rIns="0" tIns="0" bIns="0" anchor="ctr"/>
+          <a:bodyPr wrap="square" lIns="0" tIns="0" rIns="0" bIns="0" anchor="ctr"/>
           <a:lstStyle/>
           <a:p>
             <a:pPr algn="ctr"/>
@@ -9318,7 +9932,7 @@
           </a:ln>
         </p:spPr>
         <p:txBody>
-          <a:bodyPr wrap="square" lIns="0" rIns="0" tIns="0" bIns="0" anchor="ctr"/>
+          <a:bodyPr wrap="square" lIns="0" tIns="0" rIns="0" bIns="0" anchor="ctr"/>
           <a:lstStyle/>
           <a:p>
             <a:pPr algn="ctr"/>
@@ -9351,7 +9965,7 @@
           </a:ln>
         </p:spPr>
         <p:txBody>
-          <a:bodyPr wrap="square" lIns="0" rIns="0" tIns="0" bIns="0" anchor="ctr"/>
+          <a:bodyPr wrap="square" lIns="0" tIns="0" rIns="0" bIns="0" anchor="ctr"/>
           <a:lstStyle/>
           <a:p>
             <a:pPr algn="ctr"/>
@@ -9384,7 +9998,7 @@
           </a:ln>
         </p:spPr>
         <p:txBody>
-          <a:bodyPr wrap="square" lIns="0" rIns="0" tIns="0" bIns="0" anchor="t"/>
+          <a:bodyPr wrap="square" lIns="0" tIns="0" rIns="0" bIns="0" anchor="t"/>
           <a:lstStyle/>
           <a:p>
             <a:pPr algn="l"/>
@@ -9417,7 +10031,7 @@
           </a:ln>
         </p:spPr>
         <p:txBody>
-          <a:bodyPr wrap="square" lIns="0" rIns="0" tIns="0" bIns="0" anchor="t"/>
+          <a:bodyPr wrap="square" lIns="0" tIns="0" rIns="0" bIns="0" anchor="t"/>
           <a:lstStyle/>
           <a:p>
             <a:pPr algn="l"/>
@@ -9472,7 +10086,7 @@
           </a:ln>
         </p:spPr>
         <p:txBody>
-          <a:bodyPr wrap="square" lIns="0" rIns="0" tIns="0" bIns="0" anchor="ctr"/>
+          <a:bodyPr wrap="square" lIns="0" tIns="0" rIns="0" bIns="0" anchor="ctr"/>
           <a:lstStyle/>
           <a:p>
             <a:pPr algn="ctr"/>
@@ -9539,7 +10153,7 @@
           </a:ln>
         </p:spPr>
         <p:txBody>
-          <a:bodyPr wrap="square" lIns="0" rIns="0" tIns="0" bIns="0" anchor="ctr"/>
+          <a:bodyPr wrap="square" lIns="0" tIns="0" rIns="0" bIns="0" anchor="ctr"/>
           <a:lstStyle/>
           <a:p>
             <a:pPr algn="ctr"/>
@@ -9606,7 +10220,7 @@
           </a:ln>
         </p:spPr>
         <p:txBody>
-          <a:bodyPr wrap="square" lIns="0" rIns="0" tIns="0" bIns="0" anchor="ctr"/>
+          <a:bodyPr wrap="square" lIns="0" tIns="0" rIns="0" bIns="0" anchor="ctr"/>
           <a:lstStyle/>
           <a:p>
             <a:pPr algn="ctr"/>
@@ -9651,7 +10265,7 @@
           </a:ln>
         </p:spPr>
         <p:txBody>
-          <a:bodyPr wrap="square" lIns="0" rIns="0" tIns="0" bIns="0" anchor="ctr"/>
+          <a:bodyPr wrap="square" lIns="0" tIns="0" rIns="0" bIns="0" anchor="ctr"/>
           <a:lstStyle/>
           <a:p>
             <a:pPr algn="ctr"/>
@@ -9684,7 +10298,7 @@
           </a:ln>
         </p:spPr>
         <p:txBody>
-          <a:bodyPr wrap="square" lIns="0" rIns="0" tIns="0" bIns="0" anchor="ctr"/>
+          <a:bodyPr wrap="square" lIns="0" tIns="0" rIns="0" bIns="0" anchor="ctr"/>
           <a:lstStyle/>
           <a:p>
             <a:pPr algn="ctr"/>
@@ -9717,7 +10331,7 @@
           </a:ln>
         </p:spPr>
         <p:txBody>
-          <a:bodyPr wrap="square" lIns="0" rIns="0" tIns="0" bIns="0" anchor="t"/>
+          <a:bodyPr wrap="square" lIns="0" tIns="0" rIns="0" bIns="0" anchor="t"/>
           <a:lstStyle/>
           <a:p>
             <a:pPr algn="l"/>
@@ -9794,7 +10408,7 @@
           </a:ln>
         </p:spPr>
         <p:txBody>
-          <a:bodyPr wrap="square" lIns="0" rIns="0" tIns="0" bIns="0" anchor="ctr"/>
+          <a:bodyPr wrap="square" lIns="0" tIns="0" rIns="0" bIns="0" anchor="ctr"/>
           <a:lstStyle/>
           <a:p>
             <a:pPr algn="l"/>
@@ -9871,7 +10485,7 @@
           </a:ln>
         </p:spPr>
         <p:txBody>
-          <a:bodyPr wrap="square" lIns="0" rIns="0" tIns="0" bIns="0" anchor="ctr"/>
+          <a:bodyPr wrap="square" lIns="0" tIns="0" rIns="0" bIns="0" anchor="ctr"/>
           <a:lstStyle/>
           <a:p>
             <a:pPr algn="l"/>
@@ -9904,7 +10518,7 @@
           </a:ln>
         </p:spPr>
         <p:txBody>
-          <a:bodyPr wrap="square" lIns="0" rIns="0" tIns="0" bIns="0" anchor="ctr"/>
+          <a:bodyPr wrap="square" lIns="0" tIns="0" rIns="0" bIns="0" anchor="ctr"/>
           <a:lstStyle/>
           <a:p>
             <a:pPr algn="r"/>
@@ -10043,15 +10657,6 @@
               </a:rPr>
               <a:t>select_events.py</a:t>
             </a:r>
-            <a:r>
-              <a:rPr lang="it-IT" sz="850" b="0" i="0" dirty="0">
-                <a:solidFill>
-                  <a:srgbClr val="52657B"/>
-                </a:solidFill>
-                <a:latin typeface="Aptos"/>
-              </a:rPr>
-              <a:t/>
-            </a:r>
           </a:p>
         </p:txBody>
       </p:sp>
@@ -10134,7 +10739,34 @@
                 </a:solidFill>
                 <a:latin typeface="Aptos"/>
               </a:rPr>
-              <a:t>Con C++/ROOT produciamo h80; Python/</a:t>
+              <a:t>Con C++/ROOT produciamo </a:t>
+            </a:r>
+            <a:r>
+              <a:rPr lang="it-IT" sz="1376" b="1" dirty="0">
+                <a:solidFill>
+                  <a:srgbClr val="0B5FA5"/>
+                </a:solidFill>
+                <a:latin typeface="Aptos"/>
+              </a:rPr>
+              <a:t>i file </a:t>
+            </a:r>
+            <a:r>
+              <a:rPr lang="it-IT" sz="1376" b="1" dirty="0" err="1">
+                <a:solidFill>
+                  <a:srgbClr val="0B5FA5"/>
+                </a:solidFill>
+                <a:latin typeface="Aptos"/>
+              </a:rPr>
+              <a:t>preanalizzati</a:t>
+            </a:r>
+            <a:r>
+              <a:rPr lang="it-IT" sz="1376" b="1" i="0" dirty="0">
+                <a:solidFill>
+                  <a:srgbClr val="0B5FA5"/>
+                </a:solidFill>
+                <a:latin typeface="Aptos"/>
+              </a:rPr>
+              <a:t>; Python/</a:t>
             </a:r>
             <a:r>
               <a:rPr lang="it-IT" sz="1376" b="1" i="0" dirty="0" err="1">
@@ -10152,7 +10784,7 @@
                 </a:solidFill>
                 <a:latin typeface="Aptos"/>
               </a:rPr>
-              <a:t> filtra gli eventi in h85.</a:t>
+              <a:t> filtra gli eventi.</a:t>
             </a:r>
           </a:p>
         </p:txBody>
@@ -10313,13 +10945,31 @@
           <a:p>
             <a:pPr algn="l"/>
             <a:r>
-              <a:rPr lang="it-IT" sz="1500" b="0" i="0">
+              <a:rPr lang="it-IT" sz="1500" b="0" i="0" dirty="0">
                 <a:solidFill>
                   <a:srgbClr val="112642"/>
                 </a:solidFill>
                 <a:latin typeface="Aptos"/>
               </a:rPr>
-              <a:t>I poligoni PID del run classificano le tracce centrali. PreAnalysis.C scrive h80 con particelle e metadati.</a:t>
+              <a:t>I poligoni PID del </a:t>
+            </a:r>
+            <a:r>
+              <a:rPr lang="it-IT" sz="1500" b="0" i="0" dirty="0" err="1">
+                <a:solidFill>
+                  <a:srgbClr val="112642"/>
+                </a:solidFill>
+                <a:latin typeface="Aptos"/>
+              </a:rPr>
+              <a:t>run</a:t>
+            </a:r>
+            <a:r>
+              <a:rPr lang="it-IT" sz="1500" b="0" i="0" dirty="0">
+                <a:solidFill>
+                  <a:srgbClr val="112642"/>
+                </a:solidFill>
+                <a:latin typeface="Aptos"/>
+              </a:rPr>
+              <a:t> classificano le tracce centrali.</a:t>
             </a:r>
           </a:p>
         </p:txBody>
@@ -10492,13 +11142,13 @@
           <a:p>
             <a:pPr algn="l"/>
             <a:r>
-              <a:rPr lang="it-IT" sz="1450" b="0" i="0">
+              <a:rPr lang="it-IT" sz="1450" b="0" i="0" dirty="0">
                 <a:solidFill>
                   <a:srgbClr val="112642"/>
                 </a:solidFill>
                 <a:latin typeface="Aptos"/>
               </a:rPr>
-              <a:t>La preselezione richiede almeno 2 fotoni e una traccia carica in avanti. h85 conserva tutti i rami; i 4 fotoni si richiedono più avanti.</a:t>
+              <a:t>La preselezione richiede almeno 2 fotoni e una traccia carica in avanti. I file selezionati conservano tutti i rami; i 4 fotoni si richiedono più avanti.</a:t>
             </a:r>
           </a:p>
         </p:txBody>
@@ -10525,13 +11175,94 @@
           <a:p>
             <a:pPr algn="l"/>
             <a:r>
-              <a:rPr lang="it-IT" sz="1400" b="0" i="0">
+              <a:rPr lang="it-IT" sz="1400" b="0" i="0" dirty="0" err="1">
                 <a:solidFill>
                   <a:srgbClr val="52657B"/>
                 </a:solidFill>
                 <a:latin typeface="Aptos"/>
               </a:rPr>
-              <a:t>RunNumber, Polarization e Xstrip restano disponibili per ricostruzione e calibrazione.</a:t>
+              <a:t>Quadrimpulsi</a:t>
+            </a:r>
+            <a:r>
+              <a:rPr lang="it-IT" sz="1400" dirty="0">
+                <a:solidFill>
+                  <a:srgbClr val="52657B"/>
+                </a:solidFill>
+                <a:latin typeface="Aptos"/>
+              </a:rPr>
+              <a:t> delle </a:t>
+            </a:r>
+            <a:r>
+              <a:rPr lang="it-IT" sz="1400" dirty="0" err="1">
+                <a:solidFill>
+                  <a:srgbClr val="52657B"/>
+                </a:solidFill>
+                <a:latin typeface="Aptos"/>
+              </a:rPr>
+              <a:t>perticelle</a:t>
+            </a:r>
+            <a:r>
+              <a:rPr lang="it-IT" sz="1400" dirty="0">
+                <a:solidFill>
+                  <a:srgbClr val="52657B"/>
+                </a:solidFill>
+                <a:latin typeface="Aptos"/>
+              </a:rPr>
+              <a:t> di interesse, </a:t>
+            </a:r>
+            <a:r>
+              <a:rPr lang="it-IT" sz="1400" b="0" i="0" dirty="0" err="1">
+                <a:solidFill>
+                  <a:srgbClr val="52657B"/>
+                </a:solidFill>
+                <a:latin typeface="Aptos"/>
+              </a:rPr>
+              <a:t>RunNumber</a:t>
+            </a:r>
+            <a:r>
+              <a:rPr lang="it-IT" sz="1400" b="0" i="0" dirty="0">
+                <a:solidFill>
+                  <a:srgbClr val="52657B"/>
+                </a:solidFill>
+                <a:latin typeface="Aptos"/>
+              </a:rPr>
+              <a:t>, </a:t>
+            </a:r>
+            <a:r>
+              <a:rPr lang="it-IT" sz="1400" b="0" i="0" dirty="0" err="1">
+                <a:solidFill>
+                  <a:srgbClr val="52657B"/>
+                </a:solidFill>
+                <a:latin typeface="Aptos"/>
+              </a:rPr>
+              <a:t>Polarization</a:t>
+            </a:r>
+            <a:r>
+              <a:rPr lang="it-IT" sz="1400" b="0" i="0" dirty="0">
+                <a:solidFill>
+                  <a:srgbClr val="52657B"/>
+                </a:solidFill>
+                <a:latin typeface="Aptos"/>
+              </a:rPr>
+              <a:t> e </a:t>
+            </a:r>
+            <a:r>
+              <a:rPr lang="it-IT" sz="1400" b="0" i="0" dirty="0" err="1">
+                <a:solidFill>
+                  <a:srgbClr val="52657B"/>
+                </a:solidFill>
+                <a:latin typeface="Aptos"/>
+              </a:rPr>
+              <a:t>Xstrip</a:t>
+            </a:r>
+            <a:r>
+              <a:rPr lang="it-IT" sz="1400" b="0" i="0" dirty="0">
+                <a:solidFill>
+                  <a:srgbClr val="52657B"/>
+                </a:solidFill>
+                <a:latin typeface="Aptos"/>
+              </a:rPr>
+              <a:t>.</a:t>
             </a:r>
           </a:p>
         </p:txBody>
@@ -10732,7 +11463,7 @@
 </file>
 
 <file path=ppt/slides/slide5.xml><?xml version="1.0" encoding="utf-8"?>
-<p:sld xmlns:p="http://schemas.openxmlformats.org/presentationml/2006/main" xmlns:a="http://schemas.openxmlformats.org/drawingml/2006/main" xmlns:r="http://schemas.openxmlformats.org/officeDocument/2006/relationships">
+<p:sld xmlns:a="http://schemas.openxmlformats.org/drawingml/2006/main" xmlns:r="http://schemas.openxmlformats.org/officeDocument/2006/relationships" xmlns:p="http://schemas.openxmlformats.org/presentationml/2006/main">
   <p:cSld>
     <p:bg>
       <p:bgPr>
@@ -10773,7 +11504,7 @@
           </a:ln>
         </p:spPr>
         <p:txBody>
-          <a:bodyPr wrap="square" lIns="0" rIns="0" tIns="0" bIns="0" anchor="t"/>
+          <a:bodyPr wrap="square" lIns="0" tIns="0" rIns="0" bIns="0" anchor="t"/>
           <a:lstStyle/>
           <a:p>
             <a:pPr algn="l"/>
@@ -10806,7 +11537,7 @@
           </a:ln>
         </p:spPr>
         <p:txBody>
-          <a:bodyPr wrap="square" lIns="0" rIns="0" tIns="0" bIns="0" anchor="t"/>
+          <a:bodyPr wrap="square" lIns="0" tIns="0" rIns="0" bIns="0" anchor="t"/>
           <a:lstStyle/>
           <a:p>
             <a:pPr algn="l"/>
@@ -10839,7 +11570,7 @@
           </a:ln>
         </p:spPr>
         <p:txBody>
-          <a:bodyPr wrap="square" lIns="0" rIns="0" tIns="0" bIns="0" anchor="t"/>
+          <a:bodyPr wrap="square" lIns="0" tIns="0" rIns="0" bIns="0" anchor="t"/>
           <a:lstStyle/>
           <a:p>
             <a:pPr algn="l"/>
@@ -10894,30 +11625,102 @@
           </a:ln>
         </p:spPr>
         <p:txBody>
-          <a:bodyPr wrap="square" lIns="0" rIns="0" tIns="0" bIns="0" anchor="ctr"/>
-          <a:lstStyle/>
-          <a:p>
-            <a:pPr algn="l"/>
-            <a:r>
-              <a:rPr lang="it-IT" sz="1270" b="0" i="0">
+          <a:bodyPr wrap="square" lIns="0" tIns="0" rIns="0" bIns="0" anchor="ctr"/>
+          <a:lstStyle/>
+          <a:p>
+            <a:pPr algn="l"/>
+            <a:r>
+              <a:rPr lang="it-IT" sz="1270" b="0" i="0" dirty="0" err="1">
                 <a:solidFill>
                   <a:srgbClr val="FFFFFF"/>
                 </a:solidFill>
                 <a:latin typeface="Aptos"/>
               </a:rPr>
-              <a:t>if chain.gammas.size() &lt; 4: continue</a:t>
-            </a:r>
-          </a:p>
-          <a:p>
-            <a:pPr algn="l"/>
-            <a:r>
-              <a:rPr lang="it-IT" sz="1270" b="0" i="0">
+              <a:t>if</a:t>
+            </a:r>
+            <a:r>
+              <a:rPr lang="it-IT" sz="1270" b="0" i="0" dirty="0">
                 <a:solidFill>
                   <a:srgbClr val="FFFFFF"/>
                 </a:solidFill>
                 <a:latin typeface="Aptos"/>
               </a:rPr>
-              <a:t>if chain.protons.size() != 1: continue</a:t>
+              <a:t> </a:t>
+            </a:r>
+            <a:r>
+              <a:rPr lang="it-IT" sz="1270" b="0" i="0" dirty="0" err="1">
+                <a:solidFill>
+                  <a:srgbClr val="FFFFFF"/>
+                </a:solidFill>
+                <a:latin typeface="Aptos"/>
+              </a:rPr>
+              <a:t>chain.gammas.size</a:t>
+            </a:r>
+            <a:r>
+              <a:rPr lang="it-IT" sz="1270" b="0" i="0" dirty="0">
+                <a:solidFill>
+                  <a:srgbClr val="FFFFFF"/>
+                </a:solidFill>
+                <a:latin typeface="Aptos"/>
+              </a:rPr>
+              <a:t>() </a:t>
+            </a:r>
+            <a:r>
+              <a:rPr lang="it-IT" sz="1270" dirty="0">
+                <a:solidFill>
+                  <a:srgbClr val="FFFFFF"/>
+                </a:solidFill>
+                <a:latin typeface="Aptos"/>
+              </a:rPr>
+              <a:t>==</a:t>
+            </a:r>
+            <a:r>
+              <a:rPr lang="it-IT" sz="1270" b="0" i="0" dirty="0">
+                <a:solidFill>
+                  <a:srgbClr val="FFFFFF"/>
+                </a:solidFill>
+                <a:latin typeface="Aptos"/>
+              </a:rPr>
+              <a:t> 4: continue</a:t>
+            </a:r>
+          </a:p>
+          <a:p>
+            <a:pPr algn="l"/>
+            <a:r>
+              <a:rPr lang="it-IT" sz="1270" b="0" i="0" dirty="0" err="1">
+                <a:solidFill>
+                  <a:srgbClr val="FFFFFF"/>
+                </a:solidFill>
+                <a:latin typeface="Aptos"/>
+              </a:rPr>
+              <a:t>if</a:t>
+            </a:r>
+            <a:r>
+              <a:rPr lang="it-IT" sz="1270" b="0" i="0" dirty="0">
+                <a:solidFill>
+                  <a:srgbClr val="FFFFFF"/>
+                </a:solidFill>
+                <a:latin typeface="Aptos"/>
+              </a:rPr>
+              <a:t> </a:t>
+            </a:r>
+            <a:r>
+              <a:rPr lang="it-IT" sz="1270" b="0" i="0" dirty="0" err="1">
+                <a:solidFill>
+                  <a:srgbClr val="FFFFFF"/>
+                </a:solidFill>
+                <a:latin typeface="Aptos"/>
+              </a:rPr>
+              <a:t>chain.protons.size</a:t>
+            </a:r>
+            <a:r>
+              <a:rPr lang="it-IT" sz="1270" b="0" i="0" dirty="0">
+                <a:solidFill>
+                  <a:srgbClr val="FFFFFF"/>
+                </a:solidFill>
+                <a:latin typeface="Aptos"/>
+              </a:rPr>
+              <a:t>() == 1: continue</a:t>
             </a:r>
           </a:p>
         </p:txBody>
@@ -10939,7 +11742,7 @@
           </a:ln>
         </p:spPr>
         <p:txBody>
-          <a:bodyPr wrap="square" lIns="0" rIns="0" tIns="0" bIns="0" anchor="ctr"/>
+          <a:bodyPr wrap="square" lIns="0" tIns="0" rIns="0" bIns="0" anchor="ctr"/>
           <a:lstStyle/>
           <a:p>
             <a:pPr algn="ctr"/>
@@ -10994,18 +11797,18 @@
           </a:ln>
         </p:spPr>
         <p:txBody>
-          <a:bodyPr wrap="square" lIns="0" rIns="0" tIns="0" bIns="0" anchor="ctr"/>
-          <a:lstStyle/>
-          <a:p>
-            <a:pPr algn="l"/>
-            <a:r>
-              <a:rPr lang="it-IT" sz="1440" b="0" i="0">
+          <a:bodyPr wrap="square" lIns="0" tIns="0" rIns="0" bIns="0" anchor="ctr"/>
+          <a:lstStyle/>
+          <a:p>
+            <a:pPr algn="l"/>
+            <a:r>
+              <a:rPr lang="it-IT" sz="1440" b="0" i="0" dirty="0">
                 <a:solidFill>
                   <a:srgbClr val="112642"/>
                 </a:solidFill>
                 <a:latin typeface="Aptos"/>
               </a:rPr>
-              <a:t>Servono almeno quattro fotoni e un solo protone. Usiamo i primi quattro fotoni e conserviamo la molteplicità originale.</a:t>
+              <a:t>Servono almeno quattro fotoni e un solo protone.</a:t>
             </a:r>
           </a:p>
         </p:txBody>
@@ -11049,7 +11852,7 @@
           </a:ln>
         </p:spPr>
         <p:txBody>
-          <a:bodyPr wrap="square" lIns="0" rIns="0" tIns="0" bIns="0" anchor="ctr"/>
+          <a:bodyPr wrap="square" lIns="0" tIns="0" rIns="0" bIns="0" anchor="ctr"/>
           <a:lstStyle/>
           <a:p>
             <a:pPr algn="l"/>
@@ -11118,7 +11921,7 @@
           </a:ln>
         </p:spPr>
         <p:txBody>
-          <a:bodyPr wrap="square" lIns="0" rIns="0" tIns="0" bIns="0" anchor="ctr"/>
+          <a:bodyPr wrap="square" lIns="0" tIns="0" rIns="0" bIns="0" anchor="ctr"/>
           <a:lstStyle/>
           <a:p>
             <a:pPr algn="ctr"/>
@@ -11173,18 +11976,36 @@
           </a:ln>
         </p:spPr>
         <p:txBody>
-          <a:bodyPr wrap="square" lIns="0" rIns="0" tIns="0" bIns="0" anchor="ctr"/>
-          <a:lstStyle/>
-          <a:p>
-            <a:pPr algn="l"/>
-            <a:r>
-              <a:rPr lang="it-IT" sz="1420" b="0" i="0">
+          <a:bodyPr wrap="square" lIns="0" tIns="0" rIns="0" bIns="0" anchor="ctr"/>
+          <a:lstStyle/>
+          <a:p>
+            <a:pPr algn="l"/>
+            <a:r>
+              <a:rPr lang="it-IT" sz="1420" b="0" i="0" dirty="0">
                 <a:solidFill>
                   <a:srgbClr val="112642"/>
                 </a:solidFill>
                 <a:latin typeface="Aptos"/>
               </a:rPr>
-              <a:t>Tre partizioni dei fotoni, con due assegnazioni ciascuna, danno sei ipotesi ηπ⁰. Scegliamo quella più vicina alle masse nominali: χ² &lt; 10.</a:t>
+              <a:t>Tre partizioni dei fotoni, con due assegnazioni ciascuna, danno sei ipotesi </a:t>
+            </a:r>
+            <a:r>
+              <a:rPr lang="it-IT" sz="1420" b="0" i="0" dirty="0" err="1">
+                <a:solidFill>
+                  <a:srgbClr val="112642"/>
+                </a:solidFill>
+                <a:latin typeface="Aptos"/>
+              </a:rPr>
+              <a:t>η</a:t>
+            </a:r>
+            <a:r>
+              <a:rPr lang="it-IT" sz="1420" b="0" i="0" dirty="0">
+                <a:solidFill>
+                  <a:srgbClr val="112642"/>
+                </a:solidFill>
+                <a:latin typeface="Aptos"/>
+              </a:rPr>
+              <a:t>π⁰. Scegliamo quella più vicina alle masse nominali: χ² &lt; 10.</a:t>
             </a:r>
           </a:p>
         </p:txBody>
@@ -11228,7 +12049,7 @@
           </a:ln>
         </p:spPr>
         <p:txBody>
-          <a:bodyPr wrap="square" lIns="0" rIns="0" tIns="0" bIns="0" anchor="ctr"/>
+          <a:bodyPr wrap="square" lIns="0" tIns="0" rIns="0" bIns="0" anchor="ctr"/>
           <a:lstStyle/>
           <a:p>
             <a:pPr algn="l"/>
@@ -11273,7 +12094,7 @@
           </a:ln>
         </p:spPr>
         <p:txBody>
-          <a:bodyPr wrap="square" lIns="0" rIns="0" tIns="0" bIns="0" anchor="ctr"/>
+          <a:bodyPr wrap="square" lIns="0" tIns="0" rIns="0" bIns="0" anchor="ctr"/>
           <a:lstStyle/>
           <a:p>
             <a:pPr algn="ctr"/>
@@ -11328,7 +12149,7 @@
           </a:ln>
         </p:spPr>
         <p:txBody>
-          <a:bodyPr wrap="square" lIns="0" rIns="0" tIns="0" bIns="0" anchor="ctr"/>
+          <a:bodyPr wrap="square" lIns="0" tIns="0" rIns="0" bIns="0" anchor="ctr"/>
           <a:lstStyle/>
           <a:p>
             <a:pPr algn="l"/>
@@ -11405,7 +12226,7 @@
           </a:ln>
         </p:spPr>
         <p:txBody>
-          <a:bodyPr wrap="square" lIns="0" rIns="0" tIns="0" bIns="0" anchor="ctr"/>
+          <a:bodyPr wrap="square" lIns="0" tIns="0" rIns="0" bIns="0" anchor="ctr"/>
           <a:lstStyle/>
           <a:p>
             <a:pPr algn="l"/>
@@ -11482,7 +12303,7 @@
           </a:ln>
         </p:spPr>
         <p:txBody>
-          <a:bodyPr wrap="square" lIns="0" rIns="0" tIns="0" bIns="0" anchor="ctr"/>
+          <a:bodyPr wrap="square" lIns="0" tIns="0" rIns="0" bIns="0" anchor="ctr"/>
           <a:lstStyle/>
           <a:p>
             <a:pPr algn="l"/>
@@ -11515,7 +12336,7 @@
           </a:ln>
         </p:spPr>
         <p:txBody>
-          <a:bodyPr wrap="square" lIns="0" rIns="0" tIns="0" bIns="0" anchor="ctr"/>
+          <a:bodyPr wrap="square" lIns="0" tIns="0" rIns="0" bIns="0" anchor="ctr"/>
           <a:lstStyle/>
           <a:p>
             <a:pPr algn="r"/>
@@ -11540,7 +12361,7 @@
 </file>
 
 <file path=ppt/slides/slide6.xml><?xml version="1.0" encoding="utf-8"?>
-<p:sld xmlns:p="http://schemas.openxmlformats.org/presentationml/2006/main" xmlns:a="http://schemas.openxmlformats.org/drawingml/2006/main" xmlns:r="http://schemas.openxmlformats.org/officeDocument/2006/relationships">
+<p:sld xmlns:a="http://schemas.openxmlformats.org/drawingml/2006/main" xmlns:r="http://schemas.openxmlformats.org/officeDocument/2006/relationships" xmlns:p="http://schemas.openxmlformats.org/presentationml/2006/main">
   <p:cSld>
     <p:bg>
       <p:bgPr>
@@ -11581,7 +12402,7 @@
           </a:ln>
         </p:spPr>
         <p:txBody>
-          <a:bodyPr wrap="square" lIns="0" rIns="0" tIns="0" bIns="0" anchor="t"/>
+          <a:bodyPr wrap="square" lIns="0" tIns="0" rIns="0" bIns="0" anchor="t"/>
           <a:lstStyle/>
           <a:p>
             <a:pPr algn="l"/>
@@ -11614,7 +12435,7 @@
           </a:ln>
         </p:spPr>
         <p:txBody>
-          <a:bodyPr wrap="square" lIns="0" rIns="0" tIns="0" bIns="0" anchor="t"/>
+          <a:bodyPr wrap="square" lIns="0" tIns="0" rIns="0" bIns="0" anchor="t"/>
           <a:lstStyle/>
           <a:p>
             <a:pPr algn="l"/>
@@ -11647,7 +12468,7 @@
           </a:ln>
         </p:spPr>
         <p:txBody>
-          <a:bodyPr wrap="square" lIns="0" rIns="0" tIns="0" bIns="0" anchor="t"/>
+          <a:bodyPr wrap="square" lIns="0" tIns="0" rIns="0" bIns="0" anchor="t"/>
           <a:lstStyle/>
           <a:p>
             <a:pPr algn="l"/>
@@ -11702,7 +12523,7 @@
           </a:ln>
         </p:spPr>
         <p:txBody>
-          <a:bodyPr wrap="square" lIns="0" rIns="0" tIns="0" bIns="0" anchor="ctr"/>
+          <a:bodyPr wrap="square" lIns="0" tIns="0" rIns="0" bIns="0" anchor="ctr"/>
           <a:lstStyle/>
           <a:p>
             <a:pPr algn="l"/>
@@ -11759,7 +12580,7 @@
           </a:ln>
         </p:spPr>
         <p:txBody>
-          <a:bodyPr wrap="square" lIns="0" rIns="0" tIns="0" bIns="0" anchor="ctr"/>
+          <a:bodyPr wrap="square" lIns="0" tIns="0" rIns="0" bIns="0" anchor="ctr"/>
           <a:lstStyle/>
           <a:p>
             <a:pPr algn="ctr"/>
@@ -11814,7 +12635,7 @@
           </a:ln>
         </p:spPr>
         <p:txBody>
-          <a:bodyPr wrap="square" lIns="0" rIns="0" tIns="0" bIns="0" anchor="ctr"/>
+          <a:bodyPr wrap="square" lIns="0" tIns="0" rIns="0" bIns="0" anchor="ctr"/>
           <a:lstStyle/>
           <a:p>
             <a:pPr algn="l"/>
@@ -11869,7 +12690,7 @@
           </a:ln>
         </p:spPr>
         <p:txBody>
-          <a:bodyPr wrap="square" lIns="0" rIns="0" tIns="0" bIns="0" anchor="ctr"/>
+          <a:bodyPr wrap="square" lIns="0" tIns="0" rIns="0" bIns="0" anchor="ctr"/>
           <a:lstStyle/>
           <a:p>
             <a:pPr algn="l"/>
@@ -11926,7 +12747,7 @@
           </a:ln>
         </p:spPr>
         <p:txBody>
-          <a:bodyPr wrap="square" lIns="0" rIns="0" tIns="0" bIns="0" anchor="ctr"/>
+          <a:bodyPr wrap="square" lIns="0" tIns="0" rIns="0" bIns="0" anchor="ctr"/>
           <a:lstStyle/>
           <a:p>
             <a:pPr algn="ctr"/>
@@ -11981,7 +12802,7 @@
           </a:ln>
         </p:spPr>
         <p:txBody>
-          <a:bodyPr wrap="square" lIns="0" rIns="0" tIns="0" bIns="0" anchor="ctr"/>
+          <a:bodyPr wrap="square" lIns="0" tIns="0" rIns="0" bIns="0" anchor="ctr"/>
           <a:lstStyle/>
           <a:p>
             <a:pPr algn="l"/>
@@ -12036,7 +12857,7 @@
           </a:ln>
         </p:spPr>
         <p:txBody>
-          <a:bodyPr wrap="square" lIns="0" rIns="0" tIns="0" bIns="0" anchor="ctr"/>
+          <a:bodyPr wrap="square" lIns="0" tIns="0" rIns="0" bIns="0" anchor="ctr"/>
           <a:lstStyle/>
           <a:p>
             <a:pPr algn="l"/>
@@ -12081,7 +12902,7 @@
           </a:ln>
         </p:spPr>
         <p:txBody>
-          <a:bodyPr wrap="square" lIns="0" rIns="0" tIns="0" bIns="0" anchor="ctr"/>
+          <a:bodyPr wrap="square" lIns="0" tIns="0" rIns="0" bIns="0" anchor="ctr"/>
           <a:lstStyle/>
           <a:p>
             <a:pPr algn="ctr"/>
@@ -12136,18 +12957,36 @@
           </a:ln>
         </p:spPr>
         <p:txBody>
-          <a:bodyPr wrap="square" lIns="0" rIns="0" tIns="0" bIns="0" anchor="ctr"/>
-          <a:lstStyle/>
-          <a:p>
-            <a:pPr algn="l"/>
-            <a:r>
-              <a:rPr lang="it-IT" sz="1280" b="0" i="0">
+          <a:bodyPr wrap="square" lIns="0" tIns="0" rIns="0" bIns="0" anchor="ctr"/>
+          <a:lstStyle/>
+          <a:p>
+            <a:pPr algn="l"/>
+            <a:r>
+              <a:rPr lang="it-IT" sz="1280" b="0" i="0" dirty="0">
                 <a:solidFill>
                   <a:srgbClr val="112642"/>
                 </a:solidFill>
                 <a:latin typeface="Aptos"/>
               </a:rPr>
-              <a:t>Per i fotoni assumiamo 10% in energia e 5°/3° negli angoli; per il protone 4% nell'impulso e 3°/2°. Il tagger ha FWHM 16 MeV.</a:t>
+              <a:t>Per i fotoni assumiamo 10% in energia e 5°/3° negli angoli; per il protone 4% nell'impulso e 3°/2°. Il </a:t>
+            </a:r>
+            <a:r>
+              <a:rPr lang="it-IT" sz="1280" b="0" i="0" dirty="0" err="1">
+                <a:solidFill>
+                  <a:srgbClr val="112642"/>
+                </a:solidFill>
+                <a:latin typeface="Aptos"/>
+              </a:rPr>
+              <a:t>tagger</a:t>
+            </a:r>
+            <a:r>
+              <a:rPr lang="it-IT" sz="1280" b="0" i="0" dirty="0">
+                <a:solidFill>
+                  <a:srgbClr val="112642"/>
+                </a:solidFill>
+                <a:latin typeface="Aptos"/>
+              </a:rPr>
+              <a:t> ha FWHM 16 MeV.</a:t>
             </a:r>
           </a:p>
         </p:txBody>
@@ -12191,7 +13030,7 @@
           </a:ln>
         </p:spPr>
         <p:txBody>
-          <a:bodyPr wrap="square" lIns="0" rIns="0" tIns="0" bIns="0" anchor="ctr"/>
+          <a:bodyPr wrap="square" lIns="0" tIns="0" rIns="0" bIns="0" anchor="ctr"/>
           <a:lstStyle/>
           <a:p>
             <a:pPr algn="l"/>
@@ -12248,7 +13087,7 @@
           </a:ln>
         </p:spPr>
         <p:txBody>
-          <a:bodyPr wrap="square" lIns="0" rIns="0" tIns="0" bIns="0" anchor="ctr"/>
+          <a:bodyPr wrap="square" lIns="0" tIns="0" rIns="0" bIns="0" anchor="ctr"/>
           <a:lstStyle/>
           <a:p>
             <a:pPr algn="ctr"/>
@@ -12303,7 +13142,7 @@
           </a:ln>
         </p:spPr>
         <p:txBody>
-          <a:bodyPr wrap="square" lIns="0" rIns="0" tIns="0" bIns="0" anchor="ctr"/>
+          <a:bodyPr wrap="square" lIns="0" tIns="0" rIns="0" bIns="0" anchor="ctr"/>
           <a:lstStyle/>
           <a:p>
             <a:pPr algn="l"/>
@@ -12380,7 +13219,7 @@
           </a:ln>
         </p:spPr>
         <p:txBody>
-          <a:bodyPr wrap="square" lIns="0" rIns="0" tIns="0" bIns="0" anchor="ctr"/>
+          <a:bodyPr wrap="square" lIns="0" tIns="0" rIns="0" bIns="0" anchor="ctr"/>
           <a:lstStyle/>
           <a:p>
             <a:pPr algn="l"/>
@@ -12457,7 +13296,7 @@
           </a:ln>
         </p:spPr>
         <p:txBody>
-          <a:bodyPr wrap="square" lIns="0" rIns="0" tIns="0" bIns="0" anchor="ctr"/>
+          <a:bodyPr wrap="square" lIns="0" tIns="0" rIns="0" bIns="0" anchor="ctr"/>
           <a:lstStyle/>
           <a:p>
             <a:pPr algn="l"/>
@@ -12490,7 +13329,7 @@
           </a:ln>
         </p:spPr>
         <p:txBody>
-          <a:bodyPr wrap="square" lIns="0" rIns="0" tIns="0" bIns="0" anchor="ctr"/>
+          <a:bodyPr wrap="square" lIns="0" tIns="0" rIns="0" bIns="0" anchor="ctr"/>
           <a:lstStyle/>
           <a:p>
             <a:pPr algn="r"/>
@@ -12515,7 +13354,7 @@
 </file>
 
 <file path=ppt/slides/slide7.xml><?xml version="1.0" encoding="utf-8"?>
-<p:sld xmlns:p="http://schemas.openxmlformats.org/presentationml/2006/main" xmlns:a="http://schemas.openxmlformats.org/drawingml/2006/main" xmlns:r="http://schemas.openxmlformats.org/officeDocument/2006/relationships">
+<p:sld xmlns:a="http://schemas.openxmlformats.org/drawingml/2006/main" xmlns:r="http://schemas.openxmlformats.org/officeDocument/2006/relationships" xmlns:p="http://schemas.openxmlformats.org/presentationml/2006/main">
   <p:cSld>
     <p:bg>
       <p:bgPr>
@@ -12556,7 +13395,7 @@
           </a:ln>
         </p:spPr>
         <p:txBody>
-          <a:bodyPr wrap="square" lIns="0" rIns="0" tIns="0" bIns="0" anchor="t"/>
+          <a:bodyPr wrap="square" lIns="0" tIns="0" rIns="0" bIns="0" anchor="t"/>
           <a:lstStyle/>
           <a:p>
             <a:pPr algn="l"/>
@@ -12589,7 +13428,7 @@
           </a:ln>
         </p:spPr>
         <p:txBody>
-          <a:bodyPr wrap="square" lIns="0" rIns="0" tIns="0" bIns="0" anchor="t"/>
+          <a:bodyPr wrap="square" lIns="0" tIns="0" rIns="0" bIns="0" anchor="t"/>
           <a:lstStyle/>
           <a:p>
             <a:pPr algn="l"/>
@@ -12622,7 +13461,7 @@
           </a:ln>
         </p:spPr>
         <p:txBody>
-          <a:bodyPr wrap="square" lIns="0" rIns="0" tIns="0" bIns="0" anchor="t"/>
+          <a:bodyPr wrap="square" lIns="0" tIns="0" rIns="0" bIns="0" anchor="t"/>
           <a:lstStyle/>
           <a:p>
             <a:pPr algn="l"/>
@@ -12677,7 +13516,7 @@
           </a:ln>
         </p:spPr>
         <p:txBody>
-          <a:bodyPr wrap="square" lIns="0" rIns="0" tIns="0" bIns="0" anchor="ctr"/>
+          <a:bodyPr wrap="square" lIns="0" tIns="0" rIns="0" bIns="0" anchor="ctr"/>
           <a:lstStyle/>
           <a:p>
             <a:pPr algn="l"/>
@@ -12710,7 +13549,7 @@
           </a:ln>
         </p:spPr>
         <p:txBody>
-          <a:bodyPr wrap="square" lIns="0" rIns="0" tIns="0" bIns="0" anchor="ctr"/>
+          <a:bodyPr wrap="square" lIns="0" tIns="0" rIns="0" bIns="0" anchor="ctr"/>
           <a:lstStyle/>
           <a:p>
             <a:pPr algn="l"/>
@@ -12765,7 +13604,7 @@
           </a:ln>
         </p:spPr>
         <p:txBody>
-          <a:bodyPr wrap="square" lIns="0" rIns="0" tIns="0" bIns="0" anchor="ctr"/>
+          <a:bodyPr wrap="square" lIns="0" tIns="0" rIns="0" bIns="0" anchor="ctr"/>
           <a:lstStyle/>
           <a:p>
             <a:pPr algn="l"/>
@@ -12798,7 +13637,7 @@
           </a:ln>
         </p:spPr>
         <p:txBody>
-          <a:bodyPr wrap="square" lIns="0" rIns="0" tIns="0" bIns="0" anchor="ctr"/>
+          <a:bodyPr wrap="square" lIns="0" tIns="0" rIns="0" bIns="0" anchor="ctr"/>
           <a:lstStyle/>
           <a:p>
             <a:pPr algn="l"/>
@@ -12853,7 +13692,7 @@
           </a:ln>
         </p:spPr>
         <p:txBody>
-          <a:bodyPr wrap="square" lIns="0" rIns="0" tIns="0" bIns="0" anchor="ctr"/>
+          <a:bodyPr wrap="square" lIns="0" tIns="0" rIns="0" bIns="0" anchor="ctr"/>
           <a:lstStyle/>
           <a:p>
             <a:pPr algn="l"/>
@@ -12886,7 +13725,7 @@
           </a:ln>
         </p:spPr>
         <p:txBody>
-          <a:bodyPr wrap="square" lIns="0" rIns="0" tIns="0" bIns="0" anchor="ctr"/>
+          <a:bodyPr wrap="square" lIns="0" tIns="0" rIns="0" bIns="0" anchor="ctr"/>
           <a:lstStyle/>
           <a:p>
             <a:pPr algn="l"/>
@@ -12919,12 +13758,12 @@
           </a:ln>
         </p:spPr>
         <p:txBody>
-          <a:bodyPr wrap="square" lIns="0" rIns="0" tIns="0" bIns="0" anchor="t"/>
-          <a:lstStyle/>
-          <a:p>
-            <a:pPr algn="l"/>
-            <a:r>
-              <a:rPr lang="it-IT" sz="1299" b="1" i="0">
+          <a:bodyPr wrap="square" lIns="0" tIns="0" rIns="0" bIns="0" anchor="t"/>
+          <a:lstStyle/>
+          <a:p>
+            <a:pPr algn="l"/>
+            <a:r>
+              <a:rPr lang="it-IT" sz="1299" b="1" i="0" dirty="0">
                 <a:solidFill>
                   <a:srgbClr val="0B5FA5"/>
                 </a:solidFill>
@@ -12996,7 +13835,7 @@
           </a:ln>
         </p:spPr>
         <p:txBody>
-          <a:bodyPr wrap="square" lIns="0" rIns="0" tIns="0" bIns="0" anchor="ctr"/>
+          <a:bodyPr wrap="square" lIns="0" tIns="0" rIns="0" bIns="0" anchor="ctr"/>
           <a:lstStyle/>
           <a:p>
             <a:pPr algn="l"/>
@@ -13073,7 +13912,7 @@
           </a:ln>
         </p:spPr>
         <p:txBody>
-          <a:bodyPr wrap="square" lIns="0" rIns="0" tIns="0" bIns="0" anchor="ctr"/>
+          <a:bodyPr wrap="square" lIns="0" tIns="0" rIns="0" bIns="0" anchor="ctr"/>
           <a:lstStyle/>
           <a:p>
             <a:pPr algn="l"/>
@@ -13106,7 +13945,7 @@
           </a:ln>
         </p:spPr>
         <p:txBody>
-          <a:bodyPr wrap="square" lIns="0" rIns="0" tIns="0" bIns="0" anchor="ctr"/>
+          <a:bodyPr wrap="square" lIns="0" tIns="0" rIns="0" bIns="0" anchor="ctr"/>
           <a:lstStyle/>
           <a:p>
             <a:pPr algn="r"/>
@@ -13131,7 +13970,7 @@
 </file>
 
 <file path=ppt/slides/slide8.xml><?xml version="1.0" encoding="utf-8"?>
-<p:sld xmlns:p="http://schemas.openxmlformats.org/presentationml/2006/main" xmlns:a="http://schemas.openxmlformats.org/drawingml/2006/main" xmlns:r="http://schemas.openxmlformats.org/officeDocument/2006/relationships">
+<p:sld xmlns:a="http://schemas.openxmlformats.org/drawingml/2006/main" xmlns:r="http://schemas.openxmlformats.org/officeDocument/2006/relationships" xmlns:p="http://schemas.openxmlformats.org/presentationml/2006/main">
   <p:cSld>
     <p:bg>
       <p:bgPr>
@@ -13172,7 +14011,7 @@
           </a:ln>
         </p:spPr>
         <p:txBody>
-          <a:bodyPr wrap="square" lIns="0" rIns="0" tIns="0" bIns="0" anchor="t"/>
+          <a:bodyPr wrap="square" lIns="0" tIns="0" rIns="0" bIns="0" anchor="t"/>
           <a:lstStyle/>
           <a:p>
             <a:pPr algn="l"/>
@@ -13205,7 +14044,7 @@
           </a:ln>
         </p:spPr>
         <p:txBody>
-          <a:bodyPr wrap="square" lIns="0" rIns="0" tIns="0" bIns="0" anchor="t"/>
+          <a:bodyPr wrap="square" lIns="0" tIns="0" rIns="0" bIns="0" anchor="t"/>
           <a:lstStyle/>
           <a:p>
             <a:pPr algn="l"/>
@@ -13238,7 +14077,7 @@
           </a:ln>
         </p:spPr>
         <p:txBody>
-          <a:bodyPr wrap="square" lIns="0" rIns="0" tIns="0" bIns="0" anchor="t"/>
+          <a:bodyPr wrap="square" lIns="0" tIns="0" rIns="0" bIns="0" anchor="t"/>
           <a:lstStyle/>
           <a:p>
             <a:pPr algn="l"/>
@@ -13271,7 +14110,7 @@
           </a:ln>
         </p:spPr>
         <p:txBody>
-          <a:bodyPr wrap="square" lIns="0" rIns="0" tIns="0" bIns="0" anchor="t"/>
+          <a:bodyPr wrap="square" lIns="0" tIns="0" rIns="0" bIns="0" anchor="t"/>
           <a:lstStyle/>
           <a:p>
             <a:pPr algn="l"/>
@@ -13304,7 +14143,7 @@
           </a:ln>
         </p:spPr>
         <p:txBody>
-          <a:bodyPr wrap="square" lIns="0" rIns="0" tIns="0" bIns="0" anchor="t"/>
+          <a:bodyPr wrap="square" lIns="0" tIns="0" rIns="0" bIns="0" anchor="t"/>
           <a:lstStyle/>
           <a:p>
             <a:pPr algn="l"/>
@@ -13337,7 +14176,7 @@
           </a:ln>
         </p:spPr>
         <p:txBody>
-          <a:bodyPr wrap="square" lIns="0" rIns="0" tIns="0" bIns="0" anchor="t"/>
+          <a:bodyPr wrap="square" lIns="0" tIns="0" rIns="0" bIns="0" anchor="t"/>
           <a:lstStyle/>
           <a:p>
             <a:pPr algn="l"/>
@@ -13370,7 +14209,7 @@
           </a:ln>
         </p:spPr>
         <p:txBody>
-          <a:bodyPr wrap="square" lIns="0" rIns="0" tIns="0" bIns="0" anchor="t"/>
+          <a:bodyPr wrap="square" lIns="0" tIns="0" rIns="0" bIns="0" anchor="t"/>
           <a:lstStyle/>
           <a:p>
             <a:pPr algn="l"/>
@@ -13390,7 +14229,7 @@
         <p:nvPicPr>
           <p:cNvPr id="9" name="decision_tree_nayak.png" descr="decision_tree_nayak.png"/>
           <p:cNvPicPr>
-            <a:picLocks noChangeAspect="1" noGrp="1"/>
+            <a:picLocks noGrp="1" noChangeAspect="1"/>
           </p:cNvPicPr>
           <p:nvPr/>
         </p:nvPicPr>
@@ -13427,7 +14266,7 @@
           </a:ln>
         </p:spPr>
         <p:txBody>
-          <a:bodyPr wrap="square" lIns="0" rIns="0" tIns="0" bIns="0" anchor="t"/>
+          <a:bodyPr wrap="square" lIns="0" tIns="0" rIns="0" bIns="0" anchor="t"/>
           <a:lstStyle/>
           <a:p>
             <a:pPr algn="ctr"/>
@@ -13460,7 +14299,7 @@
           </a:ln>
         </p:spPr>
         <p:txBody>
-          <a:bodyPr wrap="square" lIns="0" rIns="0" tIns="0" bIns="0" anchor="t"/>
+          <a:bodyPr wrap="square" lIns="0" tIns="0" rIns="0" bIns="0" anchor="t"/>
           <a:lstStyle/>
           <a:p>
             <a:pPr algn="l"/>
@@ -13537,7 +14376,7 @@
           </a:ln>
         </p:spPr>
         <p:txBody>
-          <a:bodyPr wrap="square" lIns="0" rIns="0" tIns="0" bIns="0" anchor="ctr"/>
+          <a:bodyPr wrap="square" lIns="0" tIns="0" rIns="0" bIns="0" anchor="ctr"/>
           <a:lstStyle/>
           <a:p>
             <a:pPr algn="l"/>
@@ -13614,7 +14453,7 @@
           </a:ln>
         </p:spPr>
         <p:txBody>
-          <a:bodyPr wrap="square" lIns="0" rIns="0" tIns="0" bIns="0" anchor="ctr"/>
+          <a:bodyPr wrap="square" lIns="0" tIns="0" rIns="0" bIns="0" anchor="ctr"/>
           <a:lstStyle/>
           <a:p>
             <a:pPr algn="l"/>
@@ -13647,7 +14486,7 @@
           </a:ln>
         </p:spPr>
         <p:txBody>
-          <a:bodyPr wrap="square" lIns="0" rIns="0" tIns="0" bIns="0" anchor="ctr"/>
+          <a:bodyPr wrap="square" lIns="0" tIns="0" rIns="0" bIns="0" anchor="ctr"/>
           <a:lstStyle/>
           <a:p>
             <a:pPr algn="r"/>
@@ -13672,7 +14511,7 @@
 </file>
 
 <file path=ppt/slides/slide9.xml><?xml version="1.0" encoding="utf-8"?>
-<p:sld xmlns:p="http://schemas.openxmlformats.org/presentationml/2006/main" xmlns:a="http://schemas.openxmlformats.org/drawingml/2006/main" xmlns:r="http://schemas.openxmlformats.org/officeDocument/2006/relationships">
+<p:sld xmlns:a="http://schemas.openxmlformats.org/drawingml/2006/main" xmlns:r="http://schemas.openxmlformats.org/officeDocument/2006/relationships" xmlns:p="http://schemas.openxmlformats.org/presentationml/2006/main">
   <p:cSld>
     <p:bg>
       <p:bgPr>
@@ -13713,7 +14552,7 @@
           </a:ln>
         </p:spPr>
         <p:txBody>
-          <a:bodyPr wrap="square" lIns="0" rIns="0" tIns="0" bIns="0" anchor="t"/>
+          <a:bodyPr wrap="square" lIns="0" tIns="0" rIns="0" bIns="0" anchor="t"/>
           <a:lstStyle/>
           <a:p>
             <a:pPr algn="l"/>
@@ -13746,7 +14585,7 @@
           </a:ln>
         </p:spPr>
         <p:txBody>
-          <a:bodyPr wrap="square" lIns="0" rIns="0" tIns="0" bIns="0" anchor="t"/>
+          <a:bodyPr wrap="square" lIns="0" tIns="0" rIns="0" bIns="0" anchor="t"/>
           <a:lstStyle/>
           <a:p>
             <a:pPr algn="l"/>
@@ -13766,7 +14605,7 @@
         <p:nvPicPr>
           <p:cNvPr id="4" name="score_uv_production.png" descr="score_uv_production.png"/>
           <p:cNvPicPr>
-            <a:picLocks noChangeAspect="1" noGrp="1"/>
+            <a:picLocks noGrp="1" noChangeAspect="1"/>
           </p:cNvPicPr>
           <p:nvPr/>
         </p:nvPicPr>
@@ -13803,7 +14642,7 @@
           </a:ln>
         </p:spPr>
         <p:txBody>
-          <a:bodyPr wrap="square" lIns="0" rIns="0" tIns="0" bIns="0" anchor="t"/>
+          <a:bodyPr wrap="square" lIns="0" tIns="0" rIns="0" bIns="0" anchor="t"/>
           <a:lstStyle/>
           <a:p>
             <a:pPr algn="l"/>
@@ -13848,7 +14687,7 @@
           </a:ln>
         </p:spPr>
         <p:txBody>
-          <a:bodyPr wrap="square" lIns="0" rIns="0" tIns="0" bIns="0" anchor="t"/>
+          <a:bodyPr wrap="square" lIns="0" tIns="0" rIns="0" bIns="0" anchor="t"/>
           <a:lstStyle/>
           <a:p>
             <a:pPr algn="l"/>
@@ -13881,7 +14720,7 @@
           </a:ln>
         </p:spPr>
         <p:txBody>
-          <a:bodyPr wrap="square" lIns="0" rIns="0" tIns="0" bIns="0" anchor="t"/>
+          <a:bodyPr wrap="square" lIns="0" tIns="0" rIns="0" bIns="0" anchor="t"/>
           <a:lstStyle/>
           <a:p>
             <a:pPr algn="l"/>
@@ -13914,7 +14753,7 @@
           </a:ln>
         </p:spPr>
         <p:txBody>
-          <a:bodyPr wrap="square" lIns="0" rIns="0" tIns="0" bIns="0" anchor="t"/>
+          <a:bodyPr wrap="square" lIns="0" tIns="0" rIns="0" bIns="0" anchor="t"/>
           <a:lstStyle/>
           <a:p>
             <a:pPr algn="l"/>
@@ -13947,7 +14786,7 @@
           </a:ln>
         </p:spPr>
         <p:txBody>
-          <a:bodyPr wrap="square" lIns="0" rIns="0" tIns="0" bIns="0" anchor="t"/>
+          <a:bodyPr wrap="square" lIns="0" tIns="0" rIns="0" bIns="0" anchor="t"/>
           <a:lstStyle/>
           <a:p>
             <a:pPr algn="l"/>
@@ -13980,7 +14819,7 @@
           </a:ln>
         </p:spPr>
         <p:txBody>
-          <a:bodyPr wrap="square" lIns="0" rIns="0" tIns="0" bIns="0" anchor="t"/>
+          <a:bodyPr wrap="square" lIns="0" tIns="0" rIns="0" bIns="0" anchor="t"/>
           <a:lstStyle/>
           <a:p>
             <a:pPr algn="l"/>
@@ -14013,7 +14852,7 @@
           </a:ln>
         </p:spPr>
         <p:txBody>
-          <a:bodyPr wrap="square" lIns="0" rIns="0" tIns="0" bIns="0" anchor="t"/>
+          <a:bodyPr wrap="square" lIns="0" tIns="0" rIns="0" bIns="0" anchor="t"/>
           <a:lstStyle/>
           <a:p>
             <a:pPr algn="l"/>
@@ -14058,12 +14897,12 @@
           </a:ln>
         </p:spPr>
         <p:txBody>
-          <a:bodyPr wrap="square" lIns="0" rIns="0" tIns="0" bIns="0" anchor="t"/>
-          <a:lstStyle/>
-          <a:p>
-            <a:pPr algn="l"/>
-            <a:r>
-              <a:rPr lang="it-IT" sz="1150" b="0" i="0">
+          <a:bodyPr wrap="square" lIns="0" tIns="0" rIns="0" bIns="0" anchor="t"/>
+          <a:lstStyle/>
+          <a:p>
+            <a:pPr algn="l"/>
+            <a:r>
+              <a:rPr lang="it-IT" sz="800" b="0" i="0" dirty="0">
                 <a:solidFill>
                   <a:srgbClr val="52657B"/>
                 </a:solidFill>
@@ -14135,7 +14974,7 @@
           </a:ln>
         </p:spPr>
         <p:txBody>
-          <a:bodyPr wrap="square" lIns="0" rIns="0" tIns="0" bIns="0" anchor="ctr"/>
+          <a:bodyPr wrap="square" lIns="0" tIns="0" rIns="0" bIns="0" anchor="ctr"/>
           <a:lstStyle/>
           <a:p>
             <a:pPr algn="l"/>
@@ -14212,7 +15051,7 @@
           </a:ln>
         </p:spPr>
         <p:txBody>
-          <a:bodyPr wrap="square" lIns="0" rIns="0" tIns="0" bIns="0" anchor="ctr"/>
+          <a:bodyPr wrap="square" lIns="0" tIns="0" rIns="0" bIns="0" anchor="ctr"/>
           <a:lstStyle/>
           <a:p>
             <a:pPr algn="l"/>
@@ -14245,7 +15084,7 @@
           </a:ln>
         </p:spPr>
         <p:txBody>
-          <a:bodyPr wrap="square" lIns="0" rIns="0" tIns="0" bIns="0" anchor="ctr"/>
+          <a:bodyPr wrap="square" lIns="0" tIns="0" rIns="0" bIns="0" anchor="ctr"/>
           <a:lstStyle/>
           <a:p>
             <a:pPr algn="r"/>
@@ -14587,4 +15426,319 @@
   </a:objectDefaults>
   <a:extraClrSchemeLst/>
 </a:theme>
+</file>
+
+<file path=ppt/theme/theme2.xml><?xml version="1.0" encoding="utf-8"?>
+<a:theme xmlns:a="http://schemas.openxmlformats.org/drawingml/2006/main" name="Office Theme">
+  <a:themeElements>
+    <a:clrScheme name="Office">
+      <a:dk1>
+        <a:sysClr val="windowText" lastClr="000000"/>
+      </a:dk1>
+      <a:lt1>
+        <a:sysClr val="window" lastClr="FFFFFF"/>
+      </a:lt1>
+      <a:dk2>
+        <a:srgbClr val="0E2841"/>
+      </a:dk2>
+      <a:lt2>
+        <a:srgbClr val="E8E8E8"/>
+      </a:lt2>
+      <a:accent1>
+        <a:srgbClr val="156082"/>
+      </a:accent1>
+      <a:accent2>
+        <a:srgbClr val="E97132"/>
+      </a:accent2>
+      <a:accent3>
+        <a:srgbClr val="196B24"/>
+      </a:accent3>
+      <a:accent4>
+        <a:srgbClr val="0F9ED5"/>
+      </a:accent4>
+      <a:accent5>
+        <a:srgbClr val="A02B93"/>
+      </a:accent5>
+      <a:accent6>
+        <a:srgbClr val="4EA72E"/>
+      </a:accent6>
+      <a:hlink>
+        <a:srgbClr val="467886"/>
+      </a:hlink>
+      <a:folHlink>
+        <a:srgbClr val="96607D"/>
+      </a:folHlink>
+    </a:clrScheme>
+    <a:fontScheme name="Office">
+      <a:majorFont>
+        <a:latin typeface="Aptos Display" panose="02110004020202020204"/>
+        <a:ea typeface=""/>
+        <a:cs typeface=""/>
+        <a:font script="Jpan" typeface="游ゴシック Light"/>
+        <a:font script="Hang" typeface="맑은 고딕"/>
+        <a:font script="Hans" typeface="等线 Light"/>
+        <a:font script="Hant" typeface="新細明體"/>
+        <a:font script="Arab" typeface="Times New Roman"/>
+        <a:font script="Hebr" typeface="Times New Roman"/>
+        <a:font script="Thai" typeface="Angsana New"/>
+        <a:font script="Ethi" typeface="Nyala"/>
+        <a:font script="Beng" typeface="Vrinda"/>
+        <a:font script="Gujr" typeface="Shruti"/>
+        <a:font script="Khmr" typeface="MoolBoran"/>
+        <a:font script="Knda" typeface="Tunga"/>
+        <a:font script="Guru" typeface="Raavi"/>
+        <a:font script="Cans" typeface="Euphemia"/>
+        <a:font script="Cher" typeface="Plantagenet Cherokee"/>
+        <a:font script="Yiii" typeface="Microsoft Yi Baiti"/>
+        <a:font script="Tibt" typeface="Microsoft Himalaya"/>
+        <a:font script="Thaa" typeface="MV Boli"/>
+        <a:font script="Deva" typeface="Mangal"/>
+        <a:font script="Telu" typeface="Gautami"/>
+        <a:font script="Taml" typeface="Latha"/>
+        <a:font script="Syrc" typeface="Estrangelo Edessa"/>
+        <a:font script="Orya" typeface="Kalinga"/>
+        <a:font script="Mlym" typeface="Kartika"/>
+        <a:font script="Laoo" typeface="DokChampa"/>
+        <a:font script="Sinh" typeface="Iskoola Pota"/>
+        <a:font script="Mong" typeface="Mongolian Baiti"/>
+        <a:font script="Viet" typeface="Times New Roman"/>
+        <a:font script="Uigh" typeface="Microsoft Uighur"/>
+        <a:font script="Geor" typeface="Sylfaen"/>
+        <a:font script="Armn" typeface="Arial"/>
+        <a:font script="Bugi" typeface="Leelawadee UI"/>
+        <a:font script="Bopo" typeface="Microsoft JhengHei"/>
+        <a:font script="Java" typeface="Javanese Text"/>
+        <a:font script="Lisu" typeface="Segoe UI"/>
+        <a:font script="Mymr" typeface="Myanmar Text"/>
+        <a:font script="Nkoo" typeface="Ebrima"/>
+        <a:font script="Olck" typeface="Nirmala UI"/>
+        <a:font script="Osma" typeface="Ebrima"/>
+        <a:font script="Phag" typeface="Phagspa"/>
+        <a:font script="Syrn" typeface="Estrangelo Edessa"/>
+        <a:font script="Syrj" typeface="Estrangelo Edessa"/>
+        <a:font script="Syre" typeface="Estrangelo Edessa"/>
+        <a:font script="Sora" typeface="Nirmala UI"/>
+        <a:font script="Tale" typeface="Microsoft Tai Le"/>
+        <a:font script="Talu" typeface="Microsoft New Tai Lue"/>
+        <a:font script="Tfng" typeface="Ebrima"/>
+      </a:majorFont>
+      <a:minorFont>
+        <a:latin typeface="Aptos" panose="02110004020202020204"/>
+        <a:ea typeface=""/>
+        <a:cs typeface=""/>
+        <a:font script="Jpan" typeface="游ゴシック"/>
+        <a:font script="Hang" typeface="맑은 고딕"/>
+        <a:font script="Hans" typeface="等线"/>
+        <a:font script="Hant" typeface="新細明體"/>
+        <a:font script="Arab" typeface="Arial"/>
+        <a:font script="Hebr" typeface="Arial"/>
+        <a:font script="Thai" typeface="Cordia New"/>
+        <a:font script="Ethi" typeface="Nyala"/>
+        <a:font script="Beng" typeface="Vrinda"/>
+        <a:font script="Gujr" typeface="Shruti"/>
+        <a:font script="Khmr" typeface="DaunPenh"/>
+        <a:font script="Knda" typeface="Tunga"/>
+        <a:font script="Guru" typeface="Raavi"/>
+        <a:font script="Cans" typeface="Euphemia"/>
+        <a:font script="Cher" typeface="Plantagenet Cherokee"/>
+        <a:font script="Yiii" typeface="Microsoft Yi Baiti"/>
+        <a:font script="Tibt" typeface="Microsoft Himalaya"/>
+        <a:font script="Thaa" typeface="MV Boli"/>
+        <a:font script="Deva" typeface="Mangal"/>
+        <a:font script="Telu" typeface="Gautami"/>
+        <a:font script="Taml" typeface="Latha"/>
+        <a:font script="Syrc" typeface="Estrangelo Edessa"/>
+        <a:font script="Orya" typeface="Kalinga"/>
+        <a:font script="Mlym" typeface="Kartika"/>
+        <a:font script="Laoo" typeface="DokChampa"/>
+        <a:font script="Sinh" typeface="Iskoola Pota"/>
+        <a:font script="Mong" typeface="Mongolian Baiti"/>
+        <a:font script="Viet" typeface="Arial"/>
+        <a:font script="Uigh" typeface="Microsoft Uighur"/>
+        <a:font script="Geor" typeface="Sylfaen"/>
+        <a:font script="Armn" typeface="Arial"/>
+        <a:font script="Bugi" typeface="Leelawadee UI"/>
+        <a:font script="Bopo" typeface="Microsoft JhengHei"/>
+        <a:font script="Java" typeface="Javanese Text"/>
+        <a:font script="Lisu" typeface="Segoe UI"/>
+        <a:font script="Mymr" typeface="Myanmar Text"/>
+        <a:font script="Nkoo" typeface="Ebrima"/>
+        <a:font script="Olck" typeface="Nirmala UI"/>
+        <a:font script="Osma" typeface="Ebrima"/>
+        <a:font script="Phag" typeface="Phagspa"/>
+        <a:font script="Syrn" typeface="Estrangelo Edessa"/>
+        <a:font script="Syrj" typeface="Estrangelo Edessa"/>
+        <a:font script="Syre" typeface="Estrangelo Edessa"/>
+        <a:font script="Sora" typeface="Nirmala UI"/>
+        <a:font script="Tale" typeface="Microsoft Tai Le"/>
+        <a:font script="Talu" typeface="Microsoft New Tai Lue"/>
+        <a:font script="Tfng" typeface="Ebrima"/>
+      </a:minorFont>
+    </a:fontScheme>
+    <a:fmtScheme name="Office">
+      <a:fillStyleLst>
+        <a:solidFill>
+          <a:schemeClr val="phClr"/>
+        </a:solidFill>
+        <a:gradFill rotWithShape="1">
+          <a:gsLst>
+            <a:gs pos="0">
+              <a:schemeClr val="phClr">
+                <a:lumMod val="110000"/>
+                <a:satMod val="105000"/>
+                <a:tint val="67000"/>
+              </a:schemeClr>
+            </a:gs>
+            <a:gs pos="50000">
+              <a:schemeClr val="phClr">
+                <a:lumMod val="105000"/>
+                <a:satMod val="103000"/>
+                <a:tint val="73000"/>
+              </a:schemeClr>
+            </a:gs>
+            <a:gs pos="100000">
+              <a:schemeClr val="phClr">
+                <a:lumMod val="105000"/>
+                <a:satMod val="109000"/>
+                <a:tint val="81000"/>
+              </a:schemeClr>
+            </a:gs>
+          </a:gsLst>
+          <a:lin ang="5400000" scaled="0"/>
+        </a:gradFill>
+        <a:gradFill rotWithShape="1">
+          <a:gsLst>
+            <a:gs pos="0">
+              <a:schemeClr val="phClr">
+                <a:satMod val="103000"/>
+                <a:lumMod val="102000"/>
+                <a:tint val="94000"/>
+              </a:schemeClr>
+            </a:gs>
+            <a:gs pos="50000">
+              <a:schemeClr val="phClr">
+                <a:satMod val="110000"/>
+                <a:lumMod val="100000"/>
+                <a:shade val="100000"/>
+              </a:schemeClr>
+            </a:gs>
+            <a:gs pos="100000">
+              <a:schemeClr val="phClr">
+                <a:lumMod val="99000"/>
+                <a:satMod val="120000"/>
+                <a:shade val="78000"/>
+              </a:schemeClr>
+            </a:gs>
+          </a:gsLst>
+          <a:lin ang="5400000" scaled="0"/>
+        </a:gradFill>
+      </a:fillStyleLst>
+      <a:lnStyleLst>
+        <a:ln w="12700" cap="flat" cmpd="sng" algn="ctr">
+          <a:solidFill>
+            <a:schemeClr val="phClr"/>
+          </a:solidFill>
+          <a:prstDash val="solid"/>
+          <a:miter lim="800000"/>
+        </a:ln>
+        <a:ln w="19050" cap="flat" cmpd="sng" algn="ctr">
+          <a:solidFill>
+            <a:schemeClr val="phClr"/>
+          </a:solidFill>
+          <a:prstDash val="solid"/>
+          <a:miter lim="800000"/>
+        </a:ln>
+        <a:ln w="25400" cap="flat" cmpd="sng" algn="ctr">
+          <a:solidFill>
+            <a:schemeClr val="phClr"/>
+          </a:solidFill>
+          <a:prstDash val="solid"/>
+          <a:miter lim="800000"/>
+        </a:ln>
+      </a:lnStyleLst>
+      <a:effectStyleLst>
+        <a:effectStyle>
+          <a:effectLst/>
+        </a:effectStyle>
+        <a:effectStyle>
+          <a:effectLst/>
+        </a:effectStyle>
+        <a:effectStyle>
+          <a:effectLst>
+            <a:outerShdw blurRad="57150" dist="19050" dir="5400000" algn="ctr" rotWithShape="0">
+              <a:srgbClr val="000000">
+                <a:alpha val="63000"/>
+              </a:srgbClr>
+            </a:outerShdw>
+          </a:effectLst>
+        </a:effectStyle>
+      </a:effectStyleLst>
+      <a:bgFillStyleLst>
+        <a:solidFill>
+          <a:schemeClr val="phClr"/>
+        </a:solidFill>
+        <a:solidFill>
+          <a:schemeClr val="phClr">
+            <a:tint val="95000"/>
+            <a:satMod val="170000"/>
+          </a:schemeClr>
+        </a:solidFill>
+        <a:gradFill rotWithShape="1">
+          <a:gsLst>
+            <a:gs pos="0">
+              <a:schemeClr val="phClr">
+                <a:tint val="93000"/>
+                <a:satMod val="150000"/>
+                <a:shade val="98000"/>
+                <a:lumMod val="102000"/>
+              </a:schemeClr>
+            </a:gs>
+            <a:gs pos="50000">
+              <a:schemeClr val="phClr">
+                <a:tint val="98000"/>
+                <a:satMod val="130000"/>
+                <a:shade val="90000"/>
+                <a:lumMod val="103000"/>
+              </a:schemeClr>
+            </a:gs>
+            <a:gs pos="100000">
+              <a:schemeClr val="phClr">
+                <a:shade val="63000"/>
+                <a:satMod val="120000"/>
+              </a:schemeClr>
+            </a:gs>
+          </a:gsLst>
+          <a:lin ang="5400000" scaled="0"/>
+        </a:gradFill>
+      </a:bgFillStyleLst>
+    </a:fmtScheme>
+  </a:themeElements>
+  <a:objectDefaults>
+    <a:lnDef>
+      <a:spPr/>
+      <a:bodyPr/>
+      <a:lstStyle/>
+      <a:style>
+        <a:lnRef idx="2">
+          <a:schemeClr val="accent1"/>
+        </a:lnRef>
+        <a:fillRef idx="0">
+          <a:schemeClr val="accent1"/>
+        </a:fillRef>
+        <a:effectRef idx="1">
+          <a:schemeClr val="accent1"/>
+        </a:effectRef>
+        <a:fontRef idx="minor">
+          <a:schemeClr val="tx1"/>
+        </a:fontRef>
+      </a:style>
+    </a:lnDef>
+  </a:objectDefaults>
+  <a:extraClrSchemeLst/>
+  <a:extLst>
+    <a:ext uri="{05A4C25C-085E-4340-85A3-A5531E510DB2}">
+      <thm15:themeFamily xmlns:thm15="http://schemas.microsoft.com/office/thememl/2012/main" name="Office Theme" id="{2E142A2C-CD16-42D6-873A-C26D2A0506FA}" vid="{1BDDFF52-6CD6-40A5-AB3C-68EB2F1E4D0A}"/>
+    </a:ext>
+  </a:extLst>
+</a:theme>
 </file>
</xml_diff>